<commit_message>
Class diagrams and slides
</commit_message>
<xml_diff>
--- a/Thesis Writing Documents/Project Development.pptx
+++ b/Thesis Writing Documents/Project Development.pptx
@@ -5,10 +5,10 @@
     <p:sldMasterId id="2147483648" r:id="rId5"/>
   </p:sldMasterIdLst>
   <p:notesMasterIdLst>
-    <p:notesMasterId r:id="rId21"/>
+    <p:notesMasterId r:id="rId25"/>
   </p:notesMasterIdLst>
   <p:handoutMasterIdLst>
-    <p:handoutMasterId r:id="rId22"/>
+    <p:handoutMasterId r:id="rId26"/>
   </p:handoutMasterIdLst>
   <p:sldIdLst>
     <p:sldId id="256" r:id="rId6"/>
@@ -18,19 +18,23 @@
     <p:sldId id="2146848305" r:id="rId10"/>
     <p:sldId id="2146848306" r:id="rId11"/>
     <p:sldId id="2146848303" r:id="rId12"/>
-    <p:sldId id="2146848307" r:id="rId13"/>
-    <p:sldId id="2146848308" r:id="rId14"/>
-    <p:sldId id="2146848309" r:id="rId15"/>
-    <p:sldId id="2146848311" r:id="rId16"/>
-    <p:sldId id="2146848310" r:id="rId17"/>
-    <p:sldId id="2146848300" r:id="rId18"/>
-    <p:sldId id="2146848312" r:id="rId19"/>
-    <p:sldId id="2146848313" r:id="rId20"/>
+    <p:sldId id="2146848316" r:id="rId13"/>
+    <p:sldId id="2146848317" r:id="rId14"/>
+    <p:sldId id="2146848307" r:id="rId15"/>
+    <p:sldId id="2146848308" r:id="rId16"/>
+    <p:sldId id="2146848309" r:id="rId17"/>
+    <p:sldId id="2146848311" r:id="rId18"/>
+    <p:sldId id="2146848310" r:id="rId19"/>
+    <p:sldId id="2146848300" r:id="rId20"/>
+    <p:sldId id="2146848312" r:id="rId21"/>
+    <p:sldId id="2146848314" r:id="rId22"/>
+    <p:sldId id="2146848313" r:id="rId23"/>
+    <p:sldId id="2146848315" r:id="rId24"/>
   </p:sldIdLst>
   <p:sldSz cx="12192000" cy="6858000"/>
   <p:notesSz cx="6800850" cy="9926638"/>
   <p:custDataLst>
-    <p:tags r:id="rId23"/>
+    <p:tags r:id="rId27"/>
   </p:custDataLst>
   <p:defaultTextStyle>
     <a:defPPr>
@@ -200,12 +204,1123 @@
 </p:presentation>
 </file>
 
+<file path=ppt/authors.xml><?xml version="1.0" encoding="utf-8"?>
+<p188:authorLst xmlns:a="http://schemas.openxmlformats.org/drawingml/2006/main" xmlns:r="http://schemas.openxmlformats.org/officeDocument/2006/relationships" xmlns:p188="http://schemas.microsoft.com/office/powerpoint/2018/8/main">
+  <p188:author id="{C5CB79AA-8EBF-1E57-EC02-8B657B2EB377}" name="Corbin Ferguson" initials="CF" userId="S::corbin.ferguson@endress.com::34a864e2-e65e-4cb2-823c-dc28f73f0e40" providerId="AD"/>
+</p188:authorLst>
+</file>
+
 <file path=ppt/revisionInfo.xml><?xml version="1.0" encoding="utf-8"?>
 <p1510:revInfo xmlns:a="http://schemas.openxmlformats.org/drawingml/2006/main" xmlns:r="http://schemas.openxmlformats.org/officeDocument/2006/relationships" xmlns:p1510="http://schemas.microsoft.com/office/powerpoint/2015/10/main">
   <p1510:revLst>
-    <p1510:client id="{22354E51-28A9-4CD1-BB37-8B89FE97107A}" v="200" dt="2026-03-16T14:14:38.242"/>
+    <p1510:client id="{F0E03B4B-CC56-43F1-8F18-BCA697229170}" v="263" dt="2026-03-16T16:46:06.936"/>
   </p1510:revLst>
 </p1510:revInfo>
+</file>
+
+<file path=ppt/changesInfos/changesInfo1.xml><?xml version="1.0" encoding="utf-8"?>
+<pc:chgInfo xmlns:a="http://schemas.openxmlformats.org/drawingml/2006/main" xmlns:r="http://schemas.openxmlformats.org/officeDocument/2006/relationships" xmlns:ac="http://schemas.microsoft.com/office/drawing/2013/main/command" xmlns:pc="http://schemas.microsoft.com/office/powerpoint/2013/main/command">
+  <pc:docChgLst>
+    <pc:chgData name="Corbin Ferguson" userId="34a864e2-e65e-4cb2-823c-dc28f73f0e40" providerId="ADAL" clId="{8D2D96CF-1319-4CCC-9EA9-073445628049}"/>
+    <pc:docChg chg="undo custSel addSld modSld sldOrd">
+      <pc:chgData name="Corbin Ferguson" userId="34a864e2-e65e-4cb2-823c-dc28f73f0e40" providerId="ADAL" clId="{8D2D96CF-1319-4CCC-9EA9-073445628049}" dt="2026-03-16T16:46:09.342" v="1562" actId="26606"/>
+      <pc:docMkLst>
+        <pc:docMk/>
+      </pc:docMkLst>
+      <pc:sldChg chg="modSp mod">
+        <pc:chgData name="Corbin Ferguson" userId="34a864e2-e65e-4cb2-823c-dc28f73f0e40" providerId="ADAL" clId="{8D2D96CF-1319-4CCC-9EA9-073445628049}" dt="2026-03-16T14:58:23.802" v="1005" actId="20577"/>
+        <pc:sldMkLst>
+          <pc:docMk/>
+          <pc:sldMk cId="1806041311" sldId="256"/>
+        </pc:sldMkLst>
+        <pc:spChg chg="mod">
+          <ac:chgData name="Corbin Ferguson" userId="34a864e2-e65e-4cb2-823c-dc28f73f0e40" providerId="ADAL" clId="{8D2D96CF-1319-4CCC-9EA9-073445628049}" dt="2026-03-16T14:58:23.802" v="1005" actId="20577"/>
+          <ac:spMkLst>
+            <pc:docMk/>
+            <pc:sldMk cId="1806041311" sldId="256"/>
+            <ac:spMk id="7" creationId="{05DBE8C5-106F-9E45-96DE-92C740078C67}"/>
+          </ac:spMkLst>
+        </pc:spChg>
+      </pc:sldChg>
+      <pc:sldChg chg="addSp delSp modSp mod">
+        <pc:chgData name="Corbin Ferguson" userId="34a864e2-e65e-4cb2-823c-dc28f73f0e40" providerId="ADAL" clId="{8D2D96CF-1319-4CCC-9EA9-073445628049}" dt="2026-03-16T15:01:20.713" v="1025" actId="732"/>
+        <pc:sldMkLst>
+          <pc:docMk/>
+          <pc:sldMk cId="463964235" sldId="257"/>
+        </pc:sldMkLst>
+        <pc:picChg chg="del mod">
+          <ac:chgData name="Corbin Ferguson" userId="34a864e2-e65e-4cb2-823c-dc28f73f0e40" providerId="ADAL" clId="{8D2D96CF-1319-4CCC-9EA9-073445628049}" dt="2026-03-16T15:00:14.797" v="1011" actId="478"/>
+          <ac:picMkLst>
+            <pc:docMk/>
+            <pc:sldMk cId="463964235" sldId="257"/>
+            <ac:picMk id="9" creationId="{1BC88699-DDD8-5B47-A357-650F499C3E03}"/>
+          </ac:picMkLst>
+        </pc:picChg>
+        <pc:picChg chg="add mod">
+          <ac:chgData name="Corbin Ferguson" userId="34a864e2-e65e-4cb2-823c-dc28f73f0e40" providerId="ADAL" clId="{8D2D96CF-1319-4CCC-9EA9-073445628049}" dt="2026-03-16T15:01:11.847" v="1024" actId="1076"/>
+          <ac:picMkLst>
+            <pc:docMk/>
+            <pc:sldMk cId="463964235" sldId="257"/>
+            <ac:picMk id="1028" creationId="{6C86E4AC-1B5D-4CB7-A176-9C365C540E23}"/>
+          </ac:picMkLst>
+        </pc:picChg>
+        <pc:picChg chg="add mod">
+          <ac:chgData name="Corbin Ferguson" userId="34a864e2-e65e-4cb2-823c-dc28f73f0e40" providerId="ADAL" clId="{8D2D96CF-1319-4CCC-9EA9-073445628049}" dt="2026-03-16T15:01:20.713" v="1025" actId="732"/>
+          <ac:picMkLst>
+            <pc:docMk/>
+            <pc:sldMk cId="463964235" sldId="257"/>
+            <ac:picMk id="1030" creationId="{84E072FF-ABEC-64D2-234E-9A5158069A12}"/>
+          </ac:picMkLst>
+        </pc:picChg>
+      </pc:sldChg>
+      <pc:sldChg chg="modSp mod">
+        <pc:chgData name="Corbin Ferguson" userId="34a864e2-e65e-4cb2-823c-dc28f73f0e40" providerId="ADAL" clId="{8D2D96CF-1319-4CCC-9EA9-073445628049}" dt="2026-03-16T15:13:05.111" v="1343" actId="20577"/>
+        <pc:sldMkLst>
+          <pc:docMk/>
+          <pc:sldMk cId="3766655233" sldId="2146848300"/>
+        </pc:sldMkLst>
+        <pc:spChg chg="mod">
+          <ac:chgData name="Corbin Ferguson" userId="34a864e2-e65e-4cb2-823c-dc28f73f0e40" providerId="ADAL" clId="{8D2D96CF-1319-4CCC-9EA9-073445628049}" dt="2026-03-16T15:13:05.111" v="1343" actId="20577"/>
+          <ac:spMkLst>
+            <pc:docMk/>
+            <pc:sldMk cId="3766655233" sldId="2146848300"/>
+            <ac:spMk id="3" creationId="{69166F1D-356D-D430-8690-D44E331BF4F9}"/>
+          </ac:spMkLst>
+        </pc:spChg>
+      </pc:sldChg>
+      <pc:sldChg chg="modSp mod">
+        <pc:chgData name="Corbin Ferguson" userId="34a864e2-e65e-4cb2-823c-dc28f73f0e40" providerId="ADAL" clId="{8D2D96CF-1319-4CCC-9EA9-073445628049}" dt="2026-03-16T15:06:18.204" v="1136" actId="20577"/>
+        <pc:sldMkLst>
+          <pc:docMk/>
+          <pc:sldMk cId="189939056" sldId="2146848304"/>
+        </pc:sldMkLst>
+        <pc:spChg chg="mod">
+          <ac:chgData name="Corbin Ferguson" userId="34a864e2-e65e-4cb2-823c-dc28f73f0e40" providerId="ADAL" clId="{8D2D96CF-1319-4CCC-9EA9-073445628049}" dt="2026-03-16T15:06:18.204" v="1136" actId="20577"/>
+          <ac:spMkLst>
+            <pc:docMk/>
+            <pc:sldMk cId="189939056" sldId="2146848304"/>
+            <ac:spMk id="13" creationId="{4B3CDBD9-BD4E-E7E3-A1E9-2D692BAA1734}"/>
+          </ac:spMkLst>
+        </pc:spChg>
+      </pc:sldChg>
+      <pc:sldChg chg="modSp mod">
+        <pc:chgData name="Corbin Ferguson" userId="34a864e2-e65e-4cb2-823c-dc28f73f0e40" providerId="ADAL" clId="{8D2D96CF-1319-4CCC-9EA9-073445628049}" dt="2026-03-16T15:02:46.111" v="1042" actId="20577"/>
+        <pc:sldMkLst>
+          <pc:docMk/>
+          <pc:sldMk cId="2928641305" sldId="2146848305"/>
+        </pc:sldMkLst>
+        <pc:spChg chg="mod">
+          <ac:chgData name="Corbin Ferguson" userId="34a864e2-e65e-4cb2-823c-dc28f73f0e40" providerId="ADAL" clId="{8D2D96CF-1319-4CCC-9EA9-073445628049}" dt="2026-03-16T15:02:46.111" v="1042" actId="20577"/>
+          <ac:spMkLst>
+            <pc:docMk/>
+            <pc:sldMk cId="2928641305" sldId="2146848305"/>
+            <ac:spMk id="2" creationId="{A59311E1-2F3C-706B-E772-4C7FF4CB0DFD}"/>
+          </ac:spMkLst>
+        </pc:spChg>
+      </pc:sldChg>
+      <pc:sldChg chg="modSp mod">
+        <pc:chgData name="Corbin Ferguson" userId="34a864e2-e65e-4cb2-823c-dc28f73f0e40" providerId="ADAL" clId="{8D2D96CF-1319-4CCC-9EA9-073445628049}" dt="2026-03-16T14:38:49.156" v="491" actId="20577"/>
+        <pc:sldMkLst>
+          <pc:docMk/>
+          <pc:sldMk cId="364984994" sldId="2146848306"/>
+        </pc:sldMkLst>
+        <pc:spChg chg="mod">
+          <ac:chgData name="Corbin Ferguson" userId="34a864e2-e65e-4cb2-823c-dc28f73f0e40" providerId="ADAL" clId="{8D2D96CF-1319-4CCC-9EA9-073445628049}" dt="2026-03-16T14:38:49.156" v="491" actId="20577"/>
+          <ac:spMkLst>
+            <pc:docMk/>
+            <pc:sldMk cId="364984994" sldId="2146848306"/>
+            <ac:spMk id="13" creationId="{ED6C0032-109D-5E6D-74D4-9A87B9B556F0}"/>
+          </ac:spMkLst>
+        </pc:spChg>
+      </pc:sldChg>
+      <pc:sldChg chg="modSp mod">
+        <pc:chgData name="Corbin Ferguson" userId="34a864e2-e65e-4cb2-823c-dc28f73f0e40" providerId="ADAL" clId="{8D2D96CF-1319-4CCC-9EA9-073445628049}" dt="2026-03-16T14:42:17.759" v="600" actId="20577"/>
+        <pc:sldMkLst>
+          <pc:docMk/>
+          <pc:sldMk cId="1957245743" sldId="2146848310"/>
+        </pc:sldMkLst>
+        <pc:spChg chg="mod">
+          <ac:chgData name="Corbin Ferguson" userId="34a864e2-e65e-4cb2-823c-dc28f73f0e40" providerId="ADAL" clId="{8D2D96CF-1319-4CCC-9EA9-073445628049}" dt="2026-03-16T14:42:17.759" v="600" actId="20577"/>
+          <ac:spMkLst>
+            <pc:docMk/>
+            <pc:sldMk cId="1957245743" sldId="2146848310"/>
+            <ac:spMk id="13" creationId="{1EC16664-E325-8471-1AD8-B488025297CB}"/>
+          </ac:spMkLst>
+        </pc:spChg>
+      </pc:sldChg>
+      <pc:sldChg chg="addSp modSp mod modClrScheme chgLayout">
+        <pc:chgData name="Corbin Ferguson" userId="34a864e2-e65e-4cb2-823c-dc28f73f0e40" providerId="ADAL" clId="{8D2D96CF-1319-4CCC-9EA9-073445628049}" dt="2026-03-16T15:08:24.308" v="1176" actId="20577"/>
+        <pc:sldMkLst>
+          <pc:docMk/>
+          <pc:sldMk cId="765330338" sldId="2146848311"/>
+        </pc:sldMkLst>
+        <pc:spChg chg="mod ord">
+          <ac:chgData name="Corbin Ferguson" userId="34a864e2-e65e-4cb2-823c-dc28f73f0e40" providerId="ADAL" clId="{8D2D96CF-1319-4CCC-9EA9-073445628049}" dt="2026-03-16T15:08:11.545" v="1166" actId="700"/>
+          <ac:spMkLst>
+            <pc:docMk/>
+            <pc:sldMk cId="765330338" sldId="2146848311"/>
+            <ac:spMk id="2" creationId="{39A6CDB0-B34B-8995-0E8B-C319A922B5B3}"/>
+          </ac:spMkLst>
+        </pc:spChg>
+        <pc:spChg chg="add mod ord">
+          <ac:chgData name="Corbin Ferguson" userId="34a864e2-e65e-4cb2-823c-dc28f73f0e40" providerId="ADAL" clId="{8D2D96CF-1319-4CCC-9EA9-073445628049}" dt="2026-03-16T15:08:24.308" v="1176" actId="20577"/>
+          <ac:spMkLst>
+            <pc:docMk/>
+            <pc:sldMk cId="765330338" sldId="2146848311"/>
+            <ac:spMk id="3" creationId="{63F6E7F2-C333-13E7-6A23-E317DC8149B0}"/>
+          </ac:spMkLst>
+        </pc:spChg>
+        <pc:spChg chg="mod ord">
+          <ac:chgData name="Corbin Ferguson" userId="34a864e2-e65e-4cb2-823c-dc28f73f0e40" providerId="ADAL" clId="{8D2D96CF-1319-4CCC-9EA9-073445628049}" dt="2026-03-16T15:08:11.545" v="1166" actId="700"/>
+          <ac:spMkLst>
+            <pc:docMk/>
+            <pc:sldMk cId="765330338" sldId="2146848311"/>
+            <ac:spMk id="4" creationId="{00FFBEF8-5E91-2668-D8BE-7A069006F3AD}"/>
+          </ac:spMkLst>
+        </pc:spChg>
+        <pc:spChg chg="mod ord">
+          <ac:chgData name="Corbin Ferguson" userId="34a864e2-e65e-4cb2-823c-dc28f73f0e40" providerId="ADAL" clId="{8D2D96CF-1319-4CCC-9EA9-073445628049}" dt="2026-03-16T15:08:11.545" v="1166" actId="700"/>
+          <ac:spMkLst>
+            <pc:docMk/>
+            <pc:sldMk cId="765330338" sldId="2146848311"/>
+            <ac:spMk id="7" creationId="{F24A93D2-C404-5313-F354-72800B3D775A}"/>
+          </ac:spMkLst>
+        </pc:spChg>
+        <pc:spChg chg="mod ord">
+          <ac:chgData name="Corbin Ferguson" userId="34a864e2-e65e-4cb2-823c-dc28f73f0e40" providerId="ADAL" clId="{8D2D96CF-1319-4CCC-9EA9-073445628049}" dt="2026-03-16T15:08:11.545" v="1166" actId="700"/>
+          <ac:spMkLst>
+            <pc:docMk/>
+            <pc:sldMk cId="765330338" sldId="2146848311"/>
+            <ac:spMk id="8" creationId="{0399E63B-65A1-3030-DC23-CA1AF7150CCF}"/>
+          </ac:spMkLst>
+        </pc:spChg>
+      </pc:sldChg>
+      <pc:sldChg chg="modSp mod">
+        <pc:chgData name="Corbin Ferguson" userId="34a864e2-e65e-4cb2-823c-dc28f73f0e40" providerId="ADAL" clId="{8D2D96CF-1319-4CCC-9EA9-073445628049}" dt="2026-03-16T15:07:15.312" v="1165" actId="20577"/>
+        <pc:sldMkLst>
+          <pc:docMk/>
+          <pc:sldMk cId="785037573" sldId="2146848312"/>
+        </pc:sldMkLst>
+        <pc:spChg chg="mod">
+          <ac:chgData name="Corbin Ferguson" userId="34a864e2-e65e-4cb2-823c-dc28f73f0e40" providerId="ADAL" clId="{8D2D96CF-1319-4CCC-9EA9-073445628049}" dt="2026-03-16T15:07:15.312" v="1165" actId="20577"/>
+          <ac:spMkLst>
+            <pc:docMk/>
+            <pc:sldMk cId="785037573" sldId="2146848312"/>
+            <ac:spMk id="9" creationId="{F12D16D0-86CF-AF46-C7E4-9E991E80B9A8}"/>
+          </ac:spMkLst>
+        </pc:spChg>
+      </pc:sldChg>
+      <pc:sldChg chg="addSp modSp add mod">
+        <pc:chgData name="Corbin Ferguson" userId="34a864e2-e65e-4cb2-823c-dc28f73f0e40" providerId="ADAL" clId="{8D2D96CF-1319-4CCC-9EA9-073445628049}" dt="2026-03-16T15:12:46.375" v="1342" actId="20577"/>
+        <pc:sldMkLst>
+          <pc:docMk/>
+          <pc:sldMk cId="1067535560" sldId="2146848314"/>
+        </pc:sldMkLst>
+        <pc:spChg chg="mod">
+          <ac:chgData name="Corbin Ferguson" userId="34a864e2-e65e-4cb2-823c-dc28f73f0e40" providerId="ADAL" clId="{8D2D96CF-1319-4CCC-9EA9-073445628049}" dt="2026-03-16T14:35:58.596" v="10" actId="20577"/>
+          <ac:spMkLst>
+            <pc:docMk/>
+            <pc:sldMk cId="1067535560" sldId="2146848314"/>
+            <ac:spMk id="2" creationId="{29DC8B36-B78B-74FC-1B96-372E60B3CCA5}"/>
+          </ac:spMkLst>
+        </pc:spChg>
+        <pc:spChg chg="mod">
+          <ac:chgData name="Corbin Ferguson" userId="34a864e2-e65e-4cb2-823c-dc28f73f0e40" providerId="ADAL" clId="{8D2D96CF-1319-4CCC-9EA9-073445628049}" dt="2026-03-16T15:12:46.375" v="1342" actId="20577"/>
+          <ac:spMkLst>
+            <pc:docMk/>
+            <pc:sldMk cId="1067535560" sldId="2146848314"/>
+            <ac:spMk id="9" creationId="{10547ECE-F4D6-7E7B-B957-03EBA9BFAC16}"/>
+          </ac:spMkLst>
+        </pc:spChg>
+        <pc:graphicFrameChg chg="add mod">
+          <ac:chgData name="Corbin Ferguson" userId="34a864e2-e65e-4cb2-823c-dc28f73f0e40" providerId="ADAL" clId="{8D2D96CF-1319-4CCC-9EA9-073445628049}" dt="2026-03-16T14:54:26.903" v="642"/>
+          <ac:graphicFrameMkLst>
+            <pc:docMk/>
+            <pc:sldMk cId="1067535560" sldId="2146848314"/>
+            <ac:graphicFrameMk id="6" creationId="{2B0FA1C0-BB02-FE95-4882-659F84EC68BF}"/>
+          </ac:graphicFrameMkLst>
+        </pc:graphicFrameChg>
+        <pc:graphicFrameChg chg="add mod">
+          <ac:chgData name="Corbin Ferguson" userId="34a864e2-e65e-4cb2-823c-dc28f73f0e40" providerId="ADAL" clId="{8D2D96CF-1319-4CCC-9EA9-073445628049}" dt="2026-03-16T14:54:31.888" v="643"/>
+          <ac:graphicFrameMkLst>
+            <pc:docMk/>
+            <pc:sldMk cId="1067535560" sldId="2146848314"/>
+            <ac:graphicFrameMk id="7" creationId="{B0DB4696-A2DE-2DAF-F42D-A13D1E03B497}"/>
+          </ac:graphicFrameMkLst>
+        </pc:graphicFrameChg>
+        <pc:graphicFrameChg chg="add mod">
+          <ac:chgData name="Corbin Ferguson" userId="34a864e2-e65e-4cb2-823c-dc28f73f0e40" providerId="ADAL" clId="{8D2D96CF-1319-4CCC-9EA9-073445628049}" dt="2026-03-16T14:54:52.519" v="648"/>
+          <ac:graphicFrameMkLst>
+            <pc:docMk/>
+            <pc:sldMk cId="1067535560" sldId="2146848314"/>
+            <ac:graphicFrameMk id="8" creationId="{0627A225-39DD-3E02-1C79-E76C3DE5AD4B}"/>
+          </ac:graphicFrameMkLst>
+        </pc:graphicFrameChg>
+        <pc:graphicFrameChg chg="add mod">
+          <ac:chgData name="Corbin Ferguson" userId="34a864e2-e65e-4cb2-823c-dc28f73f0e40" providerId="ADAL" clId="{8D2D96CF-1319-4CCC-9EA9-073445628049}" dt="2026-03-16T14:56:54.559" v="881"/>
+          <ac:graphicFrameMkLst>
+            <pc:docMk/>
+            <pc:sldMk cId="1067535560" sldId="2146848314"/>
+            <ac:graphicFrameMk id="10" creationId="{6AE61343-672E-4651-8B93-D5EAA608BA5B}"/>
+          </ac:graphicFrameMkLst>
+        </pc:graphicFrameChg>
+      </pc:sldChg>
+      <pc:sldChg chg="modSp add mod ord">
+        <pc:chgData name="Corbin Ferguson" userId="34a864e2-e65e-4cb2-823c-dc28f73f0e40" providerId="ADAL" clId="{8D2D96CF-1319-4CCC-9EA9-073445628049}" dt="2026-03-16T14:42:49.632" v="602"/>
+        <pc:sldMkLst>
+          <pc:docMk/>
+          <pc:sldMk cId="1869098219" sldId="2146848315"/>
+        </pc:sldMkLst>
+        <pc:spChg chg="mod">
+          <ac:chgData name="Corbin Ferguson" userId="34a864e2-e65e-4cb2-823c-dc28f73f0e40" providerId="ADAL" clId="{8D2D96CF-1319-4CCC-9EA9-073445628049}" dt="2026-03-16T14:39:31.709" v="503" actId="20577"/>
+          <ac:spMkLst>
+            <pc:docMk/>
+            <pc:sldMk cId="1869098219" sldId="2146848315"/>
+            <ac:spMk id="2" creationId="{42490D66-69B9-FCB3-4EE3-71E22ADE614D}"/>
+          </ac:spMkLst>
+        </pc:spChg>
+        <pc:spChg chg="mod">
+          <ac:chgData name="Corbin Ferguson" userId="34a864e2-e65e-4cb2-823c-dc28f73f0e40" providerId="ADAL" clId="{8D2D96CF-1319-4CCC-9EA9-073445628049}" dt="2026-03-16T14:42:49.632" v="602"/>
+          <ac:spMkLst>
+            <pc:docMk/>
+            <pc:sldMk cId="1869098219" sldId="2146848315"/>
+            <ac:spMk id="9" creationId="{01007C77-2DF3-8DD9-8D8C-832A640C674D}"/>
+          </ac:spMkLst>
+        </pc:spChg>
+      </pc:sldChg>
+      <pc:sldChg chg="addSp delSp modSp add mod modClrScheme chgLayout">
+        <pc:chgData name="Corbin Ferguson" userId="34a864e2-e65e-4cb2-823c-dc28f73f0e40" providerId="ADAL" clId="{8D2D96CF-1319-4CCC-9EA9-073445628049}" dt="2026-03-16T16:45:57.083" v="1559" actId="26606"/>
+        <pc:sldMkLst>
+          <pc:docMk/>
+          <pc:sldMk cId="2077614573" sldId="2146848316"/>
+        </pc:sldMkLst>
+        <pc:spChg chg="mod ord">
+          <ac:chgData name="Corbin Ferguson" userId="34a864e2-e65e-4cb2-823c-dc28f73f0e40" providerId="ADAL" clId="{8D2D96CF-1319-4CCC-9EA9-073445628049}" dt="2026-03-16T16:39:10.614" v="1550" actId="26606"/>
+          <ac:spMkLst>
+            <pc:docMk/>
+            <pc:sldMk cId="2077614573" sldId="2146848316"/>
+            <ac:spMk id="2" creationId="{07BCF97A-6A5E-DA70-0A21-4FF0D5A9B2D1}"/>
+          </ac:spMkLst>
+        </pc:spChg>
+        <pc:spChg chg="mod ord">
+          <ac:chgData name="Corbin Ferguson" userId="34a864e2-e65e-4cb2-823c-dc28f73f0e40" providerId="ADAL" clId="{8D2D96CF-1319-4CCC-9EA9-073445628049}" dt="2026-03-16T16:39:10.614" v="1550" actId="26606"/>
+          <ac:spMkLst>
+            <pc:docMk/>
+            <pc:sldMk cId="2077614573" sldId="2146848316"/>
+            <ac:spMk id="4" creationId="{6F1C84BC-19BE-D2D3-DB6B-179BB01EE861}"/>
+          </ac:spMkLst>
+        </pc:spChg>
+        <pc:spChg chg="mod ord">
+          <ac:chgData name="Corbin Ferguson" userId="34a864e2-e65e-4cb2-823c-dc28f73f0e40" providerId="ADAL" clId="{8D2D96CF-1319-4CCC-9EA9-073445628049}" dt="2026-03-16T16:39:10.614" v="1550" actId="26606"/>
+          <ac:spMkLst>
+            <pc:docMk/>
+            <pc:sldMk cId="2077614573" sldId="2146848316"/>
+            <ac:spMk id="7" creationId="{3583879C-95E5-7299-C98A-2B7D0B63F807}"/>
+          </ac:spMkLst>
+        </pc:spChg>
+        <pc:spChg chg="mod ord">
+          <ac:chgData name="Corbin Ferguson" userId="34a864e2-e65e-4cb2-823c-dc28f73f0e40" providerId="ADAL" clId="{8D2D96CF-1319-4CCC-9EA9-073445628049}" dt="2026-03-16T16:39:10.614" v="1550" actId="26606"/>
+          <ac:spMkLst>
+            <pc:docMk/>
+            <pc:sldMk cId="2077614573" sldId="2146848316"/>
+            <ac:spMk id="8" creationId="{4C7D5AC9-EA29-86A4-7EF8-4DF941130DC8}"/>
+          </ac:spMkLst>
+        </pc:spChg>
+        <pc:spChg chg="del mod">
+          <ac:chgData name="Corbin Ferguson" userId="34a864e2-e65e-4cb2-823c-dc28f73f0e40" providerId="ADAL" clId="{8D2D96CF-1319-4CCC-9EA9-073445628049}" dt="2026-03-16T16:13:34.801" v="1460" actId="478"/>
+          <ac:spMkLst>
+            <pc:docMk/>
+            <pc:sldMk cId="2077614573" sldId="2146848316"/>
+            <ac:spMk id="13" creationId="{D7D4E759-8FDE-86E6-E731-24ECD92780CE}"/>
+          </ac:spMkLst>
+        </pc:spChg>
+        <pc:spChg chg="del">
+          <ac:chgData name="Corbin Ferguson" userId="34a864e2-e65e-4cb2-823c-dc28f73f0e40" providerId="ADAL" clId="{8D2D96CF-1319-4CCC-9EA9-073445628049}" dt="2026-03-16T16:13:29.237" v="1456" actId="478"/>
+          <ac:spMkLst>
+            <pc:docMk/>
+            <pc:sldMk cId="2077614573" sldId="2146848316"/>
+            <ac:spMk id="24" creationId="{686D1B61-5B63-C724-2CB5-FD3BFC6AFDD4}"/>
+          </ac:spMkLst>
+        </pc:spChg>
+        <pc:spChg chg="del">
+          <ac:chgData name="Corbin Ferguson" userId="34a864e2-e65e-4cb2-823c-dc28f73f0e40" providerId="ADAL" clId="{8D2D96CF-1319-4CCC-9EA9-073445628049}" dt="2026-03-16T16:13:29.237" v="1456" actId="478"/>
+          <ac:spMkLst>
+            <pc:docMk/>
+            <pc:sldMk cId="2077614573" sldId="2146848316"/>
+            <ac:spMk id="36" creationId="{744595BF-62E0-2BA1-92DD-CD78756D96D0}"/>
+          </ac:spMkLst>
+        </pc:spChg>
+        <pc:spChg chg="del">
+          <ac:chgData name="Corbin Ferguson" userId="34a864e2-e65e-4cb2-823c-dc28f73f0e40" providerId="ADAL" clId="{8D2D96CF-1319-4CCC-9EA9-073445628049}" dt="2026-03-16T16:13:29.237" v="1456" actId="478"/>
+          <ac:spMkLst>
+            <pc:docMk/>
+            <pc:sldMk cId="2077614573" sldId="2146848316"/>
+            <ac:spMk id="42" creationId="{BC769C5F-21DA-B5F2-C497-39B7F975B55B}"/>
+          </ac:spMkLst>
+        </pc:spChg>
+        <pc:spChg chg="mod topLvl">
+          <ac:chgData name="Corbin Ferguson" userId="34a864e2-e65e-4cb2-823c-dc28f73f0e40" providerId="ADAL" clId="{8D2D96CF-1319-4CCC-9EA9-073445628049}" dt="2026-03-16T16:02:03.946" v="1375" actId="165"/>
+          <ac:spMkLst>
+            <pc:docMk/>
+            <pc:sldMk cId="2077614573" sldId="2146848316"/>
+            <ac:spMk id="55" creationId="{28DFFED1-D271-35C0-A749-731C7D90E772}"/>
+          </ac:spMkLst>
+        </pc:spChg>
+        <pc:spChg chg="del">
+          <ac:chgData name="Corbin Ferguson" userId="34a864e2-e65e-4cb2-823c-dc28f73f0e40" providerId="ADAL" clId="{8D2D96CF-1319-4CCC-9EA9-073445628049}" dt="2026-03-16T16:13:29.237" v="1456" actId="478"/>
+          <ac:spMkLst>
+            <pc:docMk/>
+            <pc:sldMk cId="2077614573" sldId="2146848316"/>
+            <ac:spMk id="56" creationId="{6C489836-C900-A02E-8277-D16D696CD472}"/>
+          </ac:spMkLst>
+        </pc:spChg>
+        <pc:spChg chg="del">
+          <ac:chgData name="Corbin Ferguson" userId="34a864e2-e65e-4cb2-823c-dc28f73f0e40" providerId="ADAL" clId="{8D2D96CF-1319-4CCC-9EA9-073445628049}" dt="2026-03-16T16:13:29.237" v="1456" actId="478"/>
+          <ac:spMkLst>
+            <pc:docMk/>
+            <pc:sldMk cId="2077614573" sldId="2146848316"/>
+            <ac:spMk id="61" creationId="{85AC204E-F4BC-E994-8003-6157E29B17C4}"/>
+          </ac:spMkLst>
+        </pc:spChg>
+        <pc:spChg chg="mod topLvl">
+          <ac:chgData name="Corbin Ferguson" userId="34a864e2-e65e-4cb2-823c-dc28f73f0e40" providerId="ADAL" clId="{8D2D96CF-1319-4CCC-9EA9-073445628049}" dt="2026-03-16T16:13:04.178" v="1437" actId="165"/>
+          <ac:spMkLst>
+            <pc:docMk/>
+            <pc:sldMk cId="2077614573" sldId="2146848316"/>
+            <ac:spMk id="8248" creationId="{5B198541-A049-C8CA-F02C-E5415B398853}"/>
+          </ac:spMkLst>
+        </pc:spChg>
+        <pc:spChg chg="mod topLvl">
+          <ac:chgData name="Corbin Ferguson" userId="34a864e2-e65e-4cb2-823c-dc28f73f0e40" providerId="ADAL" clId="{8D2D96CF-1319-4CCC-9EA9-073445628049}" dt="2026-03-16T16:13:04.178" v="1437" actId="165"/>
+          <ac:spMkLst>
+            <pc:docMk/>
+            <pc:sldMk cId="2077614573" sldId="2146848316"/>
+            <ac:spMk id="8291" creationId="{4434AD16-C590-BE76-6B5E-13209D698BC4}"/>
+          </ac:spMkLst>
+        </pc:spChg>
+        <pc:spChg chg="mod">
+          <ac:chgData name="Corbin Ferguson" userId="34a864e2-e65e-4cb2-823c-dc28f73f0e40" providerId="ADAL" clId="{8D2D96CF-1319-4CCC-9EA9-073445628049}" dt="2026-03-16T16:01:40.264" v="1371" actId="165"/>
+          <ac:spMkLst>
+            <pc:docMk/>
+            <pc:sldMk cId="2077614573" sldId="2146848316"/>
+            <ac:spMk id="8544" creationId="{E5D84286-4EE9-53B8-4951-8D0A3816D9B8}"/>
+          </ac:spMkLst>
+        </pc:spChg>
+        <pc:spChg chg="add del mod ord modVis">
+          <ac:chgData name="Corbin Ferguson" userId="34a864e2-e65e-4cb2-823c-dc28f73f0e40" providerId="ADAL" clId="{8D2D96CF-1319-4CCC-9EA9-073445628049}" dt="2026-03-16T16:13:02.702" v="1436" actId="207"/>
+          <ac:spMkLst>
+            <pc:docMk/>
+            <pc:sldMk cId="2077614573" sldId="2146848316"/>
+            <ac:spMk id="8567" creationId="{73615F16-59EB-B70F-8238-D5B33CF342BB}"/>
+          </ac:spMkLst>
+        </pc:spChg>
+        <pc:spChg chg="mod topLvl">
+          <ac:chgData name="Corbin Ferguson" userId="34a864e2-e65e-4cb2-823c-dc28f73f0e40" providerId="ADAL" clId="{8D2D96CF-1319-4CCC-9EA9-073445628049}" dt="2026-03-16T16:13:04.178" v="1437" actId="165"/>
+          <ac:spMkLst>
+            <pc:docMk/>
+            <pc:sldMk cId="2077614573" sldId="2146848316"/>
+            <ac:spMk id="8568" creationId="{743FE570-5A53-F9B3-A590-6FA06FF2E4D7}"/>
+          </ac:spMkLst>
+        </pc:spChg>
+        <pc:spChg chg="mod">
+          <ac:chgData name="Corbin Ferguson" userId="34a864e2-e65e-4cb2-823c-dc28f73f0e40" providerId="ADAL" clId="{8D2D96CF-1319-4CCC-9EA9-073445628049}" dt="2026-03-16T16:01:40.264" v="1371" actId="165"/>
+          <ac:spMkLst>
+            <pc:docMk/>
+            <pc:sldMk cId="2077614573" sldId="2146848316"/>
+            <ac:spMk id="8632" creationId="{4EA6240F-3582-C7A6-A438-BDE40D59BCDE}"/>
+          </ac:spMkLst>
+        </pc:spChg>
+        <pc:spChg chg="mod">
+          <ac:chgData name="Corbin Ferguson" userId="34a864e2-e65e-4cb2-823c-dc28f73f0e40" providerId="ADAL" clId="{8D2D96CF-1319-4CCC-9EA9-073445628049}" dt="2026-03-16T16:01:40.264" v="1371" actId="165"/>
+          <ac:spMkLst>
+            <pc:docMk/>
+            <pc:sldMk cId="2077614573" sldId="2146848316"/>
+            <ac:spMk id="8643" creationId="{2C0C8624-EC81-B2A3-06C4-53B52A47364E}"/>
+          </ac:spMkLst>
+        </pc:spChg>
+        <pc:spChg chg="mod">
+          <ac:chgData name="Corbin Ferguson" userId="34a864e2-e65e-4cb2-823c-dc28f73f0e40" providerId="ADAL" clId="{8D2D96CF-1319-4CCC-9EA9-073445628049}" dt="2026-03-16T16:02:03.946" v="1375" actId="165"/>
+          <ac:spMkLst>
+            <pc:docMk/>
+            <pc:sldMk cId="2077614573" sldId="2146848316"/>
+            <ac:spMk id="8961" creationId="{1DEDA1F4-5534-3ABA-796A-43CBE331391B}"/>
+          </ac:spMkLst>
+        </pc:spChg>
+        <pc:spChg chg="mod topLvl">
+          <ac:chgData name="Corbin Ferguson" userId="34a864e2-e65e-4cb2-823c-dc28f73f0e40" providerId="ADAL" clId="{8D2D96CF-1319-4CCC-9EA9-073445628049}" dt="2026-03-16T16:13:07.664" v="1441" actId="165"/>
+          <ac:spMkLst>
+            <pc:docMk/>
+            <pc:sldMk cId="2077614573" sldId="2146848316"/>
+            <ac:spMk id="9026" creationId="{6C204C66-8F61-60B6-6DAE-F9365A8C27F3}"/>
+          </ac:spMkLst>
+        </pc:spChg>
+        <pc:spChg chg="mod topLvl">
+          <ac:chgData name="Corbin Ferguson" userId="34a864e2-e65e-4cb2-823c-dc28f73f0e40" providerId="ADAL" clId="{8D2D96CF-1319-4CCC-9EA9-073445628049}" dt="2026-03-16T16:13:07.664" v="1441" actId="165"/>
+          <ac:spMkLst>
+            <pc:docMk/>
+            <pc:sldMk cId="2077614573" sldId="2146848316"/>
+            <ac:spMk id="9093" creationId="{685AD8E8-7F61-1BE9-F294-D9D90AA4BCB3}"/>
+          </ac:spMkLst>
+        </pc:spChg>
+        <pc:spChg chg="mod topLvl">
+          <ac:chgData name="Corbin Ferguson" userId="34a864e2-e65e-4cb2-823c-dc28f73f0e40" providerId="ADAL" clId="{8D2D96CF-1319-4CCC-9EA9-073445628049}" dt="2026-03-16T16:13:07.664" v="1441" actId="165"/>
+          <ac:spMkLst>
+            <pc:docMk/>
+            <pc:sldMk cId="2077614573" sldId="2146848316"/>
+            <ac:spMk id="9118" creationId="{8CC27F9C-D0D8-C07D-3B62-C7B575A1DD65}"/>
+          </ac:spMkLst>
+        </pc:spChg>
+        <pc:spChg chg="mod">
+          <ac:chgData name="Corbin Ferguson" userId="34a864e2-e65e-4cb2-823c-dc28f73f0e40" providerId="ADAL" clId="{8D2D96CF-1319-4CCC-9EA9-073445628049}" dt="2026-03-16T16:02:03.946" v="1375" actId="165"/>
+          <ac:spMkLst>
+            <pc:docMk/>
+            <pc:sldMk cId="2077614573" sldId="2146848316"/>
+            <ac:spMk id="9188" creationId="{41F6D49B-BF20-C635-F3DC-E8E78B672334}"/>
+          </ac:spMkLst>
+        </pc:spChg>
+        <pc:spChg chg="mod">
+          <ac:chgData name="Corbin Ferguson" userId="34a864e2-e65e-4cb2-823c-dc28f73f0e40" providerId="ADAL" clId="{8D2D96CF-1319-4CCC-9EA9-073445628049}" dt="2026-03-16T16:01:40.264" v="1371" actId="165"/>
+          <ac:spMkLst>
+            <pc:docMk/>
+            <pc:sldMk cId="2077614573" sldId="2146848316"/>
+            <ac:spMk id="9259" creationId="{40AA7F6B-5945-AA9A-4084-91670E0E3BA6}"/>
+          </ac:spMkLst>
+        </pc:spChg>
+        <pc:spChg chg="mod topLvl">
+          <ac:chgData name="Corbin Ferguson" userId="34a864e2-e65e-4cb2-823c-dc28f73f0e40" providerId="ADAL" clId="{8D2D96CF-1319-4CCC-9EA9-073445628049}" dt="2026-03-16T16:13:07.664" v="1441" actId="165"/>
+          <ac:spMkLst>
+            <pc:docMk/>
+            <pc:sldMk cId="2077614573" sldId="2146848316"/>
+            <ac:spMk id="9401" creationId="{0D334F6E-4CA3-A5D7-A441-4C7445A6288C}"/>
+          </ac:spMkLst>
+        </pc:spChg>
+        <pc:spChg chg="mod topLvl">
+          <ac:chgData name="Corbin Ferguson" userId="34a864e2-e65e-4cb2-823c-dc28f73f0e40" providerId="ADAL" clId="{8D2D96CF-1319-4CCC-9EA9-073445628049}" dt="2026-03-16T16:13:07.664" v="1441" actId="165"/>
+          <ac:spMkLst>
+            <pc:docMk/>
+            <pc:sldMk cId="2077614573" sldId="2146848316"/>
+            <ac:spMk id="9404" creationId="{A5F2C69B-31F9-1FF4-A5E1-9AF7743B7361}"/>
+          </ac:spMkLst>
+        </pc:spChg>
+        <pc:spChg chg="mod">
+          <ac:chgData name="Corbin Ferguson" userId="34a864e2-e65e-4cb2-823c-dc28f73f0e40" providerId="ADAL" clId="{8D2D96CF-1319-4CCC-9EA9-073445628049}" dt="2026-03-16T16:02:03.946" v="1375" actId="165"/>
+          <ac:spMkLst>
+            <pc:docMk/>
+            <pc:sldMk cId="2077614573" sldId="2146848316"/>
+            <ac:spMk id="9444" creationId="{4F6E9EA8-2F4F-5D2A-2F5B-1BCA7597DA8F}"/>
+          </ac:spMkLst>
+        </pc:spChg>
+        <pc:spChg chg="mod">
+          <ac:chgData name="Corbin Ferguson" userId="34a864e2-e65e-4cb2-823c-dc28f73f0e40" providerId="ADAL" clId="{8D2D96CF-1319-4CCC-9EA9-073445628049}" dt="2026-03-16T16:01:40.264" v="1371" actId="165"/>
+          <ac:spMkLst>
+            <pc:docMk/>
+            <pc:sldMk cId="2077614573" sldId="2146848316"/>
+            <ac:spMk id="9845" creationId="{45A65B3C-704D-81A8-9CB8-1B808C9DB46F}"/>
+          </ac:spMkLst>
+        </pc:spChg>
+        <pc:spChg chg="del">
+          <ac:chgData name="Corbin Ferguson" userId="34a864e2-e65e-4cb2-823c-dc28f73f0e40" providerId="ADAL" clId="{8D2D96CF-1319-4CCC-9EA9-073445628049}" dt="2026-03-16T16:13:29.237" v="1456" actId="478"/>
+          <ac:spMkLst>
+            <pc:docMk/>
+            <pc:sldMk cId="2077614573" sldId="2146848316"/>
+            <ac:spMk id="9990" creationId="{1A14FB88-5FB8-61A3-5A87-F8C40EF53100}"/>
+          </ac:spMkLst>
+        </pc:spChg>
+        <pc:spChg chg="del">
+          <ac:chgData name="Corbin Ferguson" userId="34a864e2-e65e-4cb2-823c-dc28f73f0e40" providerId="ADAL" clId="{8D2D96CF-1319-4CCC-9EA9-073445628049}" dt="2026-03-16T16:13:38.282" v="1461" actId="478"/>
+          <ac:spMkLst>
+            <pc:docMk/>
+            <pc:sldMk cId="2077614573" sldId="2146848316"/>
+            <ac:spMk id="9997" creationId="{6078BC0C-7BF6-79C6-9752-3CCDACE1113B}"/>
+          </ac:spMkLst>
+        </pc:spChg>
+        <pc:spChg chg="del">
+          <ac:chgData name="Corbin Ferguson" userId="34a864e2-e65e-4cb2-823c-dc28f73f0e40" providerId="ADAL" clId="{8D2D96CF-1319-4CCC-9EA9-073445628049}" dt="2026-03-16T16:13:38.282" v="1461" actId="478"/>
+          <ac:spMkLst>
+            <pc:docMk/>
+            <pc:sldMk cId="2077614573" sldId="2146848316"/>
+            <ac:spMk id="9998" creationId="{88600233-ABCB-3174-F69A-401D513C7624}"/>
+          </ac:spMkLst>
+        </pc:spChg>
+        <pc:spChg chg="del">
+          <ac:chgData name="Corbin Ferguson" userId="34a864e2-e65e-4cb2-823c-dc28f73f0e40" providerId="ADAL" clId="{8D2D96CF-1319-4CCC-9EA9-073445628049}" dt="2026-03-16T16:13:38.282" v="1461" actId="478"/>
+          <ac:spMkLst>
+            <pc:docMk/>
+            <pc:sldMk cId="2077614573" sldId="2146848316"/>
+            <ac:spMk id="9999" creationId="{7D5B8841-DB8C-5C65-782F-42DB1A2994E5}"/>
+          </ac:spMkLst>
+        </pc:spChg>
+        <pc:spChg chg="del">
+          <ac:chgData name="Corbin Ferguson" userId="34a864e2-e65e-4cb2-823c-dc28f73f0e40" providerId="ADAL" clId="{8D2D96CF-1319-4CCC-9EA9-073445628049}" dt="2026-03-16T16:13:38.282" v="1461" actId="478"/>
+          <ac:spMkLst>
+            <pc:docMk/>
+            <pc:sldMk cId="2077614573" sldId="2146848316"/>
+            <ac:spMk id="10000" creationId="{18773B56-FBA6-3A3A-1D0D-353C9A1CAB64}"/>
+          </ac:spMkLst>
+        </pc:spChg>
+        <pc:spChg chg="mod">
+          <ac:chgData name="Corbin Ferguson" userId="34a864e2-e65e-4cb2-823c-dc28f73f0e40" providerId="ADAL" clId="{8D2D96CF-1319-4CCC-9EA9-073445628049}" dt="2026-03-16T16:01:40.264" v="1371" actId="165"/>
+          <ac:spMkLst>
+            <pc:docMk/>
+            <pc:sldMk cId="2077614573" sldId="2146848316"/>
+            <ac:spMk id="10003" creationId="{8624F5E2-E70C-6B88-1C23-FE10AFC7DD90}"/>
+          </ac:spMkLst>
+        </pc:spChg>
+        <pc:spChg chg="del">
+          <ac:chgData name="Corbin Ferguson" userId="34a864e2-e65e-4cb2-823c-dc28f73f0e40" providerId="ADAL" clId="{8D2D96CF-1319-4CCC-9EA9-073445628049}" dt="2026-03-16T16:13:29.237" v="1456" actId="478"/>
+          <ac:spMkLst>
+            <pc:docMk/>
+            <pc:sldMk cId="2077614573" sldId="2146848316"/>
+            <ac:spMk id="10008" creationId="{B1F0841A-FA07-A4E0-A080-3A495483D6B6}"/>
+          </ac:spMkLst>
+        </pc:spChg>
+        <pc:spChg chg="del">
+          <ac:chgData name="Corbin Ferguson" userId="34a864e2-e65e-4cb2-823c-dc28f73f0e40" providerId="ADAL" clId="{8D2D96CF-1319-4CCC-9EA9-073445628049}" dt="2026-03-16T16:13:29.237" v="1456" actId="478"/>
+          <ac:spMkLst>
+            <pc:docMk/>
+            <pc:sldMk cId="2077614573" sldId="2146848316"/>
+            <ac:spMk id="10019" creationId="{0F32F3BF-4493-282F-6406-56917E91F62A}"/>
+          </ac:spMkLst>
+        </pc:spChg>
+        <pc:spChg chg="del">
+          <ac:chgData name="Corbin Ferguson" userId="34a864e2-e65e-4cb2-823c-dc28f73f0e40" providerId="ADAL" clId="{8D2D96CF-1319-4CCC-9EA9-073445628049}" dt="2026-03-16T16:13:29.237" v="1456" actId="478"/>
+          <ac:spMkLst>
+            <pc:docMk/>
+            <pc:sldMk cId="2077614573" sldId="2146848316"/>
+            <ac:spMk id="10020" creationId="{0B140EB4-2DD4-A169-C104-950692A145B1}"/>
+          </ac:spMkLst>
+        </pc:spChg>
+        <pc:spChg chg="del">
+          <ac:chgData name="Corbin Ferguson" userId="34a864e2-e65e-4cb2-823c-dc28f73f0e40" providerId="ADAL" clId="{8D2D96CF-1319-4CCC-9EA9-073445628049}" dt="2026-03-16T16:13:29.237" v="1456" actId="478"/>
+          <ac:spMkLst>
+            <pc:docMk/>
+            <pc:sldMk cId="2077614573" sldId="2146848316"/>
+            <ac:spMk id="10025" creationId="{FE71403A-2281-5DDC-DFAB-21BA5FD84C6C}"/>
+          </ac:spMkLst>
+        </pc:spChg>
+        <pc:spChg chg="del">
+          <ac:chgData name="Corbin Ferguson" userId="34a864e2-e65e-4cb2-823c-dc28f73f0e40" providerId="ADAL" clId="{8D2D96CF-1319-4CCC-9EA9-073445628049}" dt="2026-03-16T16:13:40.693" v="1462" actId="478"/>
+          <ac:spMkLst>
+            <pc:docMk/>
+            <pc:sldMk cId="2077614573" sldId="2146848316"/>
+            <ac:spMk id="10029" creationId="{6256A978-DF3A-CA52-E8E9-04CAB46297B6}"/>
+          </ac:spMkLst>
+        </pc:spChg>
+        <pc:spChg chg="del">
+          <ac:chgData name="Corbin Ferguson" userId="34a864e2-e65e-4cb2-823c-dc28f73f0e40" providerId="ADAL" clId="{8D2D96CF-1319-4CCC-9EA9-073445628049}" dt="2026-03-16T16:13:40.693" v="1462" actId="478"/>
+          <ac:spMkLst>
+            <pc:docMk/>
+            <pc:sldMk cId="2077614573" sldId="2146848316"/>
+            <ac:spMk id="10030" creationId="{A2F065D7-7A97-DCAF-9AEB-2EA5464EC424}"/>
+          </ac:spMkLst>
+        </pc:spChg>
+        <pc:spChg chg="del">
+          <ac:chgData name="Corbin Ferguson" userId="34a864e2-e65e-4cb2-823c-dc28f73f0e40" providerId="ADAL" clId="{8D2D96CF-1319-4CCC-9EA9-073445628049}" dt="2026-03-16T16:13:40.693" v="1462" actId="478"/>
+          <ac:spMkLst>
+            <pc:docMk/>
+            <pc:sldMk cId="2077614573" sldId="2146848316"/>
+            <ac:spMk id="10031" creationId="{7386F5C3-5ED2-1E35-3F2A-7F615097E0FD}"/>
+          </ac:spMkLst>
+        </pc:spChg>
+        <pc:spChg chg="del">
+          <ac:chgData name="Corbin Ferguson" userId="34a864e2-e65e-4cb2-823c-dc28f73f0e40" providerId="ADAL" clId="{8D2D96CF-1319-4CCC-9EA9-073445628049}" dt="2026-03-16T16:13:38.282" v="1461" actId="478"/>
+          <ac:spMkLst>
+            <pc:docMk/>
+            <pc:sldMk cId="2077614573" sldId="2146848316"/>
+            <ac:spMk id="10039" creationId="{A767D995-2245-EFF0-B2A3-EED0E0B5ABE0}"/>
+          </ac:spMkLst>
+        </pc:spChg>
+        <pc:spChg chg="del">
+          <ac:chgData name="Corbin Ferguson" userId="34a864e2-e65e-4cb2-823c-dc28f73f0e40" providerId="ADAL" clId="{8D2D96CF-1319-4CCC-9EA9-073445628049}" dt="2026-03-16T16:13:38.282" v="1461" actId="478"/>
+          <ac:spMkLst>
+            <pc:docMk/>
+            <pc:sldMk cId="2077614573" sldId="2146848316"/>
+            <ac:spMk id="10040" creationId="{F5F31AD6-77DE-1B28-21CF-F269EC311F1F}"/>
+          </ac:spMkLst>
+        </pc:spChg>
+        <pc:spChg chg="mod">
+          <ac:chgData name="Corbin Ferguson" userId="34a864e2-e65e-4cb2-823c-dc28f73f0e40" providerId="ADAL" clId="{8D2D96CF-1319-4CCC-9EA9-073445628049}" dt="2026-03-16T16:02:03.946" v="1375" actId="165"/>
+          <ac:spMkLst>
+            <pc:docMk/>
+            <pc:sldMk cId="2077614573" sldId="2146848316"/>
+            <ac:spMk id="10163" creationId="{9DA64397-879A-CC61-3C2F-AC5F268A765A}"/>
+          </ac:spMkLst>
+        </pc:spChg>
+        <pc:spChg chg="mod">
+          <ac:chgData name="Corbin Ferguson" userId="34a864e2-e65e-4cb2-823c-dc28f73f0e40" providerId="ADAL" clId="{8D2D96CF-1319-4CCC-9EA9-073445628049}" dt="2026-03-16T16:01:40.264" v="1371" actId="165"/>
+          <ac:spMkLst>
+            <pc:docMk/>
+            <pc:sldMk cId="2077614573" sldId="2146848316"/>
+            <ac:spMk id="10261" creationId="{DFFE02BB-2D22-323B-9346-35A5106901E7}"/>
+          </ac:spMkLst>
+        </pc:spChg>
+        <pc:spChg chg="mod">
+          <ac:chgData name="Corbin Ferguson" userId="34a864e2-e65e-4cb2-823c-dc28f73f0e40" providerId="ADAL" clId="{8D2D96CF-1319-4CCC-9EA9-073445628049}" dt="2026-03-16T16:02:03.946" v="1375" actId="165"/>
+          <ac:spMkLst>
+            <pc:docMk/>
+            <pc:sldMk cId="2077614573" sldId="2146848316"/>
+            <ac:spMk id="10271" creationId="{3DFE3B36-1D23-B941-B786-CF08850E2BBC}"/>
+          </ac:spMkLst>
+        </pc:spChg>
+        <pc:spChg chg="mod topLvl">
+          <ac:chgData name="Corbin Ferguson" userId="34a864e2-e65e-4cb2-823c-dc28f73f0e40" providerId="ADAL" clId="{8D2D96CF-1319-4CCC-9EA9-073445628049}" dt="2026-03-16T16:13:07.664" v="1441" actId="165"/>
+          <ac:spMkLst>
+            <pc:docMk/>
+            <pc:sldMk cId="2077614573" sldId="2146848316"/>
+            <ac:spMk id="10419" creationId="{4B6A0A59-0841-ACBC-9ACF-8DDC7F585AD8}"/>
+          </ac:spMkLst>
+        </pc:spChg>
+        <pc:spChg chg="mod topLvl">
+          <ac:chgData name="Corbin Ferguson" userId="34a864e2-e65e-4cb2-823c-dc28f73f0e40" providerId="ADAL" clId="{8D2D96CF-1319-4CCC-9EA9-073445628049}" dt="2026-03-16T16:13:07.664" v="1441" actId="165"/>
+          <ac:spMkLst>
+            <pc:docMk/>
+            <pc:sldMk cId="2077614573" sldId="2146848316"/>
+            <ac:spMk id="10434" creationId="{71299B70-E2A2-36F6-BF08-C9A0A5683ADE}"/>
+          </ac:spMkLst>
+        </pc:spChg>
+        <pc:spChg chg="mod topLvl">
+          <ac:chgData name="Corbin Ferguson" userId="34a864e2-e65e-4cb2-823c-dc28f73f0e40" providerId="ADAL" clId="{8D2D96CF-1319-4CCC-9EA9-073445628049}" dt="2026-03-16T16:13:07.664" v="1441" actId="165"/>
+          <ac:spMkLst>
+            <pc:docMk/>
+            <pc:sldMk cId="2077614573" sldId="2146848316"/>
+            <ac:spMk id="10438" creationId="{18D18D81-FEBF-37F5-6C20-B6F09FFFD838}"/>
+          </ac:spMkLst>
+        </pc:spChg>
+        <pc:spChg chg="mod modVis">
+          <ac:chgData name="Corbin Ferguson" userId="34a864e2-e65e-4cb2-823c-dc28f73f0e40" providerId="ADAL" clId="{8D2D96CF-1319-4CCC-9EA9-073445628049}" dt="2026-03-16T16:13:14.640" v="1452" actId="14429"/>
+          <ac:spMkLst>
+            <pc:docMk/>
+            <pc:sldMk cId="2077614573" sldId="2146848316"/>
+            <ac:spMk id="10454" creationId="{AAA717C8-C7BD-FAAA-2E81-4D76EA54C548}"/>
+          </ac:spMkLst>
+        </pc:spChg>
+        <pc:spChg chg="mod modVis">
+          <ac:chgData name="Corbin Ferguson" userId="34a864e2-e65e-4cb2-823c-dc28f73f0e40" providerId="ADAL" clId="{8D2D96CF-1319-4CCC-9EA9-073445628049}" dt="2026-03-16T16:13:14.263" v="1451" actId="14430"/>
+          <ac:spMkLst>
+            <pc:docMk/>
+            <pc:sldMk cId="2077614573" sldId="2146848316"/>
+            <ac:spMk id="10456" creationId="{10928AD7-DDD4-A9F4-ED11-2D3FCBAB2AF7}"/>
+          </ac:spMkLst>
+        </pc:spChg>
+        <pc:spChg chg="mod modVis">
+          <ac:chgData name="Corbin Ferguson" userId="34a864e2-e65e-4cb2-823c-dc28f73f0e40" providerId="ADAL" clId="{8D2D96CF-1319-4CCC-9EA9-073445628049}" dt="2026-03-16T16:13:13.462" v="1449" actId="14430"/>
+          <ac:spMkLst>
+            <pc:docMk/>
+            <pc:sldMk cId="2077614573" sldId="2146848316"/>
+            <ac:spMk id="10457" creationId="{E4D783BE-4B50-1EE9-293B-212C35D871F3}"/>
+          </ac:spMkLst>
+        </pc:spChg>
+        <pc:spChg chg="mod modVis">
+          <ac:chgData name="Corbin Ferguson" userId="34a864e2-e65e-4cb2-823c-dc28f73f0e40" providerId="ADAL" clId="{8D2D96CF-1319-4CCC-9EA9-073445628049}" dt="2026-03-16T16:13:12.614" v="1447" actId="14430"/>
+          <ac:spMkLst>
+            <pc:docMk/>
+            <pc:sldMk cId="2077614573" sldId="2146848316"/>
+            <ac:spMk id="10458" creationId="{CB731D3F-3E72-28D4-6275-824262BB1A26}"/>
+          </ac:spMkLst>
+        </pc:spChg>
+        <pc:spChg chg="mod topLvl">
+          <ac:chgData name="Corbin Ferguson" userId="34a864e2-e65e-4cb2-823c-dc28f73f0e40" providerId="ADAL" clId="{8D2D96CF-1319-4CCC-9EA9-073445628049}" dt="2026-03-16T16:13:07.664" v="1441" actId="165"/>
+          <ac:spMkLst>
+            <pc:docMk/>
+            <pc:sldMk cId="2077614573" sldId="2146848316"/>
+            <ac:spMk id="10469" creationId="{3DF84D1F-2D12-0BC2-D0E1-AE32F687E41E}"/>
+          </ac:spMkLst>
+        </pc:spChg>
+        <pc:spChg chg="mod modVis">
+          <ac:chgData name="Corbin Ferguson" userId="34a864e2-e65e-4cb2-823c-dc28f73f0e40" providerId="ADAL" clId="{8D2D96CF-1319-4CCC-9EA9-073445628049}" dt="2026-03-16T16:03:33.804" v="1406" actId="14429"/>
+          <ac:spMkLst>
+            <pc:docMk/>
+            <pc:sldMk cId="2077614573" sldId="2146848316"/>
+            <ac:spMk id="10476" creationId="{1BB2F026-A377-8A25-813A-5F255959DD51}"/>
+          </ac:spMkLst>
+        </pc:spChg>
+        <pc:spChg chg="mod modVis">
+          <ac:chgData name="Corbin Ferguson" userId="34a864e2-e65e-4cb2-823c-dc28f73f0e40" providerId="ADAL" clId="{8D2D96CF-1319-4CCC-9EA9-073445628049}" dt="2026-03-16T16:03:31.319" v="1402" actId="14429"/>
+          <ac:spMkLst>
+            <pc:docMk/>
+            <pc:sldMk cId="2077614573" sldId="2146848316"/>
+            <ac:spMk id="10477" creationId="{6EDA60F5-0155-1969-4303-C8E1ECB68C04}"/>
+          </ac:spMkLst>
+        </pc:spChg>
+        <pc:spChg chg="mod modVis">
+          <ac:chgData name="Corbin Ferguson" userId="34a864e2-e65e-4cb2-823c-dc28f73f0e40" providerId="ADAL" clId="{8D2D96CF-1319-4CCC-9EA9-073445628049}" dt="2026-03-16T16:03:32.507" v="1404" actId="14429"/>
+          <ac:spMkLst>
+            <pc:docMk/>
+            <pc:sldMk cId="2077614573" sldId="2146848316"/>
+            <ac:spMk id="10478" creationId="{EF29C8E0-E33D-F434-F784-79635682E34D}"/>
+          </ac:spMkLst>
+        </pc:spChg>
+        <pc:spChg chg="mod topLvl">
+          <ac:chgData name="Corbin Ferguson" userId="34a864e2-e65e-4cb2-823c-dc28f73f0e40" providerId="ADAL" clId="{8D2D96CF-1319-4CCC-9EA9-073445628049}" dt="2026-03-16T16:13:07.664" v="1441" actId="165"/>
+          <ac:spMkLst>
+            <pc:docMk/>
+            <pc:sldMk cId="2077614573" sldId="2146848316"/>
+            <ac:spMk id="10479" creationId="{D902B22C-C8C4-FC29-FD78-C8791BD9E2CC}"/>
+          </ac:spMkLst>
+        </pc:spChg>
+        <pc:spChg chg="mod">
+          <ac:chgData name="Corbin Ferguson" userId="34a864e2-e65e-4cb2-823c-dc28f73f0e40" providerId="ADAL" clId="{8D2D96CF-1319-4CCC-9EA9-073445628049}" dt="2026-03-16T16:01:40.264" v="1371" actId="165"/>
+          <ac:spMkLst>
+            <pc:docMk/>
+            <pc:sldMk cId="2077614573" sldId="2146848316"/>
+            <ac:spMk id="10510" creationId="{2ADD0366-DE82-45B0-F168-8CD88ADFB3B6}"/>
+          </ac:spMkLst>
+        </pc:spChg>
+        <pc:spChg chg="mod">
+          <ac:chgData name="Corbin Ferguson" userId="34a864e2-e65e-4cb2-823c-dc28f73f0e40" providerId="ADAL" clId="{8D2D96CF-1319-4CCC-9EA9-073445628049}" dt="2026-03-16T16:02:03.946" v="1375" actId="165"/>
+          <ac:spMkLst>
+            <pc:docMk/>
+            <pc:sldMk cId="2077614573" sldId="2146848316"/>
+            <ac:spMk id="10530" creationId="{E5A31BEE-6EDA-EE4B-F580-37AC596BEBCC}"/>
+          </ac:spMkLst>
+        </pc:spChg>
+        <pc:spChg chg="mod">
+          <ac:chgData name="Corbin Ferguson" userId="34a864e2-e65e-4cb2-823c-dc28f73f0e40" providerId="ADAL" clId="{8D2D96CF-1319-4CCC-9EA9-073445628049}" dt="2026-03-16T16:01:40.264" v="1371" actId="165"/>
+          <ac:spMkLst>
+            <pc:docMk/>
+            <pc:sldMk cId="2077614573" sldId="2146848316"/>
+            <ac:spMk id="10586" creationId="{C440AF32-A01E-BC5A-EB6F-9F358FDE1989}"/>
+          </ac:spMkLst>
+        </pc:spChg>
+        <pc:spChg chg="mod">
+          <ac:chgData name="Corbin Ferguson" userId="34a864e2-e65e-4cb2-823c-dc28f73f0e40" providerId="ADAL" clId="{8D2D96CF-1319-4CCC-9EA9-073445628049}" dt="2026-03-16T16:02:03.946" v="1375" actId="165"/>
+          <ac:spMkLst>
+            <pc:docMk/>
+            <pc:sldMk cId="2077614573" sldId="2146848316"/>
+            <ac:spMk id="10687" creationId="{9621F235-C373-80D3-9770-B71FE923BFC5}"/>
+          </ac:spMkLst>
+        </pc:spChg>
+        <pc:spChg chg="mod">
+          <ac:chgData name="Corbin Ferguson" userId="34a864e2-e65e-4cb2-823c-dc28f73f0e40" providerId="ADAL" clId="{8D2D96CF-1319-4CCC-9EA9-073445628049}" dt="2026-03-16T16:01:40.264" v="1371" actId="165"/>
+          <ac:spMkLst>
+            <pc:docMk/>
+            <pc:sldMk cId="2077614573" sldId="2146848316"/>
+            <ac:spMk id="10740" creationId="{61B952FE-E7A4-0D04-592D-0C422FE6B368}"/>
+          </ac:spMkLst>
+        </pc:spChg>
+        <pc:spChg chg="mod">
+          <ac:chgData name="Corbin Ferguson" userId="34a864e2-e65e-4cb2-823c-dc28f73f0e40" providerId="ADAL" clId="{8D2D96CF-1319-4CCC-9EA9-073445628049}" dt="2026-03-16T16:02:03.946" v="1375" actId="165"/>
+          <ac:spMkLst>
+            <pc:docMk/>
+            <pc:sldMk cId="2077614573" sldId="2146848316"/>
+            <ac:spMk id="10759" creationId="{43DDD9A3-EB88-656E-9B37-FC8511FCDD1B}"/>
+          </ac:spMkLst>
+        </pc:spChg>
+        <pc:spChg chg="mod topLvl">
+          <ac:chgData name="Corbin Ferguson" userId="34a864e2-e65e-4cb2-823c-dc28f73f0e40" providerId="ADAL" clId="{8D2D96CF-1319-4CCC-9EA9-073445628049}" dt="2026-03-16T16:13:04.178" v="1437" actId="165"/>
+          <ac:spMkLst>
+            <pc:docMk/>
+            <pc:sldMk cId="2077614573" sldId="2146848316"/>
+            <ac:spMk id="10803" creationId="{BDF784A6-CB84-62F6-3B49-D10C2D6392ED}"/>
+          </ac:spMkLst>
+        </pc:spChg>
+        <pc:spChg chg="mod topLvl">
+          <ac:chgData name="Corbin Ferguson" userId="34a864e2-e65e-4cb2-823c-dc28f73f0e40" providerId="ADAL" clId="{8D2D96CF-1319-4CCC-9EA9-073445628049}" dt="2026-03-16T16:13:04.178" v="1437" actId="165"/>
+          <ac:spMkLst>
+            <pc:docMk/>
+            <pc:sldMk cId="2077614573" sldId="2146848316"/>
+            <ac:spMk id="10818" creationId="{BD6D1489-B3D4-696E-8DC3-0C02A6377A0C}"/>
+          </ac:spMkLst>
+        </pc:spChg>
+        <pc:spChg chg="mod topLvl">
+          <ac:chgData name="Corbin Ferguson" userId="34a864e2-e65e-4cb2-823c-dc28f73f0e40" providerId="ADAL" clId="{8D2D96CF-1319-4CCC-9EA9-073445628049}" dt="2026-03-16T16:13:04.178" v="1437" actId="165"/>
+          <ac:spMkLst>
+            <pc:docMk/>
+            <pc:sldMk cId="2077614573" sldId="2146848316"/>
+            <ac:spMk id="10820" creationId="{4E375D8D-9893-0EF9-21C5-A4FD87C2D98A}"/>
+          </ac:spMkLst>
+        </pc:spChg>
+        <pc:spChg chg="mod topLvl">
+          <ac:chgData name="Corbin Ferguson" userId="34a864e2-e65e-4cb2-823c-dc28f73f0e40" providerId="ADAL" clId="{8D2D96CF-1319-4CCC-9EA9-073445628049}" dt="2026-03-16T16:13:04.178" v="1437" actId="165"/>
+          <ac:spMkLst>
+            <pc:docMk/>
+            <pc:sldMk cId="2077614573" sldId="2146848316"/>
+            <ac:spMk id="10847" creationId="{CDB448F4-DDEA-7232-A26A-9F4C6D8EBAFB}"/>
+          </ac:spMkLst>
+        </pc:spChg>
+        <pc:spChg chg="mod">
+          <ac:chgData name="Corbin Ferguson" userId="34a864e2-e65e-4cb2-823c-dc28f73f0e40" providerId="ADAL" clId="{8D2D96CF-1319-4CCC-9EA9-073445628049}" dt="2026-03-16T16:02:03.946" v="1375" actId="165"/>
+          <ac:spMkLst>
+            <pc:docMk/>
+            <pc:sldMk cId="2077614573" sldId="2146848316"/>
+            <ac:spMk id="10849" creationId="{D706CB23-ECA8-F94E-0123-9D2D8AEEB319}"/>
+          </ac:spMkLst>
+        </pc:spChg>
+        <pc:spChg chg="mod topLvl">
+          <ac:chgData name="Corbin Ferguson" userId="34a864e2-e65e-4cb2-823c-dc28f73f0e40" providerId="ADAL" clId="{8D2D96CF-1319-4CCC-9EA9-073445628049}" dt="2026-03-16T16:13:04.178" v="1437" actId="165"/>
+          <ac:spMkLst>
+            <pc:docMk/>
+            <pc:sldMk cId="2077614573" sldId="2146848316"/>
+            <ac:spMk id="10864" creationId="{3D49FB3A-FA28-5254-0381-D659100DD293}"/>
+          </ac:spMkLst>
+        </pc:spChg>
+        <pc:spChg chg="mod topLvl">
+          <ac:chgData name="Corbin Ferguson" userId="34a864e2-e65e-4cb2-823c-dc28f73f0e40" providerId="ADAL" clId="{8D2D96CF-1319-4CCC-9EA9-073445628049}" dt="2026-03-16T16:13:04.178" v="1437" actId="165"/>
+          <ac:spMkLst>
+            <pc:docMk/>
+            <pc:sldMk cId="2077614573" sldId="2146848316"/>
+            <ac:spMk id="10882" creationId="{7E181B4E-AFDE-1988-2754-6F3E2FD335AD}"/>
+          </ac:spMkLst>
+        </pc:spChg>
+        <pc:spChg chg="mod topLvl">
+          <ac:chgData name="Corbin Ferguson" userId="34a864e2-e65e-4cb2-823c-dc28f73f0e40" providerId="ADAL" clId="{8D2D96CF-1319-4CCC-9EA9-073445628049}" dt="2026-03-16T16:13:04.178" v="1437" actId="165"/>
+          <ac:spMkLst>
+            <pc:docMk/>
+            <pc:sldMk cId="2077614573" sldId="2146848316"/>
+            <ac:spMk id="10901" creationId="{260D5BFC-8D99-2DF3-3788-EC0316444132}"/>
+          </ac:spMkLst>
+        </pc:spChg>
+        <pc:grpChg chg="add del mod modVis">
+          <ac:chgData name="Corbin Ferguson" userId="34a864e2-e65e-4cb2-823c-dc28f73f0e40" providerId="ADAL" clId="{8D2D96CF-1319-4CCC-9EA9-073445628049}" dt="2026-03-16T16:13:24.497" v="1455" actId="478"/>
+          <ac:grpSpMkLst>
+            <pc:docMk/>
+            <pc:sldMk cId="2077614573" sldId="2146848316"/>
+            <ac:grpSpMk id="14" creationId="{24BD7666-D6A4-D570-E479-D9C1E24A98D3}"/>
+          </ac:grpSpMkLst>
+        </pc:grpChg>
+        <pc:grpChg chg="mod modVis">
+          <ac:chgData name="Corbin Ferguson" userId="34a864e2-e65e-4cb2-823c-dc28f73f0e40" providerId="ADAL" clId="{8D2D96CF-1319-4CCC-9EA9-073445628049}" dt="2026-03-16T16:03:17.864" v="1394" actId="14429"/>
+          <ac:grpSpMkLst>
+            <pc:docMk/>
+            <pc:sldMk cId="2077614573" sldId="2146848316"/>
+            <ac:grpSpMk id="16" creationId="{1591C2AE-17F1-0EE1-027C-BE8C34BCE3CC}"/>
+          </ac:grpSpMkLst>
+        </pc:grpChg>
+        <pc:grpChg chg="del mod modVis">
+          <ac:chgData name="Corbin Ferguson" userId="34a864e2-e65e-4cb2-823c-dc28f73f0e40" providerId="ADAL" clId="{8D2D96CF-1319-4CCC-9EA9-073445628049}" dt="2026-03-16T16:13:38.282" v="1461" actId="478"/>
+          <ac:grpSpMkLst>
+            <pc:docMk/>
+            <pc:sldMk cId="2077614573" sldId="2146848316"/>
+            <ac:grpSpMk id="17" creationId="{3B72B237-E1BF-EE5F-0E3B-FDA8A14AE1C8}"/>
+          </ac:grpSpMkLst>
+        </pc:grpChg>
+        <pc:grpChg chg="del mod modVis">
+          <ac:chgData name="Corbin Ferguson" userId="34a864e2-e65e-4cb2-823c-dc28f73f0e40" providerId="ADAL" clId="{8D2D96CF-1319-4CCC-9EA9-073445628049}" dt="2026-03-16T16:13:38.282" v="1461" actId="478"/>
+          <ac:grpSpMkLst>
+            <pc:docMk/>
+            <pc:sldMk cId="2077614573" sldId="2146848316"/>
+            <ac:grpSpMk id="18" creationId="{75CD6B92-65FC-FE36-FC57-794EA5976853}"/>
+          </ac:grpSpMkLst>
+        </pc:grpChg>
+        <pc:grpChg chg="mod modVis">
+          <ac:chgData name="Corbin Ferguson" userId="34a864e2-e65e-4cb2-823c-dc28f73f0e40" providerId="ADAL" clId="{8D2D96CF-1319-4CCC-9EA9-073445628049}" dt="2026-03-16T16:03:23.716" v="1400" actId="14429"/>
+          <ac:grpSpMkLst>
+            <pc:docMk/>
+            <pc:sldMk cId="2077614573" sldId="2146848316"/>
+            <ac:grpSpMk id="19" creationId="{501463A7-693C-D89C-0D3F-C9AC66AA15D4}"/>
+          </ac:grpSpMkLst>
+        </pc:grpChg>
+        <pc:grpChg chg="add del">
+          <ac:chgData name="Corbin Ferguson" userId="34a864e2-e65e-4cb2-823c-dc28f73f0e40" providerId="ADAL" clId="{8D2D96CF-1319-4CCC-9EA9-073445628049}" dt="2026-03-16T16:13:01.240" v="1432" actId="478"/>
+          <ac:grpSpMkLst>
+            <pc:docMk/>
+            <pc:sldMk cId="2077614573" sldId="2146848316"/>
+            <ac:grpSpMk id="23" creationId="{77F3592F-D463-8558-91D1-AF26484A5B05}"/>
+          </ac:grpSpMkLst>
+        </pc:grpChg>
+        <pc:picChg chg="add del mod">
+          <ac:chgData name="Corbin Ferguson" userId="34a864e2-e65e-4cb2-823c-dc28f73f0e40" providerId="ADAL" clId="{8D2D96CF-1319-4CCC-9EA9-073445628049}" dt="2026-03-16T15:45:11.303" v="1349" actId="478"/>
+          <ac:picMkLst>
+            <pc:docMk/>
+            <pc:sldMk cId="2077614573" sldId="2146848316"/>
+            <ac:picMk id="5" creationId="{1CAC52FA-C254-5FF7-A91C-88C0A8842080}"/>
+          </ac:picMkLst>
+        </pc:picChg>
+        <pc:picChg chg="add del mod">
+          <ac:chgData name="Corbin Ferguson" userId="34a864e2-e65e-4cb2-823c-dc28f73f0e40" providerId="ADAL" clId="{8D2D96CF-1319-4CCC-9EA9-073445628049}" dt="2026-03-16T15:48:04.705" v="1352" actId="478"/>
+          <ac:picMkLst>
+            <pc:docMk/>
+            <pc:sldMk cId="2077614573" sldId="2146848316"/>
+            <ac:picMk id="9" creationId="{430551EE-87DD-0553-0AFE-29775E2D2392}"/>
+          </ac:picMkLst>
+        </pc:picChg>
+        <pc:picChg chg="add del mod ord">
+          <ac:chgData name="Corbin Ferguson" userId="34a864e2-e65e-4cb2-823c-dc28f73f0e40" providerId="ADAL" clId="{8D2D96CF-1319-4CCC-9EA9-073445628049}" dt="2026-03-16T16:01:51.115" v="1374" actId="338"/>
+          <ac:picMkLst>
+            <pc:docMk/>
+            <pc:sldMk cId="2077614573" sldId="2146848316"/>
+            <ac:picMk id="11" creationId="{D14058B6-AC8F-6982-F515-E572E1436816}"/>
+          </ac:picMkLst>
+        </pc:picChg>
+        <pc:picChg chg="del">
+          <ac:chgData name="Corbin Ferguson" userId="34a864e2-e65e-4cb2-823c-dc28f73f0e40" providerId="ADAL" clId="{8D2D96CF-1319-4CCC-9EA9-073445628049}" dt="2026-03-16T15:42:39.157" v="1345" actId="478"/>
+          <ac:picMkLst>
+            <pc:docMk/>
+            <pc:sldMk cId="2077614573" sldId="2146848316"/>
+            <ac:picMk id="15" creationId="{BACB85A8-B9AD-3E0D-DA82-B68BDCBBD8C9}"/>
+          </ac:picMkLst>
+        </pc:picChg>
+        <pc:picChg chg="add del mod">
+          <ac:chgData name="Corbin Ferguson" userId="34a864e2-e65e-4cb2-823c-dc28f73f0e40" providerId="ADAL" clId="{8D2D96CF-1319-4CCC-9EA9-073445628049}" dt="2026-03-16T16:15:39.561" v="1507" actId="478"/>
+          <ac:picMkLst>
+            <pc:docMk/>
+            <pc:sldMk cId="2077614573" sldId="2146848316"/>
+            <ac:picMk id="8352" creationId="{ED480CF8-327A-1146-55D3-6EEF1CB4996D}"/>
+          </ac:picMkLst>
+        </pc:picChg>
+        <pc:picChg chg="add del mod ord">
+          <ac:chgData name="Corbin Ferguson" userId="34a864e2-e65e-4cb2-823c-dc28f73f0e40" providerId="ADAL" clId="{8D2D96CF-1319-4CCC-9EA9-073445628049}" dt="2026-03-16T16:22:46.609" v="1526" actId="478"/>
+          <ac:picMkLst>
+            <pc:docMk/>
+            <pc:sldMk cId="2077614573" sldId="2146848316"/>
+            <ac:picMk id="8354" creationId="{C8A49E57-BF04-273B-0328-EA90A1EE242B}"/>
+          </ac:picMkLst>
+        </pc:picChg>
+        <pc:picChg chg="add del mod">
+          <ac:chgData name="Corbin Ferguson" userId="34a864e2-e65e-4cb2-823c-dc28f73f0e40" providerId="ADAL" clId="{8D2D96CF-1319-4CCC-9EA9-073445628049}" dt="2026-03-16T16:15:40.381" v="1509" actId="478"/>
+          <ac:picMkLst>
+            <pc:docMk/>
+            <pc:sldMk cId="2077614573" sldId="2146848316"/>
+            <ac:picMk id="8356" creationId="{48AA5230-156E-1B19-834E-65774ADBFB8C}"/>
+          </ac:picMkLst>
+        </pc:picChg>
+        <pc:picChg chg="add del mod ord modCrop">
+          <ac:chgData name="Corbin Ferguson" userId="34a864e2-e65e-4cb2-823c-dc28f73f0e40" providerId="ADAL" clId="{8D2D96CF-1319-4CCC-9EA9-073445628049}" dt="2026-03-16T16:38:59.731" v="1543" actId="478"/>
+          <ac:picMkLst>
+            <pc:docMk/>
+            <pc:sldMk cId="2077614573" sldId="2146848316"/>
+            <ac:picMk id="8358" creationId="{16C12B4B-667C-C698-8AB7-6A7EAEC39E2E}"/>
+          </ac:picMkLst>
+        </pc:picChg>
+        <pc:picChg chg="add del mod ord">
+          <ac:chgData name="Corbin Ferguson" userId="34a864e2-e65e-4cb2-823c-dc28f73f0e40" providerId="ADAL" clId="{8D2D96CF-1319-4CCC-9EA9-073445628049}" dt="2026-03-16T16:45:51.625" v="1557" actId="478"/>
+          <ac:picMkLst>
+            <pc:docMk/>
+            <pc:sldMk cId="2077614573" sldId="2146848316"/>
+            <ac:picMk id="8360" creationId="{AA1DB74E-7D0E-154A-067C-B10A6CA3976F}"/>
+          </ac:picMkLst>
+        </pc:picChg>
+        <pc:picChg chg="add mod ord">
+          <ac:chgData name="Corbin Ferguson" userId="34a864e2-e65e-4cb2-823c-dc28f73f0e40" providerId="ADAL" clId="{8D2D96CF-1319-4CCC-9EA9-073445628049}" dt="2026-03-16T16:45:57.083" v="1559" actId="26606"/>
+          <ac:picMkLst>
+            <pc:docMk/>
+            <pc:sldMk cId="2077614573" sldId="2146848316"/>
+            <ac:picMk id="8362" creationId="{5B32580E-8B7E-FCBF-145C-131D2AA75C68}"/>
+          </ac:picMkLst>
+        </pc:picChg>
+        <pc:picChg chg="mod modVis">
+          <ac:chgData name="Corbin Ferguson" userId="34a864e2-e65e-4cb2-823c-dc28f73f0e40" providerId="ADAL" clId="{8D2D96CF-1319-4CCC-9EA9-073445628049}" dt="2026-03-16T16:02:36.808" v="1385" actId="14429"/>
+          <ac:picMkLst>
+            <pc:docMk/>
+            <pc:sldMk cId="2077614573" sldId="2146848316"/>
+            <ac:picMk id="8369" creationId="{1432331A-ED63-06D9-B692-FAB1A42D7193}"/>
+          </ac:picMkLst>
+        </pc:picChg>
+        <pc:picChg chg="mod modVis">
+          <ac:chgData name="Corbin Ferguson" userId="34a864e2-e65e-4cb2-823c-dc28f73f0e40" providerId="ADAL" clId="{8D2D96CF-1319-4CCC-9EA9-073445628049}" dt="2026-03-16T16:03:39.595" v="1410" actId="14429"/>
+          <ac:picMkLst>
+            <pc:docMk/>
+            <pc:sldMk cId="2077614573" sldId="2146848316"/>
+            <ac:picMk id="9150" creationId="{6A9C2A39-93CA-0897-20FA-17DB258118EA}"/>
+          </ac:picMkLst>
+        </pc:picChg>
+        <pc:picChg chg="mod modVis">
+          <ac:chgData name="Corbin Ferguson" userId="34a864e2-e65e-4cb2-823c-dc28f73f0e40" providerId="ADAL" clId="{8D2D96CF-1319-4CCC-9EA9-073445628049}" dt="2026-03-16T16:03:38.213" v="1408" actId="14429"/>
+          <ac:picMkLst>
+            <pc:docMk/>
+            <pc:sldMk cId="2077614573" sldId="2146848316"/>
+            <ac:picMk id="9151" creationId="{1CE7A485-6D52-9B7E-BB0D-AC43B0B8B90B}"/>
+          </ac:picMkLst>
+        </pc:picChg>
+        <pc:picChg chg="del">
+          <ac:chgData name="Corbin Ferguson" userId="34a864e2-e65e-4cb2-823c-dc28f73f0e40" providerId="ADAL" clId="{8D2D96CF-1319-4CCC-9EA9-073445628049}" dt="2026-03-16T16:13:38.282" v="1461" actId="478"/>
+          <ac:picMkLst>
+            <pc:docMk/>
+            <pc:sldMk cId="2077614573" sldId="2146848316"/>
+            <ac:picMk id="10119" creationId="{DA93CEAA-2052-B167-8E52-151AAB275CE4}"/>
+          </ac:picMkLst>
+        </pc:picChg>
+        <pc:picChg chg="del">
+          <ac:chgData name="Corbin Ferguson" userId="34a864e2-e65e-4cb2-823c-dc28f73f0e40" providerId="ADAL" clId="{8D2D96CF-1319-4CCC-9EA9-073445628049}" dt="2026-03-16T16:13:38.282" v="1461" actId="478"/>
+          <ac:picMkLst>
+            <pc:docMk/>
+            <pc:sldMk cId="2077614573" sldId="2146848316"/>
+            <ac:picMk id="10120" creationId="{8A73F059-DDA2-3BEC-5638-7DA80C4F1400}"/>
+          </ac:picMkLst>
+        </pc:picChg>
+        <pc:picChg chg="add del mod">
+          <ac:chgData name="Corbin Ferguson" userId="34a864e2-e65e-4cb2-823c-dc28f73f0e40" providerId="ADAL" clId="{8D2D96CF-1319-4CCC-9EA9-073445628049}" dt="2026-03-16T16:13:02.319" v="1435" actId="22"/>
+          <ac:picMkLst>
+            <pc:docMk/>
+            <pc:sldMk cId="2077614573" sldId="2146848316"/>
+            <ac:picMk id="10908" creationId="{5BBDBB99-399A-3E78-8D76-C542D48741AD}"/>
+          </ac:picMkLst>
+        </pc:picChg>
+        <pc:picChg chg="add del mod">
+          <ac:chgData name="Corbin Ferguson" userId="34a864e2-e65e-4cb2-823c-dc28f73f0e40" providerId="ADAL" clId="{8D2D96CF-1319-4CCC-9EA9-073445628049}" dt="2026-03-16T16:15:39.901" v="1508" actId="478"/>
+          <ac:picMkLst>
+            <pc:docMk/>
+            <pc:sldMk cId="2077614573" sldId="2146848316"/>
+            <ac:picMk id="10910" creationId="{9D937817-7381-1FE2-843B-1E01F2130801}"/>
+          </ac:picMkLst>
+        </pc:picChg>
+      </pc:sldChg>
+      <pc:sldChg chg="addSp delSp modSp add mod">
+        <pc:chgData name="Corbin Ferguson" userId="34a864e2-e65e-4cb2-823c-dc28f73f0e40" providerId="ADAL" clId="{8D2D96CF-1319-4CCC-9EA9-073445628049}" dt="2026-03-16T16:46:09.342" v="1562" actId="26606"/>
+        <pc:sldMkLst>
+          <pc:docMk/>
+          <pc:sldMk cId="1692918807" sldId="2146848317"/>
+        </pc:sldMkLst>
+        <pc:spChg chg="mod">
+          <ac:chgData name="Corbin Ferguson" userId="34a864e2-e65e-4cb2-823c-dc28f73f0e40" providerId="ADAL" clId="{8D2D96CF-1319-4CCC-9EA9-073445628049}" dt="2026-03-16T16:16:24.772" v="1525" actId="20577"/>
+          <ac:spMkLst>
+            <pc:docMk/>
+            <pc:sldMk cId="1692918807" sldId="2146848317"/>
+            <ac:spMk id="2" creationId="{5EBCB58C-1369-EDD7-5D5E-7C1E1415DB2E}"/>
+          </ac:spMkLst>
+        </pc:spChg>
+        <pc:picChg chg="add del mod ord">
+          <ac:chgData name="Corbin Ferguson" userId="34a864e2-e65e-4cb2-823c-dc28f73f0e40" providerId="ADAL" clId="{8D2D96CF-1319-4CCC-9EA9-073445628049}" dt="2026-03-16T16:46:03.814" v="1560" actId="478"/>
+          <ac:picMkLst>
+            <pc:docMk/>
+            <pc:sldMk cId="1692918807" sldId="2146848317"/>
+            <ac:picMk id="5" creationId="{3B859A28-2ACE-A4B7-DEC7-316954D7B566}"/>
+          </ac:picMkLst>
+        </pc:picChg>
+        <pc:picChg chg="add mod ord">
+          <ac:chgData name="Corbin Ferguson" userId="34a864e2-e65e-4cb2-823c-dc28f73f0e40" providerId="ADAL" clId="{8D2D96CF-1319-4CCC-9EA9-073445628049}" dt="2026-03-16T16:46:09.342" v="1562" actId="26606"/>
+          <ac:picMkLst>
+            <pc:docMk/>
+            <pc:sldMk cId="1692918807" sldId="2146848317"/>
+            <ac:picMk id="9" creationId="{A889D74E-A641-8FCA-9F55-93231CDB546D}"/>
+          </ac:picMkLst>
+        </pc:picChg>
+        <pc:picChg chg="del mod">
+          <ac:chgData name="Corbin Ferguson" userId="34a864e2-e65e-4cb2-823c-dc28f73f0e40" providerId="ADAL" clId="{8D2D96CF-1319-4CCC-9EA9-073445628049}" dt="2026-03-16T16:42:30.470" v="1553" actId="478"/>
+          <ac:picMkLst>
+            <pc:docMk/>
+            <pc:sldMk cId="1692918807" sldId="2146848317"/>
+            <ac:picMk id="8352" creationId="{80F05C8E-9631-A510-8677-5DD7385BC4AE}"/>
+          </ac:picMkLst>
+        </pc:picChg>
+        <pc:picChg chg="del">
+          <ac:chgData name="Corbin Ferguson" userId="34a864e2-e65e-4cb2-823c-dc28f73f0e40" providerId="ADAL" clId="{8D2D96CF-1319-4CCC-9EA9-073445628049}" dt="2026-03-16T16:15:22.910" v="1499" actId="478"/>
+          <ac:picMkLst>
+            <pc:docMk/>
+            <pc:sldMk cId="1692918807" sldId="2146848317"/>
+            <ac:picMk id="8354" creationId="{E90019A8-76BA-2ED0-32B4-272D74BDE709}"/>
+          </ac:picMkLst>
+        </pc:picChg>
+        <pc:picChg chg="del mod">
+          <ac:chgData name="Corbin Ferguson" userId="34a864e2-e65e-4cb2-823c-dc28f73f0e40" providerId="ADAL" clId="{8D2D96CF-1319-4CCC-9EA9-073445628049}" dt="2026-03-16T16:42:30.820" v="1554" actId="478"/>
+          <ac:picMkLst>
+            <pc:docMk/>
+            <pc:sldMk cId="1692918807" sldId="2146848317"/>
+            <ac:picMk id="8356" creationId="{D199DA8A-A808-1059-BF00-DD0A3C6CA781}"/>
+          </ac:picMkLst>
+        </pc:picChg>
+        <pc:picChg chg="del mod">
+          <ac:chgData name="Corbin Ferguson" userId="34a864e2-e65e-4cb2-823c-dc28f73f0e40" providerId="ADAL" clId="{8D2D96CF-1319-4CCC-9EA9-073445628049}" dt="2026-03-16T16:42:30.138" v="1552" actId="478"/>
+          <ac:picMkLst>
+            <pc:docMk/>
+            <pc:sldMk cId="1692918807" sldId="2146848317"/>
+            <ac:picMk id="10910" creationId="{5EB4AF2A-E1DF-5181-7810-0E4B05E08A25}"/>
+          </ac:picMkLst>
+        </pc:picChg>
+      </pc:sldChg>
+    </pc:docChg>
+  </pc:docChgLst>
+</pc:chgInfo>
 </file>
 
 <file path=ppt/charts/chart1.xml><?xml version="1.0" encoding="utf-8"?>
@@ -4156,6 +5271,27 @@
 </cs:chartStyle>
 </file>
 
+<file path=ppt/comments/modernComment_7FF64E2C_E0829901.xml><?xml version="1.0" encoding="utf-8"?>
+<p188:cmLst xmlns:a="http://schemas.openxmlformats.org/drawingml/2006/main" xmlns:r="http://schemas.openxmlformats.org/officeDocument/2006/relationships" xmlns:p188="http://schemas.microsoft.com/office/powerpoint/2018/8/main">
+  <p188:cm id="{556C706D-509E-4C8A-87BA-280BEA73EA40}" authorId="{C5CB79AA-8EBF-1E57-EC02-8B657B2EB377}" created="2026-03-16T15:13:51.405">
+    <pc:sldMkLst xmlns:pc="http://schemas.microsoft.com/office/powerpoint/2013/main/command">
+      <pc:docMk/>
+      <pc:sldMk cId="3766655233" sldId="2146848300"/>
+    </pc:sldMkLst>
+    <p188:txBody>
+      <a:bodyPr/>
+      <a:lstStyle/>
+      <a:p>
+        <a:r>
+          <a:rPr lang="en-US"/>
+          <a:t>If there continues to be failing tests, highlight why. Explain why the 1 test is skipped</a:t>
+        </a:r>
+      </a:p>
+    </p188:txBody>
+  </p188:cm>
+</p188:cmLst>
+</file>
+
 <file path=ppt/handoutMasters/handoutMaster1.xml><?xml version="1.0" encoding="utf-8"?>
 <p:handoutMaster xmlns:a="http://schemas.openxmlformats.org/drawingml/2006/main" xmlns:r="http://schemas.openxmlformats.org/officeDocument/2006/relationships" xmlns:p="http://schemas.openxmlformats.org/presentationml/2006/main">
   <p:cSld>
@@ -18241,7 +19377,7 @@
             </a:pPr>
             <a:r>
               <a:rPr lang="en-US" sz="1900" dirty="0"/>
-              <a:t>This is a subtitle which shall be written in maximum two lines! This is a subtitle which shall be written in maximum two lines! </a:t>
+              <a:t>Creating an alternative tool for generating L5X files for use in Rockwell Automation’s Studio 5000 Logix Designer</a:t>
             </a:r>
           </a:p>
         </p:txBody>
@@ -18322,6 +19458,514 @@
 </file>
 
 <file path=ppt/slides/slide10.xml><?xml version="1.0" encoding="utf-8"?>
+<p:sld xmlns:a="http://schemas.openxmlformats.org/drawingml/2006/main" xmlns:r="http://schemas.openxmlformats.org/officeDocument/2006/relationships" xmlns:p="http://schemas.openxmlformats.org/presentationml/2006/main">
+  <p:cSld>
+    <p:spTree>
+      <p:nvGrpSpPr>
+        <p:cNvPr id="1" name="">
+          <a:extLst>
+            <a:ext uri="{FF2B5EF4-FFF2-40B4-BE49-F238E27FC236}">
+              <a16:creationId xmlns:a16="http://schemas.microsoft.com/office/drawing/2014/main" id="{93938A11-EECC-9BC6-7865-435054160CD9}"/>
+            </a:ext>
+          </a:extLst>
+        </p:cNvPr>
+        <p:cNvGrpSpPr/>
+        <p:nvPr/>
+      </p:nvGrpSpPr>
+      <p:grpSpPr>
+        <a:xfrm>
+          <a:off x="0" y="0"/>
+          <a:ext cx="0" cy="0"/>
+          <a:chOff x="0" y="0"/>
+          <a:chExt cx="0" cy="0"/>
+        </a:xfrm>
+      </p:grpSpPr>
+      <p:sp>
+        <p:nvSpPr>
+          <p:cNvPr id="2" name="Title 1">
+            <a:extLst>
+              <a:ext uri="{FF2B5EF4-FFF2-40B4-BE49-F238E27FC236}">
+                <a16:creationId xmlns:a16="http://schemas.microsoft.com/office/drawing/2014/main" id="{2A18B76F-2AF4-F180-30B2-B28BCC59D004}"/>
+              </a:ext>
+            </a:extLst>
+          </p:cNvPr>
+          <p:cNvSpPr>
+            <a:spLocks noGrp="1"/>
+          </p:cNvSpPr>
+          <p:nvPr>
+            <p:ph type="title"/>
+          </p:nvPr>
+        </p:nvSpPr>
+        <p:spPr>
+          <a:xfrm>
+            <a:off x="334963" y="620690"/>
+            <a:ext cx="5903913" cy="360041"/>
+          </a:xfrm>
+        </p:spPr>
+        <p:txBody>
+          <a:bodyPr/>
+          <a:lstStyle/>
+          <a:p>
+            <a:r>
+              <a:rPr lang="en-US" dirty="0"/>
+              <a:t>New Elements Sequences Charts</a:t>
+            </a:r>
+          </a:p>
+        </p:txBody>
+      </p:sp>
+      <p:sp>
+        <p:nvSpPr>
+          <p:cNvPr id="4" name="Date Placeholder 3">
+            <a:extLst>
+              <a:ext uri="{FF2B5EF4-FFF2-40B4-BE49-F238E27FC236}">
+                <a16:creationId xmlns:a16="http://schemas.microsoft.com/office/drawing/2014/main" id="{9A01F89D-9B16-8125-D461-9AF251E3A9E1}"/>
+              </a:ext>
+            </a:extLst>
+          </p:cNvPr>
+          <p:cNvSpPr>
+            <a:spLocks noGrp="1"/>
+          </p:cNvSpPr>
+          <p:nvPr>
+            <p:ph type="dt" sz="half" idx="10"/>
+          </p:nvPr>
+        </p:nvSpPr>
+        <p:spPr/>
+        <p:txBody>
+          <a:bodyPr/>
+          <a:lstStyle/>
+          <a:p>
+            <a:r>
+              <a:rPr lang="en-US"/>
+              <a:t>L5X Automation Build Tool</a:t>
+            </a:r>
+            <a:endParaRPr lang="en-US" dirty="0"/>
+          </a:p>
+        </p:txBody>
+      </p:sp>
+      <p:sp>
+        <p:nvSpPr>
+          <p:cNvPr id="7" name="Slide Number Placeholder 6">
+            <a:extLst>
+              <a:ext uri="{FF2B5EF4-FFF2-40B4-BE49-F238E27FC236}">
+                <a16:creationId xmlns:a16="http://schemas.microsoft.com/office/drawing/2014/main" id="{0BAF9346-2F50-F0FB-C237-28D282CCCF63}"/>
+              </a:ext>
+            </a:extLst>
+          </p:cNvPr>
+          <p:cNvSpPr>
+            <a:spLocks noGrp="1"/>
+          </p:cNvSpPr>
+          <p:nvPr>
+            <p:ph type="sldNum" sz="quarter" idx="12"/>
+          </p:nvPr>
+        </p:nvSpPr>
+        <p:spPr/>
+        <p:txBody>
+          <a:bodyPr/>
+          <a:lstStyle/>
+          <a:p>
+            <a:r>
+              <a:rPr lang="en-US"/>
+              <a:t>Slide </a:t>
+            </a:r>
+            <a:fld id="{78C39363-BD0C-4CE6-8DE9-7D78215F2B9F}" type="slidenum">
+              <a:rPr lang="en-US" smtClean="0"/>
+              <a:t>10</a:t>
+            </a:fld>
+            <a:endParaRPr lang="en-US" dirty="0"/>
+          </a:p>
+        </p:txBody>
+      </p:sp>
+      <p:sp>
+        <p:nvSpPr>
+          <p:cNvPr id="8" name="Footer Placeholder 7">
+            <a:extLst>
+              <a:ext uri="{FF2B5EF4-FFF2-40B4-BE49-F238E27FC236}">
+                <a16:creationId xmlns:a16="http://schemas.microsoft.com/office/drawing/2014/main" id="{9EB94696-3F28-AFA0-7505-55910BF18FFA}"/>
+              </a:ext>
+            </a:extLst>
+          </p:cNvPr>
+          <p:cNvSpPr>
+            <a:spLocks noGrp="1"/>
+          </p:cNvSpPr>
+          <p:nvPr>
+            <p:ph type="ftr" sz="quarter" idx="11"/>
+          </p:nvPr>
+        </p:nvSpPr>
+        <p:spPr/>
+        <p:txBody>
+          <a:bodyPr/>
+          <a:lstStyle/>
+          <a:p>
+            <a:r>
+              <a:rPr lang="en-US"/>
+              <a:t>Corbin Ferguson</a:t>
+            </a:r>
+            <a:endParaRPr lang="en-US" dirty="0"/>
+          </a:p>
+        </p:txBody>
+      </p:sp>
+      <p:pic>
+        <p:nvPicPr>
+          <p:cNvPr id="3074" name="Picture 2">
+            <a:extLst>
+              <a:ext uri="{FF2B5EF4-FFF2-40B4-BE49-F238E27FC236}">
+                <a16:creationId xmlns:a16="http://schemas.microsoft.com/office/drawing/2014/main" id="{72CA8AB4-E276-87CC-8117-E47CD1C46076}"/>
+              </a:ext>
+            </a:extLst>
+          </p:cNvPr>
+          <p:cNvPicPr>
+            <a:picLocks noChangeAspect="1" noChangeArrowheads="1"/>
+          </p:cNvPicPr>
+          <p:nvPr/>
+        </p:nvPicPr>
+        <p:blipFill>
+          <a:blip r:embed="rId2" cstate="print">
+            <a:extLst>
+              <a:ext uri="{28A0092B-C50C-407E-A947-70E740481C1C}">
+                <a14:useLocalDpi xmlns:a14="http://schemas.microsoft.com/office/drawing/2010/main" val="0"/>
+              </a:ext>
+            </a:extLst>
+          </a:blip>
+          <a:srcRect/>
+          <a:stretch>
+            <a:fillRect/>
+          </a:stretch>
+        </p:blipFill>
+        <p:spPr bwMode="auto">
+          <a:xfrm>
+            <a:off x="6238876" y="89360"/>
+            <a:ext cx="5867400" cy="6116194"/>
+          </a:xfrm>
+          <a:prstGeom prst="rect">
+            <a:avLst/>
+          </a:prstGeom>
+          <a:noFill/>
+          <a:extLst>
+            <a:ext uri="{909E8E84-426E-40DD-AFC4-6F175D3DCCD1}">
+              <a14:hiddenFill xmlns:a14="http://schemas.microsoft.com/office/drawing/2010/main">
+                <a:solidFill>
+                  <a:srgbClr val="FFFFFF"/>
+                </a:solidFill>
+              </a14:hiddenFill>
+            </a:ext>
+          </a:extLst>
+        </p:spPr>
+      </p:pic>
+      <p:pic>
+        <p:nvPicPr>
+          <p:cNvPr id="3078" name="Picture 6">
+            <a:extLst>
+              <a:ext uri="{FF2B5EF4-FFF2-40B4-BE49-F238E27FC236}">
+                <a16:creationId xmlns:a16="http://schemas.microsoft.com/office/drawing/2014/main" id="{0AE53FD7-985C-4CAE-5485-DA0AC6FB44D1}"/>
+              </a:ext>
+            </a:extLst>
+          </p:cNvPr>
+          <p:cNvPicPr>
+            <a:picLocks noChangeAspect="1" noChangeArrowheads="1"/>
+          </p:cNvPicPr>
+          <p:nvPr/>
+        </p:nvPicPr>
+        <p:blipFill rotWithShape="1">
+          <a:blip r:embed="rId3" cstate="print">
+            <a:extLst>
+              <a:ext uri="{28A0092B-C50C-407E-A947-70E740481C1C}">
+                <a14:useLocalDpi xmlns:a14="http://schemas.microsoft.com/office/drawing/2010/main" val="0"/>
+              </a:ext>
+            </a:extLst>
+          </a:blip>
+          <a:srcRect r="7667"/>
+          <a:stretch>
+            <a:fillRect/>
+          </a:stretch>
+        </p:blipFill>
+        <p:spPr bwMode="auto">
+          <a:xfrm>
+            <a:off x="82103" y="1129116"/>
+            <a:ext cx="6156773" cy="4734269"/>
+          </a:xfrm>
+          <a:prstGeom prst="rect">
+            <a:avLst/>
+          </a:prstGeom>
+          <a:noFill/>
+          <a:extLst>
+            <a:ext uri="{909E8E84-426E-40DD-AFC4-6F175D3DCCD1}">
+              <a14:hiddenFill xmlns:a14="http://schemas.microsoft.com/office/drawing/2010/main">
+                <a:solidFill>
+                  <a:srgbClr val="FFFFFF"/>
+                </a:solidFill>
+              </a14:hiddenFill>
+            </a:ext>
+          </a:extLst>
+        </p:spPr>
+      </p:pic>
+    </p:spTree>
+    <p:extLst>
+      <p:ext uri="{BB962C8B-B14F-4D97-AF65-F5344CB8AC3E}">
+        <p14:creationId xmlns:p14="http://schemas.microsoft.com/office/powerpoint/2010/main" val="1350697150"/>
+      </p:ext>
+    </p:extLst>
+  </p:cSld>
+  <p:clrMapOvr>
+    <a:masterClrMapping/>
+  </p:clrMapOvr>
+</p:sld>
+</file>
+
+<file path=ppt/slides/slide11.xml><?xml version="1.0" encoding="utf-8"?>
+<p:sld xmlns:a="http://schemas.openxmlformats.org/drawingml/2006/main" xmlns:r="http://schemas.openxmlformats.org/officeDocument/2006/relationships" xmlns:p="http://schemas.openxmlformats.org/presentationml/2006/main">
+  <p:cSld>
+    <p:spTree>
+      <p:nvGrpSpPr>
+        <p:cNvPr id="1" name="">
+          <a:extLst>
+            <a:ext uri="{FF2B5EF4-FFF2-40B4-BE49-F238E27FC236}">
+              <a16:creationId xmlns:a16="http://schemas.microsoft.com/office/drawing/2014/main" id="{EF9DF529-63FE-ADF8-53ED-6BE7FB507424}"/>
+            </a:ext>
+          </a:extLst>
+        </p:cNvPr>
+        <p:cNvGrpSpPr/>
+        <p:nvPr/>
+      </p:nvGrpSpPr>
+      <p:grpSpPr>
+        <a:xfrm>
+          <a:off x="0" y="0"/>
+          <a:ext cx="0" cy="0"/>
+          <a:chOff x="0" y="0"/>
+          <a:chExt cx="0" cy="0"/>
+        </a:xfrm>
+      </p:grpSpPr>
+      <p:sp>
+        <p:nvSpPr>
+          <p:cNvPr id="2" name="Title 1">
+            <a:extLst>
+              <a:ext uri="{FF2B5EF4-FFF2-40B4-BE49-F238E27FC236}">
+                <a16:creationId xmlns:a16="http://schemas.microsoft.com/office/drawing/2014/main" id="{1BEC76E2-5D10-E119-28DF-87EA10623968}"/>
+              </a:ext>
+            </a:extLst>
+          </p:cNvPr>
+          <p:cNvSpPr>
+            <a:spLocks noGrp="1"/>
+          </p:cNvSpPr>
+          <p:nvPr>
+            <p:ph type="title"/>
+          </p:nvPr>
+        </p:nvSpPr>
+        <p:spPr>
+          <a:xfrm>
+            <a:off x="334963" y="620690"/>
+            <a:ext cx="7018337" cy="360041"/>
+          </a:xfrm>
+        </p:spPr>
+        <p:txBody>
+          <a:bodyPr/>
+          <a:lstStyle/>
+          <a:p>
+            <a:r>
+              <a:rPr lang="en-US" dirty="0"/>
+              <a:t>Element Editing Sequences Charts</a:t>
+            </a:r>
+          </a:p>
+        </p:txBody>
+      </p:sp>
+      <p:sp>
+        <p:nvSpPr>
+          <p:cNvPr id="4" name="Date Placeholder 3">
+            <a:extLst>
+              <a:ext uri="{FF2B5EF4-FFF2-40B4-BE49-F238E27FC236}">
+                <a16:creationId xmlns:a16="http://schemas.microsoft.com/office/drawing/2014/main" id="{4AB04ED2-D7AC-3763-1039-630C099F3A4C}"/>
+              </a:ext>
+            </a:extLst>
+          </p:cNvPr>
+          <p:cNvSpPr>
+            <a:spLocks noGrp="1"/>
+          </p:cNvSpPr>
+          <p:nvPr>
+            <p:ph type="dt" sz="half" idx="10"/>
+          </p:nvPr>
+        </p:nvSpPr>
+        <p:spPr/>
+        <p:txBody>
+          <a:bodyPr/>
+          <a:lstStyle/>
+          <a:p>
+            <a:r>
+              <a:rPr lang="en-US"/>
+              <a:t>L5X Automation Build Tool</a:t>
+            </a:r>
+            <a:endParaRPr lang="en-US" dirty="0"/>
+          </a:p>
+        </p:txBody>
+      </p:sp>
+      <p:sp>
+        <p:nvSpPr>
+          <p:cNvPr id="7" name="Slide Number Placeholder 6">
+            <a:extLst>
+              <a:ext uri="{FF2B5EF4-FFF2-40B4-BE49-F238E27FC236}">
+                <a16:creationId xmlns:a16="http://schemas.microsoft.com/office/drawing/2014/main" id="{FA5C2B7C-90AB-FD77-3161-D3654154603E}"/>
+              </a:ext>
+            </a:extLst>
+          </p:cNvPr>
+          <p:cNvSpPr>
+            <a:spLocks noGrp="1"/>
+          </p:cNvSpPr>
+          <p:nvPr>
+            <p:ph type="sldNum" sz="quarter" idx="12"/>
+          </p:nvPr>
+        </p:nvSpPr>
+        <p:spPr/>
+        <p:txBody>
+          <a:bodyPr/>
+          <a:lstStyle/>
+          <a:p>
+            <a:r>
+              <a:rPr lang="en-US"/>
+              <a:t>Slide </a:t>
+            </a:r>
+            <a:fld id="{599786A8-973E-49A8-9C43-0BE71F98A081}" type="slidenum">
+              <a:rPr lang="en-US" smtClean="0"/>
+              <a:t>11</a:t>
+            </a:fld>
+            <a:endParaRPr lang="en-US" dirty="0"/>
+          </a:p>
+        </p:txBody>
+      </p:sp>
+      <p:sp>
+        <p:nvSpPr>
+          <p:cNvPr id="8" name="Footer Placeholder 7">
+            <a:extLst>
+              <a:ext uri="{FF2B5EF4-FFF2-40B4-BE49-F238E27FC236}">
+                <a16:creationId xmlns:a16="http://schemas.microsoft.com/office/drawing/2014/main" id="{C2F6AD5B-E994-0A83-78C8-94E2F6F39074}"/>
+              </a:ext>
+            </a:extLst>
+          </p:cNvPr>
+          <p:cNvSpPr>
+            <a:spLocks noGrp="1"/>
+          </p:cNvSpPr>
+          <p:nvPr>
+            <p:ph type="ftr" sz="quarter" idx="11"/>
+          </p:nvPr>
+        </p:nvSpPr>
+        <p:spPr/>
+        <p:txBody>
+          <a:bodyPr/>
+          <a:lstStyle/>
+          <a:p>
+            <a:r>
+              <a:rPr lang="en-US"/>
+              <a:t>Corbin Ferguson</a:t>
+            </a:r>
+            <a:endParaRPr lang="en-US" dirty="0"/>
+          </a:p>
+        </p:txBody>
+      </p:sp>
+      <p:pic>
+        <p:nvPicPr>
+          <p:cNvPr id="4100" name="Picture 4">
+            <a:extLst>
+              <a:ext uri="{FF2B5EF4-FFF2-40B4-BE49-F238E27FC236}">
+                <a16:creationId xmlns:a16="http://schemas.microsoft.com/office/drawing/2014/main" id="{BB53261F-4A38-01BF-14A0-AC05F4918629}"/>
+              </a:ext>
+            </a:extLst>
+          </p:cNvPr>
+          <p:cNvPicPr>
+            <a:picLocks noChangeAspect="1" noChangeArrowheads="1"/>
+          </p:cNvPicPr>
+          <p:nvPr/>
+        </p:nvPicPr>
+        <p:blipFill>
+          <a:blip r:embed="rId2" cstate="print">
+            <a:extLst>
+              <a:ext uri="{28A0092B-C50C-407E-A947-70E740481C1C}">
+                <a14:useLocalDpi xmlns:a14="http://schemas.microsoft.com/office/drawing/2010/main" val="0"/>
+              </a:ext>
+            </a:extLst>
+          </a:blip>
+          <a:srcRect/>
+          <a:stretch>
+            <a:fillRect/>
+          </a:stretch>
+        </p:blipFill>
+        <p:spPr bwMode="auto">
+          <a:xfrm>
+            <a:off x="5660591" y="194736"/>
+            <a:ext cx="6482994" cy="5720289"/>
+          </a:xfrm>
+          <a:prstGeom prst="rect">
+            <a:avLst/>
+          </a:prstGeom>
+          <a:noFill/>
+          <a:extLst>
+            <a:ext uri="{909E8E84-426E-40DD-AFC4-6F175D3DCCD1}">
+              <a14:hiddenFill xmlns:a14="http://schemas.microsoft.com/office/drawing/2010/main">
+                <a:solidFill>
+                  <a:srgbClr val="FFFFFF"/>
+                </a:solidFill>
+              </a14:hiddenFill>
+            </a:ext>
+          </a:extLst>
+        </p:spPr>
+      </p:pic>
+      <p:pic>
+        <p:nvPicPr>
+          <p:cNvPr id="4102" name="Picture 6">
+            <a:extLst>
+              <a:ext uri="{FF2B5EF4-FFF2-40B4-BE49-F238E27FC236}">
+                <a16:creationId xmlns:a16="http://schemas.microsoft.com/office/drawing/2014/main" id="{1369CFC5-7E6D-03BD-C62A-74FBF0D2D610}"/>
+              </a:ext>
+            </a:extLst>
+          </p:cNvPr>
+          <p:cNvPicPr>
+            <a:picLocks noChangeAspect="1" noChangeArrowheads="1"/>
+          </p:cNvPicPr>
+          <p:nvPr/>
+        </p:nvPicPr>
+        <p:blipFill>
+          <a:blip r:embed="rId3" cstate="print">
+            <a:extLst>
+              <a:ext uri="{28A0092B-C50C-407E-A947-70E740481C1C}">
+                <a14:useLocalDpi xmlns:a14="http://schemas.microsoft.com/office/drawing/2010/main" val="0"/>
+              </a:ext>
+            </a:extLst>
+          </a:blip>
+          <a:srcRect/>
+          <a:stretch>
+            <a:fillRect/>
+          </a:stretch>
+        </p:blipFill>
+        <p:spPr bwMode="auto">
+          <a:xfrm>
+            <a:off x="48416" y="1482391"/>
+            <a:ext cx="5677702" cy="3727784"/>
+          </a:xfrm>
+          <a:prstGeom prst="rect">
+            <a:avLst/>
+          </a:prstGeom>
+          <a:noFill/>
+          <a:extLst>
+            <a:ext uri="{909E8E84-426E-40DD-AFC4-6F175D3DCCD1}">
+              <a14:hiddenFill xmlns:a14="http://schemas.microsoft.com/office/drawing/2010/main">
+                <a:solidFill>
+                  <a:srgbClr val="FFFFFF"/>
+                </a:solidFill>
+              </a14:hiddenFill>
+            </a:ext>
+          </a:extLst>
+        </p:spPr>
+      </p:pic>
+    </p:spTree>
+    <p:extLst>
+      <p:ext uri="{BB962C8B-B14F-4D97-AF65-F5344CB8AC3E}">
+        <p14:creationId xmlns:p14="http://schemas.microsoft.com/office/powerpoint/2010/main" val="3038692604"/>
+      </p:ext>
+    </p:extLst>
+  </p:cSld>
+  <p:clrMapOvr>
+    <a:masterClrMapping/>
+  </p:clrMapOvr>
+</p:sld>
+</file>
+
+<file path=ppt/slides/slide12.xml><?xml version="1.0" encoding="utf-8"?>
 <p:sld xmlns:a="http://schemas.openxmlformats.org/drawingml/2006/main" xmlns:r="http://schemas.openxmlformats.org/officeDocument/2006/relationships" xmlns:p="http://schemas.openxmlformats.org/presentationml/2006/main">
   <p:cSld>
     <p:spTree>
@@ -18433,7 +20077,7 @@
             </a:r>
             <a:fld id="{DEE51C30-41E2-4709-97ED-40F16AE6C836}" type="slidenum">
               <a:rPr lang="en-US" smtClean="0"/>
-              <a:t>10</a:t>
+              <a:t>12</a:t>
             </a:fld>
             <a:endParaRPr lang="en-US" dirty="0"/>
           </a:p>
@@ -18669,7 +20313,7 @@
 </p:sld>
 </file>
 
-<file path=ppt/slides/slide11.xml><?xml version="1.0" encoding="utf-8"?>
+<file path=ppt/slides/slide13.xml><?xml version="1.0" encoding="utf-8"?>
 <p:sld xmlns:a="http://schemas.openxmlformats.org/drawingml/2006/main" xmlns:r="http://schemas.openxmlformats.org/officeDocument/2006/relationships" xmlns:p="http://schemas.openxmlformats.org/presentationml/2006/main">
   <p:cSld>
     <p:spTree>
@@ -18694,6 +20338,96 @@
       </p:grpSpPr>
       <p:sp>
         <p:nvSpPr>
+          <p:cNvPr id="8" name="Footer Placeholder 7">
+            <a:extLst>
+              <a:ext uri="{FF2B5EF4-FFF2-40B4-BE49-F238E27FC236}">
+                <a16:creationId xmlns:a16="http://schemas.microsoft.com/office/drawing/2014/main" id="{0399E63B-65A1-3030-DC23-CA1AF7150CCF}"/>
+              </a:ext>
+            </a:extLst>
+          </p:cNvPr>
+          <p:cNvSpPr>
+            <a:spLocks noGrp="1"/>
+          </p:cNvSpPr>
+          <p:nvPr>
+            <p:ph type="ftr" sz="quarter" idx="19"/>
+          </p:nvPr>
+        </p:nvSpPr>
+        <p:spPr/>
+        <p:txBody>
+          <a:bodyPr/>
+          <a:lstStyle/>
+          <a:p>
+            <a:r>
+              <a:rPr lang="en-US"/>
+              <a:t>Corbin Ferguson</a:t>
+            </a:r>
+            <a:endParaRPr lang="en-US" dirty="0"/>
+          </a:p>
+        </p:txBody>
+      </p:sp>
+      <p:sp>
+        <p:nvSpPr>
+          <p:cNvPr id="7" name="Slide Number Placeholder 6">
+            <a:extLst>
+              <a:ext uri="{FF2B5EF4-FFF2-40B4-BE49-F238E27FC236}">
+                <a16:creationId xmlns:a16="http://schemas.microsoft.com/office/drawing/2014/main" id="{F24A93D2-C404-5313-F354-72800B3D775A}"/>
+              </a:ext>
+            </a:extLst>
+          </p:cNvPr>
+          <p:cNvSpPr>
+            <a:spLocks noGrp="1"/>
+          </p:cNvSpPr>
+          <p:nvPr>
+            <p:ph type="sldNum" sz="quarter" idx="20"/>
+          </p:nvPr>
+        </p:nvSpPr>
+        <p:spPr/>
+        <p:txBody>
+          <a:bodyPr/>
+          <a:lstStyle/>
+          <a:p>
+            <a:r>
+              <a:rPr lang="en-US"/>
+              <a:t>Slide </a:t>
+            </a:r>
+            <a:fld id="{32B897BE-5B46-4D7A-8E5C-716C3CDA6A39}" type="slidenum">
+              <a:rPr lang="en-US" smtClean="0"/>
+              <a:t>13</a:t>
+            </a:fld>
+            <a:endParaRPr lang="en-US" dirty="0"/>
+          </a:p>
+        </p:txBody>
+      </p:sp>
+      <p:sp>
+        <p:nvSpPr>
+          <p:cNvPr id="3" name="Subtitle 2">
+            <a:extLst>
+              <a:ext uri="{FF2B5EF4-FFF2-40B4-BE49-F238E27FC236}">
+                <a16:creationId xmlns:a16="http://schemas.microsoft.com/office/drawing/2014/main" id="{63F6E7F2-C333-13E7-6A23-E317DC8149B0}"/>
+              </a:ext>
+            </a:extLst>
+          </p:cNvPr>
+          <p:cNvSpPr>
+            <a:spLocks noGrp="1"/>
+          </p:cNvSpPr>
+          <p:nvPr>
+            <p:ph type="subTitle" idx="1"/>
+          </p:nvPr>
+        </p:nvSpPr>
+        <p:spPr/>
+        <p:txBody>
+          <a:bodyPr/>
+          <a:lstStyle/>
+          <a:p>
+            <a:r>
+              <a:rPr lang="en-US" dirty="0"/>
+              <a:t>Live Demo!</a:t>
+            </a:r>
+          </a:p>
+        </p:txBody>
+      </p:sp>
+      <p:sp>
+        <p:nvSpPr>
           <p:cNvPr id="2" name="Title 1">
             <a:extLst>
               <a:ext uri="{FF2B5EF4-FFF2-40B4-BE49-F238E27FC236}">
@@ -18705,13 +20439,13 @@
             <a:spLocks noGrp="1"/>
           </p:cNvSpPr>
           <p:nvPr>
-            <p:ph type="title"/>
+            <p:ph type="title" idx="4294967295"/>
           </p:nvPr>
         </p:nvSpPr>
         <p:spPr>
           <a:xfrm>
-            <a:off x="334963" y="620690"/>
-            <a:ext cx="5227637" cy="360041"/>
+            <a:off x="0" y="620713"/>
+            <a:ext cx="5227638" cy="360362"/>
           </a:xfrm>
         </p:spPr>
         <p:txBody>
@@ -18738,10 +20472,15 @@
             <a:spLocks noGrp="1"/>
           </p:cNvSpPr>
           <p:nvPr>
-            <p:ph type="dt" sz="half" idx="10"/>
-          </p:nvPr>
-        </p:nvSpPr>
-        <p:spPr/>
+            <p:ph type="dt" sz="half" idx="4294967295"/>
+          </p:nvPr>
+        </p:nvSpPr>
+        <p:spPr>
+          <a:xfrm>
+            <a:off x="0" y="195263"/>
+            <a:ext cx="9674225" cy="179387"/>
+          </a:xfrm>
+        </p:spPr>
         <p:txBody>
           <a:bodyPr/>
           <a:lstStyle/>
@@ -18749,68 +20488,6 @@
             <a:r>
               <a:rPr lang="en-US"/>
               <a:t>L5X Automation Build Tool</a:t>
-            </a:r>
-            <a:endParaRPr lang="en-US" dirty="0"/>
-          </a:p>
-        </p:txBody>
-      </p:sp>
-      <p:sp>
-        <p:nvSpPr>
-          <p:cNvPr id="7" name="Slide Number Placeholder 6">
-            <a:extLst>
-              <a:ext uri="{FF2B5EF4-FFF2-40B4-BE49-F238E27FC236}">
-                <a16:creationId xmlns:a16="http://schemas.microsoft.com/office/drawing/2014/main" id="{F24A93D2-C404-5313-F354-72800B3D775A}"/>
-              </a:ext>
-            </a:extLst>
-          </p:cNvPr>
-          <p:cNvSpPr>
-            <a:spLocks noGrp="1"/>
-          </p:cNvSpPr>
-          <p:nvPr>
-            <p:ph type="sldNum" sz="quarter" idx="12"/>
-          </p:nvPr>
-        </p:nvSpPr>
-        <p:spPr/>
-        <p:txBody>
-          <a:bodyPr/>
-          <a:lstStyle/>
-          <a:p>
-            <a:r>
-              <a:rPr lang="en-US"/>
-              <a:t>Slide </a:t>
-            </a:r>
-            <a:fld id="{32B897BE-5B46-4D7A-8E5C-716C3CDA6A39}" type="slidenum">
-              <a:rPr lang="en-US" smtClean="0"/>
-              <a:t>11</a:t>
-            </a:fld>
-            <a:endParaRPr lang="en-US" dirty="0"/>
-          </a:p>
-        </p:txBody>
-      </p:sp>
-      <p:sp>
-        <p:nvSpPr>
-          <p:cNvPr id="8" name="Footer Placeholder 7">
-            <a:extLst>
-              <a:ext uri="{FF2B5EF4-FFF2-40B4-BE49-F238E27FC236}">
-                <a16:creationId xmlns:a16="http://schemas.microsoft.com/office/drawing/2014/main" id="{0399E63B-65A1-3030-DC23-CA1AF7150CCF}"/>
-              </a:ext>
-            </a:extLst>
-          </p:cNvPr>
-          <p:cNvSpPr>
-            <a:spLocks noGrp="1"/>
-          </p:cNvSpPr>
-          <p:nvPr>
-            <p:ph type="ftr" sz="quarter" idx="11"/>
-          </p:nvPr>
-        </p:nvSpPr>
-        <p:spPr/>
-        <p:txBody>
-          <a:bodyPr/>
-          <a:lstStyle/>
-          <a:p>
-            <a:r>
-              <a:rPr lang="en-US"/>
-              <a:t>Corbin Ferguson</a:t>
             </a:r>
             <a:endParaRPr lang="en-US" dirty="0"/>
           </a:p>
@@ -18829,7 +20506,7 @@
 </p:sld>
 </file>
 
-<file path=ppt/slides/slide12.xml><?xml version="1.0" encoding="utf-8"?>
+<file path=ppt/slides/slide14.xml><?xml version="1.0" encoding="utf-8"?>
 <p:sld xmlns:a="http://schemas.openxmlformats.org/drawingml/2006/main" xmlns:r="http://schemas.openxmlformats.org/officeDocument/2006/relationships" xmlns:p="http://schemas.openxmlformats.org/presentationml/2006/main">
   <p:cSld>
     <p:spTree>
@@ -18911,7 +20588,15 @@
             </a:pPr>
             <a:r>
               <a:rPr lang="en-US" dirty="0"/>
-              <a:t>The test suite is split into 3 different namespaces:</a:t>
+              <a:t>The tests are written in C# utilizing </a:t>
+            </a:r>
+            <a:r>
+              <a:rPr lang="en-US" dirty="0" err="1"/>
+              <a:t>MSTest</a:t>
+            </a:r>
+            <a:r>
+              <a:rPr lang="en-US" dirty="0"/>
+              <a:t>, and are split into 3 different namespaces:</a:t>
             </a:r>
           </a:p>
           <a:p>
@@ -19059,7 +20744,7 @@
             </a:r>
             <a:fld id="{5BFF8BEA-C7AD-416A-8E1B-AC59D078A379}" type="slidenum">
               <a:rPr lang="en-US" smtClean="0"/>
-              <a:t>12</a:t>
+              <a:t>14</a:t>
             </a:fld>
             <a:endParaRPr lang="en-US" dirty="0"/>
           </a:p>
@@ -19107,7 +20792,7 @@
 </p:sld>
 </file>
 
-<file path=ppt/slides/slide13.xml><?xml version="1.0" encoding="utf-8"?>
+<file path=ppt/slides/slide15.xml><?xml version="1.0" encoding="utf-8"?>
 <p:sld xmlns:a="http://schemas.openxmlformats.org/drawingml/2006/main" xmlns:r="http://schemas.openxmlformats.org/officeDocument/2006/relationships" xmlns:p="http://schemas.openxmlformats.org/presentationml/2006/main">
   <p:cSld>
     <p:spTree>
@@ -19177,7 +20862,7 @@
           <a:p>
             <a:r>
               <a:rPr lang="en-US" dirty="0"/>
-              <a:t>Final Test Results</a:t>
+              <a:t>Test Results</a:t>
             </a:r>
           </a:p>
         </p:txBody>
@@ -19238,7 +20923,7 @@
             </a:r>
             <a:fld id="{358A1964-41C6-43E7-8879-EF27F633EDD1}" type="slidenum">
               <a:rPr lang="en-US" smtClean="0"/>
-              <a:t>13</a:t>
+              <a:t>15</a:t>
             </a:fld>
             <a:endParaRPr lang="en-US" dirty="0"/>
           </a:p>
@@ -19299,7 +20984,7 @@
         </p:xfrm>
         <a:graphic>
           <a:graphicData uri="http://schemas.openxmlformats.org/drawingml/2006/chart">
-            <c:chart xmlns:c="http://schemas.openxmlformats.org/drawingml/2006/chart" xmlns:r="http://schemas.openxmlformats.org/officeDocument/2006/relationships" r:id="rId2"/>
+            <c:chart xmlns:c="http://schemas.openxmlformats.org/drawingml/2006/chart" xmlns:r="http://schemas.openxmlformats.org/officeDocument/2006/relationships" r:id="rId3"/>
           </a:graphicData>
         </a:graphic>
       </p:graphicFrame>
@@ -19329,7 +21014,7 @@
         </p:xfrm>
         <a:graphic>
           <a:graphicData uri="http://schemas.openxmlformats.org/drawingml/2006/chart">
-            <c:chart xmlns:c="http://schemas.openxmlformats.org/drawingml/2006/chart" xmlns:r="http://schemas.openxmlformats.org/officeDocument/2006/relationships" r:id="rId3"/>
+            <c:chart xmlns:c="http://schemas.openxmlformats.org/drawingml/2006/chart" xmlns:r="http://schemas.openxmlformats.org/officeDocument/2006/relationships" r:id="rId4"/>
           </a:graphicData>
         </a:graphic>
       </p:graphicFrame>
@@ -19359,7 +21044,7 @@
         </p:xfrm>
         <a:graphic>
           <a:graphicData uri="http://schemas.openxmlformats.org/drawingml/2006/chart">
-            <c:chart xmlns:c="http://schemas.openxmlformats.org/drawingml/2006/chart" xmlns:r="http://schemas.openxmlformats.org/officeDocument/2006/relationships" r:id="rId4"/>
+            <c:chart xmlns:c="http://schemas.openxmlformats.org/drawingml/2006/chart" xmlns:r="http://schemas.openxmlformats.org/officeDocument/2006/relationships" r:id="rId5"/>
           </a:graphicData>
         </a:graphic>
       </p:graphicFrame>
@@ -19389,7 +21074,7 @@
         </p:xfrm>
         <a:graphic>
           <a:graphicData uri="http://schemas.openxmlformats.org/drawingml/2006/chart">
-            <c:chart xmlns:c="http://schemas.openxmlformats.org/drawingml/2006/chart" xmlns:r="http://schemas.openxmlformats.org/officeDocument/2006/relationships" r:id="rId5"/>
+            <c:chart xmlns:c="http://schemas.openxmlformats.org/drawingml/2006/chart" xmlns:r="http://schemas.openxmlformats.org/officeDocument/2006/relationships" r:id="rId6"/>
           </a:graphicData>
         </a:graphic>
       </p:graphicFrame>
@@ -19403,10 +21088,15 @@
   <p:clrMapOvr>
     <a:masterClrMapping/>
   </p:clrMapOvr>
+  <p:extLst>
+    <p:ext uri="{6950BFC3-D8DA-4A85-94F7-54DA5524770B}">
+      <p188:commentRel xmlns:p188="http://schemas.microsoft.com/office/powerpoint/2018/8/main" r:id="rId2"/>
+    </p:ext>
+  </p:extLst>
 </p:sld>
 </file>
 
-<file path=ppt/slides/slide14.xml><?xml version="1.0" encoding="utf-8"?>
+<file path=ppt/slides/slide16.xml><?xml version="1.0" encoding="utf-8"?>
 <p:sld xmlns:a="http://schemas.openxmlformats.org/drawingml/2006/main" xmlns:r="http://schemas.openxmlformats.org/officeDocument/2006/relationships" xmlns:p="http://schemas.openxmlformats.org/presentationml/2006/main">
   <p:cSld>
     <p:spTree>
@@ -19460,7 +21150,7 @@
             </a:pPr>
             <a:r>
               <a:rPr lang="en-US" sz="2200" dirty="0"/>
-              <a:t>Integrate documentation work throughout development, rather than separately</a:t>
+              <a:t>Segment out and abstract classes from the start, interfaces were very helpful</a:t>
             </a:r>
           </a:p>
           <a:p>
@@ -19480,7 +21170,7 @@
             </a:pPr>
             <a:r>
               <a:rPr lang="en-US" sz="2200" dirty="0"/>
-              <a:t>Segment out and abstract classes, interfaces are very helpful</a:t>
+              <a:t>Integrate documentation work throughout development, rather than separately</a:t>
             </a:r>
           </a:p>
           <a:p>
@@ -19500,7 +21190,7 @@
             </a:pPr>
             <a:r>
               <a:rPr lang="en-US" sz="2200" dirty="0"/>
-              <a:t>Keep a constant line of communication open with the client(Matt)</a:t>
+              <a:t>Keep a constant line of communication open with the client(Matt) for better workflow in system design</a:t>
             </a:r>
           </a:p>
         </p:txBody>
@@ -19590,7 +21280,7 @@
             </a:r>
             <a:fld id="{B7F1FE61-F696-4BC2-948F-7278C8C6DBB9}" type="slidenum">
               <a:rPr lang="en-US" smtClean="0"/>
-              <a:t>14</a:t>
+              <a:t>16</a:t>
             </a:fld>
             <a:endParaRPr lang="en-US" dirty="0"/>
           </a:p>
@@ -19637,7 +21327,234 @@
 </p:sld>
 </file>
 
-<file path=ppt/slides/slide15.xml><?xml version="1.0" encoding="utf-8"?>
+<file path=ppt/slides/slide17.xml><?xml version="1.0" encoding="utf-8"?>
+<p:sld xmlns:a="http://schemas.openxmlformats.org/drawingml/2006/main" xmlns:r="http://schemas.openxmlformats.org/officeDocument/2006/relationships" xmlns:p="http://schemas.openxmlformats.org/presentationml/2006/main">
+  <p:cSld>
+    <p:spTree>
+      <p:nvGrpSpPr>
+        <p:cNvPr id="1" name="">
+          <a:extLst>
+            <a:ext uri="{FF2B5EF4-FFF2-40B4-BE49-F238E27FC236}">
+              <a16:creationId xmlns:a16="http://schemas.microsoft.com/office/drawing/2014/main" id="{B2FF2CB5-4411-5F8F-ECAD-B9723833255F}"/>
+            </a:ext>
+          </a:extLst>
+        </p:cNvPr>
+        <p:cNvGrpSpPr/>
+        <p:nvPr/>
+      </p:nvGrpSpPr>
+      <p:grpSpPr>
+        <a:xfrm>
+          <a:off x="0" y="0"/>
+          <a:ext cx="0" cy="0"/>
+          <a:chOff x="0" y="0"/>
+          <a:chExt cx="0" cy="0"/>
+        </a:xfrm>
+      </p:grpSpPr>
+      <p:sp>
+        <p:nvSpPr>
+          <p:cNvPr id="9" name="Text Placeholder 8">
+            <a:extLst>
+              <a:ext uri="{FF2B5EF4-FFF2-40B4-BE49-F238E27FC236}">
+                <a16:creationId xmlns:a16="http://schemas.microsoft.com/office/drawing/2014/main" id="{10547ECE-F4D6-7E7B-B957-03EBA9BFAC16}"/>
+              </a:ext>
+            </a:extLst>
+          </p:cNvPr>
+          <p:cNvSpPr>
+            <a:spLocks noGrp="1"/>
+          </p:cNvSpPr>
+          <p:nvPr>
+            <p:ph type="body" sz="quarter" idx="13"/>
+          </p:nvPr>
+        </p:nvSpPr>
+        <p:spPr/>
+        <p:txBody>
+          <a:bodyPr/>
+          <a:lstStyle/>
+          <a:p>
+            <a:pPr marL="342900" indent="-342900">
+              <a:buFont typeface="Arial" panose="020B0604020202020204" pitchFamily="34" charset="0"/>
+              <a:buChar char="•"/>
+            </a:pPr>
+            <a:r>
+              <a:rPr lang="en-US" dirty="0"/>
+              <a:t>Gained substantial experience in software design principles, test‑driven development practices, UML modeling, and project management techniques for single‑developer projects.</a:t>
+            </a:r>
+          </a:p>
+          <a:p>
+            <a:pPr marL="342900" indent="-342900">
+              <a:buFont typeface="Arial" panose="020B0604020202020204" pitchFamily="34" charset="0"/>
+              <a:buChar char="•"/>
+            </a:pPr>
+            <a:r>
+              <a:rPr lang="en-US" dirty="0"/>
+              <a:t>Application state OK but not shippable</a:t>
+            </a:r>
+          </a:p>
+          <a:p>
+            <a:pPr marL="342900" indent="-342900">
+              <a:buFont typeface="Arial" panose="020B0604020202020204" pitchFamily="34" charset="0"/>
+              <a:buChar char="•"/>
+            </a:pPr>
+            <a:r>
+              <a:rPr lang="en-US" dirty="0"/>
+              <a:t>Significant additional input and item‑level validation is required to ensure data integrity and make the tool viable for real‑world deployment.</a:t>
+            </a:r>
+          </a:p>
+          <a:p>
+            <a:pPr marL="703263" lvl="1" indent="-342900">
+              <a:buFont typeface="Arial" panose="020B0604020202020204" pitchFamily="34" charset="0"/>
+              <a:buChar char="•"/>
+            </a:pPr>
+            <a:r>
+              <a:rPr lang="en-US" sz="2000" dirty="0"/>
+              <a:t>Still requires extensive manual corrections outside of the defined XML schema, reducing reliability and increasing error risk.</a:t>
+            </a:r>
+          </a:p>
+          <a:p>
+            <a:pPr marL="703263" lvl="1" indent="-342900">
+              <a:buFont typeface="Arial" panose="020B0604020202020204" pitchFamily="34" charset="0"/>
+              <a:buChar char="•"/>
+            </a:pPr>
+            <a:r>
+              <a:rPr lang="en-US" sz="2000" dirty="0"/>
+              <a:t>Not all dependencies function like normal XML dependencies but are unique to L5X, meaning they cannot be included in the schema</a:t>
+            </a:r>
+          </a:p>
+        </p:txBody>
+      </p:sp>
+      <p:sp>
+        <p:nvSpPr>
+          <p:cNvPr id="3" name="Date Placeholder 2">
+            <a:extLst>
+              <a:ext uri="{FF2B5EF4-FFF2-40B4-BE49-F238E27FC236}">
+                <a16:creationId xmlns:a16="http://schemas.microsoft.com/office/drawing/2014/main" id="{E4CEC92F-70B2-5955-59BA-71F8FCCF7607}"/>
+              </a:ext>
+            </a:extLst>
+          </p:cNvPr>
+          <p:cNvSpPr>
+            <a:spLocks noGrp="1"/>
+          </p:cNvSpPr>
+          <p:nvPr>
+            <p:ph type="dt" sz="half" idx="14"/>
+          </p:nvPr>
+        </p:nvSpPr>
+        <p:spPr/>
+        <p:txBody>
+          <a:bodyPr/>
+          <a:lstStyle/>
+          <a:p>
+            <a:r>
+              <a:rPr lang="en-US"/>
+              <a:t>L5X Automation Build Tool</a:t>
+            </a:r>
+            <a:endParaRPr lang="en-US" dirty="0"/>
+          </a:p>
+        </p:txBody>
+      </p:sp>
+      <p:sp>
+        <p:nvSpPr>
+          <p:cNvPr id="4" name="Footer Placeholder 3">
+            <a:extLst>
+              <a:ext uri="{FF2B5EF4-FFF2-40B4-BE49-F238E27FC236}">
+                <a16:creationId xmlns:a16="http://schemas.microsoft.com/office/drawing/2014/main" id="{ABD4DDF0-37C4-840E-A856-383B023B3228}"/>
+              </a:ext>
+            </a:extLst>
+          </p:cNvPr>
+          <p:cNvSpPr>
+            <a:spLocks noGrp="1"/>
+          </p:cNvSpPr>
+          <p:nvPr>
+            <p:ph type="ftr" sz="quarter" idx="15"/>
+          </p:nvPr>
+        </p:nvSpPr>
+        <p:spPr/>
+        <p:txBody>
+          <a:bodyPr/>
+          <a:lstStyle/>
+          <a:p>
+            <a:r>
+              <a:rPr lang="en-US"/>
+              <a:t>Corbin Ferguson</a:t>
+            </a:r>
+            <a:endParaRPr lang="en-US" dirty="0"/>
+          </a:p>
+        </p:txBody>
+      </p:sp>
+      <p:sp>
+        <p:nvSpPr>
+          <p:cNvPr id="5" name="Slide Number Placeholder 4">
+            <a:extLst>
+              <a:ext uri="{FF2B5EF4-FFF2-40B4-BE49-F238E27FC236}">
+                <a16:creationId xmlns:a16="http://schemas.microsoft.com/office/drawing/2014/main" id="{E1A1F705-1454-F7D1-51D1-6A08783759F2}"/>
+              </a:ext>
+            </a:extLst>
+          </p:cNvPr>
+          <p:cNvSpPr>
+            <a:spLocks noGrp="1"/>
+          </p:cNvSpPr>
+          <p:nvPr>
+            <p:ph type="sldNum" sz="quarter" idx="16"/>
+          </p:nvPr>
+        </p:nvSpPr>
+        <p:spPr/>
+        <p:txBody>
+          <a:bodyPr/>
+          <a:lstStyle/>
+          <a:p>
+            <a:r>
+              <a:rPr lang="en-US"/>
+              <a:t>Slide </a:t>
+            </a:r>
+            <a:fld id="{B7F1FE61-F696-4BC2-948F-7278C8C6DBB9}" type="slidenum">
+              <a:rPr lang="en-US" smtClean="0"/>
+              <a:t>17</a:t>
+            </a:fld>
+            <a:endParaRPr lang="en-US" dirty="0"/>
+          </a:p>
+        </p:txBody>
+      </p:sp>
+      <p:sp>
+        <p:nvSpPr>
+          <p:cNvPr id="2" name="Title 1">
+            <a:extLst>
+              <a:ext uri="{FF2B5EF4-FFF2-40B4-BE49-F238E27FC236}">
+                <a16:creationId xmlns:a16="http://schemas.microsoft.com/office/drawing/2014/main" id="{29DC8B36-B78B-74FC-1B96-372E60B3CCA5}"/>
+              </a:ext>
+            </a:extLst>
+          </p:cNvPr>
+          <p:cNvSpPr>
+            <a:spLocks noGrp="1"/>
+          </p:cNvSpPr>
+          <p:nvPr>
+            <p:ph type="title"/>
+          </p:nvPr>
+        </p:nvSpPr>
+        <p:spPr/>
+        <p:txBody>
+          <a:bodyPr/>
+          <a:lstStyle/>
+          <a:p>
+            <a:r>
+              <a:rPr lang="en-US" dirty="0"/>
+              <a:t>Conclusion</a:t>
+            </a:r>
+          </a:p>
+        </p:txBody>
+      </p:sp>
+    </p:spTree>
+    <p:extLst>
+      <p:ext uri="{BB962C8B-B14F-4D97-AF65-F5344CB8AC3E}">
+        <p14:creationId xmlns:p14="http://schemas.microsoft.com/office/powerpoint/2010/main" val="1067535560"/>
+      </p:ext>
+    </p:extLst>
+  </p:cSld>
+  <p:clrMapOvr>
+    <a:masterClrMapping/>
+  </p:clrMapOvr>
+</p:sld>
+</file>
+
+<file path=ppt/slides/slide18.xml><?xml version="1.0" encoding="utf-8"?>
 <p:sld xmlns:a="http://schemas.openxmlformats.org/drawingml/2006/main" xmlns:r="http://schemas.openxmlformats.org/officeDocument/2006/relationships" xmlns:p="http://schemas.openxmlformats.org/presentationml/2006/main">
   <p:cSld>
     <p:spTree>
@@ -19687,7 +21604,7 @@
             </a:r>
             <a:fld id="{C20DA095-8283-4DCC-BA55-3B61E88C6181}" type="slidenum">
               <a:rPr lang="en-US" smtClean="0"/>
-              <a:t>15</a:t>
+              <a:t>18</a:t>
             </a:fld>
             <a:endParaRPr lang="en-US" dirty="0"/>
           </a:p>
@@ -19781,6 +21698,328 @@
 </p:sld>
 </file>
 
+<file path=ppt/slides/slide19.xml><?xml version="1.0" encoding="utf-8"?>
+<p:sld xmlns:a="http://schemas.openxmlformats.org/drawingml/2006/main" xmlns:r="http://schemas.openxmlformats.org/officeDocument/2006/relationships" xmlns:p="http://schemas.openxmlformats.org/presentationml/2006/main">
+  <p:cSld>
+    <p:spTree>
+      <p:nvGrpSpPr>
+        <p:cNvPr id="1" name="">
+          <a:extLst>
+            <a:ext uri="{FF2B5EF4-FFF2-40B4-BE49-F238E27FC236}">
+              <a16:creationId xmlns:a16="http://schemas.microsoft.com/office/drawing/2014/main" id="{2261480E-EC27-6782-E840-077677AC47DA}"/>
+            </a:ext>
+          </a:extLst>
+        </p:cNvPr>
+        <p:cNvGrpSpPr/>
+        <p:nvPr/>
+      </p:nvGrpSpPr>
+      <p:grpSpPr>
+        <a:xfrm>
+          <a:off x="0" y="0"/>
+          <a:ext cx="0" cy="0"/>
+          <a:chOff x="0" y="0"/>
+          <a:chExt cx="0" cy="0"/>
+        </a:xfrm>
+      </p:grpSpPr>
+      <p:sp>
+        <p:nvSpPr>
+          <p:cNvPr id="9" name="Text Placeholder 8">
+            <a:extLst>
+              <a:ext uri="{FF2B5EF4-FFF2-40B4-BE49-F238E27FC236}">
+                <a16:creationId xmlns:a16="http://schemas.microsoft.com/office/drawing/2014/main" id="{01007C77-2DF3-8DD9-8D8C-832A640C674D}"/>
+              </a:ext>
+            </a:extLst>
+          </p:cNvPr>
+          <p:cNvSpPr>
+            <a:spLocks noGrp="1"/>
+          </p:cNvSpPr>
+          <p:nvPr>
+            <p:ph type="body" sz="quarter" idx="13"/>
+          </p:nvPr>
+        </p:nvSpPr>
+        <p:spPr/>
+        <p:txBody>
+          <a:bodyPr/>
+          <a:lstStyle/>
+          <a:p>
+            <a:pPr marL="342900" indent="-342900">
+              <a:buFont typeface="Arial" panose="020B0604020202020204" pitchFamily="34" charset="0"/>
+              <a:buChar char="•"/>
+            </a:pPr>
+            <a:r>
+              <a:rPr lang="en-US" dirty="0">
+                <a:hlinkClick r:id="rId2"/>
+              </a:rPr>
+              <a:t>RSLogix5000_V35.xsd</a:t>
+            </a:r>
+            <a:endParaRPr lang="en-US" dirty="0"/>
+          </a:p>
+          <a:p>
+            <a:pPr marL="342900" indent="-342900">
+              <a:buFont typeface="Arial" panose="020B0604020202020204" pitchFamily="34" charset="0"/>
+              <a:buChar char="•"/>
+            </a:pPr>
+            <a:r>
+              <a:rPr lang="en-US" dirty="0">
+                <a:hlinkClick r:id="rId3"/>
+              </a:rPr>
+              <a:t>https://literature.rockwellautomation.com/idc/groups/literature/documents/pm/1756-pm019_-en-p.pdf</a:t>
+            </a:r>
+            <a:endParaRPr lang="en-US" dirty="0"/>
+          </a:p>
+          <a:p>
+            <a:pPr marL="342900" indent="-342900">
+              <a:buFont typeface="Arial" panose="020B0604020202020204" pitchFamily="34" charset="0"/>
+              <a:buChar char="•"/>
+            </a:pPr>
+            <a:r>
+              <a:rPr lang="en-US" dirty="0">
+                <a:hlinkClick r:id="rId4"/>
+              </a:rPr>
+              <a:t>https://literature.rockwellautomation.com/idc/groups/literature/documents/rm/1756-rm014_-en-p.pdf</a:t>
+            </a:r>
+            <a:endParaRPr lang="en-US" dirty="0"/>
+          </a:p>
+          <a:p>
+            <a:pPr marL="342900" indent="-342900">
+              <a:buFont typeface="Arial" panose="020B0604020202020204" pitchFamily="34" charset="0"/>
+              <a:buChar char="•"/>
+            </a:pPr>
+            <a:r>
+              <a:rPr lang="en-US" dirty="0" err="1">
+                <a:hlinkClick r:id="rId5"/>
+              </a:rPr>
+              <a:t>System.Xml.Linq</a:t>
+            </a:r>
+            <a:r>
+              <a:rPr lang="en-US" dirty="0">
+                <a:hlinkClick r:id="rId5"/>
+              </a:rPr>
+              <a:t> Namespace | Microsoft Learn</a:t>
+            </a:r>
+            <a:endParaRPr lang="en-US" dirty="0"/>
+          </a:p>
+          <a:p>
+            <a:pPr marL="342900" indent="-342900">
+              <a:buFont typeface="Arial" panose="020B0604020202020204" pitchFamily="34" charset="0"/>
+              <a:buChar char="•"/>
+            </a:pPr>
+            <a:r>
+              <a:rPr lang="en-US" dirty="0" err="1">
+                <a:hlinkClick r:id="rId6"/>
+              </a:rPr>
+              <a:t>devlooped</a:t>
+            </a:r>
+            <a:r>
+              <a:rPr lang="en-US" dirty="0">
+                <a:hlinkClick r:id="rId6"/>
+              </a:rPr>
+              <a:t>/</a:t>
+            </a:r>
+            <a:r>
+              <a:rPr lang="en-US" dirty="0" err="1">
+                <a:hlinkClick r:id="rId6"/>
+              </a:rPr>
+              <a:t>moq</a:t>
+            </a:r>
+            <a:r>
+              <a:rPr lang="en-US" dirty="0">
+                <a:hlinkClick r:id="rId6"/>
+              </a:rPr>
+              <a:t>: The most popular and friendly mocking framework for .NET</a:t>
+            </a:r>
+            <a:endParaRPr lang="en-US" dirty="0"/>
+          </a:p>
+          <a:p>
+            <a:pPr marL="342900" indent="-342900">
+              <a:buFont typeface="Arial" panose="020B0604020202020204" pitchFamily="34" charset="0"/>
+              <a:buChar char="•"/>
+            </a:pPr>
+            <a:r>
+              <a:rPr lang="en-US" dirty="0" err="1">
+                <a:hlinkClick r:id="rId7"/>
+              </a:rPr>
+              <a:t>FlaUI</a:t>
+            </a:r>
+            <a:r>
+              <a:rPr lang="en-US" dirty="0">
+                <a:hlinkClick r:id="rId7"/>
+              </a:rPr>
+              <a:t>/</a:t>
+            </a:r>
+            <a:r>
+              <a:rPr lang="en-US" dirty="0" err="1">
+                <a:hlinkClick r:id="rId7"/>
+              </a:rPr>
+              <a:t>FlaUI</a:t>
+            </a:r>
+            <a:r>
+              <a:rPr lang="en-US" dirty="0">
+                <a:hlinkClick r:id="rId7"/>
+              </a:rPr>
+              <a:t>: UI automation library for </a:t>
+            </a:r>
+            <a:r>
+              <a:rPr lang="en-US" dirty="0" err="1">
+                <a:hlinkClick r:id="rId7"/>
+              </a:rPr>
+              <a:t>.Net</a:t>
+            </a:r>
+            <a:endParaRPr lang="en-US" dirty="0"/>
+          </a:p>
+          <a:p>
+            <a:pPr marL="342900" indent="-342900">
+              <a:buFont typeface="Arial" panose="020B0604020202020204" pitchFamily="34" charset="0"/>
+              <a:buChar char="•"/>
+            </a:pPr>
+            <a:r>
+              <a:rPr lang="en-US" dirty="0" err="1">
+                <a:hlinkClick r:id="rId8"/>
+              </a:rPr>
+              <a:t>MSTest</a:t>
+            </a:r>
+            <a:r>
+              <a:rPr lang="en-US" dirty="0">
+                <a:hlinkClick r:id="rId8"/>
+              </a:rPr>
+              <a:t> overview - .NET | Microsoft Learn</a:t>
+            </a:r>
+            <a:endParaRPr lang="en-US" sz="2000" dirty="0"/>
+          </a:p>
+        </p:txBody>
+      </p:sp>
+      <p:sp>
+        <p:nvSpPr>
+          <p:cNvPr id="3" name="Date Placeholder 2">
+            <a:extLst>
+              <a:ext uri="{FF2B5EF4-FFF2-40B4-BE49-F238E27FC236}">
+                <a16:creationId xmlns:a16="http://schemas.microsoft.com/office/drawing/2014/main" id="{F9289A25-DE32-EAA4-17EE-075AAEC9AFBF}"/>
+              </a:ext>
+            </a:extLst>
+          </p:cNvPr>
+          <p:cNvSpPr>
+            <a:spLocks noGrp="1"/>
+          </p:cNvSpPr>
+          <p:nvPr>
+            <p:ph type="dt" sz="half" idx="14"/>
+          </p:nvPr>
+        </p:nvSpPr>
+        <p:spPr/>
+        <p:txBody>
+          <a:bodyPr/>
+          <a:lstStyle/>
+          <a:p>
+            <a:r>
+              <a:rPr lang="en-US"/>
+              <a:t>L5X Automation Build Tool</a:t>
+            </a:r>
+            <a:endParaRPr lang="en-US" dirty="0"/>
+          </a:p>
+        </p:txBody>
+      </p:sp>
+      <p:sp>
+        <p:nvSpPr>
+          <p:cNvPr id="4" name="Footer Placeholder 3">
+            <a:extLst>
+              <a:ext uri="{FF2B5EF4-FFF2-40B4-BE49-F238E27FC236}">
+                <a16:creationId xmlns:a16="http://schemas.microsoft.com/office/drawing/2014/main" id="{4033C15C-D89A-56B7-E112-A72F740A71B9}"/>
+              </a:ext>
+            </a:extLst>
+          </p:cNvPr>
+          <p:cNvSpPr>
+            <a:spLocks noGrp="1"/>
+          </p:cNvSpPr>
+          <p:nvPr>
+            <p:ph type="ftr" sz="quarter" idx="15"/>
+          </p:nvPr>
+        </p:nvSpPr>
+        <p:spPr/>
+        <p:txBody>
+          <a:bodyPr/>
+          <a:lstStyle/>
+          <a:p>
+            <a:r>
+              <a:rPr lang="en-US"/>
+              <a:t>Corbin Ferguson</a:t>
+            </a:r>
+            <a:endParaRPr lang="en-US" dirty="0"/>
+          </a:p>
+        </p:txBody>
+      </p:sp>
+      <p:sp>
+        <p:nvSpPr>
+          <p:cNvPr id="5" name="Slide Number Placeholder 4">
+            <a:extLst>
+              <a:ext uri="{FF2B5EF4-FFF2-40B4-BE49-F238E27FC236}">
+                <a16:creationId xmlns:a16="http://schemas.microsoft.com/office/drawing/2014/main" id="{E66F4642-FAF3-185E-7CBC-239DE9E56FBF}"/>
+              </a:ext>
+            </a:extLst>
+          </p:cNvPr>
+          <p:cNvSpPr>
+            <a:spLocks noGrp="1"/>
+          </p:cNvSpPr>
+          <p:nvPr>
+            <p:ph type="sldNum" sz="quarter" idx="16"/>
+          </p:nvPr>
+        </p:nvSpPr>
+        <p:spPr/>
+        <p:txBody>
+          <a:bodyPr/>
+          <a:lstStyle/>
+          <a:p>
+            <a:r>
+              <a:rPr lang="en-US"/>
+              <a:t>Slide </a:t>
+            </a:r>
+            <a:fld id="{B7F1FE61-F696-4BC2-948F-7278C8C6DBB9}" type="slidenum">
+              <a:rPr lang="en-US" smtClean="0"/>
+              <a:t>19</a:t>
+            </a:fld>
+            <a:endParaRPr lang="en-US" dirty="0"/>
+          </a:p>
+        </p:txBody>
+      </p:sp>
+      <p:sp>
+        <p:nvSpPr>
+          <p:cNvPr id="2" name="Title 1">
+            <a:extLst>
+              <a:ext uri="{FF2B5EF4-FFF2-40B4-BE49-F238E27FC236}">
+                <a16:creationId xmlns:a16="http://schemas.microsoft.com/office/drawing/2014/main" id="{42490D66-69B9-FCB3-4EE3-71E22ADE614D}"/>
+              </a:ext>
+            </a:extLst>
+          </p:cNvPr>
+          <p:cNvSpPr>
+            <a:spLocks noGrp="1"/>
+          </p:cNvSpPr>
+          <p:nvPr>
+            <p:ph type="title"/>
+          </p:nvPr>
+        </p:nvSpPr>
+        <p:spPr/>
+        <p:txBody>
+          <a:bodyPr/>
+          <a:lstStyle/>
+          <a:p>
+            <a:r>
+              <a:rPr lang="en-US" dirty="0"/>
+              <a:t>Resources</a:t>
+            </a:r>
+          </a:p>
+        </p:txBody>
+      </p:sp>
+    </p:spTree>
+    <p:extLst>
+      <p:ext uri="{BB962C8B-B14F-4D97-AF65-F5344CB8AC3E}">
+        <p14:creationId xmlns:p14="http://schemas.microsoft.com/office/powerpoint/2010/main" val="1869098219"/>
+      </p:ext>
+    </p:extLst>
+  </p:cSld>
+  <p:clrMapOvr>
+    <a:masterClrMapping/>
+  </p:clrMapOvr>
+</p:sld>
+</file>
+
 <file path=ppt/slides/slide2.xml><?xml version="1.0" encoding="utf-8"?>
 <p:sld xmlns:a="http://schemas.openxmlformats.org/drawingml/2006/main" xmlns:r="http://schemas.openxmlformats.org/officeDocument/2006/relationships" xmlns:p="http://schemas.openxmlformats.org/presentationml/2006/main">
   <p:cSld>
@@ -20215,33 +22454,96 @@
       </p:sp>
       <p:pic>
         <p:nvPicPr>
-          <p:cNvPr id="9" name="Picture 8" descr="A white and blue design with black text&#10;&#10;AI-generated content may be incorrect.">
+          <p:cNvPr id="1028" name="Picture 4" descr="5 Tips for Getting Started in RSLogix 5000 | DMC, Inc.">
             <a:extLst>
               <a:ext uri="{FF2B5EF4-FFF2-40B4-BE49-F238E27FC236}">
-                <a16:creationId xmlns:a16="http://schemas.microsoft.com/office/drawing/2014/main" id="{1BC88699-DDD8-5B47-A357-650F499C3E03}"/>
+                <a16:creationId xmlns:a16="http://schemas.microsoft.com/office/drawing/2014/main" id="{6C86E4AC-1B5D-4CB7-A176-9C365C540E23}"/>
               </a:ext>
             </a:extLst>
           </p:cNvPr>
           <p:cNvPicPr>
-            <a:picLocks noChangeAspect="1"/>
+            <a:picLocks noChangeAspect="1" noChangeArrowheads="1"/>
           </p:cNvPicPr>
           <p:nvPr/>
         </p:nvPicPr>
-        <p:blipFill>
-          <a:blip r:embed="rId2"/>
-          <a:srcRect l="844" t="2038" r="-1"/>
+        <p:blipFill rotWithShape="1">
+          <a:blip r:embed="rId2">
+            <a:extLst>
+              <a:ext uri="{28A0092B-C50C-407E-A947-70E740481C1C}">
+                <a14:useLocalDpi xmlns:a14="http://schemas.microsoft.com/office/drawing/2010/main" val="0"/>
+              </a:ext>
+            </a:extLst>
+          </a:blip>
+          <a:srcRect t="19922" b="19921"/>
           <a:stretch>
             <a:fillRect/>
           </a:stretch>
         </p:blipFill>
-        <p:spPr>
+        <p:spPr bwMode="auto">
           <a:xfrm>
-            <a:off x="10172700" y="85725"/>
-            <a:ext cx="1879731" cy="1073204"/>
+            <a:off x="9769601" y="2034348"/>
+            <a:ext cx="2276475" cy="1369477"/>
           </a:xfrm>
           <a:prstGeom prst="rect">
             <a:avLst/>
           </a:prstGeom>
+          <a:noFill/>
+          <a:extLst>
+            <a:ext uri="{909E8E84-426E-40DD-AFC4-6F175D3DCCD1}">
+              <a14:hiddenFill xmlns:a14="http://schemas.microsoft.com/office/drawing/2010/main">
+                <a:solidFill>
+                  <a:srgbClr val="FFFFFF"/>
+                </a:solidFill>
+              </a14:hiddenFill>
+            </a:ext>
+          </a:extLst>
+        </p:spPr>
+      </p:pic>
+      <p:pic>
+        <p:nvPicPr>
+          <p:cNvPr id="1030" name="Picture 6" descr="Day6 Part3 Rockwell Studio 5000 training Complete Function Block diagram  FBD programming">
+            <a:extLst>
+              <a:ext uri="{FF2B5EF4-FFF2-40B4-BE49-F238E27FC236}">
+                <a16:creationId xmlns:a16="http://schemas.microsoft.com/office/drawing/2014/main" id="{84E072FF-ABEC-64D2-234E-9A5158069A12}"/>
+              </a:ext>
+            </a:extLst>
+          </p:cNvPr>
+          <p:cNvPicPr>
+            <a:picLocks noChangeAspect="1" noChangeArrowheads="1"/>
+          </p:cNvPicPr>
+          <p:nvPr/>
+        </p:nvPicPr>
+        <p:blipFill rotWithShape="1">
+          <a:blip r:embed="rId3">
+            <a:extLst>
+              <a:ext uri="{28A0092B-C50C-407E-A947-70E740481C1C}">
+                <a14:useLocalDpi xmlns:a14="http://schemas.microsoft.com/office/drawing/2010/main" val="0"/>
+              </a:ext>
+            </a:extLst>
+          </a:blip>
+          <a:srcRect b="5099"/>
+          <a:stretch>
+            <a:fillRect/>
+          </a:stretch>
+        </p:blipFill>
+        <p:spPr bwMode="auto">
+          <a:xfrm>
+            <a:off x="7010400" y="3403826"/>
+            <a:ext cx="5035676" cy="2689000"/>
+          </a:xfrm>
+          <a:prstGeom prst="rect">
+            <a:avLst/>
+          </a:prstGeom>
+          <a:noFill/>
+          <a:extLst>
+            <a:ext uri="{909E8E84-426E-40DD-AFC4-6F175D3DCCD1}">
+              <a14:hiddenFill xmlns:a14="http://schemas.microsoft.com/office/drawing/2010/main">
+                <a:solidFill>
+                  <a:srgbClr val="FFFFFF"/>
+                </a:solidFill>
+              </a14:hiddenFill>
+            </a:ext>
+          </a:extLst>
         </p:spPr>
       </p:pic>
     </p:spTree>
@@ -20343,14 +22645,14 @@
             <a:pPr lvl="1"/>
             <a:r>
               <a:rPr lang="en-US" dirty="0"/>
-              <a:t>Investigation</a:t>
+              <a:t>Investigation into applicable tools and resources</a:t>
             </a:r>
           </a:p>
           <a:p>
             <a:pPr lvl="1"/>
             <a:r>
               <a:rPr lang="en-US" dirty="0"/>
-              <a:t>Feature outline</a:t>
+              <a:t>Feature outline and requirements development</a:t>
             </a:r>
           </a:p>
           <a:p>
@@ -20377,14 +22679,21 @@
             <a:pPr lvl="1"/>
             <a:r>
               <a:rPr lang="en-US" dirty="0"/>
-              <a:t>Testing and Verification</a:t>
+              <a:t>Testing and verification</a:t>
             </a:r>
           </a:p>
           <a:p>
             <a:pPr lvl="1"/>
             <a:r>
               <a:rPr lang="en-US" dirty="0"/>
-              <a:t>Final Reporting</a:t>
+              <a:t>Application cleanup</a:t>
+            </a:r>
+          </a:p>
+          <a:p>
+            <a:pPr lvl="1"/>
+            <a:r>
+              <a:rPr lang="en-US" dirty="0"/>
+              <a:t>Final reporting</a:t>
             </a:r>
           </a:p>
         </p:txBody>
@@ -20549,7 +22858,7 @@
           <a:p>
             <a:r>
               <a:rPr lang="en-US" dirty="0"/>
-              <a:t>Intended Features</a:t>
+              <a:t>Necessary Features</a:t>
             </a:r>
           </a:p>
         </p:txBody>
@@ -20874,6 +23183,27 @@
               <a:rPr lang="en-US" dirty="0"/>
               <a:t>Business logic implemented using LINQ (Language Integrated Query)</a:t>
             </a:r>
+          </a:p>
+          <a:p>
+            <a:r>
+              <a:rPr lang="en-US" dirty="0"/>
+              <a:t>Utilizes an XML schema file(</a:t>
+            </a:r>
+            <a:r>
+              <a:rPr lang="en-US" dirty="0">
+                <a:hlinkClick r:id="rId2"/>
+              </a:rPr>
+              <a:t>RSLogix5000_V35.xsd</a:t>
+            </a:r>
+            <a:r>
+              <a:rPr lang="en-US" dirty="0"/>
+              <a:t>) developed by Jeremy Medders on </a:t>
+            </a:r>
+            <a:r>
+              <a:rPr lang="en-US" dirty="0" err="1"/>
+              <a:t>dropbox</a:t>
+            </a:r>
+            <a:endParaRPr lang="en-US" dirty="0"/>
           </a:p>
           <a:p>
             <a:r>
@@ -21196,7 +23526,7 @@
         <p:cNvPr id="1" name="">
           <a:extLst>
             <a:ext uri="{FF2B5EF4-FFF2-40B4-BE49-F238E27FC236}">
-              <a16:creationId xmlns:a16="http://schemas.microsoft.com/office/drawing/2014/main" id="{93938A11-EECC-9BC6-7865-435054160CD9}"/>
+              <a16:creationId xmlns:a16="http://schemas.microsoft.com/office/drawing/2014/main" id="{AE741E45-B413-0AAD-097D-05F3401E8023}"/>
             </a:ext>
           </a:extLst>
         </p:cNvPr>
@@ -21211,228 +23541,218 @@
           <a:chExt cx="0" cy="0"/>
         </a:xfrm>
       </p:grpSpPr>
-      <p:sp>
-        <p:nvSpPr>
-          <p:cNvPr id="2" name="Title 1">
+      <p:pic>
+        <p:nvPicPr>
+          <p:cNvPr id="8362" name="Picture 8361">
             <a:extLst>
               <a:ext uri="{FF2B5EF4-FFF2-40B4-BE49-F238E27FC236}">
-                <a16:creationId xmlns:a16="http://schemas.microsoft.com/office/drawing/2014/main" id="{2A18B76F-2AF4-F180-30B2-B28BCC59D004}"/>
-              </a:ext>
-            </a:extLst>
-          </p:cNvPr>
-          <p:cNvSpPr>
-            <a:spLocks noGrp="1"/>
-          </p:cNvSpPr>
-          <p:nvPr>
-            <p:ph type="title"/>
-          </p:nvPr>
-        </p:nvSpPr>
-        <p:spPr>
-          <a:xfrm>
-            <a:off x="334963" y="620690"/>
-            <a:ext cx="5903913" cy="360041"/>
-          </a:xfrm>
-        </p:spPr>
-        <p:txBody>
-          <a:bodyPr/>
-          <a:lstStyle/>
-          <a:p>
-            <a:r>
-              <a:rPr lang="en-US" dirty="0"/>
-              <a:t>New Elements Sequences Charts</a:t>
-            </a:r>
-          </a:p>
-        </p:txBody>
-      </p:sp>
-      <p:sp>
-        <p:nvSpPr>
-          <p:cNvPr id="4" name="Date Placeholder 3">
-            <a:extLst>
-              <a:ext uri="{FF2B5EF4-FFF2-40B4-BE49-F238E27FC236}">
-                <a16:creationId xmlns:a16="http://schemas.microsoft.com/office/drawing/2014/main" id="{9A01F89D-9B16-8125-D461-9AF251E3A9E1}"/>
-              </a:ext>
-            </a:extLst>
-          </p:cNvPr>
-          <p:cNvSpPr>
-            <a:spLocks noGrp="1"/>
-          </p:cNvSpPr>
-          <p:nvPr>
-            <p:ph type="dt" sz="half" idx="10"/>
-          </p:nvPr>
-        </p:nvSpPr>
-        <p:spPr/>
-        <p:txBody>
-          <a:bodyPr/>
-          <a:lstStyle/>
-          <a:p>
-            <a:r>
-              <a:rPr lang="en-US"/>
-              <a:t>L5X Automation Build Tool</a:t>
-            </a:r>
-            <a:endParaRPr lang="en-US" dirty="0"/>
-          </a:p>
-        </p:txBody>
-      </p:sp>
-      <p:sp>
-        <p:nvSpPr>
-          <p:cNvPr id="7" name="Slide Number Placeholder 6">
-            <a:extLst>
-              <a:ext uri="{FF2B5EF4-FFF2-40B4-BE49-F238E27FC236}">
-                <a16:creationId xmlns:a16="http://schemas.microsoft.com/office/drawing/2014/main" id="{0BAF9346-2F50-F0FB-C237-28D282CCCF63}"/>
-              </a:ext>
-            </a:extLst>
-          </p:cNvPr>
-          <p:cNvSpPr>
-            <a:spLocks noGrp="1"/>
-          </p:cNvSpPr>
-          <p:nvPr>
-            <p:ph type="sldNum" sz="quarter" idx="12"/>
-          </p:nvPr>
-        </p:nvSpPr>
-        <p:spPr/>
-        <p:txBody>
-          <a:bodyPr/>
-          <a:lstStyle/>
-          <a:p>
-            <a:r>
-              <a:rPr lang="en-US"/>
-              <a:t>Slide </a:t>
-            </a:r>
-            <a:fld id="{78C39363-BD0C-4CE6-8DE9-7D78215F2B9F}" type="slidenum">
-              <a:rPr lang="en-US" smtClean="0"/>
-              <a:t>8</a:t>
-            </a:fld>
-            <a:endParaRPr lang="en-US" dirty="0"/>
-          </a:p>
-        </p:txBody>
-      </p:sp>
-      <p:sp>
-        <p:nvSpPr>
-          <p:cNvPr id="8" name="Footer Placeholder 7">
-            <a:extLst>
-              <a:ext uri="{FF2B5EF4-FFF2-40B4-BE49-F238E27FC236}">
-                <a16:creationId xmlns:a16="http://schemas.microsoft.com/office/drawing/2014/main" id="{9EB94696-3F28-AFA0-7505-55910BF18FFA}"/>
-              </a:ext>
-            </a:extLst>
-          </p:cNvPr>
-          <p:cNvSpPr>
-            <a:spLocks noGrp="1"/>
-          </p:cNvSpPr>
-          <p:nvPr>
-            <p:ph type="ftr" sz="quarter" idx="11"/>
-          </p:nvPr>
-        </p:nvSpPr>
-        <p:spPr/>
-        <p:txBody>
-          <a:bodyPr/>
-          <a:lstStyle/>
-          <a:p>
-            <a:r>
-              <a:rPr lang="en-US"/>
-              <a:t>Corbin Ferguson</a:t>
-            </a:r>
-            <a:endParaRPr lang="en-US" dirty="0"/>
-          </a:p>
-        </p:txBody>
-      </p:sp>
-      <p:pic>
-        <p:nvPicPr>
-          <p:cNvPr id="3074" name="Picture 2">
-            <a:extLst>
-              <a:ext uri="{FF2B5EF4-FFF2-40B4-BE49-F238E27FC236}">
-                <a16:creationId xmlns:a16="http://schemas.microsoft.com/office/drawing/2014/main" id="{72CA8AB4-E276-87CC-8117-E47CD1C46076}"/>
+                <a16:creationId xmlns:a16="http://schemas.microsoft.com/office/drawing/2014/main" id="{5B32580E-8B7E-FCBF-145C-131D2AA75C68}"/>
               </a:ext>
             </a:extLst>
           </p:cNvPr>
           <p:cNvPicPr>
-            <a:picLocks noChangeAspect="1" noChangeArrowheads="1"/>
+            <a:picLocks noChangeAspect="1"/>
           </p:cNvPicPr>
           <p:nvPr/>
         </p:nvPicPr>
         <p:blipFill>
-          <a:blip r:embed="rId2" cstate="print">
-            <a:extLst>
-              <a:ext uri="{28A0092B-C50C-407E-A947-70E740481C1C}">
-                <a14:useLocalDpi xmlns:a14="http://schemas.microsoft.com/office/drawing/2010/main" val="0"/>
-              </a:ext>
-            </a:extLst>
-          </a:blip>
-          <a:srcRect/>
+          <a:blip r:embed="rId2"/>
           <a:stretch>
             <a:fillRect/>
           </a:stretch>
         </p:blipFill>
-        <p:spPr bwMode="auto">
+        <p:spPr>
           <a:xfrm>
-            <a:off x="6238876" y="89360"/>
-            <a:ext cx="5867400" cy="6116194"/>
+            <a:off x="2687786" y="1160462"/>
+            <a:ext cx="6816427" cy="5113337"/>
           </a:xfrm>
           <a:prstGeom prst="rect">
             <a:avLst/>
           </a:prstGeom>
           <a:noFill/>
-          <a:extLst>
-            <a:ext uri="{909E8E84-426E-40DD-AFC4-6F175D3DCCD1}">
-              <a14:hiddenFill xmlns:a14="http://schemas.microsoft.com/office/drawing/2010/main">
-                <a:solidFill>
-                  <a:srgbClr val="FFFFFF"/>
-                </a:solidFill>
-              </a14:hiddenFill>
-            </a:ext>
-          </a:extLst>
         </p:spPr>
       </p:pic>
-      <p:pic>
-        <p:nvPicPr>
-          <p:cNvPr id="3078" name="Picture 6">
+      <p:sp>
+        <p:nvSpPr>
+          <p:cNvPr id="8" name="Footer Placeholder 7">
             <a:extLst>
               <a:ext uri="{FF2B5EF4-FFF2-40B4-BE49-F238E27FC236}">
-                <a16:creationId xmlns:a16="http://schemas.microsoft.com/office/drawing/2014/main" id="{0AE53FD7-985C-4CAE-5485-DA0AC6FB44D1}"/>
+                <a16:creationId xmlns:a16="http://schemas.microsoft.com/office/drawing/2014/main" id="{4C7D5AC9-EA29-86A4-7EF8-4DF941130DC8}"/>
               </a:ext>
             </a:extLst>
           </p:cNvPr>
-          <p:cNvPicPr>
-            <a:picLocks noChangeAspect="1" noChangeArrowheads="1"/>
-          </p:cNvPicPr>
-          <p:nvPr/>
-        </p:nvPicPr>
-        <p:blipFill rotWithShape="1">
-          <a:blip r:embed="rId3" cstate="print">
+          <p:cNvSpPr>
+            <a:spLocks noGrp="1"/>
+          </p:cNvSpPr>
+          <p:nvPr>
+            <p:ph type="ftr" sz="quarter" idx="19"/>
+          </p:nvPr>
+        </p:nvSpPr>
+        <p:spPr>
+          <a:xfrm>
+            <a:off x="4086351" y="6469380"/>
+            <a:ext cx="1130300" cy="180000"/>
+          </a:xfrm>
+        </p:spPr>
+        <p:txBody>
+          <a:bodyPr wrap="none" anchor="ctr">
+            <a:normAutofit/>
+          </a:bodyPr>
+          <a:lstStyle/>
+          <a:p>
+            <a:pPr>
+              <a:lnSpc>
+                <a:spcPct val="90000"/>
+              </a:lnSpc>
+              <a:spcAft>
+                <a:spcPts val="600"/>
+              </a:spcAft>
+            </a:pPr>
+            <a:r>
+              <a:rPr lang="en-US"/>
+              <a:t>Corbin Ferguson</a:t>
+            </a:r>
+          </a:p>
+        </p:txBody>
+      </p:sp>
+      <p:sp>
+        <p:nvSpPr>
+          <p:cNvPr id="7" name="Slide Number Placeholder 6">
             <a:extLst>
-              <a:ext uri="{28A0092B-C50C-407E-A947-70E740481C1C}">
-                <a14:useLocalDpi xmlns:a14="http://schemas.microsoft.com/office/drawing/2010/main" val="0"/>
+              <a:ext uri="{FF2B5EF4-FFF2-40B4-BE49-F238E27FC236}">
+                <a16:creationId xmlns:a16="http://schemas.microsoft.com/office/drawing/2014/main" id="{3583879C-95E5-7299-C98A-2B7D0B63F807}"/>
               </a:ext>
             </a:extLst>
-          </a:blip>
-          <a:srcRect r="7667"/>
-          <a:stretch>
-            <a:fillRect/>
-          </a:stretch>
-        </p:blipFill>
-        <p:spPr bwMode="auto">
+          </p:cNvPr>
+          <p:cNvSpPr>
+            <a:spLocks noGrp="1"/>
+          </p:cNvSpPr>
+          <p:nvPr>
+            <p:ph type="sldNum" sz="quarter" idx="20"/>
+          </p:nvPr>
+        </p:nvSpPr>
+        <p:spPr>
           <a:xfrm>
-            <a:off x="82103" y="1129116"/>
-            <a:ext cx="6156773" cy="4734269"/>
+            <a:off x="1633051" y="6469380"/>
+            <a:ext cx="571500" cy="180000"/>
           </a:xfrm>
-          <a:prstGeom prst="rect">
-            <a:avLst/>
-          </a:prstGeom>
-          <a:noFill/>
-          <a:extLst>
-            <a:ext uri="{909E8E84-426E-40DD-AFC4-6F175D3DCCD1}">
-              <a14:hiddenFill xmlns:a14="http://schemas.microsoft.com/office/drawing/2010/main">
-                <a:solidFill>
-                  <a:srgbClr val="FFFFFF"/>
-                </a:solidFill>
-              </a14:hiddenFill>
-            </a:ext>
-          </a:extLst>
         </p:spPr>
-      </p:pic>
+        <p:txBody>
+          <a:bodyPr wrap="none" anchor="ctr">
+            <a:normAutofit/>
+          </a:bodyPr>
+          <a:lstStyle/>
+          <a:p>
+            <a:pPr>
+              <a:lnSpc>
+                <a:spcPct val="90000"/>
+              </a:lnSpc>
+              <a:spcAft>
+                <a:spcPts val="600"/>
+              </a:spcAft>
+            </a:pPr>
+            <a:r>
+              <a:rPr lang="en-US"/>
+              <a:t>Slide </a:t>
+            </a:r>
+            <a:fld id="{C6F8E2D1-BFA0-484A-B7F1-E348F2594759}" type="slidenum">
+              <a:rPr lang="en-US" smtClean="0"/>
+              <a:pPr>
+                <a:lnSpc>
+                  <a:spcPct val="90000"/>
+                </a:lnSpc>
+                <a:spcAft>
+                  <a:spcPts val="600"/>
+                </a:spcAft>
+              </a:pPr>
+              <a:t>8</a:t>
+            </a:fld>
+            <a:endParaRPr lang="en-US"/>
+          </a:p>
+        </p:txBody>
+      </p:sp>
+      <p:sp>
+        <p:nvSpPr>
+          <p:cNvPr id="4" name="Date Placeholder 3">
+            <a:extLst>
+              <a:ext uri="{FF2B5EF4-FFF2-40B4-BE49-F238E27FC236}">
+                <a16:creationId xmlns:a16="http://schemas.microsoft.com/office/drawing/2014/main" id="{6F1C84BC-19BE-D2D3-DB6B-179BB01EE861}"/>
+              </a:ext>
+            </a:extLst>
+          </p:cNvPr>
+          <p:cNvSpPr>
+            <a:spLocks noGrp="1"/>
+          </p:cNvSpPr>
+          <p:nvPr>
+            <p:ph type="dt" sz="half" idx="21"/>
+          </p:nvPr>
+        </p:nvSpPr>
+        <p:spPr>
+          <a:xfrm>
+            <a:off x="334963" y="194736"/>
+            <a:ext cx="9674225" cy="180000"/>
+          </a:xfrm>
+        </p:spPr>
+        <p:txBody>
+          <a:bodyPr wrap="none" anchor="t">
+            <a:normAutofit/>
+          </a:bodyPr>
+          <a:lstStyle/>
+          <a:p>
+            <a:pPr>
+              <a:lnSpc>
+                <a:spcPct val="90000"/>
+              </a:lnSpc>
+              <a:spcAft>
+                <a:spcPts val="600"/>
+              </a:spcAft>
+            </a:pPr>
+            <a:r>
+              <a:rPr lang="en-US"/>
+              <a:t>L5X Automation Build Tool</a:t>
+            </a:r>
+          </a:p>
+        </p:txBody>
+      </p:sp>
+      <p:sp>
+        <p:nvSpPr>
+          <p:cNvPr id="2" name="Title 1">
+            <a:extLst>
+              <a:ext uri="{FF2B5EF4-FFF2-40B4-BE49-F238E27FC236}">
+                <a16:creationId xmlns:a16="http://schemas.microsoft.com/office/drawing/2014/main" id="{07BCF97A-6A5E-DA70-0A21-4FF0D5A9B2D1}"/>
+              </a:ext>
+            </a:extLst>
+          </p:cNvPr>
+          <p:cNvSpPr>
+            <a:spLocks noGrp="1"/>
+          </p:cNvSpPr>
+          <p:nvPr>
+            <p:ph type="title"/>
+          </p:nvPr>
+        </p:nvSpPr>
+        <p:spPr>
+          <a:xfrm>
+            <a:off x="334963" y="620690"/>
+            <a:ext cx="11522075" cy="360041"/>
+          </a:xfrm>
+        </p:spPr>
+        <p:txBody>
+          <a:bodyPr wrap="none" anchor="t">
+            <a:normAutofit/>
+          </a:bodyPr>
+          <a:lstStyle/>
+          <a:p>
+            <a:r>
+              <a:rPr lang="en-US" dirty="0"/>
+              <a:t>Class Diagram</a:t>
+            </a:r>
+          </a:p>
+        </p:txBody>
+      </p:sp>
     </p:spTree>
     <p:extLst>
       <p:ext uri="{BB962C8B-B14F-4D97-AF65-F5344CB8AC3E}">
-        <p14:creationId xmlns:p14="http://schemas.microsoft.com/office/powerpoint/2010/main" val="1350697150"/>
+        <p14:creationId xmlns:p14="http://schemas.microsoft.com/office/powerpoint/2010/main" val="2077614573"/>
       </p:ext>
     </p:extLst>
   </p:cSld>
@@ -21450,7 +23770,7 @@
         <p:cNvPr id="1" name="">
           <a:extLst>
             <a:ext uri="{FF2B5EF4-FFF2-40B4-BE49-F238E27FC236}">
-              <a16:creationId xmlns:a16="http://schemas.microsoft.com/office/drawing/2014/main" id="{EF9DF529-63FE-ADF8-53ED-6BE7FB507424}"/>
+              <a16:creationId xmlns:a16="http://schemas.microsoft.com/office/drawing/2014/main" id="{B031D0FB-813C-A1A9-95BF-F0A18A2C1086}"/>
             </a:ext>
           </a:extLst>
         </p:cNvPr>
@@ -21465,228 +23785,218 @@
           <a:chExt cx="0" cy="0"/>
         </a:xfrm>
       </p:grpSpPr>
-      <p:sp>
-        <p:nvSpPr>
-          <p:cNvPr id="2" name="Title 1">
+      <p:pic>
+        <p:nvPicPr>
+          <p:cNvPr id="9" name="Picture 8">
             <a:extLst>
               <a:ext uri="{FF2B5EF4-FFF2-40B4-BE49-F238E27FC236}">
-                <a16:creationId xmlns:a16="http://schemas.microsoft.com/office/drawing/2014/main" id="{1BEC76E2-5D10-E119-28DF-87EA10623968}"/>
-              </a:ext>
-            </a:extLst>
-          </p:cNvPr>
-          <p:cNvSpPr>
-            <a:spLocks noGrp="1"/>
-          </p:cNvSpPr>
-          <p:nvPr>
-            <p:ph type="title"/>
-          </p:nvPr>
-        </p:nvSpPr>
-        <p:spPr>
-          <a:xfrm>
-            <a:off x="334963" y="620690"/>
-            <a:ext cx="7018337" cy="360041"/>
-          </a:xfrm>
-        </p:spPr>
-        <p:txBody>
-          <a:bodyPr/>
-          <a:lstStyle/>
-          <a:p>
-            <a:r>
-              <a:rPr lang="en-US" dirty="0"/>
-              <a:t>Element Editing Sequences Charts</a:t>
-            </a:r>
-          </a:p>
-        </p:txBody>
-      </p:sp>
-      <p:sp>
-        <p:nvSpPr>
-          <p:cNvPr id="4" name="Date Placeholder 3">
-            <a:extLst>
-              <a:ext uri="{FF2B5EF4-FFF2-40B4-BE49-F238E27FC236}">
-                <a16:creationId xmlns:a16="http://schemas.microsoft.com/office/drawing/2014/main" id="{4AB04ED2-D7AC-3763-1039-630C099F3A4C}"/>
-              </a:ext>
-            </a:extLst>
-          </p:cNvPr>
-          <p:cNvSpPr>
-            <a:spLocks noGrp="1"/>
-          </p:cNvSpPr>
-          <p:nvPr>
-            <p:ph type="dt" sz="half" idx="10"/>
-          </p:nvPr>
-        </p:nvSpPr>
-        <p:spPr/>
-        <p:txBody>
-          <a:bodyPr/>
-          <a:lstStyle/>
-          <a:p>
-            <a:r>
-              <a:rPr lang="en-US"/>
-              <a:t>L5X Automation Build Tool</a:t>
-            </a:r>
-            <a:endParaRPr lang="en-US" dirty="0"/>
-          </a:p>
-        </p:txBody>
-      </p:sp>
-      <p:sp>
-        <p:nvSpPr>
-          <p:cNvPr id="7" name="Slide Number Placeholder 6">
-            <a:extLst>
-              <a:ext uri="{FF2B5EF4-FFF2-40B4-BE49-F238E27FC236}">
-                <a16:creationId xmlns:a16="http://schemas.microsoft.com/office/drawing/2014/main" id="{FA5C2B7C-90AB-FD77-3161-D3654154603E}"/>
-              </a:ext>
-            </a:extLst>
-          </p:cNvPr>
-          <p:cNvSpPr>
-            <a:spLocks noGrp="1"/>
-          </p:cNvSpPr>
-          <p:nvPr>
-            <p:ph type="sldNum" sz="quarter" idx="12"/>
-          </p:nvPr>
-        </p:nvSpPr>
-        <p:spPr/>
-        <p:txBody>
-          <a:bodyPr/>
-          <a:lstStyle/>
-          <a:p>
-            <a:r>
-              <a:rPr lang="en-US"/>
-              <a:t>Slide </a:t>
-            </a:r>
-            <a:fld id="{599786A8-973E-49A8-9C43-0BE71F98A081}" type="slidenum">
-              <a:rPr lang="en-US" smtClean="0"/>
-              <a:t>9</a:t>
-            </a:fld>
-            <a:endParaRPr lang="en-US" dirty="0"/>
-          </a:p>
-        </p:txBody>
-      </p:sp>
-      <p:sp>
-        <p:nvSpPr>
-          <p:cNvPr id="8" name="Footer Placeholder 7">
-            <a:extLst>
-              <a:ext uri="{FF2B5EF4-FFF2-40B4-BE49-F238E27FC236}">
-                <a16:creationId xmlns:a16="http://schemas.microsoft.com/office/drawing/2014/main" id="{C2F6AD5B-E994-0A83-78C8-94E2F6F39074}"/>
-              </a:ext>
-            </a:extLst>
-          </p:cNvPr>
-          <p:cNvSpPr>
-            <a:spLocks noGrp="1"/>
-          </p:cNvSpPr>
-          <p:nvPr>
-            <p:ph type="ftr" sz="quarter" idx="11"/>
-          </p:nvPr>
-        </p:nvSpPr>
-        <p:spPr/>
-        <p:txBody>
-          <a:bodyPr/>
-          <a:lstStyle/>
-          <a:p>
-            <a:r>
-              <a:rPr lang="en-US"/>
-              <a:t>Corbin Ferguson</a:t>
-            </a:r>
-            <a:endParaRPr lang="en-US" dirty="0"/>
-          </a:p>
-        </p:txBody>
-      </p:sp>
-      <p:pic>
-        <p:nvPicPr>
-          <p:cNvPr id="4100" name="Picture 4">
-            <a:extLst>
-              <a:ext uri="{FF2B5EF4-FFF2-40B4-BE49-F238E27FC236}">
-                <a16:creationId xmlns:a16="http://schemas.microsoft.com/office/drawing/2014/main" id="{BB53261F-4A38-01BF-14A0-AC05F4918629}"/>
+                <a16:creationId xmlns:a16="http://schemas.microsoft.com/office/drawing/2014/main" id="{A889D74E-A641-8FCA-9F55-93231CDB546D}"/>
               </a:ext>
             </a:extLst>
           </p:cNvPr>
           <p:cNvPicPr>
-            <a:picLocks noChangeAspect="1" noChangeArrowheads="1"/>
+            <a:picLocks noChangeAspect="1"/>
           </p:cNvPicPr>
           <p:nvPr/>
         </p:nvPicPr>
         <p:blipFill>
-          <a:blip r:embed="rId2" cstate="print">
-            <a:extLst>
-              <a:ext uri="{28A0092B-C50C-407E-A947-70E740481C1C}">
-                <a14:useLocalDpi xmlns:a14="http://schemas.microsoft.com/office/drawing/2010/main" val="0"/>
-              </a:ext>
-            </a:extLst>
-          </a:blip>
-          <a:srcRect/>
+          <a:blip r:embed="rId2"/>
           <a:stretch>
             <a:fillRect/>
           </a:stretch>
         </p:blipFill>
-        <p:spPr bwMode="auto">
+        <p:spPr>
           <a:xfrm>
-            <a:off x="5660591" y="194736"/>
-            <a:ext cx="6482994" cy="5720289"/>
+            <a:off x="1176290" y="1160462"/>
+            <a:ext cx="9839419" cy="5113337"/>
           </a:xfrm>
           <a:prstGeom prst="rect">
             <a:avLst/>
           </a:prstGeom>
           <a:noFill/>
-          <a:extLst>
-            <a:ext uri="{909E8E84-426E-40DD-AFC4-6F175D3DCCD1}">
-              <a14:hiddenFill xmlns:a14="http://schemas.microsoft.com/office/drawing/2010/main">
-                <a:solidFill>
-                  <a:srgbClr val="FFFFFF"/>
-                </a:solidFill>
-              </a14:hiddenFill>
-            </a:ext>
-          </a:extLst>
         </p:spPr>
       </p:pic>
-      <p:pic>
-        <p:nvPicPr>
-          <p:cNvPr id="4102" name="Picture 6">
+      <p:sp>
+        <p:nvSpPr>
+          <p:cNvPr id="8" name="Footer Placeholder 7">
             <a:extLst>
               <a:ext uri="{FF2B5EF4-FFF2-40B4-BE49-F238E27FC236}">
-                <a16:creationId xmlns:a16="http://schemas.microsoft.com/office/drawing/2014/main" id="{1369CFC5-7E6D-03BD-C62A-74FBF0D2D610}"/>
+                <a16:creationId xmlns:a16="http://schemas.microsoft.com/office/drawing/2014/main" id="{71C973FB-1860-D33D-FFB0-E373255B1325}"/>
               </a:ext>
             </a:extLst>
           </p:cNvPr>
-          <p:cNvPicPr>
-            <a:picLocks noChangeAspect="1" noChangeArrowheads="1"/>
-          </p:cNvPicPr>
-          <p:nvPr/>
-        </p:nvPicPr>
-        <p:blipFill>
-          <a:blip r:embed="rId3" cstate="print">
+          <p:cNvSpPr>
+            <a:spLocks noGrp="1"/>
+          </p:cNvSpPr>
+          <p:nvPr>
+            <p:ph type="ftr" sz="quarter" idx="19"/>
+          </p:nvPr>
+        </p:nvSpPr>
+        <p:spPr>
+          <a:xfrm>
+            <a:off x="4086351" y="6469380"/>
+            <a:ext cx="1130300" cy="180000"/>
+          </a:xfrm>
+        </p:spPr>
+        <p:txBody>
+          <a:bodyPr wrap="none" anchor="ctr">
+            <a:normAutofit/>
+          </a:bodyPr>
+          <a:lstStyle/>
+          <a:p>
+            <a:pPr>
+              <a:lnSpc>
+                <a:spcPct val="90000"/>
+              </a:lnSpc>
+              <a:spcAft>
+                <a:spcPts val="600"/>
+              </a:spcAft>
+            </a:pPr>
+            <a:r>
+              <a:rPr lang="en-US"/>
+              <a:t>Corbin Ferguson</a:t>
+            </a:r>
+          </a:p>
+        </p:txBody>
+      </p:sp>
+      <p:sp>
+        <p:nvSpPr>
+          <p:cNvPr id="7" name="Slide Number Placeholder 6">
             <a:extLst>
-              <a:ext uri="{28A0092B-C50C-407E-A947-70E740481C1C}">
-                <a14:useLocalDpi xmlns:a14="http://schemas.microsoft.com/office/drawing/2010/main" val="0"/>
+              <a:ext uri="{FF2B5EF4-FFF2-40B4-BE49-F238E27FC236}">
+                <a16:creationId xmlns:a16="http://schemas.microsoft.com/office/drawing/2014/main" id="{FF861633-550D-9192-7E16-88623F1FDD40}"/>
               </a:ext>
             </a:extLst>
-          </a:blip>
-          <a:srcRect/>
-          <a:stretch>
-            <a:fillRect/>
-          </a:stretch>
-        </p:blipFill>
-        <p:spPr bwMode="auto">
+          </p:cNvPr>
+          <p:cNvSpPr>
+            <a:spLocks noGrp="1"/>
+          </p:cNvSpPr>
+          <p:nvPr>
+            <p:ph type="sldNum" sz="quarter" idx="20"/>
+          </p:nvPr>
+        </p:nvSpPr>
+        <p:spPr>
           <a:xfrm>
-            <a:off x="48416" y="1482391"/>
-            <a:ext cx="5677702" cy="3727784"/>
+            <a:off x="1633051" y="6469380"/>
+            <a:ext cx="571500" cy="180000"/>
           </a:xfrm>
-          <a:prstGeom prst="rect">
-            <a:avLst/>
-          </a:prstGeom>
-          <a:noFill/>
-          <a:extLst>
-            <a:ext uri="{909E8E84-426E-40DD-AFC4-6F175D3DCCD1}">
-              <a14:hiddenFill xmlns:a14="http://schemas.microsoft.com/office/drawing/2010/main">
-                <a:solidFill>
-                  <a:srgbClr val="FFFFFF"/>
-                </a:solidFill>
-              </a14:hiddenFill>
-            </a:ext>
-          </a:extLst>
         </p:spPr>
-      </p:pic>
+        <p:txBody>
+          <a:bodyPr wrap="none" anchor="ctr">
+            <a:normAutofit/>
+          </a:bodyPr>
+          <a:lstStyle/>
+          <a:p>
+            <a:pPr>
+              <a:lnSpc>
+                <a:spcPct val="90000"/>
+              </a:lnSpc>
+              <a:spcAft>
+                <a:spcPts val="600"/>
+              </a:spcAft>
+            </a:pPr>
+            <a:r>
+              <a:rPr lang="en-US"/>
+              <a:t>Slide </a:t>
+            </a:r>
+            <a:fld id="{C6F8E2D1-BFA0-484A-B7F1-E348F2594759}" type="slidenum">
+              <a:rPr lang="en-US" smtClean="0"/>
+              <a:pPr>
+                <a:lnSpc>
+                  <a:spcPct val="90000"/>
+                </a:lnSpc>
+                <a:spcAft>
+                  <a:spcPts val="600"/>
+                </a:spcAft>
+              </a:pPr>
+              <a:t>9</a:t>
+            </a:fld>
+            <a:endParaRPr lang="en-US"/>
+          </a:p>
+        </p:txBody>
+      </p:sp>
+      <p:sp>
+        <p:nvSpPr>
+          <p:cNvPr id="4" name="Date Placeholder 3">
+            <a:extLst>
+              <a:ext uri="{FF2B5EF4-FFF2-40B4-BE49-F238E27FC236}">
+                <a16:creationId xmlns:a16="http://schemas.microsoft.com/office/drawing/2014/main" id="{5D0DCAB8-9A4F-6068-74B2-D5C8356B650C}"/>
+              </a:ext>
+            </a:extLst>
+          </p:cNvPr>
+          <p:cNvSpPr>
+            <a:spLocks noGrp="1"/>
+          </p:cNvSpPr>
+          <p:nvPr>
+            <p:ph type="dt" sz="half" idx="21"/>
+          </p:nvPr>
+        </p:nvSpPr>
+        <p:spPr>
+          <a:xfrm>
+            <a:off x="334963" y="194736"/>
+            <a:ext cx="9674225" cy="180000"/>
+          </a:xfrm>
+        </p:spPr>
+        <p:txBody>
+          <a:bodyPr wrap="none" anchor="t">
+            <a:normAutofit/>
+          </a:bodyPr>
+          <a:lstStyle/>
+          <a:p>
+            <a:pPr>
+              <a:lnSpc>
+                <a:spcPct val="90000"/>
+              </a:lnSpc>
+              <a:spcAft>
+                <a:spcPts val="600"/>
+              </a:spcAft>
+            </a:pPr>
+            <a:r>
+              <a:rPr lang="en-US"/>
+              <a:t>L5X Automation Build Tool</a:t>
+            </a:r>
+          </a:p>
+        </p:txBody>
+      </p:sp>
+      <p:sp>
+        <p:nvSpPr>
+          <p:cNvPr id="2" name="Title 1">
+            <a:extLst>
+              <a:ext uri="{FF2B5EF4-FFF2-40B4-BE49-F238E27FC236}">
+                <a16:creationId xmlns:a16="http://schemas.microsoft.com/office/drawing/2014/main" id="{5EBCB58C-1369-EDD7-5D5E-7C1E1415DB2E}"/>
+              </a:ext>
+            </a:extLst>
+          </p:cNvPr>
+          <p:cNvSpPr>
+            <a:spLocks noGrp="1"/>
+          </p:cNvSpPr>
+          <p:nvPr>
+            <p:ph type="title"/>
+          </p:nvPr>
+        </p:nvSpPr>
+        <p:spPr>
+          <a:xfrm>
+            <a:off x="334963" y="620690"/>
+            <a:ext cx="11522075" cy="360041"/>
+          </a:xfrm>
+        </p:spPr>
+        <p:txBody>
+          <a:bodyPr wrap="none" anchor="t">
+            <a:normAutofit/>
+          </a:bodyPr>
+          <a:lstStyle/>
+          <a:p>
+            <a:r>
+              <a:rPr lang="en-US" dirty="0"/>
+              <a:t>Class Diagram Cont.</a:t>
+            </a:r>
+          </a:p>
+        </p:txBody>
+      </p:sp>
     </p:spTree>
     <p:extLst>
       <p:ext uri="{BB962C8B-B14F-4D97-AF65-F5344CB8AC3E}">
-        <p14:creationId xmlns:p14="http://schemas.microsoft.com/office/powerpoint/2010/main" val="3038692604"/>
+        <p14:creationId xmlns:p14="http://schemas.microsoft.com/office/powerpoint/2010/main" val="1692918807"/>
       </p:ext>
     </p:extLst>
   </p:cSld>

</xml_diff>

<commit_message>
animations for ppt :)
</commit_message>
<xml_diff>
--- a/Thesis Writing Documents/Project Development.pptx
+++ b/Thesis Writing Documents/Project Development.pptx
@@ -5,10 +5,10 @@
     <p:sldMasterId id="2147483648" r:id="rId5"/>
   </p:sldMasterIdLst>
   <p:notesMasterIdLst>
-    <p:notesMasterId r:id="rId25"/>
+    <p:notesMasterId r:id="rId30"/>
   </p:notesMasterIdLst>
   <p:handoutMasterIdLst>
-    <p:handoutMasterId r:id="rId26"/>
+    <p:handoutMasterId r:id="rId31"/>
   </p:handoutMasterIdLst>
   <p:sldIdLst>
     <p:sldId id="256" r:id="rId6"/>
@@ -17,24 +17,29 @@
     <p:sldId id="2146848304" r:id="rId9"/>
     <p:sldId id="2146848305" r:id="rId10"/>
     <p:sldId id="2146848306" r:id="rId11"/>
-    <p:sldId id="2146848303" r:id="rId12"/>
-    <p:sldId id="2146848316" r:id="rId13"/>
-    <p:sldId id="2146848317" r:id="rId14"/>
-    <p:sldId id="2146848307" r:id="rId15"/>
-    <p:sldId id="2146848308" r:id="rId16"/>
-    <p:sldId id="2146848309" r:id="rId17"/>
-    <p:sldId id="2146848311" r:id="rId18"/>
-    <p:sldId id="2146848310" r:id="rId19"/>
-    <p:sldId id="2146848300" r:id="rId20"/>
-    <p:sldId id="2146848312" r:id="rId21"/>
-    <p:sldId id="2146848314" r:id="rId22"/>
-    <p:sldId id="2146848313" r:id="rId23"/>
-    <p:sldId id="2146848315" r:id="rId24"/>
+    <p:sldId id="2146848319" r:id="rId12"/>
+    <p:sldId id="2146848322" r:id="rId13"/>
+    <p:sldId id="2146848323" r:id="rId14"/>
+    <p:sldId id="2146848318" r:id="rId15"/>
+    <p:sldId id="2146848324" r:id="rId16"/>
+    <p:sldId id="2146848325" r:id="rId17"/>
+    <p:sldId id="2146848316" r:id="rId18"/>
+    <p:sldId id="2146848317" r:id="rId19"/>
+    <p:sldId id="2146848307" r:id="rId20"/>
+    <p:sldId id="2146848308" r:id="rId21"/>
+    <p:sldId id="2146848309" r:id="rId22"/>
+    <p:sldId id="2146848311" r:id="rId23"/>
+    <p:sldId id="2146848310" r:id="rId24"/>
+    <p:sldId id="2146848300" r:id="rId25"/>
+    <p:sldId id="2146848312" r:id="rId26"/>
+    <p:sldId id="2146848314" r:id="rId27"/>
+    <p:sldId id="2146848313" r:id="rId28"/>
+    <p:sldId id="2146848315" r:id="rId29"/>
   </p:sldIdLst>
   <p:sldSz cx="12192000" cy="6858000"/>
   <p:notesSz cx="6800850" cy="9926638"/>
   <p:custDataLst>
-    <p:tags r:id="rId27"/>
+    <p:tags r:id="rId32"/>
   </p:custDataLst>
   <p:defaultTextStyle>
     <a:defPPr>
@@ -213,7 +218,7 @@
 <file path=ppt/revisionInfo.xml><?xml version="1.0" encoding="utf-8"?>
 <p1510:revInfo xmlns:a="http://schemas.openxmlformats.org/drawingml/2006/main" xmlns:r="http://schemas.openxmlformats.org/officeDocument/2006/relationships" xmlns:p1510="http://schemas.microsoft.com/office/powerpoint/2015/10/main">
   <p1510:revLst>
-    <p1510:client id="{F0E03B4B-CC56-43F1-8F18-BCA697229170}" v="271" dt="2026-03-16T18:23:33.003"/>
+    <p1510:client id="{F0E03B4B-CC56-43F1-8F18-BCA697229170}" v="436" dt="2026-03-16T21:03:18.013"/>
   </p1510:revLst>
 </p1510:revInfo>
 </file>
@@ -222,8 +227,8 @@
 <pc:chgInfo xmlns:a="http://schemas.openxmlformats.org/drawingml/2006/main" xmlns:r="http://schemas.openxmlformats.org/officeDocument/2006/relationships" xmlns:ac="http://schemas.microsoft.com/office/drawing/2013/main/command" xmlns:pc="http://schemas.microsoft.com/office/powerpoint/2013/main/command">
   <pc:docChgLst>
     <pc:chgData name="Corbin Ferguson" userId="34a864e2-e65e-4cb2-823c-dc28f73f0e40" providerId="ADAL" clId="{8D2D96CF-1319-4CCC-9EA9-073445628049}"/>
-    <pc:docChg chg="undo custSel addSld modSld sldOrd">
-      <pc:chgData name="Corbin Ferguson" userId="34a864e2-e65e-4cb2-823c-dc28f73f0e40" providerId="ADAL" clId="{8D2D96CF-1319-4CCC-9EA9-073445628049}" dt="2026-03-16T18:25:23.793" v="1576" actId="14100"/>
+    <pc:docChg chg="undo redo custSel addSld delSld modSld sldOrd">
+      <pc:chgData name="Corbin Ferguson" userId="34a864e2-e65e-4cb2-823c-dc28f73f0e40" providerId="ADAL" clId="{8D2D96CF-1319-4CCC-9EA9-073445628049}" dt="2026-03-16T21:03:53.279" v="2075" actId="1036"/>
       <pc:docMkLst>
         <pc:docMk/>
       </pc:docMkLst>
@@ -288,14 +293,30 @@
           </ac:spMkLst>
         </pc:spChg>
       </pc:sldChg>
-      <pc:sldChg chg="modSp mod">
-        <pc:chgData name="Corbin Ferguson" userId="34a864e2-e65e-4cb2-823c-dc28f73f0e40" providerId="ADAL" clId="{8D2D96CF-1319-4CCC-9EA9-073445628049}" dt="2026-03-16T18:25:23.793" v="1576" actId="14100"/>
+      <pc:sldChg chg="addSp delSp modSp del mod delAnim modAnim">
+        <pc:chgData name="Corbin Ferguson" userId="34a864e2-e65e-4cb2-823c-dc28f73f0e40" providerId="ADAL" clId="{8D2D96CF-1319-4CCC-9EA9-073445628049}" dt="2026-03-16T20:32:39.784" v="1827" actId="2696"/>
         <pc:sldMkLst>
           <pc:docMk/>
           <pc:sldMk cId="1979168377" sldId="2146848303"/>
         </pc:sldMkLst>
-        <pc:picChg chg="mod">
-          <ac:chgData name="Corbin Ferguson" userId="34a864e2-e65e-4cb2-823c-dc28f73f0e40" providerId="ADAL" clId="{8D2D96CF-1319-4CCC-9EA9-073445628049}" dt="2026-03-16T18:25:23.793" v="1576" actId="14100"/>
+        <pc:spChg chg="add del mod">
+          <ac:chgData name="Corbin Ferguson" userId="34a864e2-e65e-4cb2-823c-dc28f73f0e40" providerId="ADAL" clId="{8D2D96CF-1319-4CCC-9EA9-073445628049}" dt="2026-03-16T20:32:17.428" v="1824" actId="478"/>
+          <ac:spMkLst>
+            <pc:docMk/>
+            <pc:sldMk cId="1979168377" sldId="2146848303"/>
+            <ac:spMk id="3" creationId="{7E1F48FE-02C8-5BA2-C31C-33633F3769D0}"/>
+          </ac:spMkLst>
+        </pc:spChg>
+        <pc:spChg chg="add del mod ord">
+          <ac:chgData name="Corbin Ferguson" userId="34a864e2-e65e-4cb2-823c-dc28f73f0e40" providerId="ADAL" clId="{8D2D96CF-1319-4CCC-9EA9-073445628049}" dt="2026-03-16T20:01:48.402" v="1596" actId="11529"/>
+          <ac:spMkLst>
+            <pc:docMk/>
+            <pc:sldMk cId="1979168377" sldId="2146848303"/>
+            <ac:spMk id="5" creationId="{B39D629C-D470-8907-C1E4-DDBFE74A2B19}"/>
+          </ac:spMkLst>
+        </pc:spChg>
+        <pc:picChg chg="add del mod modCrop">
+          <ac:chgData name="Corbin Ferguson" userId="34a864e2-e65e-4cb2-823c-dc28f73f0e40" providerId="ADAL" clId="{8D2D96CF-1319-4CCC-9EA9-073445628049}" dt="2026-03-16T20:32:37.321" v="1826" actId="732"/>
           <ac:picMkLst>
             <pc:docMk/>
             <pc:sldMk cId="1979168377" sldId="2146848303"/>
@@ -1377,6 +1398,430 @@
             <pc:docMk/>
             <pc:sldMk cId="1692918807" sldId="2146848317"/>
             <ac:picMk id="10910" creationId="{5EB4AF2A-E1DF-5181-7810-0E4B05E08A25}"/>
+          </ac:picMkLst>
+        </pc:picChg>
+      </pc:sldChg>
+      <pc:sldChg chg="addSp delSp modSp add mod modTransition delAnim modAnim">
+        <pc:chgData name="Corbin Ferguson" userId="34a864e2-e65e-4cb2-823c-dc28f73f0e40" providerId="ADAL" clId="{8D2D96CF-1319-4CCC-9EA9-073445628049}" dt="2026-03-16T20:58:06.345" v="2029" actId="1035"/>
+        <pc:sldMkLst>
+          <pc:docMk/>
+          <pc:sldMk cId="3831013115" sldId="2146848318"/>
+        </pc:sldMkLst>
+        <pc:spChg chg="mod">
+          <ac:chgData name="Corbin Ferguson" userId="34a864e2-e65e-4cb2-823c-dc28f73f0e40" providerId="ADAL" clId="{8D2D96CF-1319-4CCC-9EA9-073445628049}" dt="2026-03-16T20:06:27.829" v="1625" actId="20577"/>
+          <ac:spMkLst>
+            <pc:docMk/>
+            <pc:sldMk cId="3831013115" sldId="2146848318"/>
+            <ac:spMk id="2" creationId="{C6FD6CC9-4051-8C8E-6F53-6558CC8D4A8F}"/>
+          </ac:spMkLst>
+        </pc:spChg>
+        <pc:spChg chg="del">
+          <ac:chgData name="Corbin Ferguson" userId="34a864e2-e65e-4cb2-823c-dc28f73f0e40" providerId="ADAL" clId="{8D2D96CF-1319-4CCC-9EA9-073445628049}" dt="2026-03-16T20:05:05.817" v="1598" actId="478"/>
+          <ac:spMkLst>
+            <pc:docMk/>
+            <pc:sldMk cId="3831013115" sldId="2146848318"/>
+            <ac:spMk id="3" creationId="{FA7BB05D-74E8-FD1A-F596-C0FBAB1002C2}"/>
+          </ac:spMkLst>
+        </pc:spChg>
+        <pc:spChg chg="add del mod">
+          <ac:chgData name="Corbin Ferguson" userId="34a864e2-e65e-4cb2-823c-dc28f73f0e40" providerId="ADAL" clId="{8D2D96CF-1319-4CCC-9EA9-073445628049}" dt="2026-03-16T20:38:42.029" v="1914" actId="478"/>
+          <ac:spMkLst>
+            <pc:docMk/>
+            <pc:sldMk cId="3831013115" sldId="2146848318"/>
+            <ac:spMk id="9" creationId="{A9535BEC-4949-27A6-BC75-04F113251855}"/>
+          </ac:spMkLst>
+        </pc:spChg>
+        <pc:spChg chg="add mod">
+          <ac:chgData name="Corbin Ferguson" userId="34a864e2-e65e-4cb2-823c-dc28f73f0e40" providerId="ADAL" clId="{8D2D96CF-1319-4CCC-9EA9-073445628049}" dt="2026-03-16T20:58:06.345" v="2029" actId="1035"/>
+          <ac:spMkLst>
+            <pc:docMk/>
+            <pc:sldMk cId="3831013115" sldId="2146848318"/>
+            <ac:spMk id="11" creationId="{C63E6493-7963-69F9-0E49-FBFB34C98CC6}"/>
+          </ac:spMkLst>
+        </pc:spChg>
+        <pc:picChg chg="add mod">
+          <ac:chgData name="Corbin Ferguson" userId="34a864e2-e65e-4cb2-823c-dc28f73f0e40" providerId="ADAL" clId="{8D2D96CF-1319-4CCC-9EA9-073445628049}" dt="2026-03-16T20:34:20.415" v="1854"/>
+          <ac:picMkLst>
+            <pc:docMk/>
+            <pc:sldMk cId="3831013115" sldId="2146848318"/>
+            <ac:picMk id="5" creationId="{D3A01971-F695-BDED-3EBA-C707EA559E2A}"/>
+          </ac:picMkLst>
+        </pc:picChg>
+        <pc:picChg chg="add del mod ord modVis">
+          <ac:chgData name="Corbin Ferguson" userId="34a864e2-e65e-4cb2-823c-dc28f73f0e40" providerId="ADAL" clId="{8D2D96CF-1319-4CCC-9EA9-073445628049}" dt="2026-03-16T20:48:04.603" v="1961" actId="478"/>
+          <ac:picMkLst>
+            <pc:docMk/>
+            <pc:sldMk cId="3831013115" sldId="2146848318"/>
+            <ac:picMk id="6" creationId="{A90F5D03-9F6A-ED0B-1CF7-9BD05CC11130}"/>
+          </ac:picMkLst>
+        </pc:picChg>
+        <pc:picChg chg="add mod ord modCrop">
+          <ac:chgData name="Corbin Ferguson" userId="34a864e2-e65e-4cb2-823c-dc28f73f0e40" providerId="ADAL" clId="{8D2D96CF-1319-4CCC-9EA9-073445628049}" dt="2026-03-16T20:54:25.304" v="2000" actId="14100"/>
+          <ac:picMkLst>
+            <pc:docMk/>
+            <pc:sldMk cId="3831013115" sldId="2146848318"/>
+            <ac:picMk id="10" creationId="{36552AD4-E539-C4C4-F016-02E1B6D7EFCF}"/>
+          </ac:picMkLst>
+        </pc:picChg>
+        <pc:picChg chg="mod ord modVis modCrop">
+          <ac:chgData name="Corbin Ferguson" userId="34a864e2-e65e-4cb2-823c-dc28f73f0e40" providerId="ADAL" clId="{8D2D96CF-1319-4CCC-9EA9-073445628049}" dt="2026-03-16T20:58:06.345" v="2029" actId="1035"/>
+          <ac:picMkLst>
+            <pc:docMk/>
+            <pc:sldMk cId="3831013115" sldId="2146848318"/>
+            <ac:picMk id="15" creationId="{5956B2B1-2846-2DBE-61A6-5C404403D377}"/>
+          </ac:picMkLst>
+        </pc:picChg>
+      </pc:sldChg>
+      <pc:sldChg chg="addSp delSp modSp add mod ord modAnim">
+        <pc:chgData name="Corbin Ferguson" userId="34a864e2-e65e-4cb2-823c-dc28f73f0e40" providerId="ADAL" clId="{8D2D96CF-1319-4CCC-9EA9-073445628049}" dt="2026-03-16T20:28:00.671" v="1805"/>
+        <pc:sldMkLst>
+          <pc:docMk/>
+          <pc:sldMk cId="3493033771" sldId="2146848319"/>
+        </pc:sldMkLst>
+        <pc:spChg chg="mod">
+          <ac:chgData name="Corbin Ferguson" userId="34a864e2-e65e-4cb2-823c-dc28f73f0e40" providerId="ADAL" clId="{8D2D96CF-1319-4CCC-9EA9-073445628049}" dt="2026-03-16T20:18:32.158" v="1713" actId="1076"/>
+          <ac:spMkLst>
+            <pc:docMk/>
+            <pc:sldMk cId="3493033771" sldId="2146848319"/>
+            <ac:spMk id="3" creationId="{ED261959-73BE-AC8F-A9DA-6CAEF5E9BB95}"/>
+          </ac:spMkLst>
+        </pc:spChg>
+        <pc:picChg chg="add del mod">
+          <ac:chgData name="Corbin Ferguson" userId="34a864e2-e65e-4cb2-823c-dc28f73f0e40" providerId="ADAL" clId="{8D2D96CF-1319-4CCC-9EA9-073445628049}" dt="2026-03-16T20:16:25.287" v="1699" actId="22"/>
+          <ac:picMkLst>
+            <pc:docMk/>
+            <pc:sldMk cId="3493033771" sldId="2146848319"/>
+            <ac:picMk id="6" creationId="{1B800A62-C9CF-F197-C3C4-1B88AD96D848}"/>
+          </ac:picMkLst>
+        </pc:picChg>
+        <pc:picChg chg="add del">
+          <ac:chgData name="Corbin Ferguson" userId="34a864e2-e65e-4cb2-823c-dc28f73f0e40" providerId="ADAL" clId="{8D2D96CF-1319-4CCC-9EA9-073445628049}" dt="2026-03-16T20:16:25.821" v="1700" actId="478"/>
+          <ac:picMkLst>
+            <pc:docMk/>
+            <pc:sldMk cId="3493033771" sldId="2146848319"/>
+            <ac:picMk id="15" creationId="{D209E713-11DD-16BC-02AC-C8F52F87573B}"/>
+          </ac:picMkLst>
+        </pc:picChg>
+        <pc:picChg chg="add mod">
+          <ac:chgData name="Corbin Ferguson" userId="34a864e2-e65e-4cb2-823c-dc28f73f0e40" providerId="ADAL" clId="{8D2D96CF-1319-4CCC-9EA9-073445628049}" dt="2026-03-16T20:17:35.362" v="1711" actId="962"/>
+          <ac:picMkLst>
+            <pc:docMk/>
+            <pc:sldMk cId="3493033771" sldId="2146848319"/>
+            <ac:picMk id="10242" creationId="{461CD87D-B8E2-EBAC-C16F-E56594D3F499}"/>
+          </ac:picMkLst>
+        </pc:picChg>
+      </pc:sldChg>
+      <pc:sldChg chg="addSp delSp modSp new del mod modTransition modClrScheme chgLayout">
+        <pc:chgData name="Corbin Ferguson" userId="34a864e2-e65e-4cb2-823c-dc28f73f0e40" providerId="ADAL" clId="{8D2D96CF-1319-4CCC-9EA9-073445628049}" dt="2026-03-16T20:23:33.104" v="1770" actId="2696"/>
+        <pc:sldMkLst>
+          <pc:docMk/>
+          <pc:sldMk cId="1273764086" sldId="2146848320"/>
+        </pc:sldMkLst>
+        <pc:spChg chg="mod">
+          <ac:chgData name="Corbin Ferguson" userId="34a864e2-e65e-4cb2-823c-dc28f73f0e40" providerId="ADAL" clId="{8D2D96CF-1319-4CCC-9EA9-073445628049}" dt="2026-03-16T20:08:58.922" v="1661" actId="20577"/>
+          <ac:spMkLst>
+            <pc:docMk/>
+            <pc:sldMk cId="1273764086" sldId="2146848320"/>
+            <ac:spMk id="2" creationId="{3FF556C6-C6F3-4F87-F431-44AF492D1490}"/>
+          </ac:spMkLst>
+        </pc:spChg>
+        <pc:spChg chg="del">
+          <ac:chgData name="Corbin Ferguson" userId="34a864e2-e65e-4cb2-823c-dc28f73f0e40" providerId="ADAL" clId="{8D2D96CF-1319-4CCC-9EA9-073445628049}" dt="2026-03-16T20:07:56.499" v="1635" actId="478"/>
+          <ac:spMkLst>
+            <pc:docMk/>
+            <pc:sldMk cId="1273764086" sldId="2146848320"/>
+            <ac:spMk id="3" creationId="{1CDC32B6-E4A1-267F-8C8F-73F879CA15C1}"/>
+          </ac:spMkLst>
+        </pc:spChg>
+        <pc:spChg chg="mod">
+          <ac:chgData name="Corbin Ferguson" userId="34a864e2-e65e-4cb2-823c-dc28f73f0e40" providerId="ADAL" clId="{8D2D96CF-1319-4CCC-9EA9-073445628049}" dt="2026-03-16T20:08:53.199" v="1652" actId="26606"/>
+          <ac:spMkLst>
+            <pc:docMk/>
+            <pc:sldMk cId="1273764086" sldId="2146848320"/>
+            <ac:spMk id="4" creationId="{CC58F1BF-F4DC-9174-D688-5197602569A5}"/>
+          </ac:spMkLst>
+        </pc:spChg>
+        <pc:spChg chg="mod">
+          <ac:chgData name="Corbin Ferguson" userId="34a864e2-e65e-4cb2-823c-dc28f73f0e40" providerId="ADAL" clId="{8D2D96CF-1319-4CCC-9EA9-073445628049}" dt="2026-03-16T20:08:53.199" v="1652" actId="26606"/>
+          <ac:spMkLst>
+            <pc:docMk/>
+            <pc:sldMk cId="1273764086" sldId="2146848320"/>
+            <ac:spMk id="5" creationId="{C177D47D-26ED-1097-B0B0-8511A0373FCF}"/>
+          </ac:spMkLst>
+        </pc:spChg>
+        <pc:spChg chg="mod">
+          <ac:chgData name="Corbin Ferguson" userId="34a864e2-e65e-4cb2-823c-dc28f73f0e40" providerId="ADAL" clId="{8D2D96CF-1319-4CCC-9EA9-073445628049}" dt="2026-03-16T20:08:53.199" v="1652" actId="26606"/>
+          <ac:spMkLst>
+            <pc:docMk/>
+            <pc:sldMk cId="1273764086" sldId="2146848320"/>
+            <ac:spMk id="6" creationId="{BD2E2879-AE0A-BC28-AA74-F77010345B5C}"/>
+          </ac:spMkLst>
+        </pc:spChg>
+        <pc:spChg chg="del">
+          <ac:chgData name="Corbin Ferguson" userId="34a864e2-e65e-4cb2-823c-dc28f73f0e40" providerId="ADAL" clId="{8D2D96CF-1319-4CCC-9EA9-073445628049}" dt="2026-03-16T20:07:55.485" v="1634" actId="478"/>
+          <ac:spMkLst>
+            <pc:docMk/>
+            <pc:sldMk cId="1273764086" sldId="2146848320"/>
+            <ac:spMk id="7" creationId="{E2E2C671-C5B3-D45A-4830-7022C8A74ABB}"/>
+          </ac:spMkLst>
+        </pc:spChg>
+        <pc:picChg chg="add del mod ord">
+          <ac:chgData name="Corbin Ferguson" userId="34a864e2-e65e-4cb2-823c-dc28f73f0e40" providerId="ADAL" clId="{8D2D96CF-1319-4CCC-9EA9-073445628049}" dt="2026-03-16T20:23:30.407" v="1769" actId="21"/>
+          <ac:picMkLst>
+            <pc:docMk/>
+            <pc:sldMk cId="1273764086" sldId="2146848320"/>
+            <ac:picMk id="9" creationId="{6A2D6E58-7219-5B27-BB56-A33060C076CA}"/>
+          </ac:picMkLst>
+        </pc:picChg>
+      </pc:sldChg>
+      <pc:sldChg chg="addSp delSp modSp add del mod ord modTransition delAnim">
+        <pc:chgData name="Corbin Ferguson" userId="34a864e2-e65e-4cb2-823c-dc28f73f0e40" providerId="ADAL" clId="{8D2D96CF-1319-4CCC-9EA9-073445628049}" dt="2026-03-16T20:31:23.737" v="1820" actId="2696"/>
+        <pc:sldMkLst>
+          <pc:docMk/>
+          <pc:sldMk cId="3845007870" sldId="2146848321"/>
+        </pc:sldMkLst>
+        <pc:spChg chg="del">
+          <ac:chgData name="Corbin Ferguson" userId="34a864e2-e65e-4cb2-823c-dc28f73f0e40" providerId="ADAL" clId="{8D2D96CF-1319-4CCC-9EA9-073445628049}" dt="2026-03-16T20:19:36.941" v="1721" actId="478"/>
+          <ac:spMkLst>
+            <pc:docMk/>
+            <pc:sldMk cId="3845007870" sldId="2146848321"/>
+            <ac:spMk id="3" creationId="{5BBD0DA6-64AC-B620-3CCA-F230B73FC9EC}"/>
+          </ac:spMkLst>
+        </pc:spChg>
+        <pc:picChg chg="add del mod">
+          <ac:chgData name="Corbin Ferguson" userId="34a864e2-e65e-4cb2-823c-dc28f73f0e40" providerId="ADAL" clId="{8D2D96CF-1319-4CCC-9EA9-073445628049}" dt="2026-03-16T20:26:07.031" v="1785" actId="478"/>
+          <ac:picMkLst>
+            <pc:docMk/>
+            <pc:sldMk cId="3845007870" sldId="2146848321"/>
+            <ac:picMk id="5" creationId="{906F1959-4BEB-93A8-2053-028869BA4669}"/>
+          </ac:picMkLst>
+        </pc:picChg>
+        <pc:picChg chg="del">
+          <ac:chgData name="Corbin Ferguson" userId="34a864e2-e65e-4cb2-823c-dc28f73f0e40" providerId="ADAL" clId="{8D2D96CF-1319-4CCC-9EA9-073445628049}" dt="2026-03-16T20:22:53.685" v="1767" actId="478"/>
+          <ac:picMkLst>
+            <pc:docMk/>
+            <pc:sldMk cId="3845007870" sldId="2146848321"/>
+            <ac:picMk id="15" creationId="{AFE6C1CC-E254-65E5-1018-8A1D8CE76641}"/>
+          </ac:picMkLst>
+        </pc:picChg>
+        <pc:picChg chg="mod">
+          <ac:chgData name="Corbin Ferguson" userId="34a864e2-e65e-4cb2-823c-dc28f73f0e40" providerId="ADAL" clId="{8D2D96CF-1319-4CCC-9EA9-073445628049}" dt="2026-03-16T20:30:33.896" v="1817" actId="14100"/>
+          <ac:picMkLst>
+            <pc:docMk/>
+            <pc:sldMk cId="3845007870" sldId="2146848321"/>
+            <ac:picMk id="10242" creationId="{CAFB99A3-B0BD-025E-F01B-2778A840C59D}"/>
+          </ac:picMkLst>
+        </pc:picChg>
+      </pc:sldChg>
+      <pc:sldChg chg="addSp delSp modSp add mod modTransition modAnim">
+        <pc:chgData name="Corbin Ferguson" userId="34a864e2-e65e-4cb2-823c-dc28f73f0e40" providerId="ADAL" clId="{8D2D96CF-1319-4CCC-9EA9-073445628049}" dt="2026-03-16T20:36:46.428" v="1904"/>
+        <pc:sldMkLst>
+          <pc:docMk/>
+          <pc:sldMk cId="462985986" sldId="2146848322"/>
+        </pc:sldMkLst>
+        <pc:spChg chg="add mod ord">
+          <ac:chgData name="Corbin Ferguson" userId="34a864e2-e65e-4cb2-823c-dc28f73f0e40" providerId="ADAL" clId="{8D2D96CF-1319-4CCC-9EA9-073445628049}" dt="2026-03-16T20:33:20.740" v="1836" actId="13244"/>
+          <ac:spMkLst>
+            <pc:docMk/>
+            <pc:sldMk cId="462985986" sldId="2146848322"/>
+            <ac:spMk id="6" creationId="{F97ADB1C-4CC1-050A-F7E0-C59FABA26D8C}"/>
+          </ac:spMkLst>
+        </pc:spChg>
+        <pc:picChg chg="add del mod">
+          <ac:chgData name="Corbin Ferguson" userId="34a864e2-e65e-4cb2-823c-dc28f73f0e40" providerId="ADAL" clId="{8D2D96CF-1319-4CCC-9EA9-073445628049}" dt="2026-03-16T20:24:44.714" v="1777" actId="478"/>
+          <ac:picMkLst>
+            <pc:docMk/>
+            <pc:sldMk cId="462985986" sldId="2146848322"/>
+            <ac:picMk id="3" creationId="{5EE884B0-0BCB-EC26-9B66-4AE2AEFF4D8A}"/>
+          </ac:picMkLst>
+        </pc:picChg>
+        <pc:picChg chg="add mod modVis">
+          <ac:chgData name="Corbin Ferguson" userId="34a864e2-e65e-4cb2-823c-dc28f73f0e40" providerId="ADAL" clId="{8D2D96CF-1319-4CCC-9EA9-073445628049}" dt="2026-03-16T20:36:12.514" v="1900" actId="14429"/>
+          <ac:picMkLst>
+            <pc:docMk/>
+            <pc:sldMk cId="462985986" sldId="2146848322"/>
+            <ac:picMk id="5" creationId="{771B8AC6-311F-3E75-33C2-615158918A8C}"/>
+          </ac:picMkLst>
+        </pc:picChg>
+        <pc:picChg chg="add del mod">
+          <ac:chgData name="Corbin Ferguson" userId="34a864e2-e65e-4cb2-823c-dc28f73f0e40" providerId="ADAL" clId="{8D2D96CF-1319-4CCC-9EA9-073445628049}" dt="2026-03-16T20:26:02.606" v="1783" actId="478"/>
+          <ac:picMkLst>
+            <pc:docMk/>
+            <pc:sldMk cId="462985986" sldId="2146848322"/>
+            <ac:picMk id="9" creationId="{6A2D6E58-7219-5B27-BB56-A33060C076CA}"/>
+          </ac:picMkLst>
+        </pc:picChg>
+        <pc:picChg chg="add mod modCrop">
+          <ac:chgData name="Corbin Ferguson" userId="34a864e2-e65e-4cb2-823c-dc28f73f0e40" providerId="ADAL" clId="{8D2D96CF-1319-4CCC-9EA9-073445628049}" dt="2026-03-16T20:33:42.403" v="1850" actId="962"/>
+          <ac:picMkLst>
+            <pc:docMk/>
+            <pc:sldMk cId="462985986" sldId="2146848322"/>
+            <ac:picMk id="10" creationId="{A8BD3308-9470-9AF2-87BA-D34E2A93E67A}"/>
+          </ac:picMkLst>
+        </pc:picChg>
+        <pc:picChg chg="mod modVis">
+          <ac:chgData name="Corbin Ferguson" userId="34a864e2-e65e-4cb2-823c-dc28f73f0e40" providerId="ADAL" clId="{8D2D96CF-1319-4CCC-9EA9-073445628049}" dt="2026-03-16T20:36:24.671" v="1902" actId="14429"/>
+          <ac:picMkLst>
+            <pc:docMk/>
+            <pc:sldMk cId="462985986" sldId="2146848322"/>
+            <ac:picMk id="10242" creationId="{F222EBA9-47DB-A494-0A25-7CD0A39D0D61}"/>
+          </ac:picMkLst>
+        </pc:picChg>
+      </pc:sldChg>
+      <pc:sldChg chg="addSp delSp modSp add mod ord delAnim modAnim">
+        <pc:chgData name="Corbin Ferguson" userId="34a864e2-e65e-4cb2-823c-dc28f73f0e40" providerId="ADAL" clId="{8D2D96CF-1319-4CCC-9EA9-073445628049}" dt="2026-03-16T20:55:06.654" v="2002" actId="732"/>
+        <pc:sldMkLst>
+          <pc:docMk/>
+          <pc:sldMk cId="1670292182" sldId="2146848323"/>
+        </pc:sldMkLst>
+        <pc:spChg chg="add del">
+          <ac:chgData name="Corbin Ferguson" userId="34a864e2-e65e-4cb2-823c-dc28f73f0e40" providerId="ADAL" clId="{8D2D96CF-1319-4CCC-9EA9-073445628049}" dt="2026-03-16T20:40:01.898" v="1920" actId="22"/>
+          <ac:spMkLst>
+            <pc:docMk/>
+            <pc:sldMk cId="1670292182" sldId="2146848323"/>
+            <ac:spMk id="5" creationId="{5DD8D43C-2C75-F7BC-6ABC-1D0F71EF9248}"/>
+          </ac:spMkLst>
+        </pc:spChg>
+        <pc:spChg chg="add del">
+          <ac:chgData name="Corbin Ferguson" userId="34a864e2-e65e-4cb2-823c-dc28f73f0e40" providerId="ADAL" clId="{8D2D96CF-1319-4CCC-9EA9-073445628049}" dt="2026-03-16T20:40:07.307" v="1922" actId="22"/>
+          <ac:spMkLst>
+            <pc:docMk/>
+            <pc:sldMk cId="1670292182" sldId="2146848323"/>
+            <ac:spMk id="10" creationId="{8937C66F-EC84-6131-1D2B-76A6DB09A7BF}"/>
+          </ac:spMkLst>
+        </pc:spChg>
+        <pc:spChg chg="add mod">
+          <ac:chgData name="Corbin Ferguson" userId="34a864e2-e65e-4cb2-823c-dc28f73f0e40" providerId="ADAL" clId="{8D2D96CF-1319-4CCC-9EA9-073445628049}" dt="2026-03-16T20:44:01.003" v="1951" actId="207"/>
+          <ac:spMkLst>
+            <pc:docMk/>
+            <pc:sldMk cId="1670292182" sldId="2146848323"/>
+            <ac:spMk id="11" creationId="{BBDD576A-A414-9915-960B-C7192C1A13D8}"/>
+          </ac:spMkLst>
+        </pc:spChg>
+        <pc:spChg chg="add del mod">
+          <ac:chgData name="Corbin Ferguson" userId="34a864e2-e65e-4cb2-823c-dc28f73f0e40" providerId="ADAL" clId="{8D2D96CF-1319-4CCC-9EA9-073445628049}" dt="2026-03-16T20:52:37.621" v="1985" actId="478"/>
+          <ac:spMkLst>
+            <pc:docMk/>
+            <pc:sldMk cId="1670292182" sldId="2146848323"/>
+            <ac:spMk id="12" creationId="{CC8204E8-E13C-33EB-CF24-007E48F2438C}"/>
+          </ac:spMkLst>
+        </pc:spChg>
+        <pc:picChg chg="mod ord">
+          <ac:chgData name="Corbin Ferguson" userId="34a864e2-e65e-4cb2-823c-dc28f73f0e40" providerId="ADAL" clId="{8D2D96CF-1319-4CCC-9EA9-073445628049}" dt="2026-03-16T20:42:31.830" v="1945" actId="13244"/>
+          <ac:picMkLst>
+            <pc:docMk/>
+            <pc:sldMk cId="1670292182" sldId="2146848323"/>
+            <ac:picMk id="6" creationId="{BF17B26E-CEBE-31E2-A928-A78B0BE175DA}"/>
+          </ac:picMkLst>
+        </pc:picChg>
+        <pc:picChg chg="del">
+          <ac:chgData name="Corbin Ferguson" userId="34a864e2-e65e-4cb2-823c-dc28f73f0e40" providerId="ADAL" clId="{8D2D96CF-1319-4CCC-9EA9-073445628049}" dt="2026-03-16T20:39:55.286" v="1918" actId="478"/>
+          <ac:picMkLst>
+            <pc:docMk/>
+            <pc:sldMk cId="1670292182" sldId="2146848323"/>
+            <ac:picMk id="15" creationId="{5CF8EE59-9274-2241-AA34-8B93965B0C2A}"/>
+          </ac:picMkLst>
+        </pc:picChg>
+        <pc:picChg chg="add del mod">
+          <ac:chgData name="Corbin Ferguson" userId="34a864e2-e65e-4cb2-823c-dc28f73f0e40" providerId="ADAL" clId="{8D2D96CF-1319-4CCC-9EA9-073445628049}" dt="2026-03-16T20:42:00.476" v="1934" actId="478"/>
+          <ac:picMkLst>
+            <pc:docMk/>
+            <pc:sldMk cId="1670292182" sldId="2146848323"/>
+            <ac:picMk id="11266" creationId="{917D32E0-211F-D44A-4E32-8791EF34FFEE}"/>
+          </ac:picMkLst>
+        </pc:picChg>
+        <pc:picChg chg="add mod modCrop">
+          <ac:chgData name="Corbin Ferguson" userId="34a864e2-e65e-4cb2-823c-dc28f73f0e40" providerId="ADAL" clId="{8D2D96CF-1319-4CCC-9EA9-073445628049}" dt="2026-03-16T20:55:06.654" v="2002" actId="732"/>
+          <ac:picMkLst>
+            <pc:docMk/>
+            <pc:sldMk cId="1670292182" sldId="2146848323"/>
+            <ac:picMk id="11268" creationId="{14AE5F5A-6C88-0F58-A592-0FB668BF99DA}"/>
+          </ac:picMkLst>
+        </pc:picChg>
+      </pc:sldChg>
+      <pc:sldChg chg="addSp delSp modSp add mod delAnim modAnim">
+        <pc:chgData name="Corbin Ferguson" userId="34a864e2-e65e-4cb2-823c-dc28f73f0e40" providerId="ADAL" clId="{8D2D96CF-1319-4CCC-9EA9-073445628049}" dt="2026-03-16T21:01:16.352" v="2046"/>
+        <pc:sldMkLst>
+          <pc:docMk/>
+          <pc:sldMk cId="2455060311" sldId="2146848324"/>
+        </pc:sldMkLst>
+        <pc:spChg chg="add mod">
+          <ac:chgData name="Corbin Ferguson" userId="34a864e2-e65e-4cb2-823c-dc28f73f0e40" providerId="ADAL" clId="{8D2D96CF-1319-4CCC-9EA9-073445628049}" dt="2026-03-16T20:58:38.750" v="2043" actId="14100"/>
+          <ac:spMkLst>
+            <pc:docMk/>
+            <pc:sldMk cId="2455060311" sldId="2146848324"/>
+            <ac:spMk id="6" creationId="{A38A10BF-2126-40C7-FAE5-7BBF6C867EF1}"/>
+          </ac:spMkLst>
+        </pc:spChg>
+        <pc:spChg chg="del">
+          <ac:chgData name="Corbin Ferguson" userId="34a864e2-e65e-4cb2-823c-dc28f73f0e40" providerId="ADAL" clId="{8D2D96CF-1319-4CCC-9EA9-073445628049}" dt="2026-03-16T20:55:50.301" v="2006" actId="478"/>
+          <ac:spMkLst>
+            <pc:docMk/>
+            <pc:sldMk cId="2455060311" sldId="2146848324"/>
+            <ac:spMk id="11" creationId="{9C0ECDBE-0763-C450-3DCA-C286F0A0A27A}"/>
+          </ac:spMkLst>
+        </pc:spChg>
+        <pc:picChg chg="add mod">
+          <ac:chgData name="Corbin Ferguson" userId="34a864e2-e65e-4cb2-823c-dc28f73f0e40" providerId="ADAL" clId="{8D2D96CF-1319-4CCC-9EA9-073445628049}" dt="2026-03-16T20:57:53.186" v="2021" actId="14100"/>
+          <ac:picMkLst>
+            <pc:docMk/>
+            <pc:sldMk cId="2455060311" sldId="2146848324"/>
+            <ac:picMk id="5" creationId="{BE5C2147-6B8C-1D93-D1D8-4113A963D2D0}"/>
+          </ac:picMkLst>
+        </pc:picChg>
+        <pc:picChg chg="del">
+          <ac:chgData name="Corbin Ferguson" userId="34a864e2-e65e-4cb2-823c-dc28f73f0e40" providerId="ADAL" clId="{8D2D96CF-1319-4CCC-9EA9-073445628049}" dt="2026-03-16T20:55:47.366" v="2005" actId="478"/>
+          <ac:picMkLst>
+            <pc:docMk/>
+            <pc:sldMk cId="2455060311" sldId="2146848324"/>
+            <ac:picMk id="10" creationId="{54360C4F-9744-9D0A-7526-A62F5CBBD343}"/>
+          </ac:picMkLst>
+        </pc:picChg>
+        <pc:picChg chg="mod">
+          <ac:chgData name="Corbin Ferguson" userId="34a864e2-e65e-4cb2-823c-dc28f73f0e40" providerId="ADAL" clId="{8D2D96CF-1319-4CCC-9EA9-073445628049}" dt="2026-03-16T20:58:13.772" v="2039" actId="14100"/>
+          <ac:picMkLst>
+            <pc:docMk/>
+            <pc:sldMk cId="2455060311" sldId="2146848324"/>
+            <ac:picMk id="15" creationId="{17752B2B-1B72-2430-A670-818B3CCFD41D}"/>
+          </ac:picMkLst>
+        </pc:picChg>
+      </pc:sldChg>
+      <pc:sldChg chg="addSp delSp modSp add mod ord delAnim modAnim">
+        <pc:chgData name="Corbin Ferguson" userId="34a864e2-e65e-4cb2-823c-dc28f73f0e40" providerId="ADAL" clId="{8D2D96CF-1319-4CCC-9EA9-073445628049}" dt="2026-03-16T21:03:53.279" v="2075" actId="1036"/>
+        <pc:sldMkLst>
+          <pc:docMk/>
+          <pc:sldMk cId="935187346" sldId="2146848325"/>
+        </pc:sldMkLst>
+        <pc:spChg chg="mod">
+          <ac:chgData name="Corbin Ferguson" userId="34a864e2-e65e-4cb2-823c-dc28f73f0e40" providerId="ADAL" clId="{8D2D96CF-1319-4CCC-9EA9-073445628049}" dt="2026-03-16T21:01:46.105" v="2051" actId="14100"/>
+          <ac:spMkLst>
+            <pc:docMk/>
+            <pc:sldMk cId="935187346" sldId="2146848325"/>
+            <ac:spMk id="11" creationId="{E527682E-55F4-1E8E-3D74-DD36AAF5EC17}"/>
+          </ac:spMkLst>
+        </pc:spChg>
+        <pc:picChg chg="add mod ord">
+          <ac:chgData name="Corbin Ferguson" userId="34a864e2-e65e-4cb2-823c-dc28f73f0e40" providerId="ADAL" clId="{8D2D96CF-1319-4CCC-9EA9-073445628049}" dt="2026-03-16T21:03:53.279" v="2075" actId="1036"/>
+          <ac:picMkLst>
+            <pc:docMk/>
+            <pc:sldMk cId="935187346" sldId="2146848325"/>
+            <ac:picMk id="3" creationId="{A34E6259-020A-CE8B-AC93-FDF3B8CB5BB9}"/>
+          </ac:picMkLst>
+        </pc:picChg>
+        <pc:picChg chg="del ord">
+          <ac:chgData name="Corbin Ferguson" userId="34a864e2-e65e-4cb2-823c-dc28f73f0e40" providerId="ADAL" clId="{8D2D96CF-1319-4CCC-9EA9-073445628049}" dt="2026-03-16T21:02:18.440" v="2053" actId="478"/>
+          <ac:picMkLst>
+            <pc:docMk/>
+            <pc:sldMk cId="935187346" sldId="2146848325"/>
+            <ac:picMk id="6" creationId="{B6127BAF-6D0E-BEB6-A0F4-C56A9F66FD85}"/>
+          </ac:picMkLst>
+        </pc:picChg>
+        <pc:picChg chg="mod modVis">
+          <ac:chgData name="Corbin Ferguson" userId="34a864e2-e65e-4cb2-823c-dc28f73f0e40" providerId="ADAL" clId="{8D2D96CF-1319-4CCC-9EA9-073445628049}" dt="2026-03-16T21:03:45.465" v="2072" actId="14100"/>
+          <ac:picMkLst>
+            <pc:docMk/>
+            <pc:sldMk cId="935187346" sldId="2146848325"/>
+            <ac:picMk id="11268" creationId="{398BFDD6-EE1D-2233-1BC7-9B7205573827}"/>
           </ac:picMkLst>
         </pc:picChg>
       </pc:sldChg>
@@ -19527,6 +19972,1740 @@
         <p:cNvPr id="1" name="">
           <a:extLst>
             <a:ext uri="{FF2B5EF4-FFF2-40B4-BE49-F238E27FC236}">
+              <a16:creationId xmlns:a16="http://schemas.microsoft.com/office/drawing/2014/main" id="{1E13B339-4EEC-59AB-4772-95A4281B42AE}"/>
+            </a:ext>
+          </a:extLst>
+        </p:cNvPr>
+        <p:cNvGrpSpPr/>
+        <p:nvPr/>
+      </p:nvGrpSpPr>
+      <p:grpSpPr>
+        <a:xfrm>
+          <a:off x="0" y="0"/>
+          <a:ext cx="0" cy="0"/>
+          <a:chOff x="0" y="0"/>
+          <a:chExt cx="0" cy="0"/>
+        </a:xfrm>
+      </p:grpSpPr>
+      <p:sp>
+        <p:nvSpPr>
+          <p:cNvPr id="2" name="Title 1">
+            <a:extLst>
+              <a:ext uri="{FF2B5EF4-FFF2-40B4-BE49-F238E27FC236}">
+                <a16:creationId xmlns:a16="http://schemas.microsoft.com/office/drawing/2014/main" id="{C6FD6CC9-4051-8C8E-6F53-6558CC8D4A8F}"/>
+              </a:ext>
+            </a:extLst>
+          </p:cNvPr>
+          <p:cNvSpPr>
+            <a:spLocks noGrp="1"/>
+          </p:cNvSpPr>
+          <p:nvPr>
+            <p:ph type="title"/>
+          </p:nvPr>
+        </p:nvSpPr>
+        <p:spPr>
+          <a:xfrm>
+            <a:off x="334963" y="620690"/>
+            <a:ext cx="7018337" cy="360041"/>
+          </a:xfrm>
+        </p:spPr>
+        <p:txBody>
+          <a:bodyPr/>
+          <a:lstStyle/>
+          <a:p>
+            <a:r>
+              <a:rPr lang="en-US" dirty="0"/>
+              <a:t>New File Pathing</a:t>
+            </a:r>
+          </a:p>
+        </p:txBody>
+      </p:sp>
+      <p:sp>
+        <p:nvSpPr>
+          <p:cNvPr id="4" name="Date Placeholder 3">
+            <a:extLst>
+              <a:ext uri="{FF2B5EF4-FFF2-40B4-BE49-F238E27FC236}">
+                <a16:creationId xmlns:a16="http://schemas.microsoft.com/office/drawing/2014/main" id="{39A7C85B-3F3C-7F47-8670-EC9B7599C42E}"/>
+              </a:ext>
+            </a:extLst>
+          </p:cNvPr>
+          <p:cNvSpPr>
+            <a:spLocks noGrp="1"/>
+          </p:cNvSpPr>
+          <p:nvPr>
+            <p:ph type="dt" sz="half" idx="10"/>
+          </p:nvPr>
+        </p:nvSpPr>
+        <p:spPr/>
+        <p:txBody>
+          <a:bodyPr/>
+          <a:lstStyle/>
+          <a:p>
+            <a:r>
+              <a:rPr lang="en-US"/>
+              <a:t>L5X Automation Build Tool</a:t>
+            </a:r>
+            <a:endParaRPr lang="en-US" dirty="0"/>
+          </a:p>
+        </p:txBody>
+      </p:sp>
+      <p:sp>
+        <p:nvSpPr>
+          <p:cNvPr id="7" name="Slide Number Placeholder 6">
+            <a:extLst>
+              <a:ext uri="{FF2B5EF4-FFF2-40B4-BE49-F238E27FC236}">
+                <a16:creationId xmlns:a16="http://schemas.microsoft.com/office/drawing/2014/main" id="{F6C98780-7782-6438-33E0-36B16CFBA93E}"/>
+              </a:ext>
+            </a:extLst>
+          </p:cNvPr>
+          <p:cNvSpPr>
+            <a:spLocks noGrp="1"/>
+          </p:cNvSpPr>
+          <p:nvPr>
+            <p:ph type="sldNum" sz="quarter" idx="12"/>
+          </p:nvPr>
+        </p:nvSpPr>
+        <p:spPr/>
+        <p:txBody>
+          <a:bodyPr/>
+          <a:lstStyle/>
+          <a:p>
+            <a:r>
+              <a:rPr lang="en-US"/>
+              <a:t>Slide </a:t>
+            </a:r>
+            <a:fld id="{C6F8E2D1-BFA0-484A-B7F1-E348F2594759}" type="slidenum">
+              <a:rPr lang="en-US" smtClean="0"/>
+              <a:t>10</a:t>
+            </a:fld>
+            <a:endParaRPr lang="en-US" dirty="0"/>
+          </a:p>
+        </p:txBody>
+      </p:sp>
+      <p:sp>
+        <p:nvSpPr>
+          <p:cNvPr id="8" name="Footer Placeholder 7">
+            <a:extLst>
+              <a:ext uri="{FF2B5EF4-FFF2-40B4-BE49-F238E27FC236}">
+                <a16:creationId xmlns:a16="http://schemas.microsoft.com/office/drawing/2014/main" id="{FD345246-AA94-A9AA-8773-390E7B836603}"/>
+              </a:ext>
+            </a:extLst>
+          </p:cNvPr>
+          <p:cNvSpPr>
+            <a:spLocks noGrp="1"/>
+          </p:cNvSpPr>
+          <p:nvPr>
+            <p:ph type="ftr" sz="quarter" idx="11"/>
+          </p:nvPr>
+        </p:nvSpPr>
+        <p:spPr/>
+        <p:txBody>
+          <a:bodyPr/>
+          <a:lstStyle/>
+          <a:p>
+            <a:r>
+              <a:rPr lang="en-US"/>
+              <a:t>Corbin Ferguson</a:t>
+            </a:r>
+            <a:endParaRPr lang="en-US" dirty="0"/>
+          </a:p>
+        </p:txBody>
+      </p:sp>
+      <p:pic>
+        <p:nvPicPr>
+          <p:cNvPr id="10" name="!NewFile">
+            <a:extLst>
+              <a:ext uri="{FF2B5EF4-FFF2-40B4-BE49-F238E27FC236}">
+                <a16:creationId xmlns:a16="http://schemas.microsoft.com/office/drawing/2014/main" id="{36552AD4-E539-C4C4-F016-02E1B6D7EFCF}"/>
+              </a:ext>
+            </a:extLst>
+          </p:cNvPr>
+          <p:cNvPicPr>
+            <a:picLocks noChangeAspect="1" noChangeArrowheads="1"/>
+          </p:cNvPicPr>
+          <p:nvPr/>
+        </p:nvPicPr>
+        <p:blipFill>
+          <a:blip r:embed="rId2">
+            <a:extLst>
+              <a:ext uri="{28A0092B-C50C-407E-A947-70E740481C1C}">
+                <a14:useLocalDpi xmlns:a14="http://schemas.microsoft.com/office/drawing/2010/main" val="0"/>
+              </a:ext>
+            </a:extLst>
+          </a:blip>
+          <a:srcRect l="19200" t="28133" r="679" b="47493"/>
+          <a:stretch>
+            <a:fillRect/>
+          </a:stretch>
+        </p:blipFill>
+        <p:spPr bwMode="auto">
+          <a:xfrm>
+            <a:off x="1173906" y="2090712"/>
+            <a:ext cx="10296628" cy="2316188"/>
+          </a:xfrm>
+          <a:prstGeom prst="rect">
+            <a:avLst/>
+          </a:prstGeom>
+          <a:solidFill>
+            <a:schemeClr val="bg1"/>
+          </a:solidFill>
+        </p:spPr>
+      </p:pic>
+      <p:pic>
+        <p:nvPicPr>
+          <p:cNvPr id="15" name="NewFile" descr="A Flow chart displaying all windows in the application and how they lead to one another">
+            <a:extLst>
+              <a:ext uri="{FF2B5EF4-FFF2-40B4-BE49-F238E27FC236}">
+                <a16:creationId xmlns:a16="http://schemas.microsoft.com/office/drawing/2014/main" id="{5956B2B1-2846-2DBE-61A6-5C404403D377}"/>
+              </a:ext>
+            </a:extLst>
+          </p:cNvPr>
+          <p:cNvPicPr>
+            <a:picLocks noChangeAspect="1"/>
+          </p:cNvPicPr>
+          <p:nvPr/>
+        </p:nvPicPr>
+        <p:blipFill>
+          <a:blip r:embed="rId3">
+            <a:extLst>
+              <a:ext uri="{28A0092B-C50C-407E-A947-70E740481C1C}">
+                <a14:useLocalDpi xmlns:a14="http://schemas.microsoft.com/office/drawing/2010/main" val="0"/>
+              </a:ext>
+            </a:extLst>
+          </a:blip>
+          <a:srcRect l="13550" t="32704" r="60214" b="51579"/>
+          <a:stretch>
+            <a:fillRect/>
+          </a:stretch>
+        </p:blipFill>
+        <p:spPr>
+          <a:xfrm>
+            <a:off x="1143001" y="1386840"/>
+            <a:ext cx="10358438" cy="3512821"/>
+          </a:xfrm>
+          <a:prstGeom prst="rect">
+            <a:avLst/>
+          </a:prstGeom>
+          <a:solidFill>
+            <a:srgbClr val="FFFFFF"/>
+          </a:solidFill>
+        </p:spPr>
+      </p:pic>
+      <p:sp>
+        <p:nvSpPr>
+          <p:cNvPr id="11" name="Rectangle: Rounded Corners 10">
+            <a:extLst>
+              <a:ext uri="{FF2B5EF4-FFF2-40B4-BE49-F238E27FC236}">
+                <a16:creationId xmlns:a16="http://schemas.microsoft.com/office/drawing/2014/main" id="{C63E6493-7963-69F9-0E49-FBFB34C98CC6}"/>
+              </a:ext>
+            </a:extLst>
+          </p:cNvPr>
+          <p:cNvSpPr/>
+          <p:nvPr/>
+        </p:nvSpPr>
+        <p:spPr>
+          <a:xfrm>
+            <a:off x="2204551" y="1992834"/>
+            <a:ext cx="2469049" cy="1512365"/>
+          </a:xfrm>
+          <a:prstGeom prst="roundRect">
+            <a:avLst/>
+          </a:prstGeom>
+          <a:solidFill>
+            <a:srgbClr val="007CAA">
+              <a:alpha val="20000"/>
+            </a:srgbClr>
+          </a:solidFill>
+          <a:ln>
+            <a:solidFill>
+              <a:srgbClr val="007CAA"/>
+            </a:solidFill>
+          </a:ln>
+          <a:effectLst>
+            <a:glow rad="63500">
+              <a:schemeClr val="accent4">
+                <a:satMod val="175000"/>
+                <a:alpha val="40000"/>
+              </a:schemeClr>
+            </a:glow>
+          </a:effectLst>
+        </p:spPr>
+        <p:style>
+          <a:lnRef idx="2">
+            <a:schemeClr val="accent1">
+              <a:shade val="50000"/>
+            </a:schemeClr>
+          </a:lnRef>
+          <a:fillRef idx="1">
+            <a:schemeClr val="accent1"/>
+          </a:fillRef>
+          <a:effectRef idx="0">
+            <a:schemeClr val="accent1"/>
+          </a:effectRef>
+          <a:fontRef idx="minor">
+            <a:schemeClr val="lt1"/>
+          </a:fontRef>
+        </p:style>
+        <p:txBody>
+          <a:bodyPr rtlCol="0" anchor="ctr"/>
+          <a:lstStyle/>
+          <a:p>
+            <a:pPr algn="ctr"/>
+            <a:endParaRPr lang="en-US" sz="2000" dirty="0" err="1">
+              <a:solidFill>
+                <a:srgbClr val="FFFFFF"/>
+              </a:solidFill>
+              <a:latin typeface="E+H Sans" panose="020B0404050202020204" pitchFamily="34" charset="0"/>
+            </a:endParaRPr>
+          </a:p>
+        </p:txBody>
+      </p:sp>
+    </p:spTree>
+    <p:extLst>
+      <p:ext uri="{BB962C8B-B14F-4D97-AF65-F5344CB8AC3E}">
+        <p14:creationId xmlns:p14="http://schemas.microsoft.com/office/powerpoint/2010/main" val="3831013115"/>
+      </p:ext>
+    </p:extLst>
+  </p:cSld>
+  <p:clrMapOvr>
+    <a:masterClrMapping/>
+  </p:clrMapOvr>
+  <mc:AlternateContent xmlns:mc="http://schemas.openxmlformats.org/markup-compatibility/2006">
+    <mc:Choice xmlns:p159="http://schemas.microsoft.com/office/powerpoint/2015/09/main" Requires="p159">
+      <p:transition xmlns:p14="http://schemas.microsoft.com/office/powerpoint/2010/main" spd="slow" p14:dur="2000">
+        <p159:morph option="byObject"/>
+      </p:transition>
+    </mc:Choice>
+    <mc:Fallback>
+      <p:transition spd="slow">
+        <p:fade/>
+      </p:transition>
+    </mc:Fallback>
+  </mc:AlternateContent>
+  <p:timing>
+    <p:tnLst>
+      <p:par>
+        <p:cTn id="1" dur="indefinite" restart="never" nodeType="tmRoot">
+          <p:childTnLst>
+            <p:seq concurrent="1" nextAc="seek">
+              <p:cTn id="2" dur="indefinite" nodeType="mainSeq">
+                <p:childTnLst>
+                  <p:par>
+                    <p:cTn id="3" fill="hold">
+                      <p:stCondLst>
+                        <p:cond delay="indefinite"/>
+                        <p:cond evt="onBegin" delay="0">
+                          <p:tn val="2"/>
+                        </p:cond>
+                      </p:stCondLst>
+                      <p:childTnLst>
+                        <p:par>
+                          <p:cTn id="4" fill="hold">
+                            <p:stCondLst>
+                              <p:cond delay="0"/>
+                            </p:stCondLst>
+                            <p:childTnLst>
+                              <p:par>
+                                <p:cTn id="5" presetID="10" presetClass="entr" presetSubtype="0" fill="hold" grpId="0" nodeType="afterEffect">
+                                  <p:stCondLst>
+                                    <p:cond delay="100"/>
+                                  </p:stCondLst>
+                                  <p:childTnLst>
+                                    <p:set>
+                                      <p:cBhvr>
+                                        <p:cTn id="6" dur="1" fill="hold">
+                                          <p:stCondLst>
+                                            <p:cond delay="0"/>
+                                          </p:stCondLst>
+                                        </p:cTn>
+                                        <p:tgtEl>
+                                          <p:spTgt spid="11"/>
+                                        </p:tgtEl>
+                                        <p:attrNameLst>
+                                          <p:attrName>style.visibility</p:attrName>
+                                        </p:attrNameLst>
+                                      </p:cBhvr>
+                                      <p:to>
+                                        <p:strVal val="visible"/>
+                                      </p:to>
+                                    </p:set>
+                                    <p:animEffect transition="in" filter="fade">
+                                      <p:cBhvr>
+                                        <p:cTn id="7" dur="500"/>
+                                        <p:tgtEl>
+                                          <p:spTgt spid="11"/>
+                                        </p:tgtEl>
+                                      </p:cBhvr>
+                                    </p:animEffect>
+                                  </p:childTnLst>
+                                </p:cTn>
+                              </p:par>
+                            </p:childTnLst>
+                          </p:cTn>
+                        </p:par>
+                      </p:childTnLst>
+                    </p:cTn>
+                  </p:par>
+                </p:childTnLst>
+              </p:cTn>
+              <p:prevCondLst>
+                <p:cond evt="onPrev" delay="0">
+                  <p:tgtEl>
+                    <p:sldTgt/>
+                  </p:tgtEl>
+                </p:cond>
+              </p:prevCondLst>
+              <p:nextCondLst>
+                <p:cond evt="onNext" delay="0">
+                  <p:tgtEl>
+                    <p:sldTgt/>
+                  </p:tgtEl>
+                </p:cond>
+              </p:nextCondLst>
+            </p:seq>
+          </p:childTnLst>
+        </p:cTn>
+      </p:par>
+    </p:tnLst>
+    <p:bldLst>
+      <p:bldP spid="11" grpId="0" animBg="1"/>
+    </p:bldLst>
+  </p:timing>
+</p:sld>
+</file>
+
+<file path=ppt/slides/slide11.xml><?xml version="1.0" encoding="utf-8"?>
+<p:sld xmlns:a="http://schemas.openxmlformats.org/drawingml/2006/main" xmlns:r="http://schemas.openxmlformats.org/officeDocument/2006/relationships" xmlns:p="http://schemas.openxmlformats.org/presentationml/2006/main">
+  <p:cSld>
+    <p:spTree>
+      <p:nvGrpSpPr>
+        <p:cNvPr id="1" name="">
+          <a:extLst>
+            <a:ext uri="{FF2B5EF4-FFF2-40B4-BE49-F238E27FC236}">
+              <a16:creationId xmlns:a16="http://schemas.microsoft.com/office/drawing/2014/main" id="{82D89F6A-C1EA-199A-6410-C327902E30E7}"/>
+            </a:ext>
+          </a:extLst>
+        </p:cNvPr>
+        <p:cNvGrpSpPr/>
+        <p:nvPr/>
+      </p:nvGrpSpPr>
+      <p:grpSpPr>
+        <a:xfrm>
+          <a:off x="0" y="0"/>
+          <a:ext cx="0" cy="0"/>
+          <a:chOff x="0" y="0"/>
+          <a:chExt cx="0" cy="0"/>
+        </a:xfrm>
+      </p:grpSpPr>
+      <p:sp>
+        <p:nvSpPr>
+          <p:cNvPr id="2" name="Title 1">
+            <a:extLst>
+              <a:ext uri="{FF2B5EF4-FFF2-40B4-BE49-F238E27FC236}">
+                <a16:creationId xmlns:a16="http://schemas.microsoft.com/office/drawing/2014/main" id="{BEF4F8F7-7FD1-D66F-55BE-B09150AA9A29}"/>
+              </a:ext>
+            </a:extLst>
+          </p:cNvPr>
+          <p:cNvSpPr>
+            <a:spLocks noGrp="1"/>
+          </p:cNvSpPr>
+          <p:nvPr>
+            <p:ph type="title"/>
+          </p:nvPr>
+        </p:nvSpPr>
+        <p:spPr>
+          <a:xfrm>
+            <a:off x="334963" y="620690"/>
+            <a:ext cx="7018337" cy="360041"/>
+          </a:xfrm>
+        </p:spPr>
+        <p:txBody>
+          <a:bodyPr/>
+          <a:lstStyle/>
+          <a:p>
+            <a:r>
+              <a:rPr lang="en-US" dirty="0"/>
+              <a:t>New File Pathing</a:t>
+            </a:r>
+          </a:p>
+        </p:txBody>
+      </p:sp>
+      <p:sp>
+        <p:nvSpPr>
+          <p:cNvPr id="4" name="Date Placeholder 3">
+            <a:extLst>
+              <a:ext uri="{FF2B5EF4-FFF2-40B4-BE49-F238E27FC236}">
+                <a16:creationId xmlns:a16="http://schemas.microsoft.com/office/drawing/2014/main" id="{B908FCD3-24C5-4D9D-9FA2-17B51B3E7CA1}"/>
+              </a:ext>
+            </a:extLst>
+          </p:cNvPr>
+          <p:cNvSpPr>
+            <a:spLocks noGrp="1"/>
+          </p:cNvSpPr>
+          <p:nvPr>
+            <p:ph type="dt" sz="half" idx="10"/>
+          </p:nvPr>
+        </p:nvSpPr>
+        <p:spPr/>
+        <p:txBody>
+          <a:bodyPr/>
+          <a:lstStyle/>
+          <a:p>
+            <a:r>
+              <a:rPr lang="en-US"/>
+              <a:t>L5X Automation Build Tool</a:t>
+            </a:r>
+            <a:endParaRPr lang="en-US" dirty="0"/>
+          </a:p>
+        </p:txBody>
+      </p:sp>
+      <p:sp>
+        <p:nvSpPr>
+          <p:cNvPr id="7" name="Slide Number Placeholder 6">
+            <a:extLst>
+              <a:ext uri="{FF2B5EF4-FFF2-40B4-BE49-F238E27FC236}">
+                <a16:creationId xmlns:a16="http://schemas.microsoft.com/office/drawing/2014/main" id="{B7AC7758-5A3A-B7B2-8B08-2352C8414B37}"/>
+              </a:ext>
+            </a:extLst>
+          </p:cNvPr>
+          <p:cNvSpPr>
+            <a:spLocks noGrp="1"/>
+          </p:cNvSpPr>
+          <p:nvPr>
+            <p:ph type="sldNum" sz="quarter" idx="12"/>
+          </p:nvPr>
+        </p:nvSpPr>
+        <p:spPr/>
+        <p:txBody>
+          <a:bodyPr/>
+          <a:lstStyle/>
+          <a:p>
+            <a:r>
+              <a:rPr lang="en-US"/>
+              <a:t>Slide </a:t>
+            </a:r>
+            <a:fld id="{C6F8E2D1-BFA0-484A-B7F1-E348F2594759}" type="slidenum">
+              <a:rPr lang="en-US" smtClean="0"/>
+              <a:t>11</a:t>
+            </a:fld>
+            <a:endParaRPr lang="en-US" dirty="0"/>
+          </a:p>
+        </p:txBody>
+      </p:sp>
+      <p:sp>
+        <p:nvSpPr>
+          <p:cNvPr id="8" name="Footer Placeholder 7">
+            <a:extLst>
+              <a:ext uri="{FF2B5EF4-FFF2-40B4-BE49-F238E27FC236}">
+                <a16:creationId xmlns:a16="http://schemas.microsoft.com/office/drawing/2014/main" id="{B9CE8CF7-B43D-DD81-DE4D-0FB8CA97A05B}"/>
+              </a:ext>
+            </a:extLst>
+          </p:cNvPr>
+          <p:cNvSpPr>
+            <a:spLocks noGrp="1"/>
+          </p:cNvSpPr>
+          <p:nvPr>
+            <p:ph type="ftr" sz="quarter" idx="11"/>
+          </p:nvPr>
+        </p:nvSpPr>
+        <p:spPr/>
+        <p:txBody>
+          <a:bodyPr/>
+          <a:lstStyle/>
+          <a:p>
+            <a:r>
+              <a:rPr lang="en-US"/>
+              <a:t>Corbin Ferguson</a:t>
+            </a:r>
+            <a:endParaRPr lang="en-US" dirty="0"/>
+          </a:p>
+        </p:txBody>
+      </p:sp>
+      <p:pic>
+        <p:nvPicPr>
+          <p:cNvPr id="15" name="!NewFile" descr="A Flow chart displaying all windows in the application and how they lead to one another">
+            <a:extLst>
+              <a:ext uri="{FF2B5EF4-FFF2-40B4-BE49-F238E27FC236}">
+                <a16:creationId xmlns:a16="http://schemas.microsoft.com/office/drawing/2014/main" id="{17752B2B-1B72-2430-A670-818B3CCFD41D}"/>
+              </a:ext>
+            </a:extLst>
+          </p:cNvPr>
+          <p:cNvPicPr>
+            <a:picLocks noChangeAspect="1"/>
+          </p:cNvPicPr>
+          <p:nvPr/>
+        </p:nvPicPr>
+        <p:blipFill>
+          <a:blip r:embed="rId2">
+            <a:extLst>
+              <a:ext uri="{28A0092B-C50C-407E-A947-70E740481C1C}">
+                <a14:useLocalDpi xmlns:a14="http://schemas.microsoft.com/office/drawing/2010/main" val="0"/>
+              </a:ext>
+            </a:extLst>
+          </a:blip>
+          <a:srcRect l="13550" t="32704" r="60214" b="51579"/>
+          <a:stretch>
+            <a:fillRect/>
+          </a:stretch>
+        </p:blipFill>
+        <p:spPr>
+          <a:xfrm>
+            <a:off x="3045421" y="1930402"/>
+            <a:ext cx="6553598" cy="2222498"/>
+          </a:xfrm>
+          <a:prstGeom prst="rect">
+            <a:avLst/>
+          </a:prstGeom>
+          <a:solidFill>
+            <a:srgbClr val="FFFFFF"/>
+          </a:solidFill>
+        </p:spPr>
+      </p:pic>
+      <p:pic>
+        <p:nvPicPr>
+          <p:cNvPr id="5" name="NewFile">
+            <a:extLst>
+              <a:ext uri="{FF2B5EF4-FFF2-40B4-BE49-F238E27FC236}">
+                <a16:creationId xmlns:a16="http://schemas.microsoft.com/office/drawing/2014/main" id="{BE5C2147-6B8C-1D93-D1D8-4113A963D2D0}"/>
+              </a:ext>
+            </a:extLst>
+          </p:cNvPr>
+          <p:cNvPicPr>
+            <a:picLocks noChangeAspect="1"/>
+          </p:cNvPicPr>
+          <p:nvPr/>
+        </p:nvPicPr>
+        <p:blipFill>
+          <a:blip r:embed="rId3"/>
+          <a:stretch>
+            <a:fillRect/>
+          </a:stretch>
+        </p:blipFill>
+        <p:spPr>
+          <a:xfrm>
+            <a:off x="1433867" y="1283432"/>
+            <a:ext cx="9776708" cy="3872768"/>
+          </a:xfrm>
+          <a:prstGeom prst="rect">
+            <a:avLst/>
+          </a:prstGeom>
+        </p:spPr>
+      </p:pic>
+      <p:sp>
+        <p:nvSpPr>
+          <p:cNvPr id="6" name="Rectangle: Rounded Corners 5">
+            <a:extLst>
+              <a:ext uri="{FF2B5EF4-FFF2-40B4-BE49-F238E27FC236}">
+                <a16:creationId xmlns:a16="http://schemas.microsoft.com/office/drawing/2014/main" id="{A38A10BF-2126-40C7-FAE5-7BBF6C867EF1}"/>
+              </a:ext>
+            </a:extLst>
+          </p:cNvPr>
+          <p:cNvSpPr/>
+          <p:nvPr/>
+        </p:nvSpPr>
+        <p:spPr>
+          <a:xfrm>
+            <a:off x="6540500" y="4330700"/>
+            <a:ext cx="2133600" cy="730896"/>
+          </a:xfrm>
+          <a:prstGeom prst="roundRect">
+            <a:avLst/>
+          </a:prstGeom>
+          <a:solidFill>
+            <a:srgbClr val="007CAA">
+              <a:alpha val="20000"/>
+            </a:srgbClr>
+          </a:solidFill>
+          <a:ln>
+            <a:solidFill>
+              <a:srgbClr val="007CAA"/>
+            </a:solidFill>
+          </a:ln>
+          <a:effectLst>
+            <a:glow rad="63500">
+              <a:schemeClr val="accent4">
+                <a:satMod val="175000"/>
+                <a:alpha val="40000"/>
+              </a:schemeClr>
+            </a:glow>
+          </a:effectLst>
+        </p:spPr>
+        <p:style>
+          <a:lnRef idx="2">
+            <a:schemeClr val="accent1">
+              <a:shade val="50000"/>
+            </a:schemeClr>
+          </a:lnRef>
+          <a:fillRef idx="1">
+            <a:schemeClr val="accent1"/>
+          </a:fillRef>
+          <a:effectRef idx="0">
+            <a:schemeClr val="accent1"/>
+          </a:effectRef>
+          <a:fontRef idx="minor">
+            <a:schemeClr val="lt1"/>
+          </a:fontRef>
+        </p:style>
+        <p:txBody>
+          <a:bodyPr rtlCol="0" anchor="ctr"/>
+          <a:lstStyle/>
+          <a:p>
+            <a:pPr algn="ctr"/>
+            <a:endParaRPr lang="en-US" sz="2000" dirty="0" err="1">
+              <a:solidFill>
+                <a:srgbClr val="FFFFFF"/>
+              </a:solidFill>
+              <a:latin typeface="E+H Sans" panose="020B0404050202020204" pitchFamily="34" charset="0"/>
+            </a:endParaRPr>
+          </a:p>
+        </p:txBody>
+      </p:sp>
+    </p:spTree>
+    <p:extLst>
+      <p:ext uri="{BB962C8B-B14F-4D97-AF65-F5344CB8AC3E}">
+        <p14:creationId xmlns:p14="http://schemas.microsoft.com/office/powerpoint/2010/main" val="2455060311"/>
+      </p:ext>
+    </p:extLst>
+  </p:cSld>
+  <p:clrMapOvr>
+    <a:masterClrMapping/>
+  </p:clrMapOvr>
+  <mc:AlternateContent xmlns:mc="http://schemas.openxmlformats.org/markup-compatibility/2006">
+    <mc:Choice xmlns:p159="http://schemas.microsoft.com/office/powerpoint/2015/09/main" Requires="p159">
+      <p:transition xmlns:p14="http://schemas.microsoft.com/office/powerpoint/2010/main" spd="slow" p14:dur="2000">
+        <p159:morph option="byObject"/>
+      </p:transition>
+    </mc:Choice>
+    <mc:Fallback>
+      <p:transition spd="slow">
+        <p:fade/>
+      </p:transition>
+    </mc:Fallback>
+  </mc:AlternateContent>
+  <p:timing>
+    <p:tnLst>
+      <p:par>
+        <p:cTn id="1" dur="indefinite" restart="never" nodeType="tmRoot">
+          <p:childTnLst>
+            <p:seq concurrent="1" nextAc="seek">
+              <p:cTn id="2" dur="indefinite" nodeType="mainSeq">
+                <p:childTnLst>
+                  <p:par>
+                    <p:cTn id="3" fill="hold">
+                      <p:stCondLst>
+                        <p:cond delay="indefinite"/>
+                        <p:cond evt="onBegin" delay="0">
+                          <p:tn val="2"/>
+                        </p:cond>
+                      </p:stCondLst>
+                      <p:childTnLst>
+                        <p:par>
+                          <p:cTn id="4" fill="hold">
+                            <p:stCondLst>
+                              <p:cond delay="0"/>
+                            </p:stCondLst>
+                            <p:childTnLst>
+                              <p:par>
+                                <p:cTn id="5" presetID="10" presetClass="entr" presetSubtype="0" fill="hold" grpId="0" nodeType="afterEffect">
+                                  <p:stCondLst>
+                                    <p:cond delay="100"/>
+                                  </p:stCondLst>
+                                  <p:childTnLst>
+                                    <p:set>
+                                      <p:cBhvr>
+                                        <p:cTn id="6" dur="1" fill="hold">
+                                          <p:stCondLst>
+                                            <p:cond delay="0"/>
+                                          </p:stCondLst>
+                                        </p:cTn>
+                                        <p:tgtEl>
+                                          <p:spTgt spid="6"/>
+                                        </p:tgtEl>
+                                        <p:attrNameLst>
+                                          <p:attrName>style.visibility</p:attrName>
+                                        </p:attrNameLst>
+                                      </p:cBhvr>
+                                      <p:to>
+                                        <p:strVal val="visible"/>
+                                      </p:to>
+                                    </p:set>
+                                    <p:animEffect transition="in" filter="fade">
+                                      <p:cBhvr>
+                                        <p:cTn id="7" dur="500"/>
+                                        <p:tgtEl>
+                                          <p:spTgt spid="6"/>
+                                        </p:tgtEl>
+                                      </p:cBhvr>
+                                    </p:animEffect>
+                                  </p:childTnLst>
+                                </p:cTn>
+                              </p:par>
+                            </p:childTnLst>
+                          </p:cTn>
+                        </p:par>
+                      </p:childTnLst>
+                    </p:cTn>
+                  </p:par>
+                </p:childTnLst>
+              </p:cTn>
+              <p:prevCondLst>
+                <p:cond evt="onPrev" delay="0">
+                  <p:tgtEl>
+                    <p:sldTgt/>
+                  </p:tgtEl>
+                </p:cond>
+              </p:prevCondLst>
+              <p:nextCondLst>
+                <p:cond evt="onNext" delay="0">
+                  <p:tgtEl>
+                    <p:sldTgt/>
+                  </p:tgtEl>
+                </p:cond>
+              </p:nextCondLst>
+            </p:seq>
+          </p:childTnLst>
+        </p:cTn>
+      </p:par>
+    </p:tnLst>
+    <p:bldLst>
+      <p:bldP spid="6" grpId="0" animBg="1"/>
+    </p:bldLst>
+  </p:timing>
+</p:sld>
+</file>
+
+<file path=ppt/slides/slide12.xml><?xml version="1.0" encoding="utf-8"?>
+<p:sld xmlns:a="http://schemas.openxmlformats.org/drawingml/2006/main" xmlns:r="http://schemas.openxmlformats.org/officeDocument/2006/relationships" xmlns:p="http://schemas.openxmlformats.org/presentationml/2006/main">
+  <p:cSld>
+    <p:spTree>
+      <p:nvGrpSpPr>
+        <p:cNvPr id="1" name="">
+          <a:extLst>
+            <a:ext uri="{FF2B5EF4-FFF2-40B4-BE49-F238E27FC236}">
+              <a16:creationId xmlns:a16="http://schemas.microsoft.com/office/drawing/2014/main" id="{62BA7F1E-9132-6B43-FA78-6CD227802AB2}"/>
+            </a:ext>
+          </a:extLst>
+        </p:cNvPr>
+        <p:cNvGrpSpPr/>
+        <p:nvPr/>
+      </p:nvGrpSpPr>
+      <p:grpSpPr>
+        <a:xfrm>
+          <a:off x="0" y="0"/>
+          <a:ext cx="0" cy="0"/>
+          <a:chOff x="0" y="0"/>
+          <a:chExt cx="0" cy="0"/>
+        </a:xfrm>
+      </p:grpSpPr>
+      <p:sp>
+        <p:nvSpPr>
+          <p:cNvPr id="2" name="Title 1">
+            <a:extLst>
+              <a:ext uri="{FF2B5EF4-FFF2-40B4-BE49-F238E27FC236}">
+                <a16:creationId xmlns:a16="http://schemas.microsoft.com/office/drawing/2014/main" id="{38154D3D-CF39-6C55-45B8-AB9F07D515DB}"/>
+              </a:ext>
+            </a:extLst>
+          </p:cNvPr>
+          <p:cNvSpPr>
+            <a:spLocks noGrp="1"/>
+          </p:cNvSpPr>
+          <p:nvPr>
+            <p:ph type="title"/>
+          </p:nvPr>
+        </p:nvSpPr>
+        <p:spPr>
+          <a:xfrm>
+            <a:off x="334963" y="620690"/>
+            <a:ext cx="7018337" cy="360041"/>
+          </a:xfrm>
+        </p:spPr>
+        <p:txBody>
+          <a:bodyPr/>
+          <a:lstStyle/>
+          <a:p>
+            <a:r>
+              <a:rPr lang="en-US" dirty="0"/>
+              <a:t>New File Pathing</a:t>
+            </a:r>
+          </a:p>
+        </p:txBody>
+      </p:sp>
+      <p:sp>
+        <p:nvSpPr>
+          <p:cNvPr id="4" name="Date Placeholder 3">
+            <a:extLst>
+              <a:ext uri="{FF2B5EF4-FFF2-40B4-BE49-F238E27FC236}">
+                <a16:creationId xmlns:a16="http://schemas.microsoft.com/office/drawing/2014/main" id="{2FC48088-5AD3-2119-84FA-2876083B74BA}"/>
+              </a:ext>
+            </a:extLst>
+          </p:cNvPr>
+          <p:cNvSpPr>
+            <a:spLocks noGrp="1"/>
+          </p:cNvSpPr>
+          <p:nvPr>
+            <p:ph type="dt" sz="half" idx="10"/>
+          </p:nvPr>
+        </p:nvSpPr>
+        <p:spPr/>
+        <p:txBody>
+          <a:bodyPr/>
+          <a:lstStyle/>
+          <a:p>
+            <a:r>
+              <a:rPr lang="en-US"/>
+              <a:t>L5X Automation Build Tool</a:t>
+            </a:r>
+            <a:endParaRPr lang="en-US" dirty="0"/>
+          </a:p>
+        </p:txBody>
+      </p:sp>
+      <p:sp>
+        <p:nvSpPr>
+          <p:cNvPr id="7" name="Slide Number Placeholder 6">
+            <a:extLst>
+              <a:ext uri="{FF2B5EF4-FFF2-40B4-BE49-F238E27FC236}">
+                <a16:creationId xmlns:a16="http://schemas.microsoft.com/office/drawing/2014/main" id="{F160AB3E-73E0-E11E-4112-DDA4E807913F}"/>
+              </a:ext>
+            </a:extLst>
+          </p:cNvPr>
+          <p:cNvSpPr>
+            <a:spLocks noGrp="1"/>
+          </p:cNvSpPr>
+          <p:nvPr>
+            <p:ph type="sldNum" sz="quarter" idx="12"/>
+          </p:nvPr>
+        </p:nvSpPr>
+        <p:spPr/>
+        <p:txBody>
+          <a:bodyPr/>
+          <a:lstStyle/>
+          <a:p>
+            <a:r>
+              <a:rPr lang="en-US"/>
+              <a:t>Slide </a:t>
+            </a:r>
+            <a:fld id="{C6F8E2D1-BFA0-484A-B7F1-E348F2594759}" type="slidenum">
+              <a:rPr lang="en-US" smtClean="0"/>
+              <a:t>12</a:t>
+            </a:fld>
+            <a:endParaRPr lang="en-US" dirty="0"/>
+          </a:p>
+        </p:txBody>
+      </p:sp>
+      <p:sp>
+        <p:nvSpPr>
+          <p:cNvPr id="8" name="Footer Placeholder 7">
+            <a:extLst>
+              <a:ext uri="{FF2B5EF4-FFF2-40B4-BE49-F238E27FC236}">
+                <a16:creationId xmlns:a16="http://schemas.microsoft.com/office/drawing/2014/main" id="{0894B326-A35F-D05E-DD5B-CAE2B4D488C1}"/>
+              </a:ext>
+            </a:extLst>
+          </p:cNvPr>
+          <p:cNvSpPr>
+            <a:spLocks noGrp="1"/>
+          </p:cNvSpPr>
+          <p:nvPr>
+            <p:ph type="ftr" sz="quarter" idx="11"/>
+          </p:nvPr>
+        </p:nvSpPr>
+        <p:spPr/>
+        <p:txBody>
+          <a:bodyPr/>
+          <a:lstStyle/>
+          <a:p>
+            <a:r>
+              <a:rPr lang="en-US"/>
+              <a:t>Corbin Ferguson</a:t>
+            </a:r>
+            <a:endParaRPr lang="en-US" dirty="0"/>
+          </a:p>
+        </p:txBody>
+      </p:sp>
+      <p:pic>
+        <p:nvPicPr>
+          <p:cNvPr id="3" name="!NewFile">
+            <a:extLst>
+              <a:ext uri="{FF2B5EF4-FFF2-40B4-BE49-F238E27FC236}">
+                <a16:creationId xmlns:a16="http://schemas.microsoft.com/office/drawing/2014/main" id="{A34E6259-020A-CE8B-AC93-FDF3B8CB5BB9}"/>
+              </a:ext>
+            </a:extLst>
+          </p:cNvPr>
+          <p:cNvPicPr>
+            <a:picLocks noChangeAspect="1"/>
+          </p:cNvPicPr>
+          <p:nvPr/>
+        </p:nvPicPr>
+        <p:blipFill>
+          <a:blip r:embed="rId2"/>
+          <a:stretch>
+            <a:fillRect/>
+          </a:stretch>
+        </p:blipFill>
+        <p:spPr>
+          <a:xfrm>
+            <a:off x="397934" y="911176"/>
+            <a:ext cx="11084414" cy="4390780"/>
+          </a:xfrm>
+          <a:prstGeom prst="rect">
+            <a:avLst/>
+          </a:prstGeom>
+        </p:spPr>
+      </p:pic>
+      <p:pic>
+        <p:nvPicPr>
+          <p:cNvPr id="11268" name="NewFile">
+            <a:extLst>
+              <a:ext uri="{FF2B5EF4-FFF2-40B4-BE49-F238E27FC236}">
+                <a16:creationId xmlns:a16="http://schemas.microsoft.com/office/drawing/2014/main" id="{398BFDD6-EE1D-2233-1BC7-9B7205573827}"/>
+              </a:ext>
+            </a:extLst>
+          </p:cNvPr>
+          <p:cNvPicPr>
+            <a:picLocks noChangeAspect="1" noChangeArrowheads="1"/>
+          </p:cNvPicPr>
+          <p:nvPr/>
+        </p:nvPicPr>
+        <p:blipFill>
+          <a:blip r:embed="rId3">
+            <a:extLst>
+              <a:ext uri="{28A0092B-C50C-407E-A947-70E740481C1C}">
+                <a14:useLocalDpi xmlns:a14="http://schemas.microsoft.com/office/drawing/2010/main" val="0"/>
+              </a:ext>
+            </a:extLst>
+          </a:blip>
+          <a:srcRect/>
+          <a:stretch>
+            <a:fillRect/>
+          </a:stretch>
+        </p:blipFill>
+        <p:spPr bwMode="auto">
+          <a:xfrm>
+            <a:off x="203201" y="911419"/>
+            <a:ext cx="11590866" cy="4951966"/>
+          </a:xfrm>
+          <a:prstGeom prst="rect">
+            <a:avLst/>
+          </a:prstGeom>
+          <a:solidFill>
+            <a:schemeClr val="bg1"/>
+          </a:solidFill>
+        </p:spPr>
+      </p:pic>
+      <p:sp>
+        <p:nvSpPr>
+          <p:cNvPr id="11" name="Rectangle: Rounded Corners 10">
+            <a:extLst>
+              <a:ext uri="{FF2B5EF4-FFF2-40B4-BE49-F238E27FC236}">
+                <a16:creationId xmlns:a16="http://schemas.microsoft.com/office/drawing/2014/main" id="{E527682E-55F4-1E8E-3D74-DD36AAF5EC17}"/>
+              </a:ext>
+            </a:extLst>
+          </p:cNvPr>
+          <p:cNvSpPr/>
+          <p:nvPr/>
+        </p:nvSpPr>
+        <p:spPr>
+          <a:xfrm>
+            <a:off x="2489200" y="3543300"/>
+            <a:ext cx="8839200" cy="1663700"/>
+          </a:xfrm>
+          <a:prstGeom prst="roundRect">
+            <a:avLst/>
+          </a:prstGeom>
+          <a:solidFill>
+            <a:srgbClr val="007CAA">
+              <a:alpha val="20000"/>
+            </a:srgbClr>
+          </a:solidFill>
+          <a:ln>
+            <a:solidFill>
+              <a:srgbClr val="007CAA"/>
+            </a:solidFill>
+          </a:ln>
+          <a:effectLst>
+            <a:glow rad="63500">
+              <a:schemeClr val="accent4">
+                <a:satMod val="175000"/>
+                <a:alpha val="40000"/>
+              </a:schemeClr>
+            </a:glow>
+          </a:effectLst>
+        </p:spPr>
+        <p:style>
+          <a:lnRef idx="2">
+            <a:schemeClr val="accent1">
+              <a:shade val="50000"/>
+            </a:schemeClr>
+          </a:lnRef>
+          <a:fillRef idx="1">
+            <a:schemeClr val="accent1"/>
+          </a:fillRef>
+          <a:effectRef idx="0">
+            <a:schemeClr val="accent1"/>
+          </a:effectRef>
+          <a:fontRef idx="minor">
+            <a:schemeClr val="lt1"/>
+          </a:fontRef>
+        </p:style>
+        <p:txBody>
+          <a:bodyPr rtlCol="0" anchor="ctr"/>
+          <a:lstStyle/>
+          <a:p>
+            <a:pPr algn="ctr"/>
+            <a:endParaRPr lang="en-US" sz="2000" dirty="0" err="1">
+              <a:solidFill>
+                <a:srgbClr val="FFFFFF"/>
+              </a:solidFill>
+              <a:latin typeface="E+H Sans" panose="020B0404050202020204" pitchFamily="34" charset="0"/>
+            </a:endParaRPr>
+          </a:p>
+        </p:txBody>
+      </p:sp>
+    </p:spTree>
+    <p:extLst>
+      <p:ext uri="{BB962C8B-B14F-4D97-AF65-F5344CB8AC3E}">
+        <p14:creationId xmlns:p14="http://schemas.microsoft.com/office/powerpoint/2010/main" val="935187346"/>
+      </p:ext>
+    </p:extLst>
+  </p:cSld>
+  <p:clrMapOvr>
+    <a:masterClrMapping/>
+  </p:clrMapOvr>
+  <mc:AlternateContent xmlns:mc="http://schemas.openxmlformats.org/markup-compatibility/2006">
+    <mc:Choice xmlns:p159="http://schemas.microsoft.com/office/powerpoint/2015/09/main" Requires="p159">
+      <p:transition xmlns:p14="http://schemas.microsoft.com/office/powerpoint/2010/main" spd="slow" p14:dur="2000">
+        <p159:morph option="byObject"/>
+      </p:transition>
+    </mc:Choice>
+    <mc:Fallback>
+      <p:transition spd="slow">
+        <p:fade/>
+      </p:transition>
+    </mc:Fallback>
+  </mc:AlternateContent>
+  <p:timing>
+    <p:tnLst>
+      <p:par>
+        <p:cTn id="1" dur="indefinite" restart="never" nodeType="tmRoot">
+          <p:childTnLst>
+            <p:seq concurrent="1" nextAc="seek">
+              <p:cTn id="2" dur="indefinite" nodeType="mainSeq">
+                <p:childTnLst>
+                  <p:par>
+                    <p:cTn id="3" fill="hold">
+                      <p:stCondLst>
+                        <p:cond delay="indefinite"/>
+                        <p:cond evt="onBegin" delay="0">
+                          <p:tn val="2"/>
+                        </p:cond>
+                      </p:stCondLst>
+                      <p:childTnLst>
+                        <p:par>
+                          <p:cTn id="4" fill="hold">
+                            <p:stCondLst>
+                              <p:cond delay="0"/>
+                            </p:stCondLst>
+                            <p:childTnLst>
+                              <p:par>
+                                <p:cTn id="5" presetID="10" presetClass="entr" presetSubtype="0" fill="hold" grpId="0" nodeType="afterEffect">
+                                  <p:stCondLst>
+                                    <p:cond delay="100"/>
+                                  </p:stCondLst>
+                                  <p:childTnLst>
+                                    <p:set>
+                                      <p:cBhvr>
+                                        <p:cTn id="6" dur="1" fill="hold">
+                                          <p:stCondLst>
+                                            <p:cond delay="0"/>
+                                          </p:stCondLst>
+                                        </p:cTn>
+                                        <p:tgtEl>
+                                          <p:spTgt spid="11"/>
+                                        </p:tgtEl>
+                                        <p:attrNameLst>
+                                          <p:attrName>style.visibility</p:attrName>
+                                        </p:attrNameLst>
+                                      </p:cBhvr>
+                                      <p:to>
+                                        <p:strVal val="visible"/>
+                                      </p:to>
+                                    </p:set>
+                                    <p:animEffect transition="in" filter="fade">
+                                      <p:cBhvr>
+                                        <p:cTn id="7" dur="500"/>
+                                        <p:tgtEl>
+                                          <p:spTgt spid="11"/>
+                                        </p:tgtEl>
+                                      </p:cBhvr>
+                                    </p:animEffect>
+                                  </p:childTnLst>
+                                </p:cTn>
+                              </p:par>
+                            </p:childTnLst>
+                          </p:cTn>
+                        </p:par>
+                        <p:par>
+                          <p:cTn id="8" fill="hold">
+                            <p:stCondLst>
+                              <p:cond delay="600"/>
+                            </p:stCondLst>
+                            <p:childTnLst>
+                              <p:par>
+                                <p:cTn id="9" presetID="1" presetClass="exit" presetSubtype="0" fill="hold" nodeType="afterEffect">
+                                  <p:stCondLst>
+                                    <p:cond delay="0"/>
+                                  </p:stCondLst>
+                                  <p:childTnLst>
+                                    <p:set>
+                                      <p:cBhvr>
+                                        <p:cTn id="10" dur="1" fill="hold">
+                                          <p:stCondLst>
+                                            <p:cond delay="0"/>
+                                          </p:stCondLst>
+                                        </p:cTn>
+                                        <p:tgtEl>
+                                          <p:spTgt spid="3"/>
+                                        </p:tgtEl>
+                                        <p:attrNameLst>
+                                          <p:attrName>style.visibility</p:attrName>
+                                        </p:attrNameLst>
+                                      </p:cBhvr>
+                                      <p:to>
+                                        <p:strVal val="hidden"/>
+                                      </p:to>
+                                    </p:set>
+                                  </p:childTnLst>
+                                </p:cTn>
+                              </p:par>
+                            </p:childTnLst>
+                          </p:cTn>
+                        </p:par>
+                      </p:childTnLst>
+                    </p:cTn>
+                  </p:par>
+                </p:childTnLst>
+              </p:cTn>
+              <p:prevCondLst>
+                <p:cond evt="onPrev" delay="0">
+                  <p:tgtEl>
+                    <p:sldTgt/>
+                  </p:tgtEl>
+                </p:cond>
+              </p:prevCondLst>
+              <p:nextCondLst>
+                <p:cond evt="onNext" delay="0">
+                  <p:tgtEl>
+                    <p:sldTgt/>
+                  </p:tgtEl>
+                </p:cond>
+              </p:nextCondLst>
+            </p:seq>
+          </p:childTnLst>
+        </p:cTn>
+      </p:par>
+    </p:tnLst>
+    <p:bldLst>
+      <p:bldP spid="11" grpId="0" animBg="1"/>
+    </p:bldLst>
+  </p:timing>
+</p:sld>
+</file>
+
+<file path=ppt/slides/slide13.xml><?xml version="1.0" encoding="utf-8"?>
+<p:sld xmlns:a="http://schemas.openxmlformats.org/drawingml/2006/main" xmlns:r="http://schemas.openxmlformats.org/officeDocument/2006/relationships" xmlns:p="http://schemas.openxmlformats.org/presentationml/2006/main">
+  <p:cSld>
+    <p:spTree>
+      <p:nvGrpSpPr>
+        <p:cNvPr id="1" name="">
+          <a:extLst>
+            <a:ext uri="{FF2B5EF4-FFF2-40B4-BE49-F238E27FC236}">
+              <a16:creationId xmlns:a16="http://schemas.microsoft.com/office/drawing/2014/main" id="{AE741E45-B413-0AAD-097D-05F3401E8023}"/>
+            </a:ext>
+          </a:extLst>
+        </p:cNvPr>
+        <p:cNvGrpSpPr/>
+        <p:nvPr/>
+      </p:nvGrpSpPr>
+      <p:grpSpPr>
+        <a:xfrm>
+          <a:off x="0" y="0"/>
+          <a:ext cx="0" cy="0"/>
+          <a:chOff x="0" y="0"/>
+          <a:chExt cx="0" cy="0"/>
+        </a:xfrm>
+      </p:grpSpPr>
+      <p:pic>
+        <p:nvPicPr>
+          <p:cNvPr id="8366" name="Picture 8365">
+            <a:extLst>
+              <a:ext uri="{FF2B5EF4-FFF2-40B4-BE49-F238E27FC236}">
+                <a16:creationId xmlns:a16="http://schemas.microsoft.com/office/drawing/2014/main" id="{60AE9E24-9AB4-5014-B6BD-6F056F5807BA}"/>
+              </a:ext>
+            </a:extLst>
+          </p:cNvPr>
+          <p:cNvPicPr>
+            <a:picLocks noChangeAspect="1"/>
+          </p:cNvPicPr>
+          <p:nvPr/>
+        </p:nvPicPr>
+        <p:blipFill>
+          <a:blip r:embed="rId2"/>
+          <a:stretch>
+            <a:fillRect/>
+          </a:stretch>
+        </p:blipFill>
+        <p:spPr>
+          <a:xfrm>
+            <a:off x="2181925" y="1160462"/>
+            <a:ext cx="7828149" cy="5113337"/>
+          </a:xfrm>
+          <a:prstGeom prst="rect">
+            <a:avLst/>
+          </a:prstGeom>
+          <a:noFill/>
+        </p:spPr>
+      </p:pic>
+      <p:sp>
+        <p:nvSpPr>
+          <p:cNvPr id="8" name="Footer Placeholder 7">
+            <a:extLst>
+              <a:ext uri="{FF2B5EF4-FFF2-40B4-BE49-F238E27FC236}">
+                <a16:creationId xmlns:a16="http://schemas.microsoft.com/office/drawing/2014/main" id="{4C7D5AC9-EA29-86A4-7EF8-4DF941130DC8}"/>
+              </a:ext>
+            </a:extLst>
+          </p:cNvPr>
+          <p:cNvSpPr>
+            <a:spLocks noGrp="1"/>
+          </p:cNvSpPr>
+          <p:nvPr>
+            <p:ph type="ftr" sz="quarter" idx="19"/>
+          </p:nvPr>
+        </p:nvSpPr>
+        <p:spPr>
+          <a:xfrm>
+            <a:off x="4086351" y="6469380"/>
+            <a:ext cx="1130300" cy="180000"/>
+          </a:xfrm>
+        </p:spPr>
+        <p:txBody>
+          <a:bodyPr wrap="none" anchor="ctr">
+            <a:normAutofit/>
+          </a:bodyPr>
+          <a:lstStyle/>
+          <a:p>
+            <a:pPr>
+              <a:lnSpc>
+                <a:spcPct val="90000"/>
+              </a:lnSpc>
+              <a:spcAft>
+                <a:spcPts val="600"/>
+              </a:spcAft>
+            </a:pPr>
+            <a:r>
+              <a:rPr lang="en-US"/>
+              <a:t>Corbin Ferguson</a:t>
+            </a:r>
+          </a:p>
+        </p:txBody>
+      </p:sp>
+      <p:sp>
+        <p:nvSpPr>
+          <p:cNvPr id="7" name="Slide Number Placeholder 6">
+            <a:extLst>
+              <a:ext uri="{FF2B5EF4-FFF2-40B4-BE49-F238E27FC236}">
+                <a16:creationId xmlns:a16="http://schemas.microsoft.com/office/drawing/2014/main" id="{3583879C-95E5-7299-C98A-2B7D0B63F807}"/>
+              </a:ext>
+            </a:extLst>
+          </p:cNvPr>
+          <p:cNvSpPr>
+            <a:spLocks noGrp="1"/>
+          </p:cNvSpPr>
+          <p:nvPr>
+            <p:ph type="sldNum" sz="quarter" idx="20"/>
+          </p:nvPr>
+        </p:nvSpPr>
+        <p:spPr>
+          <a:xfrm>
+            <a:off x="1633051" y="6469380"/>
+            <a:ext cx="571500" cy="180000"/>
+          </a:xfrm>
+        </p:spPr>
+        <p:txBody>
+          <a:bodyPr wrap="none" anchor="ctr">
+            <a:normAutofit/>
+          </a:bodyPr>
+          <a:lstStyle/>
+          <a:p>
+            <a:pPr>
+              <a:lnSpc>
+                <a:spcPct val="90000"/>
+              </a:lnSpc>
+              <a:spcAft>
+                <a:spcPts val="600"/>
+              </a:spcAft>
+            </a:pPr>
+            <a:r>
+              <a:rPr lang="en-US"/>
+              <a:t>Slide </a:t>
+            </a:r>
+            <a:fld id="{C6F8E2D1-BFA0-484A-B7F1-E348F2594759}" type="slidenum">
+              <a:rPr lang="en-US" smtClean="0"/>
+              <a:pPr>
+                <a:lnSpc>
+                  <a:spcPct val="90000"/>
+                </a:lnSpc>
+                <a:spcAft>
+                  <a:spcPts val="600"/>
+                </a:spcAft>
+              </a:pPr>
+              <a:t>13</a:t>
+            </a:fld>
+            <a:endParaRPr lang="en-US"/>
+          </a:p>
+        </p:txBody>
+      </p:sp>
+      <p:sp>
+        <p:nvSpPr>
+          <p:cNvPr id="4" name="Date Placeholder 3">
+            <a:extLst>
+              <a:ext uri="{FF2B5EF4-FFF2-40B4-BE49-F238E27FC236}">
+                <a16:creationId xmlns:a16="http://schemas.microsoft.com/office/drawing/2014/main" id="{6F1C84BC-19BE-D2D3-DB6B-179BB01EE861}"/>
+              </a:ext>
+            </a:extLst>
+          </p:cNvPr>
+          <p:cNvSpPr>
+            <a:spLocks noGrp="1"/>
+          </p:cNvSpPr>
+          <p:nvPr>
+            <p:ph type="dt" sz="half" idx="21"/>
+          </p:nvPr>
+        </p:nvSpPr>
+        <p:spPr>
+          <a:xfrm>
+            <a:off x="334963" y="194736"/>
+            <a:ext cx="9674225" cy="180000"/>
+          </a:xfrm>
+        </p:spPr>
+        <p:txBody>
+          <a:bodyPr wrap="none" anchor="t">
+            <a:normAutofit/>
+          </a:bodyPr>
+          <a:lstStyle/>
+          <a:p>
+            <a:pPr>
+              <a:lnSpc>
+                <a:spcPct val="90000"/>
+              </a:lnSpc>
+              <a:spcAft>
+                <a:spcPts val="600"/>
+              </a:spcAft>
+            </a:pPr>
+            <a:r>
+              <a:rPr lang="en-US"/>
+              <a:t>L5X Automation Build Tool</a:t>
+            </a:r>
+          </a:p>
+        </p:txBody>
+      </p:sp>
+      <p:sp>
+        <p:nvSpPr>
+          <p:cNvPr id="2" name="Title 1">
+            <a:extLst>
+              <a:ext uri="{FF2B5EF4-FFF2-40B4-BE49-F238E27FC236}">
+                <a16:creationId xmlns:a16="http://schemas.microsoft.com/office/drawing/2014/main" id="{07BCF97A-6A5E-DA70-0A21-4FF0D5A9B2D1}"/>
+              </a:ext>
+            </a:extLst>
+          </p:cNvPr>
+          <p:cNvSpPr>
+            <a:spLocks noGrp="1"/>
+          </p:cNvSpPr>
+          <p:nvPr>
+            <p:ph type="title"/>
+          </p:nvPr>
+        </p:nvSpPr>
+        <p:spPr>
+          <a:xfrm>
+            <a:off x="334963" y="620690"/>
+            <a:ext cx="11522075" cy="360041"/>
+          </a:xfrm>
+        </p:spPr>
+        <p:txBody>
+          <a:bodyPr wrap="none" anchor="t">
+            <a:normAutofit/>
+          </a:bodyPr>
+          <a:lstStyle/>
+          <a:p>
+            <a:r>
+              <a:rPr lang="en-US" dirty="0"/>
+              <a:t>Class Diagram</a:t>
+            </a:r>
+          </a:p>
+        </p:txBody>
+      </p:sp>
+    </p:spTree>
+    <p:extLst>
+      <p:ext uri="{BB962C8B-B14F-4D97-AF65-F5344CB8AC3E}">
+        <p14:creationId xmlns:p14="http://schemas.microsoft.com/office/powerpoint/2010/main" val="2077614573"/>
+      </p:ext>
+    </p:extLst>
+  </p:cSld>
+  <p:clrMapOvr>
+    <a:masterClrMapping/>
+  </p:clrMapOvr>
+</p:sld>
+</file>
+
+<file path=ppt/slides/slide14.xml><?xml version="1.0" encoding="utf-8"?>
+<p:sld xmlns:a="http://schemas.openxmlformats.org/drawingml/2006/main" xmlns:r="http://schemas.openxmlformats.org/officeDocument/2006/relationships" xmlns:p="http://schemas.openxmlformats.org/presentationml/2006/main">
+  <p:cSld>
+    <p:spTree>
+      <p:nvGrpSpPr>
+        <p:cNvPr id="1" name="">
+          <a:extLst>
+            <a:ext uri="{FF2B5EF4-FFF2-40B4-BE49-F238E27FC236}">
+              <a16:creationId xmlns:a16="http://schemas.microsoft.com/office/drawing/2014/main" id="{B031D0FB-813C-A1A9-95BF-F0A18A2C1086}"/>
+            </a:ext>
+          </a:extLst>
+        </p:cNvPr>
+        <p:cNvGrpSpPr/>
+        <p:nvPr/>
+      </p:nvGrpSpPr>
+      <p:grpSpPr>
+        <a:xfrm>
+          <a:off x="0" y="0"/>
+          <a:ext cx="0" cy="0"/>
+          <a:chOff x="0" y="0"/>
+          <a:chExt cx="0" cy="0"/>
+        </a:xfrm>
+      </p:grpSpPr>
+      <p:pic>
+        <p:nvPicPr>
+          <p:cNvPr id="9" name="Picture 8">
+            <a:extLst>
+              <a:ext uri="{FF2B5EF4-FFF2-40B4-BE49-F238E27FC236}">
+                <a16:creationId xmlns:a16="http://schemas.microsoft.com/office/drawing/2014/main" id="{A889D74E-A641-8FCA-9F55-93231CDB546D}"/>
+              </a:ext>
+            </a:extLst>
+          </p:cNvPr>
+          <p:cNvPicPr>
+            <a:picLocks noChangeAspect="1"/>
+          </p:cNvPicPr>
+          <p:nvPr/>
+        </p:nvPicPr>
+        <p:blipFill>
+          <a:blip r:embed="rId2"/>
+          <a:stretch>
+            <a:fillRect/>
+          </a:stretch>
+        </p:blipFill>
+        <p:spPr>
+          <a:xfrm>
+            <a:off x="1176290" y="1160462"/>
+            <a:ext cx="9839419" cy="5113337"/>
+          </a:xfrm>
+          <a:prstGeom prst="rect">
+            <a:avLst/>
+          </a:prstGeom>
+          <a:noFill/>
+        </p:spPr>
+      </p:pic>
+      <p:sp>
+        <p:nvSpPr>
+          <p:cNvPr id="8" name="Footer Placeholder 7">
+            <a:extLst>
+              <a:ext uri="{FF2B5EF4-FFF2-40B4-BE49-F238E27FC236}">
+                <a16:creationId xmlns:a16="http://schemas.microsoft.com/office/drawing/2014/main" id="{71C973FB-1860-D33D-FFB0-E373255B1325}"/>
+              </a:ext>
+            </a:extLst>
+          </p:cNvPr>
+          <p:cNvSpPr>
+            <a:spLocks noGrp="1"/>
+          </p:cNvSpPr>
+          <p:nvPr>
+            <p:ph type="ftr" sz="quarter" idx="19"/>
+          </p:nvPr>
+        </p:nvSpPr>
+        <p:spPr>
+          <a:xfrm>
+            <a:off x="4086351" y="6469380"/>
+            <a:ext cx="1130300" cy="180000"/>
+          </a:xfrm>
+        </p:spPr>
+        <p:txBody>
+          <a:bodyPr wrap="none" anchor="ctr">
+            <a:normAutofit/>
+          </a:bodyPr>
+          <a:lstStyle/>
+          <a:p>
+            <a:pPr>
+              <a:lnSpc>
+                <a:spcPct val="90000"/>
+              </a:lnSpc>
+              <a:spcAft>
+                <a:spcPts val="600"/>
+              </a:spcAft>
+            </a:pPr>
+            <a:r>
+              <a:rPr lang="en-US"/>
+              <a:t>Corbin Ferguson</a:t>
+            </a:r>
+          </a:p>
+        </p:txBody>
+      </p:sp>
+      <p:sp>
+        <p:nvSpPr>
+          <p:cNvPr id="7" name="Slide Number Placeholder 6">
+            <a:extLst>
+              <a:ext uri="{FF2B5EF4-FFF2-40B4-BE49-F238E27FC236}">
+                <a16:creationId xmlns:a16="http://schemas.microsoft.com/office/drawing/2014/main" id="{FF861633-550D-9192-7E16-88623F1FDD40}"/>
+              </a:ext>
+            </a:extLst>
+          </p:cNvPr>
+          <p:cNvSpPr>
+            <a:spLocks noGrp="1"/>
+          </p:cNvSpPr>
+          <p:nvPr>
+            <p:ph type="sldNum" sz="quarter" idx="20"/>
+          </p:nvPr>
+        </p:nvSpPr>
+        <p:spPr>
+          <a:xfrm>
+            <a:off x="1633051" y="6469380"/>
+            <a:ext cx="571500" cy="180000"/>
+          </a:xfrm>
+        </p:spPr>
+        <p:txBody>
+          <a:bodyPr wrap="none" anchor="ctr">
+            <a:normAutofit/>
+          </a:bodyPr>
+          <a:lstStyle/>
+          <a:p>
+            <a:pPr>
+              <a:lnSpc>
+                <a:spcPct val="90000"/>
+              </a:lnSpc>
+              <a:spcAft>
+                <a:spcPts val="600"/>
+              </a:spcAft>
+            </a:pPr>
+            <a:r>
+              <a:rPr lang="en-US"/>
+              <a:t>Slide </a:t>
+            </a:r>
+            <a:fld id="{C6F8E2D1-BFA0-484A-B7F1-E348F2594759}" type="slidenum">
+              <a:rPr lang="en-US" smtClean="0"/>
+              <a:pPr>
+                <a:lnSpc>
+                  <a:spcPct val="90000"/>
+                </a:lnSpc>
+                <a:spcAft>
+                  <a:spcPts val="600"/>
+                </a:spcAft>
+              </a:pPr>
+              <a:t>14</a:t>
+            </a:fld>
+            <a:endParaRPr lang="en-US"/>
+          </a:p>
+        </p:txBody>
+      </p:sp>
+      <p:sp>
+        <p:nvSpPr>
+          <p:cNvPr id="4" name="Date Placeholder 3">
+            <a:extLst>
+              <a:ext uri="{FF2B5EF4-FFF2-40B4-BE49-F238E27FC236}">
+                <a16:creationId xmlns:a16="http://schemas.microsoft.com/office/drawing/2014/main" id="{5D0DCAB8-9A4F-6068-74B2-D5C8356B650C}"/>
+              </a:ext>
+            </a:extLst>
+          </p:cNvPr>
+          <p:cNvSpPr>
+            <a:spLocks noGrp="1"/>
+          </p:cNvSpPr>
+          <p:nvPr>
+            <p:ph type="dt" sz="half" idx="21"/>
+          </p:nvPr>
+        </p:nvSpPr>
+        <p:spPr>
+          <a:xfrm>
+            <a:off x="334963" y="194736"/>
+            <a:ext cx="9674225" cy="180000"/>
+          </a:xfrm>
+        </p:spPr>
+        <p:txBody>
+          <a:bodyPr wrap="none" anchor="t">
+            <a:normAutofit/>
+          </a:bodyPr>
+          <a:lstStyle/>
+          <a:p>
+            <a:pPr>
+              <a:lnSpc>
+                <a:spcPct val="90000"/>
+              </a:lnSpc>
+              <a:spcAft>
+                <a:spcPts val="600"/>
+              </a:spcAft>
+            </a:pPr>
+            <a:r>
+              <a:rPr lang="en-US"/>
+              <a:t>L5X Automation Build Tool</a:t>
+            </a:r>
+          </a:p>
+        </p:txBody>
+      </p:sp>
+      <p:sp>
+        <p:nvSpPr>
+          <p:cNvPr id="2" name="Title 1">
+            <a:extLst>
+              <a:ext uri="{FF2B5EF4-FFF2-40B4-BE49-F238E27FC236}">
+                <a16:creationId xmlns:a16="http://schemas.microsoft.com/office/drawing/2014/main" id="{5EBCB58C-1369-EDD7-5D5E-7C1E1415DB2E}"/>
+              </a:ext>
+            </a:extLst>
+          </p:cNvPr>
+          <p:cNvSpPr>
+            <a:spLocks noGrp="1"/>
+          </p:cNvSpPr>
+          <p:nvPr>
+            <p:ph type="title"/>
+          </p:nvPr>
+        </p:nvSpPr>
+        <p:spPr>
+          <a:xfrm>
+            <a:off x="334963" y="620690"/>
+            <a:ext cx="11522075" cy="360041"/>
+          </a:xfrm>
+        </p:spPr>
+        <p:txBody>
+          <a:bodyPr wrap="none" anchor="t">
+            <a:normAutofit/>
+          </a:bodyPr>
+          <a:lstStyle/>
+          <a:p>
+            <a:r>
+              <a:rPr lang="en-US" dirty="0"/>
+              <a:t>Class Diagram Cont.</a:t>
+            </a:r>
+          </a:p>
+        </p:txBody>
+      </p:sp>
+    </p:spTree>
+    <p:extLst>
+      <p:ext uri="{BB962C8B-B14F-4D97-AF65-F5344CB8AC3E}">
+        <p14:creationId xmlns:p14="http://schemas.microsoft.com/office/powerpoint/2010/main" val="1692918807"/>
+      </p:ext>
+    </p:extLst>
+  </p:cSld>
+  <p:clrMapOvr>
+    <a:masterClrMapping/>
+  </p:clrMapOvr>
+</p:sld>
+</file>
+
+<file path=ppt/slides/slide15.xml><?xml version="1.0" encoding="utf-8"?>
+<p:sld xmlns:a="http://schemas.openxmlformats.org/drawingml/2006/main" xmlns:r="http://schemas.openxmlformats.org/officeDocument/2006/relationships" xmlns:p="http://schemas.openxmlformats.org/presentationml/2006/main">
+  <p:cSld>
+    <p:spTree>
+      <p:nvGrpSpPr>
+        <p:cNvPr id="1" name="">
+          <a:extLst>
+            <a:ext uri="{FF2B5EF4-FFF2-40B4-BE49-F238E27FC236}">
               <a16:creationId xmlns:a16="http://schemas.microsoft.com/office/drawing/2014/main" id="{93938A11-EECC-9BC6-7865-435054160CD9}"/>
             </a:ext>
           </a:extLst>
@@ -19631,7 +21810,7 @@
             </a:r>
             <a:fld id="{78C39363-BD0C-4CE6-8DE9-7D78215F2B9F}" type="slidenum">
               <a:rPr lang="en-US" smtClean="0"/>
-              <a:t>10</a:t>
+              <a:t>15</a:t>
             </a:fld>
             <a:endParaRPr lang="en-US" dirty="0"/>
           </a:p>
@@ -19773,7 +21952,7 @@
 </p:sld>
 </file>
 
-<file path=ppt/slides/slide11.xml><?xml version="1.0" encoding="utf-8"?>
+<file path=ppt/slides/slide16.xml><?xml version="1.0" encoding="utf-8"?>
 <p:sld xmlns:a="http://schemas.openxmlformats.org/drawingml/2006/main" xmlns:r="http://schemas.openxmlformats.org/officeDocument/2006/relationships" xmlns:p="http://schemas.openxmlformats.org/presentationml/2006/main">
   <p:cSld>
     <p:spTree>
@@ -19885,7 +22064,7 @@
             </a:r>
             <a:fld id="{599786A8-973E-49A8-9C43-0BE71F98A081}" type="slidenum">
               <a:rPr lang="en-US" smtClean="0"/>
-              <a:t>11</a:t>
+              <a:t>16</a:t>
             </a:fld>
             <a:endParaRPr lang="en-US" dirty="0"/>
           </a:p>
@@ -20027,7 +22206,7 @@
 </p:sld>
 </file>
 
-<file path=ppt/slides/slide12.xml><?xml version="1.0" encoding="utf-8"?>
+<file path=ppt/slides/slide17.xml><?xml version="1.0" encoding="utf-8"?>
 <p:sld xmlns:a="http://schemas.openxmlformats.org/drawingml/2006/main" xmlns:r="http://schemas.openxmlformats.org/officeDocument/2006/relationships" xmlns:p="http://schemas.openxmlformats.org/presentationml/2006/main">
   <p:cSld>
     <p:spTree>
@@ -20139,7 +22318,7 @@
             </a:r>
             <a:fld id="{DEE51C30-41E2-4709-97ED-40F16AE6C836}" type="slidenum">
               <a:rPr lang="en-US" smtClean="0"/>
-              <a:t>12</a:t>
+              <a:t>17</a:t>
             </a:fld>
             <a:endParaRPr lang="en-US" dirty="0"/>
           </a:p>
@@ -20375,7 +22554,7 @@
 </p:sld>
 </file>
 
-<file path=ppt/slides/slide13.xml><?xml version="1.0" encoding="utf-8"?>
+<file path=ppt/slides/slide18.xml><?xml version="1.0" encoding="utf-8"?>
 <p:sld xmlns:a="http://schemas.openxmlformats.org/drawingml/2006/main" xmlns:r="http://schemas.openxmlformats.org/officeDocument/2006/relationships" xmlns:p="http://schemas.openxmlformats.org/presentationml/2006/main">
   <p:cSld>
     <p:spTree>
@@ -20454,7 +22633,7 @@
             </a:r>
             <a:fld id="{32B897BE-5B46-4D7A-8E5C-716C3CDA6A39}" type="slidenum">
               <a:rPr lang="en-US" smtClean="0"/>
-              <a:t>13</a:t>
+              <a:t>18</a:t>
             </a:fld>
             <a:endParaRPr lang="en-US" dirty="0"/>
           </a:p>
@@ -20568,7 +22747,7 @@
 </p:sld>
 </file>
 
-<file path=ppt/slides/slide14.xml><?xml version="1.0" encoding="utf-8"?>
+<file path=ppt/slides/slide19.xml><?xml version="1.0" encoding="utf-8"?>
 <p:sld xmlns:a="http://schemas.openxmlformats.org/drawingml/2006/main" xmlns:r="http://schemas.openxmlformats.org/officeDocument/2006/relationships" xmlns:p="http://schemas.openxmlformats.org/presentationml/2006/main">
   <p:cSld>
     <p:spTree>
@@ -20806,7 +22985,7 @@
             </a:r>
             <a:fld id="{5BFF8BEA-C7AD-416A-8E1B-AC59D078A379}" type="slidenum">
               <a:rPr lang="en-US" smtClean="0"/>
-              <a:t>14</a:t>
+              <a:t>19</a:t>
             </a:fld>
             <a:endParaRPr lang="en-US" dirty="0"/>
           </a:p>
@@ -20854,7 +23033,236 @@
 </p:sld>
 </file>
 
-<file path=ppt/slides/slide15.xml><?xml version="1.0" encoding="utf-8"?>
+<file path=ppt/slides/slide2.xml><?xml version="1.0" encoding="utf-8"?>
+<p:sld xmlns:a="http://schemas.openxmlformats.org/drawingml/2006/main" xmlns:r="http://schemas.openxmlformats.org/officeDocument/2006/relationships" xmlns:p="http://schemas.openxmlformats.org/presentationml/2006/main">
+  <p:cSld>
+    <p:spTree>
+      <p:nvGrpSpPr>
+        <p:cNvPr id="1" name="">
+          <a:extLst>
+            <a:ext uri="{FF2B5EF4-FFF2-40B4-BE49-F238E27FC236}">
+              <a16:creationId xmlns:a16="http://schemas.microsoft.com/office/drawing/2014/main" id="{ECC06C52-67BC-A4C8-3ED0-3636080E3212}"/>
+            </a:ext>
+          </a:extLst>
+        </p:cNvPr>
+        <p:cNvGrpSpPr/>
+        <p:nvPr/>
+      </p:nvGrpSpPr>
+      <p:grpSpPr>
+        <a:xfrm>
+          <a:off x="0" y="0"/>
+          <a:ext cx="0" cy="0"/>
+          <a:chOff x="0" y="0"/>
+          <a:chExt cx="0" cy="0"/>
+        </a:xfrm>
+      </p:grpSpPr>
+      <p:sp>
+        <p:nvSpPr>
+          <p:cNvPr id="2" name="Title 1">
+            <a:extLst>
+              <a:ext uri="{FF2B5EF4-FFF2-40B4-BE49-F238E27FC236}">
+                <a16:creationId xmlns:a16="http://schemas.microsoft.com/office/drawing/2014/main" id="{389C7A2E-1427-5278-B512-F2A80C319122}"/>
+              </a:ext>
+            </a:extLst>
+          </p:cNvPr>
+          <p:cNvSpPr>
+            <a:spLocks noGrp="1"/>
+          </p:cNvSpPr>
+          <p:nvPr>
+            <p:ph type="title"/>
+          </p:nvPr>
+        </p:nvSpPr>
+        <p:spPr>
+          <a:xfrm>
+            <a:off x="334963" y="620690"/>
+            <a:ext cx="11522075" cy="360041"/>
+          </a:xfrm>
+        </p:spPr>
+        <p:txBody>
+          <a:bodyPr/>
+          <a:lstStyle/>
+          <a:p>
+            <a:r>
+              <a:rPr lang="en-US" dirty="0"/>
+              <a:t>Outline</a:t>
+            </a:r>
+          </a:p>
+        </p:txBody>
+      </p:sp>
+      <p:sp>
+        <p:nvSpPr>
+          <p:cNvPr id="13" name="Content Placeholder 12">
+            <a:extLst>
+              <a:ext uri="{FF2B5EF4-FFF2-40B4-BE49-F238E27FC236}">
+                <a16:creationId xmlns:a16="http://schemas.microsoft.com/office/drawing/2014/main" id="{9ABB78FB-6052-78C4-38A0-9B7AF58E9FCB}"/>
+              </a:ext>
+            </a:extLst>
+          </p:cNvPr>
+          <p:cNvSpPr>
+            <a:spLocks noGrp="1"/>
+          </p:cNvSpPr>
+          <p:nvPr>
+            <p:ph idx="1"/>
+          </p:nvPr>
+        </p:nvSpPr>
+        <p:spPr/>
+        <p:txBody>
+          <a:bodyPr/>
+          <a:lstStyle/>
+          <a:p>
+            <a:r>
+              <a:rPr lang="en-US" dirty="0"/>
+              <a:t>Project Goals</a:t>
+            </a:r>
+          </a:p>
+          <a:p>
+            <a:r>
+              <a:rPr lang="en-US" dirty="0"/>
+              <a:t>Implemented Features</a:t>
+            </a:r>
+          </a:p>
+          <a:p>
+            <a:r>
+              <a:rPr lang="en-US" dirty="0"/>
+              <a:t>Design timeline</a:t>
+            </a:r>
+          </a:p>
+          <a:p>
+            <a:r>
+              <a:rPr lang="en-US" dirty="0"/>
+              <a:t>Tools Used</a:t>
+            </a:r>
+          </a:p>
+          <a:p>
+            <a:r>
+              <a:rPr lang="en-US" dirty="0"/>
+              <a:t>System Design</a:t>
+            </a:r>
+          </a:p>
+          <a:p>
+            <a:r>
+              <a:rPr lang="en-US" dirty="0"/>
+              <a:t>Testing and Verification</a:t>
+            </a:r>
+          </a:p>
+          <a:p>
+            <a:r>
+              <a:rPr lang="en-US" dirty="0"/>
+              <a:t>Lessons Learned</a:t>
+            </a:r>
+          </a:p>
+        </p:txBody>
+      </p:sp>
+      <p:sp>
+        <p:nvSpPr>
+          <p:cNvPr id="4" name="Date Placeholder 3">
+            <a:extLst>
+              <a:ext uri="{FF2B5EF4-FFF2-40B4-BE49-F238E27FC236}">
+                <a16:creationId xmlns:a16="http://schemas.microsoft.com/office/drawing/2014/main" id="{64344D59-887A-89DB-90DC-83D1F2848381}"/>
+              </a:ext>
+            </a:extLst>
+          </p:cNvPr>
+          <p:cNvSpPr>
+            <a:spLocks noGrp="1"/>
+          </p:cNvSpPr>
+          <p:nvPr>
+            <p:ph type="dt" sz="half" idx="10"/>
+          </p:nvPr>
+        </p:nvSpPr>
+        <p:spPr>
+          <a:xfrm>
+            <a:off x="334963" y="194736"/>
+            <a:ext cx="9674225" cy="180000"/>
+          </a:xfrm>
+        </p:spPr>
+        <p:txBody>
+          <a:bodyPr/>
+          <a:lstStyle/>
+          <a:p>
+            <a:r>
+              <a:rPr lang="en-US"/>
+              <a:t>L5X Automation Build Tool</a:t>
+            </a:r>
+            <a:endParaRPr lang="en-US" dirty="0"/>
+          </a:p>
+        </p:txBody>
+      </p:sp>
+      <p:sp>
+        <p:nvSpPr>
+          <p:cNvPr id="3" name="Slide Number Placeholder 2">
+            <a:extLst>
+              <a:ext uri="{FF2B5EF4-FFF2-40B4-BE49-F238E27FC236}">
+                <a16:creationId xmlns:a16="http://schemas.microsoft.com/office/drawing/2014/main" id="{D1AEB583-7C00-647F-EA4B-940732920BC4}"/>
+              </a:ext>
+            </a:extLst>
+          </p:cNvPr>
+          <p:cNvSpPr>
+            <a:spLocks noGrp="1"/>
+          </p:cNvSpPr>
+          <p:nvPr>
+            <p:ph type="sldNum" sz="quarter" idx="12"/>
+          </p:nvPr>
+        </p:nvSpPr>
+        <p:spPr/>
+        <p:txBody>
+          <a:bodyPr/>
+          <a:lstStyle/>
+          <a:p>
+            <a:r>
+              <a:rPr lang="en-US"/>
+              <a:t>Slide </a:t>
+            </a:r>
+            <a:fld id="{6ED4F0B8-A3B9-4B6F-BEC0-B0E78C1192A7}" type="slidenum">
+              <a:rPr lang="en-US" smtClean="0"/>
+              <a:t>2</a:t>
+            </a:fld>
+            <a:endParaRPr lang="en-US" dirty="0"/>
+          </a:p>
+        </p:txBody>
+      </p:sp>
+      <p:sp>
+        <p:nvSpPr>
+          <p:cNvPr id="7" name="Footer Placeholder 6">
+            <a:extLst>
+              <a:ext uri="{FF2B5EF4-FFF2-40B4-BE49-F238E27FC236}">
+                <a16:creationId xmlns:a16="http://schemas.microsoft.com/office/drawing/2014/main" id="{9F92DEA4-6CF8-8F90-FC4B-A9A798E29D53}"/>
+              </a:ext>
+            </a:extLst>
+          </p:cNvPr>
+          <p:cNvSpPr>
+            <a:spLocks noGrp="1"/>
+          </p:cNvSpPr>
+          <p:nvPr>
+            <p:ph type="ftr" sz="quarter" idx="11"/>
+          </p:nvPr>
+        </p:nvSpPr>
+        <p:spPr/>
+        <p:txBody>
+          <a:bodyPr/>
+          <a:lstStyle/>
+          <a:p>
+            <a:r>
+              <a:rPr lang="en-US"/>
+              <a:t>Corbin Ferguson</a:t>
+            </a:r>
+            <a:endParaRPr lang="en-US" dirty="0"/>
+          </a:p>
+        </p:txBody>
+      </p:sp>
+    </p:spTree>
+    <p:extLst>
+      <p:ext uri="{BB962C8B-B14F-4D97-AF65-F5344CB8AC3E}">
+        <p14:creationId xmlns:p14="http://schemas.microsoft.com/office/powerpoint/2010/main" val="4050751982"/>
+      </p:ext>
+    </p:extLst>
+  </p:cSld>
+  <p:clrMapOvr>
+    <a:masterClrMapping/>
+  </p:clrMapOvr>
+</p:sld>
+</file>
+
+<file path=ppt/slides/slide20.xml><?xml version="1.0" encoding="utf-8"?>
 <p:sld xmlns:a="http://schemas.openxmlformats.org/drawingml/2006/main" xmlns:r="http://schemas.openxmlformats.org/officeDocument/2006/relationships" xmlns:p="http://schemas.openxmlformats.org/presentationml/2006/main">
   <p:cSld>
     <p:spTree>
@@ -20985,7 +23393,7 @@
             </a:r>
             <a:fld id="{358A1964-41C6-43E7-8879-EF27F633EDD1}" type="slidenum">
               <a:rPr lang="en-US" smtClean="0"/>
-              <a:t>15</a:t>
+              <a:t>20</a:t>
             </a:fld>
             <a:endParaRPr lang="en-US" dirty="0"/>
           </a:p>
@@ -21158,7 +23566,7 @@
 </p:sld>
 </file>
 
-<file path=ppt/slides/slide16.xml><?xml version="1.0" encoding="utf-8"?>
+<file path=ppt/slides/slide21.xml><?xml version="1.0" encoding="utf-8"?>
 <p:sld xmlns:a="http://schemas.openxmlformats.org/drawingml/2006/main" xmlns:r="http://schemas.openxmlformats.org/officeDocument/2006/relationships" xmlns:p="http://schemas.openxmlformats.org/presentationml/2006/main">
   <p:cSld>
     <p:spTree>
@@ -21342,7 +23750,7 @@
             </a:r>
             <a:fld id="{B7F1FE61-F696-4BC2-948F-7278C8C6DBB9}" type="slidenum">
               <a:rPr lang="en-US" smtClean="0"/>
-              <a:t>16</a:t>
+              <a:t>21</a:t>
             </a:fld>
             <a:endParaRPr lang="en-US" dirty="0"/>
           </a:p>
@@ -21389,7 +23797,7 @@
 </p:sld>
 </file>
 
-<file path=ppt/slides/slide17.xml><?xml version="1.0" encoding="utf-8"?>
+<file path=ppt/slides/slide22.xml><?xml version="1.0" encoding="utf-8"?>
 <p:sld xmlns:a="http://schemas.openxmlformats.org/drawingml/2006/main" xmlns:r="http://schemas.openxmlformats.org/officeDocument/2006/relationships" xmlns:p="http://schemas.openxmlformats.org/presentationml/2006/main">
   <p:cSld>
     <p:spTree>
@@ -21569,7 +23977,7 @@
             </a:r>
             <a:fld id="{B7F1FE61-F696-4BC2-948F-7278C8C6DBB9}" type="slidenum">
               <a:rPr lang="en-US" smtClean="0"/>
-              <a:t>17</a:t>
+              <a:t>22</a:t>
             </a:fld>
             <a:endParaRPr lang="en-US" dirty="0"/>
           </a:p>
@@ -21616,7 +24024,7 @@
 </p:sld>
 </file>
 
-<file path=ppt/slides/slide18.xml><?xml version="1.0" encoding="utf-8"?>
+<file path=ppt/slides/slide23.xml><?xml version="1.0" encoding="utf-8"?>
 <p:sld xmlns:a="http://schemas.openxmlformats.org/drawingml/2006/main" xmlns:r="http://schemas.openxmlformats.org/officeDocument/2006/relationships" xmlns:p="http://schemas.openxmlformats.org/presentationml/2006/main">
   <p:cSld>
     <p:spTree>
@@ -21666,7 +24074,7 @@
             </a:r>
             <a:fld id="{C20DA095-8283-4DCC-BA55-3B61E88C6181}" type="slidenum">
               <a:rPr lang="en-US" smtClean="0"/>
-              <a:t>18</a:t>
+              <a:t>23</a:t>
             </a:fld>
             <a:endParaRPr lang="en-US" dirty="0"/>
           </a:p>
@@ -21760,7 +24168,7 @@
 </p:sld>
 </file>
 
-<file path=ppt/slides/slide19.xml><?xml version="1.0" encoding="utf-8"?>
+<file path=ppt/slides/slide24.xml><?xml version="1.0" encoding="utf-8"?>
 <p:sld xmlns:a="http://schemas.openxmlformats.org/drawingml/2006/main" xmlns:r="http://schemas.openxmlformats.org/officeDocument/2006/relationships" xmlns:p="http://schemas.openxmlformats.org/presentationml/2006/main">
   <p:cSld>
     <p:spTree>
@@ -22035,7 +24443,7 @@
             </a:r>
             <a:fld id="{B7F1FE61-F696-4BC2-948F-7278C8C6DBB9}" type="slidenum">
               <a:rPr lang="en-US" smtClean="0"/>
-              <a:t>19</a:t>
+              <a:t>24</a:t>
             </a:fld>
             <a:endParaRPr lang="en-US" dirty="0"/>
           </a:p>
@@ -22073,235 +24481,6 @@
     <p:extLst>
       <p:ext uri="{BB962C8B-B14F-4D97-AF65-F5344CB8AC3E}">
         <p14:creationId xmlns:p14="http://schemas.microsoft.com/office/powerpoint/2010/main" val="1869098219"/>
-      </p:ext>
-    </p:extLst>
-  </p:cSld>
-  <p:clrMapOvr>
-    <a:masterClrMapping/>
-  </p:clrMapOvr>
-</p:sld>
-</file>
-
-<file path=ppt/slides/slide2.xml><?xml version="1.0" encoding="utf-8"?>
-<p:sld xmlns:a="http://schemas.openxmlformats.org/drawingml/2006/main" xmlns:r="http://schemas.openxmlformats.org/officeDocument/2006/relationships" xmlns:p="http://schemas.openxmlformats.org/presentationml/2006/main">
-  <p:cSld>
-    <p:spTree>
-      <p:nvGrpSpPr>
-        <p:cNvPr id="1" name="">
-          <a:extLst>
-            <a:ext uri="{FF2B5EF4-FFF2-40B4-BE49-F238E27FC236}">
-              <a16:creationId xmlns:a16="http://schemas.microsoft.com/office/drawing/2014/main" id="{ECC06C52-67BC-A4C8-3ED0-3636080E3212}"/>
-            </a:ext>
-          </a:extLst>
-        </p:cNvPr>
-        <p:cNvGrpSpPr/>
-        <p:nvPr/>
-      </p:nvGrpSpPr>
-      <p:grpSpPr>
-        <a:xfrm>
-          <a:off x="0" y="0"/>
-          <a:ext cx="0" cy="0"/>
-          <a:chOff x="0" y="0"/>
-          <a:chExt cx="0" cy="0"/>
-        </a:xfrm>
-      </p:grpSpPr>
-      <p:sp>
-        <p:nvSpPr>
-          <p:cNvPr id="2" name="Title 1">
-            <a:extLst>
-              <a:ext uri="{FF2B5EF4-FFF2-40B4-BE49-F238E27FC236}">
-                <a16:creationId xmlns:a16="http://schemas.microsoft.com/office/drawing/2014/main" id="{389C7A2E-1427-5278-B512-F2A80C319122}"/>
-              </a:ext>
-            </a:extLst>
-          </p:cNvPr>
-          <p:cNvSpPr>
-            <a:spLocks noGrp="1"/>
-          </p:cNvSpPr>
-          <p:nvPr>
-            <p:ph type="title"/>
-          </p:nvPr>
-        </p:nvSpPr>
-        <p:spPr>
-          <a:xfrm>
-            <a:off x="334963" y="620690"/>
-            <a:ext cx="11522075" cy="360041"/>
-          </a:xfrm>
-        </p:spPr>
-        <p:txBody>
-          <a:bodyPr/>
-          <a:lstStyle/>
-          <a:p>
-            <a:r>
-              <a:rPr lang="en-US" dirty="0"/>
-              <a:t>Outline</a:t>
-            </a:r>
-          </a:p>
-        </p:txBody>
-      </p:sp>
-      <p:sp>
-        <p:nvSpPr>
-          <p:cNvPr id="13" name="Content Placeholder 12">
-            <a:extLst>
-              <a:ext uri="{FF2B5EF4-FFF2-40B4-BE49-F238E27FC236}">
-                <a16:creationId xmlns:a16="http://schemas.microsoft.com/office/drawing/2014/main" id="{9ABB78FB-6052-78C4-38A0-9B7AF58E9FCB}"/>
-              </a:ext>
-            </a:extLst>
-          </p:cNvPr>
-          <p:cNvSpPr>
-            <a:spLocks noGrp="1"/>
-          </p:cNvSpPr>
-          <p:nvPr>
-            <p:ph idx="1"/>
-          </p:nvPr>
-        </p:nvSpPr>
-        <p:spPr/>
-        <p:txBody>
-          <a:bodyPr/>
-          <a:lstStyle/>
-          <a:p>
-            <a:r>
-              <a:rPr lang="en-US" dirty="0"/>
-              <a:t>Project Goals</a:t>
-            </a:r>
-          </a:p>
-          <a:p>
-            <a:r>
-              <a:rPr lang="en-US" dirty="0"/>
-              <a:t>Implemented Features</a:t>
-            </a:r>
-          </a:p>
-          <a:p>
-            <a:r>
-              <a:rPr lang="en-US" dirty="0"/>
-              <a:t>Design timeline</a:t>
-            </a:r>
-          </a:p>
-          <a:p>
-            <a:r>
-              <a:rPr lang="en-US" dirty="0"/>
-              <a:t>Tools Used</a:t>
-            </a:r>
-          </a:p>
-          <a:p>
-            <a:r>
-              <a:rPr lang="en-US" dirty="0"/>
-              <a:t>System Design</a:t>
-            </a:r>
-          </a:p>
-          <a:p>
-            <a:r>
-              <a:rPr lang="en-US" dirty="0"/>
-              <a:t>Testing and Verification</a:t>
-            </a:r>
-          </a:p>
-          <a:p>
-            <a:r>
-              <a:rPr lang="en-US" dirty="0"/>
-              <a:t>Lessons Learned</a:t>
-            </a:r>
-          </a:p>
-        </p:txBody>
-      </p:sp>
-      <p:sp>
-        <p:nvSpPr>
-          <p:cNvPr id="4" name="Date Placeholder 3">
-            <a:extLst>
-              <a:ext uri="{FF2B5EF4-FFF2-40B4-BE49-F238E27FC236}">
-                <a16:creationId xmlns:a16="http://schemas.microsoft.com/office/drawing/2014/main" id="{64344D59-887A-89DB-90DC-83D1F2848381}"/>
-              </a:ext>
-            </a:extLst>
-          </p:cNvPr>
-          <p:cNvSpPr>
-            <a:spLocks noGrp="1"/>
-          </p:cNvSpPr>
-          <p:nvPr>
-            <p:ph type="dt" sz="half" idx="10"/>
-          </p:nvPr>
-        </p:nvSpPr>
-        <p:spPr>
-          <a:xfrm>
-            <a:off x="334963" y="194736"/>
-            <a:ext cx="9674225" cy="180000"/>
-          </a:xfrm>
-        </p:spPr>
-        <p:txBody>
-          <a:bodyPr/>
-          <a:lstStyle/>
-          <a:p>
-            <a:r>
-              <a:rPr lang="en-US"/>
-              <a:t>L5X Automation Build Tool</a:t>
-            </a:r>
-            <a:endParaRPr lang="en-US" dirty="0"/>
-          </a:p>
-        </p:txBody>
-      </p:sp>
-      <p:sp>
-        <p:nvSpPr>
-          <p:cNvPr id="3" name="Slide Number Placeholder 2">
-            <a:extLst>
-              <a:ext uri="{FF2B5EF4-FFF2-40B4-BE49-F238E27FC236}">
-                <a16:creationId xmlns:a16="http://schemas.microsoft.com/office/drawing/2014/main" id="{D1AEB583-7C00-647F-EA4B-940732920BC4}"/>
-              </a:ext>
-            </a:extLst>
-          </p:cNvPr>
-          <p:cNvSpPr>
-            <a:spLocks noGrp="1"/>
-          </p:cNvSpPr>
-          <p:nvPr>
-            <p:ph type="sldNum" sz="quarter" idx="12"/>
-          </p:nvPr>
-        </p:nvSpPr>
-        <p:spPr/>
-        <p:txBody>
-          <a:bodyPr/>
-          <a:lstStyle/>
-          <a:p>
-            <a:r>
-              <a:rPr lang="en-US"/>
-              <a:t>Slide </a:t>
-            </a:r>
-            <a:fld id="{6ED4F0B8-A3B9-4B6F-BEC0-B0E78C1192A7}" type="slidenum">
-              <a:rPr lang="en-US" smtClean="0"/>
-              <a:t>2</a:t>
-            </a:fld>
-            <a:endParaRPr lang="en-US" dirty="0"/>
-          </a:p>
-        </p:txBody>
-      </p:sp>
-      <p:sp>
-        <p:nvSpPr>
-          <p:cNvPr id="7" name="Footer Placeholder 6">
-            <a:extLst>
-              <a:ext uri="{FF2B5EF4-FFF2-40B4-BE49-F238E27FC236}">
-                <a16:creationId xmlns:a16="http://schemas.microsoft.com/office/drawing/2014/main" id="{9F92DEA4-6CF8-8F90-FC4B-A9A798E29D53}"/>
-              </a:ext>
-            </a:extLst>
-          </p:cNvPr>
-          <p:cNvSpPr>
-            <a:spLocks noGrp="1"/>
-          </p:cNvSpPr>
-          <p:nvPr>
-            <p:ph type="ftr" sz="quarter" idx="11"/>
-          </p:nvPr>
-        </p:nvSpPr>
-        <p:spPr/>
-        <p:txBody>
-          <a:bodyPr/>
-          <a:lstStyle/>
-          <a:p>
-            <a:r>
-              <a:rPr lang="en-US"/>
-              <a:t>Corbin Ferguson</a:t>
-            </a:r>
-            <a:endParaRPr lang="en-US" dirty="0"/>
-          </a:p>
-        </p:txBody>
-      </p:sp>
-    </p:spTree>
-    <p:extLst>
-      <p:ext uri="{BB962C8B-B14F-4D97-AF65-F5344CB8AC3E}">
-        <p14:creationId xmlns:p14="http://schemas.microsoft.com/office/powerpoint/2010/main" val="4050751982"/>
       </p:ext>
     </p:extLst>
   </p:cSld>
@@ -23392,7 +25571,7 @@
         <p:cNvPr id="1" name="">
           <a:extLst>
             <a:ext uri="{FF2B5EF4-FFF2-40B4-BE49-F238E27FC236}">
-              <a16:creationId xmlns:a16="http://schemas.microsoft.com/office/drawing/2014/main" id="{B8FC7F66-5EAF-7CD6-5507-37789ADF879D}"/>
+              <a16:creationId xmlns:a16="http://schemas.microsoft.com/office/drawing/2014/main" id="{C1B326D9-95CE-9C7A-9B22-3CD559A064B4}"/>
             </a:ext>
           </a:extLst>
         </p:cNvPr>
@@ -23412,7 +25591,7 @@
           <p:cNvPr id="2" name="Title 1">
             <a:extLst>
               <a:ext uri="{FF2B5EF4-FFF2-40B4-BE49-F238E27FC236}">
-                <a16:creationId xmlns:a16="http://schemas.microsoft.com/office/drawing/2014/main" id="{2315E467-E348-D3A8-4D11-C2CBEDF12071}"/>
+                <a16:creationId xmlns:a16="http://schemas.microsoft.com/office/drawing/2014/main" id="{7E9D4B76-A3DE-8B10-4584-CAA5BCEAB3C3}"/>
               </a:ext>
             </a:extLst>
           </p:cNvPr>
@@ -23445,7 +25624,7 @@
           <p:cNvPr id="4" name="Date Placeholder 3">
             <a:extLst>
               <a:ext uri="{FF2B5EF4-FFF2-40B4-BE49-F238E27FC236}">
-                <a16:creationId xmlns:a16="http://schemas.microsoft.com/office/drawing/2014/main" id="{4317EBB6-D6BF-B489-80A4-08333792E136}"/>
+                <a16:creationId xmlns:a16="http://schemas.microsoft.com/office/drawing/2014/main" id="{72BD1437-1814-4718-15B2-4F4FE59D8788}"/>
               </a:ext>
             </a:extLst>
           </p:cNvPr>
@@ -23474,7 +25653,7 @@
           <p:cNvPr id="7" name="Slide Number Placeholder 6">
             <a:extLst>
               <a:ext uri="{FF2B5EF4-FFF2-40B4-BE49-F238E27FC236}">
-                <a16:creationId xmlns:a16="http://schemas.microsoft.com/office/drawing/2014/main" id="{7F6DEF74-2F72-3CD0-58A5-4EF19B8A9A56}"/>
+                <a16:creationId xmlns:a16="http://schemas.microsoft.com/office/drawing/2014/main" id="{4462FE55-B206-389E-6D0D-9464FE39EC4E}"/>
               </a:ext>
             </a:extLst>
           </p:cNvPr>
@@ -23507,7 +25686,7 @@
           <p:cNvPr id="8" name="Footer Placeholder 7">
             <a:extLst>
               <a:ext uri="{FF2B5EF4-FFF2-40B4-BE49-F238E27FC236}">
-                <a16:creationId xmlns:a16="http://schemas.microsoft.com/office/drawing/2014/main" id="{1CA91728-2710-BB92-A4D9-A62940118DD7}"/>
+                <a16:creationId xmlns:a16="http://schemas.microsoft.com/office/drawing/2014/main" id="{0BF0E17D-BE8E-1377-A679-B5EA93B3AE8F}"/>
               </a:ext>
             </a:extLst>
           </p:cNvPr>
@@ -23536,7 +25715,7 @@
           <p:cNvPr id="15" name="Picture 14" descr="A Flow chart displaying all windows in the application and how they lead to one another">
             <a:extLst>
               <a:ext uri="{FF2B5EF4-FFF2-40B4-BE49-F238E27FC236}">
-                <a16:creationId xmlns:a16="http://schemas.microsoft.com/office/drawing/2014/main" id="{6244959B-B329-3457-CDC8-8A5F7BF28B7D}"/>
+                <a16:creationId xmlns:a16="http://schemas.microsoft.com/office/drawing/2014/main" id="{D209E713-11DD-16BC-02AC-C8F52F87573B}"/>
               </a:ext>
             </a:extLst>
           </p:cNvPr>
@@ -23567,16 +25746,230 @@
           </a:prstGeom>
         </p:spPr>
       </p:pic>
+      <p:pic>
+        <p:nvPicPr>
+          <p:cNvPr id="10242" name="ActionSelect">
+            <a:extLst>
+              <a:ext uri="{FF2B5EF4-FFF2-40B4-BE49-F238E27FC236}">
+                <a16:creationId xmlns:a16="http://schemas.microsoft.com/office/drawing/2014/main" id="{461CD87D-B8E2-EBAC-C16F-E56594D3F499}"/>
+              </a:ext>
+            </a:extLst>
+          </p:cNvPr>
+          <p:cNvPicPr>
+            <a:picLocks noChangeAspect="1" noChangeArrowheads="1"/>
+          </p:cNvPicPr>
+          <p:nvPr/>
+        </p:nvPicPr>
+        <p:blipFill>
+          <a:blip r:embed="rId3">
+            <a:extLst>
+              <a:ext uri="{28A0092B-C50C-407E-A947-70E740481C1C}">
+                <a14:useLocalDpi xmlns:a14="http://schemas.microsoft.com/office/drawing/2010/main" val="0"/>
+              </a:ext>
+            </a:extLst>
+          </a:blip>
+          <a:srcRect/>
+          <a:stretch>
+            <a:fillRect/>
+          </a:stretch>
+        </p:blipFill>
+        <p:spPr bwMode="auto">
+          <a:xfrm>
+            <a:off x="5488780" y="3113311"/>
+            <a:ext cx="720731" cy="463327"/>
+          </a:xfrm>
+          <a:prstGeom prst="rect">
+            <a:avLst/>
+          </a:prstGeom>
+          <a:noFill/>
+          <a:extLst>
+            <a:ext uri="{909E8E84-426E-40DD-AFC4-6F175D3DCCD1}">
+              <a14:hiddenFill xmlns:a14="http://schemas.microsoft.com/office/drawing/2010/main">
+                <a:solidFill>
+                  <a:srgbClr val="FFFFFF"/>
+                </a:solidFill>
+              </a14:hiddenFill>
+            </a:ext>
+          </a:extLst>
+        </p:spPr>
+      </p:pic>
+      <p:sp>
+        <p:nvSpPr>
+          <p:cNvPr id="3" name="Rectangle: Rounded Corners 2">
+            <a:extLst>
+              <a:ext uri="{FF2B5EF4-FFF2-40B4-BE49-F238E27FC236}">
+                <a16:creationId xmlns:a16="http://schemas.microsoft.com/office/drawing/2014/main" id="{ED261959-73BE-AC8F-A9DA-6CAEF5E9BB95}"/>
+              </a:ext>
+            </a:extLst>
+          </p:cNvPr>
+          <p:cNvSpPr/>
+          <p:nvPr/>
+        </p:nvSpPr>
+        <p:spPr>
+          <a:xfrm>
+            <a:off x="5466560" y="3090863"/>
+            <a:ext cx="742951" cy="485775"/>
+          </a:xfrm>
+          <a:prstGeom prst="roundRect">
+            <a:avLst/>
+          </a:prstGeom>
+          <a:solidFill>
+            <a:schemeClr val="accent6">
+              <a:lumMod val="60000"/>
+              <a:lumOff val="40000"/>
+              <a:alpha val="60000"/>
+            </a:schemeClr>
+          </a:solidFill>
+          <a:ln w="38100">
+            <a:solidFill>
+              <a:schemeClr val="accent6">
+                <a:lumMod val="60000"/>
+                <a:lumOff val="40000"/>
+              </a:schemeClr>
+            </a:solidFill>
+          </a:ln>
+          <a:effectLst>
+            <a:glow rad="139700">
+              <a:schemeClr val="accent6">
+                <a:satMod val="175000"/>
+                <a:alpha val="40000"/>
+              </a:schemeClr>
+            </a:glow>
+          </a:effectLst>
+        </p:spPr>
+        <p:style>
+          <a:lnRef idx="2">
+            <a:schemeClr val="accent1">
+              <a:shade val="50000"/>
+            </a:schemeClr>
+          </a:lnRef>
+          <a:fillRef idx="1">
+            <a:schemeClr val="accent1"/>
+          </a:fillRef>
+          <a:effectRef idx="0">
+            <a:schemeClr val="accent1"/>
+          </a:effectRef>
+          <a:fontRef idx="minor">
+            <a:schemeClr val="lt1"/>
+          </a:fontRef>
+        </p:style>
+        <p:txBody>
+          <a:bodyPr rtlCol="0" anchor="ctr"/>
+          <a:lstStyle/>
+          <a:p>
+            <a:pPr algn="ctr"/>
+            <a:endParaRPr lang="en-US" sz="2000" dirty="0" err="1">
+              <a:solidFill>
+                <a:srgbClr val="FFFFFF"/>
+              </a:solidFill>
+              <a:effectLst>
+                <a:glow rad="63500">
+                  <a:srgbClr val="FF0000">
+                    <a:alpha val="40000"/>
+                  </a:srgbClr>
+                </a:glow>
+              </a:effectLst>
+              <a:latin typeface="E+H Sans" panose="020B0404050202020204" pitchFamily="34" charset="0"/>
+            </a:endParaRPr>
+          </a:p>
+        </p:txBody>
+      </p:sp>
     </p:spTree>
     <p:extLst>
       <p:ext uri="{BB962C8B-B14F-4D97-AF65-F5344CB8AC3E}">
-        <p14:creationId xmlns:p14="http://schemas.microsoft.com/office/powerpoint/2010/main" val="1979168377"/>
+        <p14:creationId xmlns:p14="http://schemas.microsoft.com/office/powerpoint/2010/main" val="3493033771"/>
       </p:ext>
     </p:extLst>
   </p:cSld>
   <p:clrMapOvr>
     <a:masterClrMapping/>
   </p:clrMapOvr>
+  <p:timing>
+    <p:tnLst>
+      <p:par>
+        <p:cTn id="1" dur="indefinite" restart="never" nodeType="tmRoot">
+          <p:childTnLst>
+            <p:seq concurrent="1" nextAc="seek">
+              <p:cTn id="2" dur="indefinite" nodeType="mainSeq">
+                <p:childTnLst>
+                  <p:par>
+                    <p:cTn id="3" fill="hold">
+                      <p:stCondLst>
+                        <p:cond delay="indefinite"/>
+                      </p:stCondLst>
+                      <p:childTnLst>
+                        <p:par>
+                          <p:cTn id="4" fill="hold">
+                            <p:stCondLst>
+                              <p:cond delay="0"/>
+                            </p:stCondLst>
+                            <p:childTnLst>
+                              <p:par>
+                                <p:cTn id="5" presetID="10" presetClass="entr" presetSubtype="0" fill="hold" grpId="0" nodeType="clickEffect">
+                                  <p:stCondLst>
+                                    <p:cond delay="0"/>
+                                  </p:stCondLst>
+                                  <p:childTnLst>
+                                    <p:set>
+                                      <p:cBhvr>
+                                        <p:cTn id="6" dur="1" fill="hold">
+                                          <p:stCondLst>
+                                            <p:cond delay="0"/>
+                                          </p:stCondLst>
+                                        </p:cTn>
+                                        <p:tgtEl>
+                                          <p:spTgt spid="3"/>
+                                        </p:tgtEl>
+                                        <p:attrNameLst>
+                                          <p:attrName>style.visibility</p:attrName>
+                                        </p:attrNameLst>
+                                      </p:cBhvr>
+                                      <p:to>
+                                        <p:strVal val="visible"/>
+                                      </p:to>
+                                    </p:set>
+                                    <p:animEffect transition="in" filter="fade">
+                                      <p:cBhvr>
+                                        <p:cTn id="7" dur="250"/>
+                                        <p:tgtEl>
+                                          <p:spTgt spid="3"/>
+                                        </p:tgtEl>
+                                      </p:cBhvr>
+                                    </p:animEffect>
+                                  </p:childTnLst>
+                                </p:cTn>
+                              </p:par>
+                            </p:childTnLst>
+                          </p:cTn>
+                        </p:par>
+                      </p:childTnLst>
+                    </p:cTn>
+                  </p:par>
+                </p:childTnLst>
+              </p:cTn>
+              <p:prevCondLst>
+                <p:cond evt="onPrev" delay="0">
+                  <p:tgtEl>
+                    <p:sldTgt/>
+                  </p:tgtEl>
+                </p:cond>
+              </p:prevCondLst>
+              <p:nextCondLst>
+                <p:cond evt="onNext" delay="0">
+                  <p:tgtEl>
+                    <p:sldTgt/>
+                  </p:tgtEl>
+                </p:cond>
+              </p:nextCondLst>
+            </p:seq>
+          </p:childTnLst>
+        </p:cTn>
+      </p:par>
+    </p:tnLst>
+    <p:bldLst>
+      <p:bldP spid="3" grpId="0" animBg="1"/>
+    </p:bldLst>
+  </p:timing>
 </p:sld>
 </file>
 
@@ -23588,7 +25981,7 @@
         <p:cNvPr id="1" name="">
           <a:extLst>
             <a:ext uri="{FF2B5EF4-FFF2-40B4-BE49-F238E27FC236}">
-              <a16:creationId xmlns:a16="http://schemas.microsoft.com/office/drawing/2014/main" id="{AE741E45-B413-0AAD-097D-05F3401E8023}"/>
+              <a16:creationId xmlns:a16="http://schemas.microsoft.com/office/drawing/2014/main" id="{89DCA1A2-FD6D-0264-7CAC-569FBB940928}"/>
             </a:ext>
           </a:extLst>
         </p:cNvPr>
@@ -23603,12 +25996,183 @@
           <a:chExt cx="0" cy="0"/>
         </a:xfrm>
       </p:grpSpPr>
+      <p:sp>
+        <p:nvSpPr>
+          <p:cNvPr id="2" name="Title 1">
+            <a:extLst>
+              <a:ext uri="{FF2B5EF4-FFF2-40B4-BE49-F238E27FC236}">
+                <a16:creationId xmlns:a16="http://schemas.microsoft.com/office/drawing/2014/main" id="{0CCFA355-078B-FB4E-2912-C0CF5C2BBF3F}"/>
+              </a:ext>
+            </a:extLst>
+          </p:cNvPr>
+          <p:cNvSpPr>
+            <a:spLocks noGrp="1"/>
+          </p:cNvSpPr>
+          <p:nvPr>
+            <p:ph type="title"/>
+          </p:nvPr>
+        </p:nvSpPr>
+        <p:spPr>
+          <a:xfrm>
+            <a:off x="334963" y="620690"/>
+            <a:ext cx="7018337" cy="360041"/>
+          </a:xfrm>
+        </p:spPr>
+        <p:txBody>
+          <a:bodyPr/>
+          <a:lstStyle/>
+          <a:p>
+            <a:r>
+              <a:rPr lang="en-US" dirty="0"/>
+              <a:t>GUI Displays Flowchart</a:t>
+            </a:r>
+          </a:p>
+        </p:txBody>
+      </p:sp>
+      <p:sp>
+        <p:nvSpPr>
+          <p:cNvPr id="4" name="Date Placeholder 3">
+            <a:extLst>
+              <a:ext uri="{FF2B5EF4-FFF2-40B4-BE49-F238E27FC236}">
+                <a16:creationId xmlns:a16="http://schemas.microsoft.com/office/drawing/2014/main" id="{35738F26-6031-7239-1A09-1427676CA467}"/>
+              </a:ext>
+            </a:extLst>
+          </p:cNvPr>
+          <p:cNvSpPr>
+            <a:spLocks noGrp="1"/>
+          </p:cNvSpPr>
+          <p:nvPr>
+            <p:ph type="dt" sz="half" idx="10"/>
+          </p:nvPr>
+        </p:nvSpPr>
+        <p:spPr/>
+        <p:txBody>
+          <a:bodyPr/>
+          <a:lstStyle/>
+          <a:p>
+            <a:r>
+              <a:rPr lang="en-US"/>
+              <a:t>L5X Automation Build Tool</a:t>
+            </a:r>
+            <a:endParaRPr lang="en-US" dirty="0"/>
+          </a:p>
+        </p:txBody>
+      </p:sp>
+      <p:sp>
+        <p:nvSpPr>
+          <p:cNvPr id="7" name="Slide Number Placeholder 6">
+            <a:extLst>
+              <a:ext uri="{FF2B5EF4-FFF2-40B4-BE49-F238E27FC236}">
+                <a16:creationId xmlns:a16="http://schemas.microsoft.com/office/drawing/2014/main" id="{65147936-E941-129B-1218-2E423FBE414C}"/>
+              </a:ext>
+            </a:extLst>
+          </p:cNvPr>
+          <p:cNvSpPr>
+            <a:spLocks noGrp="1"/>
+          </p:cNvSpPr>
+          <p:nvPr>
+            <p:ph type="sldNum" sz="quarter" idx="12"/>
+          </p:nvPr>
+        </p:nvSpPr>
+        <p:spPr/>
+        <p:txBody>
+          <a:bodyPr/>
+          <a:lstStyle/>
+          <a:p>
+            <a:r>
+              <a:rPr lang="en-US"/>
+              <a:t>Slide </a:t>
+            </a:r>
+            <a:fld id="{C6F8E2D1-BFA0-484A-B7F1-E348F2594759}" type="slidenum">
+              <a:rPr lang="en-US" smtClean="0"/>
+              <a:t>8</a:t>
+            </a:fld>
+            <a:endParaRPr lang="en-US" dirty="0"/>
+          </a:p>
+        </p:txBody>
+      </p:sp>
+      <p:sp>
+        <p:nvSpPr>
+          <p:cNvPr id="8" name="Footer Placeholder 7">
+            <a:extLst>
+              <a:ext uri="{FF2B5EF4-FFF2-40B4-BE49-F238E27FC236}">
+                <a16:creationId xmlns:a16="http://schemas.microsoft.com/office/drawing/2014/main" id="{64C07567-307C-AFF3-49AC-7E0858B2FFE0}"/>
+              </a:ext>
+            </a:extLst>
+          </p:cNvPr>
+          <p:cNvSpPr>
+            <a:spLocks noGrp="1"/>
+          </p:cNvSpPr>
+          <p:nvPr>
+            <p:ph type="ftr" sz="quarter" idx="11"/>
+          </p:nvPr>
+        </p:nvSpPr>
+        <p:spPr/>
+        <p:txBody>
+          <a:bodyPr/>
+          <a:lstStyle/>
+          <a:p>
+            <a:r>
+              <a:rPr lang="en-US"/>
+              <a:t>Corbin Ferguson</a:t>
+            </a:r>
+            <a:endParaRPr lang="en-US" dirty="0"/>
+          </a:p>
+        </p:txBody>
+      </p:sp>
       <p:pic>
         <p:nvPicPr>
-          <p:cNvPr id="8366" name="Picture 8365">
+          <p:cNvPr id="10242" name="!ActionSelect">
             <a:extLst>
               <a:ext uri="{FF2B5EF4-FFF2-40B4-BE49-F238E27FC236}">
-                <a16:creationId xmlns:a16="http://schemas.microsoft.com/office/drawing/2014/main" id="{60AE9E24-9AB4-5014-B6BD-6F056F5807BA}"/>
+                <a16:creationId xmlns:a16="http://schemas.microsoft.com/office/drawing/2014/main" id="{F222EBA9-47DB-A494-0A25-7CD0A39D0D61}"/>
+              </a:ext>
+            </a:extLst>
+          </p:cNvPr>
+          <p:cNvPicPr>
+            <a:picLocks noChangeAspect="1" noChangeArrowheads="1"/>
+          </p:cNvPicPr>
+          <p:nvPr/>
+        </p:nvPicPr>
+        <p:blipFill>
+          <a:blip r:embed="rId2">
+            <a:extLst>
+              <a:ext uri="{28A0092B-C50C-407E-A947-70E740481C1C}">
+                <a14:useLocalDpi xmlns:a14="http://schemas.microsoft.com/office/drawing/2010/main" val="0"/>
+              </a:ext>
+            </a:extLst>
+          </a:blip>
+          <a:srcRect/>
+          <a:stretch>
+            <a:fillRect/>
+          </a:stretch>
+        </p:blipFill>
+        <p:spPr bwMode="auto">
+          <a:xfrm>
+            <a:off x="1680314" y="444588"/>
+            <a:ext cx="8328874" cy="5792722"/>
+          </a:xfrm>
+          <a:prstGeom prst="rect">
+            <a:avLst/>
+          </a:prstGeom>
+          <a:noFill/>
+          <a:extLst>
+            <a:ext uri="{909E8E84-426E-40DD-AFC4-6F175D3DCCD1}">
+              <a14:hiddenFill xmlns:a14="http://schemas.microsoft.com/office/drawing/2010/main">
+                <a:solidFill>
+                  <a:srgbClr val="FFFFFF"/>
+                </a:solidFill>
+              </a14:hiddenFill>
+            </a:ext>
+          </a:extLst>
+        </p:spPr>
+      </p:pic>
+      <p:pic>
+        <p:nvPicPr>
+          <p:cNvPr id="5" name="ActionSelect">
+            <a:extLst>
+              <a:ext uri="{FF2B5EF4-FFF2-40B4-BE49-F238E27FC236}">
+                <a16:creationId xmlns:a16="http://schemas.microsoft.com/office/drawing/2014/main" id="{771B8AC6-311F-3E75-33C2-615158918A8C}"/>
               </a:ext>
             </a:extLst>
           </p:cNvPr>
@@ -23618,15 +26182,15 @@
           <p:nvPr/>
         </p:nvPicPr>
         <p:blipFill>
-          <a:blip r:embed="rId2"/>
+          <a:blip r:embed="rId3"/>
           <a:stretch>
             <a:fillRect/>
           </a:stretch>
         </p:blipFill>
         <p:spPr>
           <a:xfrm>
-            <a:off x="2181925" y="1160462"/>
-            <a:ext cx="7828149" cy="5113337"/>
+            <a:off x="2417888" y="1114340"/>
+            <a:ext cx="6853725" cy="4316230"/>
           </a:xfrm>
           <a:prstGeom prst="rect">
             <a:avLst/>
@@ -23634,193 +26198,263 @@
           <a:noFill/>
         </p:spPr>
       </p:pic>
-      <p:sp>
-        <p:nvSpPr>
-          <p:cNvPr id="8" name="Footer Placeholder 7">
+      <p:pic>
+        <p:nvPicPr>
+          <p:cNvPr id="10" name="NewFile">
             <a:extLst>
               <a:ext uri="{FF2B5EF4-FFF2-40B4-BE49-F238E27FC236}">
-                <a16:creationId xmlns:a16="http://schemas.microsoft.com/office/drawing/2014/main" id="{4C7D5AC9-EA29-86A4-7EF8-4DF941130DC8}"/>
+                <a16:creationId xmlns:a16="http://schemas.microsoft.com/office/drawing/2014/main" id="{A8BD3308-9470-9AF2-87BA-D34E2A93E67A}"/>
               </a:ext>
             </a:extLst>
           </p:cNvPr>
-          <p:cNvSpPr>
-            <a:spLocks noGrp="1"/>
-          </p:cNvSpPr>
-          <p:nvPr>
-            <p:ph type="ftr" sz="quarter" idx="19"/>
-          </p:nvPr>
-        </p:nvSpPr>
+          <p:cNvPicPr>
+            <a:picLocks noChangeAspect="1"/>
+          </p:cNvPicPr>
+          <p:nvPr/>
+        </p:nvPicPr>
+        <p:blipFill>
+          <a:blip r:embed="rId3"/>
+          <a:srcRect l="5131" t="67604" r="73596" b="17547"/>
+          <a:stretch>
+            <a:fillRect/>
+          </a:stretch>
+        </p:blipFill>
         <p:spPr>
           <a:xfrm>
-            <a:off x="4086351" y="6469380"/>
-            <a:ext cx="1130300" cy="180000"/>
+            <a:off x="2770368" y="4038600"/>
+            <a:ext cx="1451588" cy="638175"/>
           </a:xfrm>
+          <a:prstGeom prst="rect">
+            <a:avLst/>
+          </a:prstGeom>
+          <a:noFill/>
         </p:spPr>
-        <p:txBody>
-          <a:bodyPr wrap="none" anchor="ctr">
-            <a:normAutofit/>
-          </a:bodyPr>
-          <a:lstStyle/>
-          <a:p>
-            <a:pPr>
-              <a:lnSpc>
-                <a:spcPct val="90000"/>
-              </a:lnSpc>
-              <a:spcAft>
-                <a:spcPts val="600"/>
-              </a:spcAft>
-            </a:pPr>
-            <a:r>
-              <a:rPr lang="en-US"/>
-              <a:t>Corbin Ferguson</a:t>
-            </a:r>
-          </a:p>
-        </p:txBody>
-      </p:sp>
-      <p:sp>
-        <p:nvSpPr>
-          <p:cNvPr id="7" name="Slide Number Placeholder 6">
+      </p:pic>
+      <p:sp>
+        <p:nvSpPr>
+          <p:cNvPr id="6" name="Rectangle: Rounded Corners 5">
             <a:extLst>
               <a:ext uri="{FF2B5EF4-FFF2-40B4-BE49-F238E27FC236}">
-                <a16:creationId xmlns:a16="http://schemas.microsoft.com/office/drawing/2014/main" id="{3583879C-95E5-7299-C98A-2B7D0B63F807}"/>
+                <a16:creationId xmlns:a16="http://schemas.microsoft.com/office/drawing/2014/main" id="{F97ADB1C-4CC1-050A-F7E0-C59FABA26D8C}"/>
               </a:ext>
             </a:extLst>
           </p:cNvPr>
-          <p:cNvSpPr>
-            <a:spLocks noGrp="1"/>
-          </p:cNvSpPr>
-          <p:nvPr>
-            <p:ph type="sldNum" sz="quarter" idx="20"/>
-          </p:nvPr>
+          <p:cNvSpPr/>
+          <p:nvPr/>
         </p:nvSpPr>
         <p:spPr>
           <a:xfrm>
-            <a:off x="1633051" y="6469380"/>
-            <a:ext cx="571500" cy="180000"/>
+            <a:off x="2675735" y="3900488"/>
+            <a:ext cx="1581940" cy="890587"/>
           </a:xfrm>
+          <a:prstGeom prst="roundRect">
+            <a:avLst/>
+          </a:prstGeom>
+          <a:solidFill>
+            <a:schemeClr val="accent6">
+              <a:lumMod val="60000"/>
+              <a:lumOff val="40000"/>
+              <a:alpha val="60000"/>
+            </a:schemeClr>
+          </a:solidFill>
+          <a:ln w="38100">
+            <a:solidFill>
+              <a:schemeClr val="accent6">
+                <a:lumMod val="60000"/>
+                <a:lumOff val="40000"/>
+              </a:schemeClr>
+            </a:solidFill>
+          </a:ln>
+          <a:effectLst>
+            <a:glow rad="139700">
+              <a:schemeClr val="accent6">
+                <a:satMod val="175000"/>
+                <a:alpha val="40000"/>
+              </a:schemeClr>
+            </a:glow>
+          </a:effectLst>
         </p:spPr>
-        <p:txBody>
-          <a:bodyPr wrap="none" anchor="ctr">
-            <a:normAutofit/>
-          </a:bodyPr>
+        <p:style>
+          <a:lnRef idx="2">
+            <a:schemeClr val="accent1">
+              <a:shade val="50000"/>
+            </a:schemeClr>
+          </a:lnRef>
+          <a:fillRef idx="1">
+            <a:schemeClr val="accent1"/>
+          </a:fillRef>
+          <a:effectRef idx="0">
+            <a:schemeClr val="accent1"/>
+          </a:effectRef>
+          <a:fontRef idx="minor">
+            <a:schemeClr val="lt1"/>
+          </a:fontRef>
+        </p:style>
+        <p:txBody>
+          <a:bodyPr rtlCol="0" anchor="ctr"/>
           <a:lstStyle/>
           <a:p>
-            <a:pPr>
-              <a:lnSpc>
-                <a:spcPct val="90000"/>
-              </a:lnSpc>
-              <a:spcAft>
-                <a:spcPts val="600"/>
-              </a:spcAft>
-            </a:pPr>
-            <a:r>
-              <a:rPr lang="en-US"/>
-              <a:t>Slide </a:t>
-            </a:r>
-            <a:fld id="{C6F8E2D1-BFA0-484A-B7F1-E348F2594759}" type="slidenum">
-              <a:rPr lang="en-US" smtClean="0"/>
-              <a:pPr>
-                <a:lnSpc>
-                  <a:spcPct val="90000"/>
-                </a:lnSpc>
-                <a:spcAft>
-                  <a:spcPts val="600"/>
-                </a:spcAft>
-              </a:pPr>
-              <a:t>8</a:t>
-            </a:fld>
-            <a:endParaRPr lang="en-US"/>
-          </a:p>
-        </p:txBody>
-      </p:sp>
-      <p:sp>
-        <p:nvSpPr>
-          <p:cNvPr id="4" name="Date Placeholder 3">
-            <a:extLst>
-              <a:ext uri="{FF2B5EF4-FFF2-40B4-BE49-F238E27FC236}">
-                <a16:creationId xmlns:a16="http://schemas.microsoft.com/office/drawing/2014/main" id="{6F1C84BC-19BE-D2D3-DB6B-179BB01EE861}"/>
-              </a:ext>
-            </a:extLst>
-          </p:cNvPr>
-          <p:cNvSpPr>
-            <a:spLocks noGrp="1"/>
-          </p:cNvSpPr>
-          <p:nvPr>
-            <p:ph type="dt" sz="half" idx="21"/>
-          </p:nvPr>
-        </p:nvSpPr>
-        <p:spPr>
-          <a:xfrm>
-            <a:off x="334963" y="194736"/>
-            <a:ext cx="9674225" cy="180000"/>
-          </a:xfrm>
-        </p:spPr>
-        <p:txBody>
-          <a:bodyPr wrap="none" anchor="t">
-            <a:normAutofit/>
-          </a:bodyPr>
-          <a:lstStyle/>
-          <a:p>
-            <a:pPr>
-              <a:lnSpc>
-                <a:spcPct val="90000"/>
-              </a:lnSpc>
-              <a:spcAft>
-                <a:spcPts val="600"/>
-              </a:spcAft>
-            </a:pPr>
-            <a:r>
-              <a:rPr lang="en-US"/>
-              <a:t>L5X Automation Build Tool</a:t>
-            </a:r>
-          </a:p>
-        </p:txBody>
-      </p:sp>
-      <p:sp>
-        <p:nvSpPr>
-          <p:cNvPr id="2" name="Title 1">
-            <a:extLst>
-              <a:ext uri="{FF2B5EF4-FFF2-40B4-BE49-F238E27FC236}">
-                <a16:creationId xmlns:a16="http://schemas.microsoft.com/office/drawing/2014/main" id="{07BCF97A-6A5E-DA70-0A21-4FF0D5A9B2D1}"/>
-              </a:ext>
-            </a:extLst>
-          </p:cNvPr>
-          <p:cNvSpPr>
-            <a:spLocks noGrp="1"/>
-          </p:cNvSpPr>
-          <p:nvPr>
-            <p:ph type="title"/>
-          </p:nvPr>
-        </p:nvSpPr>
-        <p:spPr>
-          <a:xfrm>
-            <a:off x="334963" y="620690"/>
-            <a:ext cx="11522075" cy="360041"/>
-          </a:xfrm>
-        </p:spPr>
-        <p:txBody>
-          <a:bodyPr wrap="none" anchor="t">
-            <a:normAutofit/>
-          </a:bodyPr>
-          <a:lstStyle/>
-          <a:p>
-            <a:r>
-              <a:rPr lang="en-US" dirty="0"/>
-              <a:t>Class Diagram</a:t>
-            </a:r>
+            <a:pPr algn="ctr"/>
+            <a:endParaRPr lang="en-US" sz="2000" dirty="0" err="1">
+              <a:solidFill>
+                <a:srgbClr val="FFFFFF"/>
+              </a:solidFill>
+              <a:effectLst>
+                <a:glow rad="63500">
+                  <a:srgbClr val="FF0000">
+                    <a:alpha val="40000"/>
+                  </a:srgbClr>
+                </a:glow>
+              </a:effectLst>
+              <a:latin typeface="E+H Sans" panose="020B0404050202020204" pitchFamily="34" charset="0"/>
+            </a:endParaRPr>
           </a:p>
         </p:txBody>
       </p:sp>
     </p:spTree>
     <p:extLst>
       <p:ext uri="{BB962C8B-B14F-4D97-AF65-F5344CB8AC3E}">
-        <p14:creationId xmlns:p14="http://schemas.microsoft.com/office/powerpoint/2010/main" val="2077614573"/>
+        <p14:creationId xmlns:p14="http://schemas.microsoft.com/office/powerpoint/2010/main" val="462985986"/>
       </p:ext>
     </p:extLst>
   </p:cSld>
   <p:clrMapOvr>
     <a:masterClrMapping/>
   </p:clrMapOvr>
+  <mc:AlternateContent xmlns:mc="http://schemas.openxmlformats.org/markup-compatibility/2006">
+    <mc:Choice xmlns:p159="http://schemas.microsoft.com/office/powerpoint/2015/09/main" Requires="p159">
+      <p:transition>
+        <p159:morph option="byObject"/>
+      </p:transition>
+    </mc:Choice>
+    <mc:Fallback>
+      <p:transition>
+        <p:fade/>
+      </p:transition>
+    </mc:Fallback>
+  </mc:AlternateContent>
+  <p:timing>
+    <p:tnLst>
+      <p:par>
+        <p:cTn id="1" dur="indefinite" restart="never" nodeType="tmRoot">
+          <p:childTnLst>
+            <p:seq concurrent="1" nextAc="seek">
+              <p:cTn id="2" dur="indefinite" nodeType="mainSeq">
+                <p:childTnLst>
+                  <p:par>
+                    <p:cTn id="3" fill="hold">
+                      <p:stCondLst>
+                        <p:cond delay="indefinite"/>
+                      </p:stCondLst>
+                      <p:childTnLst>
+                        <p:par>
+                          <p:cTn id="4" fill="hold">
+                            <p:stCondLst>
+                              <p:cond delay="0"/>
+                            </p:stCondLst>
+                            <p:childTnLst>
+                              <p:par>
+                                <p:cTn id="5" presetID="10" presetClass="entr" presetSubtype="0" fill="hold" grpId="0" nodeType="clickEffect">
+                                  <p:stCondLst>
+                                    <p:cond delay="0"/>
+                                  </p:stCondLst>
+                                  <p:childTnLst>
+                                    <p:set>
+                                      <p:cBhvr>
+                                        <p:cTn id="6" dur="1" fill="hold">
+                                          <p:stCondLst>
+                                            <p:cond delay="0"/>
+                                          </p:stCondLst>
+                                        </p:cTn>
+                                        <p:tgtEl>
+                                          <p:spTgt spid="6"/>
+                                        </p:tgtEl>
+                                        <p:attrNameLst>
+                                          <p:attrName>style.visibility</p:attrName>
+                                        </p:attrNameLst>
+                                      </p:cBhvr>
+                                      <p:to>
+                                        <p:strVal val="visible"/>
+                                      </p:to>
+                                    </p:set>
+                                    <p:animEffect transition="in" filter="fade">
+                                      <p:cBhvr>
+                                        <p:cTn id="7" dur="250"/>
+                                        <p:tgtEl>
+                                          <p:spTgt spid="6"/>
+                                        </p:tgtEl>
+                                      </p:cBhvr>
+                                    </p:animEffect>
+                                  </p:childTnLst>
+                                </p:cTn>
+                              </p:par>
+                            </p:childTnLst>
+                          </p:cTn>
+                        </p:par>
+                        <p:par>
+                          <p:cTn id="8" fill="hold">
+                            <p:stCondLst>
+                              <p:cond delay="250"/>
+                            </p:stCondLst>
+                            <p:childTnLst>
+                              <p:par>
+                                <p:cTn id="9" presetID="1" presetClass="exit" presetSubtype="0" fill="hold" nodeType="afterEffect">
+                                  <p:stCondLst>
+                                    <p:cond delay="0"/>
+                                  </p:stCondLst>
+                                  <p:childTnLst>
+                                    <p:set>
+                                      <p:cBhvr>
+                                        <p:cTn id="10" dur="1" fill="hold">
+                                          <p:stCondLst>
+                                            <p:cond delay="0"/>
+                                          </p:stCondLst>
+                                        </p:cTn>
+                                        <p:tgtEl>
+                                          <p:spTgt spid="10242"/>
+                                        </p:tgtEl>
+                                        <p:attrNameLst>
+                                          <p:attrName>style.visibility</p:attrName>
+                                        </p:attrNameLst>
+                                      </p:cBhvr>
+                                      <p:to>
+                                        <p:strVal val="hidden"/>
+                                      </p:to>
+                                    </p:set>
+                                  </p:childTnLst>
+                                </p:cTn>
+                              </p:par>
+                            </p:childTnLst>
+                          </p:cTn>
+                        </p:par>
+                      </p:childTnLst>
+                    </p:cTn>
+                  </p:par>
+                </p:childTnLst>
+              </p:cTn>
+              <p:prevCondLst>
+                <p:cond evt="onPrev" delay="0">
+                  <p:tgtEl>
+                    <p:sldTgt/>
+                  </p:tgtEl>
+                </p:cond>
+              </p:prevCondLst>
+              <p:nextCondLst>
+                <p:cond evt="onNext" delay="0">
+                  <p:tgtEl>
+                    <p:sldTgt/>
+                  </p:tgtEl>
+                </p:cond>
+              </p:nextCondLst>
+            </p:seq>
+          </p:childTnLst>
+        </p:cTn>
+      </p:par>
+    </p:tnLst>
+    <p:bldLst>
+      <p:bldP spid="6" grpId="0" animBg="1"/>
+    </p:bldLst>
+  </p:timing>
 </p:sld>
 </file>
 
@@ -23832,7 +26466,7 @@
         <p:cNvPr id="1" name="">
           <a:extLst>
             <a:ext uri="{FF2B5EF4-FFF2-40B4-BE49-F238E27FC236}">
-              <a16:creationId xmlns:a16="http://schemas.microsoft.com/office/drawing/2014/main" id="{B031D0FB-813C-A1A9-95BF-F0A18A2C1086}"/>
+              <a16:creationId xmlns:a16="http://schemas.microsoft.com/office/drawing/2014/main" id="{7E4A68EB-BBA3-381D-430F-E3F9DF8BD3FB}"/>
             </a:ext>
           </a:extLst>
         </p:cNvPr>
@@ -23847,12 +26481,136 @@
           <a:chExt cx="0" cy="0"/>
         </a:xfrm>
       </p:grpSpPr>
+      <p:sp>
+        <p:nvSpPr>
+          <p:cNvPr id="2" name="Title 1">
+            <a:extLst>
+              <a:ext uri="{FF2B5EF4-FFF2-40B4-BE49-F238E27FC236}">
+                <a16:creationId xmlns:a16="http://schemas.microsoft.com/office/drawing/2014/main" id="{A767FD57-0C1F-53FC-E4AC-6E4AC4F8F9F9}"/>
+              </a:ext>
+            </a:extLst>
+          </p:cNvPr>
+          <p:cNvSpPr>
+            <a:spLocks noGrp="1"/>
+          </p:cNvSpPr>
+          <p:nvPr>
+            <p:ph type="title"/>
+          </p:nvPr>
+        </p:nvSpPr>
+        <p:spPr>
+          <a:xfrm>
+            <a:off x="334963" y="620690"/>
+            <a:ext cx="7018337" cy="360041"/>
+          </a:xfrm>
+        </p:spPr>
+        <p:txBody>
+          <a:bodyPr/>
+          <a:lstStyle/>
+          <a:p>
+            <a:r>
+              <a:rPr lang="en-US" dirty="0"/>
+              <a:t>New File Pathing</a:t>
+            </a:r>
+          </a:p>
+        </p:txBody>
+      </p:sp>
+      <p:sp>
+        <p:nvSpPr>
+          <p:cNvPr id="4" name="Date Placeholder 3">
+            <a:extLst>
+              <a:ext uri="{FF2B5EF4-FFF2-40B4-BE49-F238E27FC236}">
+                <a16:creationId xmlns:a16="http://schemas.microsoft.com/office/drawing/2014/main" id="{A7555496-A425-4EB0-4B85-1B98E6B462DC}"/>
+              </a:ext>
+            </a:extLst>
+          </p:cNvPr>
+          <p:cNvSpPr>
+            <a:spLocks noGrp="1"/>
+          </p:cNvSpPr>
+          <p:nvPr>
+            <p:ph type="dt" sz="half" idx="10"/>
+          </p:nvPr>
+        </p:nvSpPr>
+        <p:spPr/>
+        <p:txBody>
+          <a:bodyPr/>
+          <a:lstStyle/>
+          <a:p>
+            <a:r>
+              <a:rPr lang="en-US"/>
+              <a:t>L5X Automation Build Tool</a:t>
+            </a:r>
+            <a:endParaRPr lang="en-US" dirty="0"/>
+          </a:p>
+        </p:txBody>
+      </p:sp>
+      <p:sp>
+        <p:nvSpPr>
+          <p:cNvPr id="7" name="Slide Number Placeholder 6">
+            <a:extLst>
+              <a:ext uri="{FF2B5EF4-FFF2-40B4-BE49-F238E27FC236}">
+                <a16:creationId xmlns:a16="http://schemas.microsoft.com/office/drawing/2014/main" id="{8C70071A-23EE-C0B0-7BC3-656D969CC96D}"/>
+              </a:ext>
+            </a:extLst>
+          </p:cNvPr>
+          <p:cNvSpPr>
+            <a:spLocks noGrp="1"/>
+          </p:cNvSpPr>
+          <p:nvPr>
+            <p:ph type="sldNum" sz="quarter" idx="12"/>
+          </p:nvPr>
+        </p:nvSpPr>
+        <p:spPr/>
+        <p:txBody>
+          <a:bodyPr/>
+          <a:lstStyle/>
+          <a:p>
+            <a:r>
+              <a:rPr lang="en-US"/>
+              <a:t>Slide </a:t>
+            </a:r>
+            <a:fld id="{C6F8E2D1-BFA0-484A-B7F1-E348F2594759}" type="slidenum">
+              <a:rPr lang="en-US" smtClean="0"/>
+              <a:t>9</a:t>
+            </a:fld>
+            <a:endParaRPr lang="en-US" dirty="0"/>
+          </a:p>
+        </p:txBody>
+      </p:sp>
+      <p:sp>
+        <p:nvSpPr>
+          <p:cNvPr id="8" name="Footer Placeholder 7">
+            <a:extLst>
+              <a:ext uri="{FF2B5EF4-FFF2-40B4-BE49-F238E27FC236}">
+                <a16:creationId xmlns:a16="http://schemas.microsoft.com/office/drawing/2014/main" id="{560F8ABB-0706-BB35-FFAC-F2F7471C56AD}"/>
+              </a:ext>
+            </a:extLst>
+          </p:cNvPr>
+          <p:cNvSpPr>
+            <a:spLocks noGrp="1"/>
+          </p:cNvSpPr>
+          <p:nvPr>
+            <p:ph type="ftr" sz="quarter" idx="11"/>
+          </p:nvPr>
+        </p:nvSpPr>
+        <p:spPr/>
+        <p:txBody>
+          <a:bodyPr/>
+          <a:lstStyle/>
+          <a:p>
+            <a:r>
+              <a:rPr lang="en-US"/>
+              <a:t>Corbin Ferguson</a:t>
+            </a:r>
+            <a:endParaRPr lang="en-US" dirty="0"/>
+          </a:p>
+        </p:txBody>
+      </p:sp>
       <p:pic>
         <p:nvPicPr>
-          <p:cNvPr id="9" name="Picture 8">
+          <p:cNvPr id="6" name="!NewFile">
             <a:extLst>
               <a:ext uri="{FF2B5EF4-FFF2-40B4-BE49-F238E27FC236}">
-                <a16:creationId xmlns:a16="http://schemas.microsoft.com/office/drawing/2014/main" id="{A889D74E-A641-8FCA-9F55-93231CDB546D}"/>
+                <a16:creationId xmlns:a16="http://schemas.microsoft.com/office/drawing/2014/main" id="{BF17B26E-CEBE-31E2-A928-A78B0BE175DA}"/>
               </a:ext>
             </a:extLst>
           </p:cNvPr>
@@ -23863,14 +26621,15 @@
         </p:nvPicPr>
         <p:blipFill>
           <a:blip r:embed="rId2"/>
+          <a:srcRect l="5131" t="67604" r="73596" b="17547"/>
           <a:stretch>
             <a:fillRect/>
           </a:stretch>
         </p:blipFill>
         <p:spPr>
           <a:xfrm>
-            <a:off x="1176290" y="1160462"/>
-            <a:ext cx="9839419" cy="5113337"/>
+            <a:off x="1545843" y="1119567"/>
+            <a:ext cx="9552756" cy="4199766"/>
           </a:xfrm>
           <a:prstGeom prst="rect">
             <a:avLst/>
@@ -23878,193 +26637,253 @@
           <a:noFill/>
         </p:spPr>
       </p:pic>
-      <p:sp>
-        <p:nvSpPr>
-          <p:cNvPr id="8" name="Footer Placeholder 7">
+      <p:pic>
+        <p:nvPicPr>
+          <p:cNvPr id="11268" name="NewFile">
             <a:extLst>
               <a:ext uri="{FF2B5EF4-FFF2-40B4-BE49-F238E27FC236}">
-                <a16:creationId xmlns:a16="http://schemas.microsoft.com/office/drawing/2014/main" id="{71C973FB-1860-D33D-FFB0-E373255B1325}"/>
+                <a16:creationId xmlns:a16="http://schemas.microsoft.com/office/drawing/2014/main" id="{14AE5F5A-6C88-0F58-A592-0FB668BF99DA}"/>
               </a:ext>
             </a:extLst>
           </p:cNvPr>
-          <p:cNvSpPr>
-            <a:spLocks noGrp="1"/>
-          </p:cNvSpPr>
-          <p:nvPr>
-            <p:ph type="ftr" sz="quarter" idx="19"/>
-          </p:nvPr>
+          <p:cNvPicPr>
+            <a:picLocks noChangeAspect="1" noChangeArrowheads="1"/>
+          </p:cNvPicPr>
+          <p:nvPr/>
+        </p:nvPicPr>
+        <p:blipFill>
+          <a:blip r:embed="rId3">
+            <a:extLst>
+              <a:ext uri="{28A0092B-C50C-407E-A947-70E740481C1C}">
+                <a14:useLocalDpi xmlns:a14="http://schemas.microsoft.com/office/drawing/2010/main" val="0"/>
+              </a:ext>
+            </a:extLst>
+          </a:blip>
+          <a:srcRect/>
+          <a:stretch>
+            <a:fillRect/>
+          </a:stretch>
+        </p:blipFill>
+        <p:spPr bwMode="auto">
+          <a:xfrm>
+            <a:off x="365435" y="980731"/>
+            <a:ext cx="11428631" cy="4882654"/>
+          </a:xfrm>
+          <a:prstGeom prst="rect">
+            <a:avLst/>
+          </a:prstGeom>
+          <a:solidFill>
+            <a:schemeClr val="bg1"/>
+          </a:solidFill>
+        </p:spPr>
+      </p:pic>
+      <p:sp>
+        <p:nvSpPr>
+          <p:cNvPr id="11" name="Rectangle: Rounded Corners 10">
+            <a:extLst>
+              <a:ext uri="{FF2B5EF4-FFF2-40B4-BE49-F238E27FC236}">
+                <a16:creationId xmlns:a16="http://schemas.microsoft.com/office/drawing/2014/main" id="{BBDD576A-A414-9915-960B-C7192C1A13D8}"/>
+              </a:ext>
+            </a:extLst>
+          </p:cNvPr>
+          <p:cNvSpPr/>
+          <p:nvPr/>
         </p:nvSpPr>
         <p:spPr>
           <a:xfrm>
-            <a:off x="4086351" y="6469380"/>
-            <a:ext cx="1130300" cy="180000"/>
+            <a:off x="2514600" y="2705100"/>
+            <a:ext cx="8839200" cy="901700"/>
           </a:xfrm>
+          <a:prstGeom prst="roundRect">
+            <a:avLst/>
+          </a:prstGeom>
+          <a:solidFill>
+            <a:srgbClr val="007CAA">
+              <a:alpha val="20000"/>
+            </a:srgbClr>
+          </a:solidFill>
+          <a:ln>
+            <a:solidFill>
+              <a:srgbClr val="007CAA"/>
+            </a:solidFill>
+          </a:ln>
+          <a:effectLst>
+            <a:glow rad="63500">
+              <a:schemeClr val="accent4">
+                <a:satMod val="175000"/>
+                <a:alpha val="40000"/>
+              </a:schemeClr>
+            </a:glow>
+          </a:effectLst>
         </p:spPr>
-        <p:txBody>
-          <a:bodyPr wrap="none" anchor="ctr">
-            <a:normAutofit/>
-          </a:bodyPr>
+        <p:style>
+          <a:lnRef idx="2">
+            <a:schemeClr val="accent1">
+              <a:shade val="50000"/>
+            </a:schemeClr>
+          </a:lnRef>
+          <a:fillRef idx="1">
+            <a:schemeClr val="accent1"/>
+          </a:fillRef>
+          <a:effectRef idx="0">
+            <a:schemeClr val="accent1"/>
+          </a:effectRef>
+          <a:fontRef idx="minor">
+            <a:schemeClr val="lt1"/>
+          </a:fontRef>
+        </p:style>
+        <p:txBody>
+          <a:bodyPr rtlCol="0" anchor="ctr"/>
           <a:lstStyle/>
           <a:p>
-            <a:pPr>
-              <a:lnSpc>
-                <a:spcPct val="90000"/>
-              </a:lnSpc>
-              <a:spcAft>
-                <a:spcPts val="600"/>
-              </a:spcAft>
-            </a:pPr>
-            <a:r>
-              <a:rPr lang="en-US"/>
-              <a:t>Corbin Ferguson</a:t>
-            </a:r>
-          </a:p>
-        </p:txBody>
-      </p:sp>
-      <p:sp>
-        <p:nvSpPr>
-          <p:cNvPr id="7" name="Slide Number Placeholder 6">
-            <a:extLst>
-              <a:ext uri="{FF2B5EF4-FFF2-40B4-BE49-F238E27FC236}">
-                <a16:creationId xmlns:a16="http://schemas.microsoft.com/office/drawing/2014/main" id="{FF861633-550D-9192-7E16-88623F1FDD40}"/>
-              </a:ext>
-            </a:extLst>
-          </p:cNvPr>
-          <p:cNvSpPr>
-            <a:spLocks noGrp="1"/>
-          </p:cNvSpPr>
-          <p:nvPr>
-            <p:ph type="sldNum" sz="quarter" idx="20"/>
-          </p:nvPr>
-        </p:nvSpPr>
-        <p:spPr>
-          <a:xfrm>
-            <a:off x="1633051" y="6469380"/>
-            <a:ext cx="571500" cy="180000"/>
-          </a:xfrm>
-        </p:spPr>
-        <p:txBody>
-          <a:bodyPr wrap="none" anchor="ctr">
-            <a:normAutofit/>
-          </a:bodyPr>
-          <a:lstStyle/>
-          <a:p>
-            <a:pPr>
-              <a:lnSpc>
-                <a:spcPct val="90000"/>
-              </a:lnSpc>
-              <a:spcAft>
-                <a:spcPts val="600"/>
-              </a:spcAft>
-            </a:pPr>
-            <a:r>
-              <a:rPr lang="en-US"/>
-              <a:t>Slide </a:t>
-            </a:r>
-            <a:fld id="{C6F8E2D1-BFA0-484A-B7F1-E348F2594759}" type="slidenum">
-              <a:rPr lang="en-US" smtClean="0"/>
-              <a:pPr>
-                <a:lnSpc>
-                  <a:spcPct val="90000"/>
-                </a:lnSpc>
-                <a:spcAft>
-                  <a:spcPts val="600"/>
-                </a:spcAft>
-              </a:pPr>
-              <a:t>9</a:t>
-            </a:fld>
-            <a:endParaRPr lang="en-US"/>
-          </a:p>
-        </p:txBody>
-      </p:sp>
-      <p:sp>
-        <p:nvSpPr>
-          <p:cNvPr id="4" name="Date Placeholder 3">
-            <a:extLst>
-              <a:ext uri="{FF2B5EF4-FFF2-40B4-BE49-F238E27FC236}">
-                <a16:creationId xmlns:a16="http://schemas.microsoft.com/office/drawing/2014/main" id="{5D0DCAB8-9A4F-6068-74B2-D5C8356B650C}"/>
-              </a:ext>
-            </a:extLst>
-          </p:cNvPr>
-          <p:cNvSpPr>
-            <a:spLocks noGrp="1"/>
-          </p:cNvSpPr>
-          <p:nvPr>
-            <p:ph type="dt" sz="half" idx="21"/>
-          </p:nvPr>
-        </p:nvSpPr>
-        <p:spPr>
-          <a:xfrm>
-            <a:off x="334963" y="194736"/>
-            <a:ext cx="9674225" cy="180000"/>
-          </a:xfrm>
-        </p:spPr>
-        <p:txBody>
-          <a:bodyPr wrap="none" anchor="t">
-            <a:normAutofit/>
-          </a:bodyPr>
-          <a:lstStyle/>
-          <a:p>
-            <a:pPr>
-              <a:lnSpc>
-                <a:spcPct val="90000"/>
-              </a:lnSpc>
-              <a:spcAft>
-                <a:spcPts val="600"/>
-              </a:spcAft>
-            </a:pPr>
-            <a:r>
-              <a:rPr lang="en-US"/>
-              <a:t>L5X Automation Build Tool</a:t>
-            </a:r>
-          </a:p>
-        </p:txBody>
-      </p:sp>
-      <p:sp>
-        <p:nvSpPr>
-          <p:cNvPr id="2" name="Title 1">
-            <a:extLst>
-              <a:ext uri="{FF2B5EF4-FFF2-40B4-BE49-F238E27FC236}">
-                <a16:creationId xmlns:a16="http://schemas.microsoft.com/office/drawing/2014/main" id="{5EBCB58C-1369-EDD7-5D5E-7C1E1415DB2E}"/>
-              </a:ext>
-            </a:extLst>
-          </p:cNvPr>
-          <p:cNvSpPr>
-            <a:spLocks noGrp="1"/>
-          </p:cNvSpPr>
-          <p:nvPr>
-            <p:ph type="title"/>
-          </p:nvPr>
-        </p:nvSpPr>
-        <p:spPr>
-          <a:xfrm>
-            <a:off x="334963" y="620690"/>
-            <a:ext cx="11522075" cy="360041"/>
-          </a:xfrm>
-        </p:spPr>
-        <p:txBody>
-          <a:bodyPr wrap="none" anchor="t">
-            <a:normAutofit/>
-          </a:bodyPr>
-          <a:lstStyle/>
-          <a:p>
-            <a:r>
-              <a:rPr lang="en-US" dirty="0"/>
-              <a:t>Class Diagram Cont.</a:t>
-            </a:r>
+            <a:pPr algn="ctr"/>
+            <a:endParaRPr lang="en-US" sz="2000" dirty="0" err="1">
+              <a:solidFill>
+                <a:srgbClr val="FFFFFF"/>
+              </a:solidFill>
+              <a:latin typeface="E+H Sans" panose="020B0404050202020204" pitchFamily="34" charset="0"/>
+            </a:endParaRPr>
           </a:p>
         </p:txBody>
       </p:sp>
     </p:spTree>
     <p:extLst>
       <p:ext uri="{BB962C8B-B14F-4D97-AF65-F5344CB8AC3E}">
-        <p14:creationId xmlns:p14="http://schemas.microsoft.com/office/powerpoint/2010/main" val="1692918807"/>
+        <p14:creationId xmlns:p14="http://schemas.microsoft.com/office/powerpoint/2010/main" val="1670292182"/>
       </p:ext>
     </p:extLst>
   </p:cSld>
   <p:clrMapOvr>
     <a:masterClrMapping/>
   </p:clrMapOvr>
+  <mc:AlternateContent xmlns:mc="http://schemas.openxmlformats.org/markup-compatibility/2006">
+    <mc:Choice xmlns:p159="http://schemas.microsoft.com/office/powerpoint/2015/09/main" Requires="p159">
+      <p:transition xmlns:p14="http://schemas.microsoft.com/office/powerpoint/2010/main" spd="slow" p14:dur="2000">
+        <p159:morph option="byObject"/>
+      </p:transition>
+    </mc:Choice>
+    <mc:Fallback>
+      <p:transition spd="slow">
+        <p:fade/>
+      </p:transition>
+    </mc:Fallback>
+  </mc:AlternateContent>
+  <p:timing>
+    <p:tnLst>
+      <p:par>
+        <p:cTn id="1" dur="indefinite" restart="never" nodeType="tmRoot">
+          <p:childTnLst>
+            <p:seq concurrent="1" nextAc="seek">
+              <p:cTn id="2" dur="indefinite" nodeType="mainSeq">
+                <p:childTnLst>
+                  <p:par>
+                    <p:cTn id="3" fill="hold">
+                      <p:stCondLst>
+                        <p:cond delay="indefinite"/>
+                        <p:cond evt="onBegin" delay="0">
+                          <p:tn val="2"/>
+                        </p:cond>
+                      </p:stCondLst>
+                      <p:childTnLst>
+                        <p:par>
+                          <p:cTn id="4" fill="hold">
+                            <p:stCondLst>
+                              <p:cond delay="0"/>
+                            </p:stCondLst>
+                            <p:childTnLst>
+                              <p:par>
+                                <p:cTn id="5" presetID="10" presetClass="entr" presetSubtype="0" fill="hold" grpId="0" nodeType="afterEffect">
+                                  <p:stCondLst>
+                                    <p:cond delay="100"/>
+                                  </p:stCondLst>
+                                  <p:childTnLst>
+                                    <p:set>
+                                      <p:cBhvr>
+                                        <p:cTn id="6" dur="1" fill="hold">
+                                          <p:stCondLst>
+                                            <p:cond delay="0"/>
+                                          </p:stCondLst>
+                                        </p:cTn>
+                                        <p:tgtEl>
+                                          <p:spTgt spid="11"/>
+                                        </p:tgtEl>
+                                        <p:attrNameLst>
+                                          <p:attrName>style.visibility</p:attrName>
+                                        </p:attrNameLst>
+                                      </p:cBhvr>
+                                      <p:to>
+                                        <p:strVal val="visible"/>
+                                      </p:to>
+                                    </p:set>
+                                    <p:animEffect transition="in" filter="fade">
+                                      <p:cBhvr>
+                                        <p:cTn id="7" dur="500"/>
+                                        <p:tgtEl>
+                                          <p:spTgt spid="11"/>
+                                        </p:tgtEl>
+                                      </p:cBhvr>
+                                    </p:animEffect>
+                                  </p:childTnLst>
+                                </p:cTn>
+                              </p:par>
+                              <p:par>
+                                <p:cTn id="8" presetID="1" presetClass="exit" presetSubtype="0" fill="hold" nodeType="withEffect">
+                                  <p:stCondLst>
+                                    <p:cond delay="0"/>
+                                  </p:stCondLst>
+                                  <p:childTnLst>
+                                    <p:set>
+                                      <p:cBhvr>
+                                        <p:cTn id="9" dur="1" fill="hold">
+                                          <p:stCondLst>
+                                            <p:cond delay="0"/>
+                                          </p:stCondLst>
+                                        </p:cTn>
+                                        <p:tgtEl>
+                                          <p:spTgt spid="6"/>
+                                        </p:tgtEl>
+                                        <p:attrNameLst>
+                                          <p:attrName>style.visibility</p:attrName>
+                                        </p:attrNameLst>
+                                      </p:cBhvr>
+                                      <p:to>
+                                        <p:strVal val="hidden"/>
+                                      </p:to>
+                                    </p:set>
+                                  </p:childTnLst>
+                                </p:cTn>
+                              </p:par>
+                            </p:childTnLst>
+                          </p:cTn>
+                        </p:par>
+                      </p:childTnLst>
+                    </p:cTn>
+                  </p:par>
+                </p:childTnLst>
+              </p:cTn>
+              <p:prevCondLst>
+                <p:cond evt="onPrev" delay="0">
+                  <p:tgtEl>
+                    <p:sldTgt/>
+                  </p:tgtEl>
+                </p:cond>
+              </p:prevCondLst>
+              <p:nextCondLst>
+                <p:cond evt="onNext" delay="0">
+                  <p:tgtEl>
+                    <p:sldTgt/>
+                  </p:tgtEl>
+                </p:cond>
+              </p:nextCondLst>
+            </p:seq>
+          </p:childTnLst>
+        </p:cTn>
+      </p:par>
+    </p:tnLst>
+    <p:bldLst>
+      <p:bldP spid="11" grpId="0" animBg="1"/>
+    </p:bldLst>
+  </p:timing>
 </p:sld>
 </file>
 

</xml_diff>

<commit_message>
Last draft(hopefully) of presentation
Finished first 2 sections of methods
</commit_message>
<xml_diff>
--- a/Thesis Writing Documents/Project Development.pptx
+++ b/Thesis Writing Documents/Project Development.pptx
@@ -218,7 +218,7 @@
 <file path=ppt/revisionInfo.xml><?xml version="1.0" encoding="utf-8"?>
 <p1510:revInfo xmlns:a="http://schemas.openxmlformats.org/drawingml/2006/main" xmlns:r="http://schemas.openxmlformats.org/officeDocument/2006/relationships" xmlns:p1510="http://schemas.microsoft.com/office/powerpoint/2015/10/main">
   <p1510:revLst>
-    <p1510:client id="{F0E03B4B-CC56-43F1-8F18-BCA697229170}" v="611" dt="2026-03-31T14:30:05.421"/>
+    <p1510:client id="{F0E03B4B-CC56-43F1-8F18-BCA697229170}" v="614" dt="2026-03-31T18:39:42.242"/>
   </p1510:revLst>
 </p1510:revInfo>
 </file>
@@ -228,7 +228,7 @@
   <pc:docChgLst>
     <pc:chgData name="Corbin Ferguson" userId="34a864e2-e65e-4cb2-823c-dc28f73f0e40" providerId="ADAL" clId="{8D2D96CF-1319-4CCC-9EA9-073445628049}"/>
     <pc:docChg chg="undo redo custSel addSld delSld modSld sldOrd modMainMaster">
-      <pc:chgData name="Corbin Ferguson" userId="34a864e2-e65e-4cb2-823c-dc28f73f0e40" providerId="ADAL" clId="{8D2D96CF-1319-4CCC-9EA9-073445628049}" dt="2026-03-31T14:30:05.421" v="10483"/>
+      <pc:chgData name="Corbin Ferguson" userId="34a864e2-e65e-4cb2-823c-dc28f73f0e40" providerId="ADAL" clId="{8D2D96CF-1319-4CCC-9EA9-073445628049}" dt="2026-03-31T20:35:44.222" v="10649" actId="20577"/>
       <pc:docMkLst>
         <pc:docMk/>
       </pc:docMkLst>
@@ -247,8 +247,8 @@
           </ac:spMkLst>
         </pc:spChg>
       </pc:sldChg>
-      <pc:sldChg chg="addSp delSp modSp mod modTransition">
-        <pc:chgData name="Corbin Ferguson" userId="34a864e2-e65e-4cb2-823c-dc28f73f0e40" providerId="ADAL" clId="{8D2D96CF-1319-4CCC-9EA9-073445628049}" dt="2026-03-31T13:31:54.415" v="9176" actId="20577"/>
+      <pc:sldChg chg="addSp delSp modSp mod modTransition modNotesTx">
+        <pc:chgData name="Corbin Ferguson" userId="34a864e2-e65e-4cb2-823c-dc28f73f0e40" providerId="ADAL" clId="{8D2D96CF-1319-4CCC-9EA9-073445628049}" dt="2026-03-31T15:08:42.956" v="10501" actId="20577"/>
         <pc:sldMkLst>
           <pc:docMk/>
           <pc:sldMk cId="463964235" sldId="257"/>
@@ -262,7 +262,7 @@
           </ac:spMkLst>
         </pc:spChg>
         <pc:spChg chg="mod">
-          <ac:chgData name="Corbin Ferguson" userId="34a864e2-e65e-4cb2-823c-dc28f73f0e40" providerId="ADAL" clId="{8D2D96CF-1319-4CCC-9EA9-073445628049}" dt="2026-03-31T13:31:54.415" v="9176" actId="20577"/>
+          <ac:chgData name="Corbin Ferguson" userId="34a864e2-e65e-4cb2-823c-dc28f73f0e40" providerId="ADAL" clId="{8D2D96CF-1319-4CCC-9EA9-073445628049}" dt="2026-03-31T15:06:41.762" v="10489" actId="20577"/>
           <ac:spMkLst>
             <pc:docMk/>
             <pc:sldMk cId="463964235" sldId="257"/>
@@ -287,13 +287,13 @@
         </pc:picChg>
       </pc:sldChg>
       <pc:sldChg chg="addSp delSp modSp mod modTransition modClrScheme chgLayout">
-        <pc:chgData name="Corbin Ferguson" userId="34a864e2-e65e-4cb2-823c-dc28f73f0e40" providerId="ADAL" clId="{8D2D96CF-1319-4CCC-9EA9-073445628049}" dt="2026-03-31T14:28:07.771" v="10465" actId="20577"/>
+        <pc:chgData name="Corbin Ferguson" userId="34a864e2-e65e-4cb2-823c-dc28f73f0e40" providerId="ADAL" clId="{8D2D96CF-1319-4CCC-9EA9-073445628049}" dt="2026-03-31T19:08:48.793" v="10626" actId="14100"/>
         <pc:sldMkLst>
           <pc:docMk/>
           <pc:sldMk cId="3766655233" sldId="2146848300"/>
         </pc:sldMkLst>
         <pc:spChg chg="mod">
-          <ac:chgData name="Corbin Ferguson" userId="34a864e2-e65e-4cb2-823c-dc28f73f0e40" providerId="ADAL" clId="{8D2D96CF-1319-4CCC-9EA9-073445628049}" dt="2026-03-30T12:20:42.313" v="2477" actId="26606"/>
+          <ac:chgData name="Corbin Ferguson" userId="34a864e2-e65e-4cb2-823c-dc28f73f0e40" providerId="ADAL" clId="{8D2D96CF-1319-4CCC-9EA9-073445628049}" dt="2026-03-31T19:08:48.793" v="10626" actId="14100"/>
           <ac:spMkLst>
             <pc:docMk/>
             <pc:sldMk cId="3766655233" sldId="2146848300"/>
@@ -333,7 +333,7 @@
           </ac:spMkLst>
         </pc:spChg>
         <pc:spChg chg="add del mod">
-          <ac:chgData name="Corbin Ferguson" userId="34a864e2-e65e-4cb2-823c-dc28f73f0e40" providerId="ADAL" clId="{8D2D96CF-1319-4CCC-9EA9-073445628049}" dt="2026-03-31T14:28:07.771" v="10465" actId="20577"/>
+          <ac:chgData name="Corbin Ferguson" userId="34a864e2-e65e-4cb2-823c-dc28f73f0e40" providerId="ADAL" clId="{8D2D96CF-1319-4CCC-9EA9-073445628049}" dt="2026-03-31T19:08:19.591" v="10625" actId="20577"/>
           <ac:spMkLst>
             <pc:docMk/>
             <pc:sldMk cId="3766655233" sldId="2146848300"/>
@@ -482,13 +482,13 @@
         </pc:sldMkLst>
       </pc:sldChg>
       <pc:sldChg chg="modSp mod ord modTransition modNotesTx">
-        <pc:chgData name="Corbin Ferguson" userId="34a864e2-e65e-4cb2-823c-dc28f73f0e40" providerId="ADAL" clId="{8D2D96CF-1319-4CCC-9EA9-073445628049}" dt="2026-03-31T14:23:19.143" v="10431" actId="20577"/>
+        <pc:chgData name="Corbin Ferguson" userId="34a864e2-e65e-4cb2-823c-dc28f73f0e40" providerId="ADAL" clId="{8D2D96CF-1319-4CCC-9EA9-073445628049}" dt="2026-03-31T18:39:42.242" v="10560"/>
         <pc:sldMkLst>
           <pc:docMk/>
           <pc:sldMk cId="1957245743" sldId="2146848310"/>
         </pc:sldMkLst>
         <pc:spChg chg="mod">
-          <ac:chgData name="Corbin Ferguson" userId="34a864e2-e65e-4cb2-823c-dc28f73f0e40" providerId="ADAL" clId="{8D2D96CF-1319-4CCC-9EA9-073445628049}" dt="2026-03-31T14:23:19.143" v="10431" actId="20577"/>
+          <ac:chgData name="Corbin Ferguson" userId="34a864e2-e65e-4cb2-823c-dc28f73f0e40" providerId="ADAL" clId="{8D2D96CF-1319-4CCC-9EA9-073445628049}" dt="2026-03-31T18:39:42.242" v="10560"/>
           <ac:spMkLst>
             <pc:docMk/>
             <pc:sldMk cId="1957245743" sldId="2146848310"/>
@@ -1087,7 +1087,7 @@
         </pc:spChg>
       </pc:sldChg>
       <pc:sldChg chg="addSp delSp modSp new mod modTransition modClrScheme chgLayout modNotesTx">
-        <pc:chgData name="Corbin Ferguson" userId="34a864e2-e65e-4cb2-823c-dc28f73f0e40" providerId="ADAL" clId="{8D2D96CF-1319-4CCC-9EA9-073445628049}" dt="2026-03-31T14:05:33.952" v="10389" actId="20577"/>
+        <pc:chgData name="Corbin Ferguson" userId="34a864e2-e65e-4cb2-823c-dc28f73f0e40" providerId="ADAL" clId="{8D2D96CF-1319-4CCC-9EA9-073445628049}" dt="2026-03-31T19:17:40.468" v="10635" actId="20577"/>
         <pc:sldMkLst>
           <pc:docMk/>
           <pc:sldMk cId="3366771104" sldId="2146848333"/>
@@ -1141,7 +1141,7 @@
           </ac:spMkLst>
         </pc:spChg>
         <pc:spChg chg="add mod">
-          <ac:chgData name="Corbin Ferguson" userId="34a864e2-e65e-4cb2-823c-dc28f73f0e40" providerId="ADAL" clId="{8D2D96CF-1319-4CCC-9EA9-073445628049}" dt="2026-03-31T13:09:54.834" v="9157" actId="368"/>
+          <ac:chgData name="Corbin Ferguson" userId="34a864e2-e65e-4cb2-823c-dc28f73f0e40" providerId="ADAL" clId="{8D2D96CF-1319-4CCC-9EA9-073445628049}" dt="2026-03-31T19:17:40.468" v="10635" actId="20577"/>
           <ac:spMkLst>
             <pc:docMk/>
             <pc:sldMk cId="3366771104" sldId="2146848333"/>
@@ -1277,7 +1277,7 @@
         </pc:picChg>
       </pc:sldChg>
       <pc:sldChg chg="addSp delSp modSp new mod modTransition">
-        <pc:chgData name="Corbin Ferguson" userId="34a864e2-e65e-4cb2-823c-dc28f73f0e40" providerId="ADAL" clId="{8D2D96CF-1319-4CCC-9EA9-073445628049}" dt="2026-03-31T14:29:15.491" v="10468"/>
+        <pc:chgData name="Corbin Ferguson" userId="34a864e2-e65e-4cb2-823c-dc28f73f0e40" providerId="ADAL" clId="{8D2D96CF-1319-4CCC-9EA9-073445628049}" dt="2026-03-31T20:35:44.222" v="10649" actId="20577"/>
         <pc:sldMkLst>
           <pc:docMk/>
           <pc:sldMk cId="1311398929" sldId="2146848335"/>
@@ -1355,7 +1355,7 @@
           </ac:spMkLst>
         </pc:spChg>
         <pc:spChg chg="add mod">
-          <ac:chgData name="Corbin Ferguson" userId="34a864e2-e65e-4cb2-823c-dc28f73f0e40" providerId="ADAL" clId="{8D2D96CF-1319-4CCC-9EA9-073445628049}" dt="2026-03-31T13:45:15.537" v="9463" actId="6549"/>
+          <ac:chgData name="Corbin Ferguson" userId="34a864e2-e65e-4cb2-823c-dc28f73f0e40" providerId="ADAL" clId="{8D2D96CF-1319-4CCC-9EA9-073445628049}" dt="2026-03-31T20:35:44.222" v="10649" actId="20577"/>
           <ac:spMkLst>
             <pc:docMk/>
             <pc:sldMk cId="1311398929" sldId="2146848335"/>
@@ -1378,12 +1378,20 @@
             <ac:picMk id="11" creationId="{9C395893-10CB-DC77-C78E-1BD27244003D}"/>
           </ac:picMkLst>
         </pc:picChg>
-        <pc:picChg chg="add mod ord">
-          <ac:chgData name="Corbin Ferguson" userId="34a864e2-e65e-4cb2-823c-dc28f73f0e40" providerId="ADAL" clId="{8D2D96CF-1319-4CCC-9EA9-073445628049}" dt="2026-03-31T12:57:01.516" v="8175" actId="14100"/>
+        <pc:picChg chg="add del mod ord">
+          <ac:chgData name="Corbin Ferguson" userId="34a864e2-e65e-4cb2-823c-dc28f73f0e40" providerId="ADAL" clId="{8D2D96CF-1319-4CCC-9EA9-073445628049}" dt="2026-03-31T15:33:04.581" v="10502" actId="478"/>
           <ac:picMkLst>
             <pc:docMk/>
             <pc:sldMk cId="1311398929" sldId="2146848335"/>
             <ac:picMk id="13" creationId="{AFD30484-7327-2EF8-F791-E8AF4C39BD5C}"/>
+          </ac:picMkLst>
+        </pc:picChg>
+        <pc:picChg chg="add mod ord">
+          <ac:chgData name="Corbin Ferguson" userId="34a864e2-e65e-4cb2-823c-dc28f73f0e40" providerId="ADAL" clId="{8D2D96CF-1319-4CCC-9EA9-073445628049}" dt="2026-03-31T15:33:16.108" v="10508" actId="26606"/>
+          <ac:picMkLst>
+            <pc:docMk/>
+            <pc:sldMk cId="1311398929" sldId="2146848335"/>
+            <ac:picMk id="17" creationId="{07E999BB-F871-651D-2CBB-38D8B9FA34BA}"/>
           </ac:picMkLst>
         </pc:picChg>
       </pc:sldChg>
@@ -1403,7 +1411,7 @@
         </pc:spChg>
       </pc:sldChg>
       <pc:sldChg chg="addSp delSp modSp new mod modTransition">
-        <pc:chgData name="Corbin Ferguson" userId="34a864e2-e65e-4cb2-823c-dc28f73f0e40" providerId="ADAL" clId="{8D2D96CF-1319-4CCC-9EA9-073445628049}" dt="2026-03-31T14:29:17.831" v="10469"/>
+        <pc:chgData name="Corbin Ferguson" userId="34a864e2-e65e-4cb2-823c-dc28f73f0e40" providerId="ADAL" clId="{8D2D96CF-1319-4CCC-9EA9-073445628049}" dt="2026-03-31T15:33:43.051" v="10516" actId="26606"/>
         <pc:sldMkLst>
           <pc:docMk/>
           <pc:sldMk cId="156436412" sldId="2146848336"/>
@@ -1457,19 +1465,27 @@
           </ac:spMkLst>
         </pc:spChg>
         <pc:spChg chg="add mod">
-          <ac:chgData name="Corbin Ferguson" userId="34a864e2-e65e-4cb2-823c-dc28f73f0e40" providerId="ADAL" clId="{8D2D96CF-1319-4CCC-9EA9-073445628049}" dt="2026-03-31T13:03:17.992" v="8854" actId="20577"/>
+          <ac:chgData name="Corbin Ferguson" userId="34a864e2-e65e-4cb2-823c-dc28f73f0e40" providerId="ADAL" clId="{8D2D96CF-1319-4CCC-9EA9-073445628049}" dt="2026-03-31T15:33:43.051" v="10516" actId="26606"/>
           <ac:spMkLst>
             <pc:docMk/>
             <pc:sldMk cId="156436412" sldId="2146848336"/>
             <ac:spMk id="14" creationId="{79AF265C-42E8-C545-68A1-2F3A0E60B9FC}"/>
           </ac:spMkLst>
         </pc:spChg>
-        <pc:picChg chg="add mod ord">
-          <ac:chgData name="Corbin Ferguson" userId="34a864e2-e65e-4cb2-823c-dc28f73f0e40" providerId="ADAL" clId="{8D2D96CF-1319-4CCC-9EA9-073445628049}" dt="2026-03-31T12:58:01.767" v="8195" actId="26606"/>
+        <pc:picChg chg="add del mod ord">
+          <ac:chgData name="Corbin Ferguson" userId="34a864e2-e65e-4cb2-823c-dc28f73f0e40" providerId="ADAL" clId="{8D2D96CF-1319-4CCC-9EA9-073445628049}" dt="2026-03-31T15:33:31.860" v="10514" actId="478"/>
           <ac:picMkLst>
             <pc:docMk/>
             <pc:sldMk cId="156436412" sldId="2146848336"/>
             <ac:picMk id="9" creationId="{9E782A90-606C-B8FC-5DCD-B4609AECF711}"/>
+          </ac:picMkLst>
+        </pc:picChg>
+        <pc:picChg chg="add mod ord">
+          <ac:chgData name="Corbin Ferguson" userId="34a864e2-e65e-4cb2-823c-dc28f73f0e40" providerId="ADAL" clId="{8D2D96CF-1319-4CCC-9EA9-073445628049}" dt="2026-03-31T15:33:43.051" v="10516" actId="26606"/>
+          <ac:picMkLst>
+            <pc:docMk/>
+            <pc:sldMk cId="156436412" sldId="2146848336"/>
+            <ac:picMk id="11" creationId="{B46A16E4-8866-CF99-290D-B3D2521747BE}"/>
           </ac:picMkLst>
         </pc:picChg>
       </pc:sldChg>
@@ -2498,7 +2514,75 @@
           <a:bodyPr/>
           <a:lstStyle/>
           <a:p>
-            <a:pPr fontAlgn="t"/>
+            <a:pPr marL="0" marR="0" lvl="0" indent="0" algn="l" defTabSz="914400" rtl="0" eaLnBrk="1" fontAlgn="base" latinLnBrk="0" hangingPunct="1">
+              <a:lnSpc>
+                <a:spcPct val="100000"/>
+              </a:lnSpc>
+              <a:spcBef>
+                <a:spcPct val="30000"/>
+              </a:spcBef>
+              <a:spcAft>
+                <a:spcPct val="0"/>
+              </a:spcAft>
+              <a:buClrTx/>
+              <a:buSzTx/>
+              <a:buFontTx/>
+              <a:buNone/>
+              <a:tabLst/>
+              <a:defRPr/>
+            </a:pPr>
+            <a:r>
+              <a:rPr lang="en-US" sz="1200" b="0" i="1" kern="1200" dirty="0">
+                <a:solidFill>
+                  <a:schemeClr val="tx1"/>
+                </a:solidFill>
+                <a:effectLst/>
+                <a:latin typeface="E+H Serif" pitchFamily="18" charset="0"/>
+                <a:ea typeface="+mn-ea"/>
+                <a:cs typeface="+mn-cs"/>
+              </a:rPr>
+              <a:t>is Rockwell Automation’s main engineering and programming environment for controllers.</a:t>
+            </a:r>
+            <a:endParaRPr lang="en-US" sz="1200" b="0" i="0" kern="1200" dirty="0">
+              <a:solidFill>
+                <a:schemeClr val="tx1"/>
+              </a:solidFill>
+              <a:effectLst/>
+              <a:latin typeface="E+H Serif" pitchFamily="18" charset="0"/>
+              <a:ea typeface="+mn-ea"/>
+              <a:cs typeface="+mn-cs"/>
+            </a:endParaRPr>
+          </a:p>
+          <a:p>
+            <a:pPr marL="0" marR="0" lvl="0" indent="0" algn="l" defTabSz="914400" rtl="0" eaLnBrk="1" fontAlgn="base" latinLnBrk="0" hangingPunct="1">
+              <a:lnSpc>
+                <a:spcPct val="100000"/>
+              </a:lnSpc>
+              <a:spcBef>
+                <a:spcPct val="30000"/>
+              </a:spcBef>
+              <a:spcAft>
+                <a:spcPct val="0"/>
+              </a:spcAft>
+              <a:buClrTx/>
+              <a:buSzTx/>
+              <a:buFontTx/>
+              <a:buNone/>
+              <a:tabLst/>
+              <a:defRPr/>
+            </a:pPr>
+            <a:r>
+              <a:rPr lang="en-US" sz="1200" b="0" i="1" kern="1200" dirty="0">
+                <a:solidFill>
+                  <a:schemeClr val="tx1"/>
+                </a:solidFill>
+                <a:effectLst/>
+                <a:latin typeface="E+H Serif" pitchFamily="18" charset="0"/>
+                <a:ea typeface="+mn-ea"/>
+                <a:cs typeface="+mn-cs"/>
+              </a:rPr>
+              <a:t>It provides a single, scalable platform to configure, program, and maintain control systems within Rockwell’s Integrated Architecture.</a:t>
+            </a:r>
             <a:r>
               <a:rPr lang="en-US" sz="1200" b="0" i="0" kern="1200" dirty="0">
                 <a:solidFill>
@@ -2509,11 +2593,20 @@
                 <a:ea typeface="+mn-ea"/>
                 <a:cs typeface="+mn-cs"/>
               </a:rPr>
-              <a:t>Studio 5000 is optimized for detailed, manual PLC development, not rapid prototyping.</a:t>
-            </a:r>
-          </a:p>
-          <a:p>
-            <a:pPr fontAlgn="t"/>
+              <a:t> </a:t>
+            </a:r>
+            <a:r>
+              <a:rPr lang="en-US" sz="1200" b="0" i="1" kern="1200" dirty="0">
+                <a:solidFill>
+                  <a:schemeClr val="tx1"/>
+                </a:solidFill>
+                <a:effectLst/>
+                <a:latin typeface="E+H Serif" pitchFamily="18" charset="0"/>
+                <a:ea typeface="+mn-ea"/>
+                <a:cs typeface="+mn-cs"/>
+              </a:rPr>
+              <a:t>The software supports multiple programming languages—Ladder, Structured Text, Function Block, and Sequential Function Chart—within one unified design environment.</a:t>
+            </a:r>
             <a:r>
               <a:rPr lang="en-US" sz="1200" b="0" i="0" kern="1200" dirty="0">
                 <a:solidFill>
@@ -2524,13 +2617,38 @@
                 <a:ea typeface="+mn-ea"/>
                 <a:cs typeface="+mn-cs"/>
               </a:rPr>
-              <a:t>Manual creation of recurring controller structures is time‑consuming and repetitive.</a:t>
-            </a:r>
-          </a:p>
-          <a:p>
-            <a:pPr fontAlgn="t"/>
-            <a:r>
-              <a:rPr lang="en-US" sz="1200" b="0" i="0" kern="1200" dirty="0">
+              <a:t> </a:t>
+            </a:r>
+            <a:endParaRPr lang="en-US" sz="1200" b="0" i="0" u="none" strike="noStrike" kern="1200" dirty="0">
+              <a:solidFill>
+                <a:schemeClr val="tx1"/>
+              </a:solidFill>
+              <a:effectLst/>
+              <a:latin typeface="E+H Serif" pitchFamily="18" charset="0"/>
+              <a:ea typeface="+mn-ea"/>
+              <a:cs typeface="+mn-cs"/>
+            </a:endParaRPr>
+          </a:p>
+          <a:p>
+            <a:pPr marL="0" marR="0" lvl="0" indent="0" algn="l" defTabSz="914400" rtl="0" eaLnBrk="1" fontAlgn="base" latinLnBrk="0" hangingPunct="1">
+              <a:lnSpc>
+                <a:spcPct val="100000"/>
+              </a:lnSpc>
+              <a:spcBef>
+                <a:spcPct val="30000"/>
+              </a:spcBef>
+              <a:spcAft>
+                <a:spcPct val="0"/>
+              </a:spcAft>
+              <a:buClrTx/>
+              <a:buSzTx/>
+              <a:buFontTx/>
+              <a:buNone/>
+              <a:tabLst/>
+              <a:defRPr/>
+            </a:pPr>
+            <a:r>
+              <a:rPr lang="en-US" sz="1200" b="0" i="1" kern="1200" dirty="0">
                 <a:solidFill>
                   <a:schemeClr val="tx1"/>
                 </a:solidFill>
@@ -2539,38 +2657,17 @@
                 <a:ea typeface="+mn-ea"/>
                 <a:cs typeface="+mn-cs"/>
               </a:rPr>
-              <a:t>No streamlined way to mass‑generate template‑based code.</a:t>
-            </a:r>
-          </a:p>
-          <a:p>
-            <a:pPr fontAlgn="t"/>
-            <a:r>
-              <a:rPr lang="en-US" sz="1200" b="0" i="0" kern="1200" dirty="0">
-                <a:solidFill>
-                  <a:schemeClr val="tx1"/>
-                </a:solidFill>
-                <a:effectLst/>
-                <a:latin typeface="E+H Serif" pitchFamily="18" charset="0"/>
-                <a:ea typeface="+mn-ea"/>
-                <a:cs typeface="+mn-cs"/>
-              </a:rPr>
-              <a:t>L5X import/export enables automated manipulation since it is XML‑based.</a:t>
-            </a:r>
-          </a:p>
-          <a:p>
-            <a:pPr fontAlgn="t"/>
-            <a:r>
-              <a:rPr lang="en-US" sz="1200" b="0" i="0" kern="1200" dirty="0">
-                <a:solidFill>
-                  <a:schemeClr val="tx1"/>
-                </a:solidFill>
-                <a:effectLst/>
-                <a:latin typeface="E+H Serif" pitchFamily="18" charset="0"/>
-                <a:ea typeface="+mn-ea"/>
-                <a:cs typeface="+mn-cs"/>
-              </a:rPr>
-              <a:t>Tool aims to automate repetitive logic creation while preserving Studio 5000 compatibility.</a:t>
-            </a:r>
+              <a:t>Engineers use it to build I/O configurations, manage tags, develop logic routines, and integrate Rockwell hardware.</a:t>
+            </a:r>
+            <a:endParaRPr lang="en-US" sz="1200" b="0" i="0" kern="1200" dirty="0">
+              <a:solidFill>
+                <a:schemeClr val="tx1"/>
+              </a:solidFill>
+              <a:effectLst/>
+              <a:latin typeface="E+H Serif" pitchFamily="18" charset="0"/>
+              <a:ea typeface="+mn-ea"/>
+              <a:cs typeface="+mn-cs"/>
+            </a:endParaRPr>
           </a:p>
           <a:p>
             <a:endParaRPr lang="en-US" dirty="0"/>
@@ -21711,7 +21808,7 @@
             <a:pPr lvl="1"/>
             <a:r>
               <a:rPr lang="en-US" dirty="0"/>
-              <a:t>Utilizes MOQ to bypass UI functionality</a:t>
+              <a:t>Utilizes MOQ to bypass external element access functions</a:t>
             </a:r>
           </a:p>
           <a:p>
@@ -21738,7 +21835,7 @@
             <a:pPr lvl="1"/>
             <a:r>
               <a:rPr lang="en-US" dirty="0"/>
-              <a:t>Utilizes MOQ to bypass UI functionality</a:t>
+              <a:t>Utilizes MOQ to bypass external element access functions</a:t>
             </a:r>
           </a:p>
           <a:p>
@@ -21927,8 +22024,8 @@
         </p:nvSpPr>
         <p:spPr>
           <a:xfrm>
-            <a:off x="334963" y="620690"/>
-            <a:ext cx="11522075" cy="360041"/>
+            <a:off x="334964" y="620690"/>
+            <a:ext cx="1869588" cy="360041"/>
           </a:xfrm>
         </p:spPr>
         <p:txBody>
@@ -22043,6 +22140,12 @@
         <p:txBody>
           <a:bodyPr/>
           <a:lstStyle/>
+          <a:p>
+            <a:r>
+              <a:rPr lang="en-US" dirty="0"/>
+              <a:t>Tests were run both locally and on Jenkins pipeline</a:t>
+            </a:r>
+          </a:p>
           <a:p>
             <a:r>
               <a:rPr lang="en-US" dirty="0"/>
@@ -23678,15 +23781,7 @@
             </a:pPr>
             <a:r>
               <a:rPr lang="en-US" dirty="0"/>
-              <a:t>The goal of this application was to create a tool that can function as an alternative to Rockwell Automation’s Studio 5000 Logix Designer. /</a:t>
-            </a:r>
-            <a:r>
-              <a:rPr lang="en-US" b="1" dirty="0"/>
-              <a:t>explain what is</a:t>
-            </a:r>
-            <a:r>
-              <a:rPr lang="en-US" dirty="0"/>
-              <a:t>/</a:t>
+              <a:t>The goal of this application was to create a tool that can function as an alternative to Rockwell Automation’s Studio 5000 Logix Designer. </a:t>
             </a:r>
           </a:p>
           <a:p>
@@ -23695,7 +23790,7 @@
             </a:pPr>
             <a:r>
               <a:rPr lang="en-US" dirty="0"/>
-              <a:t> It needed to address the following issues with the existing designer:</a:t>
+              <a:t>It needed to address the following issues with the existing designer:</a:t>
             </a:r>
           </a:p>
           <a:p>
@@ -24587,7 +24682,7 @@
             </a:pPr>
             <a:r>
               <a:rPr lang="en-US" dirty="0"/>
-              <a:t>Creates, modifies, deletes</a:t>
+              <a:t>Imports, Creates, modifies, deletes</a:t>
             </a:r>
           </a:p>
           <a:p>
@@ -24900,12 +24995,210 @@
           </a:p>
         </p:txBody>
       </p:sp>
+      <p:sp>
+        <p:nvSpPr>
+          <p:cNvPr id="26" name="Content Placeholder 4">
+            <a:extLst>
+              <a:ext uri="{FF2B5EF4-FFF2-40B4-BE49-F238E27FC236}">
+                <a16:creationId xmlns:a16="http://schemas.microsoft.com/office/drawing/2014/main" id="{ED360616-AB19-F180-EAE4-E484295C9E7C}"/>
+              </a:ext>
+            </a:extLst>
+          </p:cNvPr>
+          <p:cNvSpPr>
+            <a:spLocks noGrp="1"/>
+          </p:cNvSpPr>
+          <p:nvPr>
+            <p:ph sz="quarter" idx="14"/>
+          </p:nvPr>
+        </p:nvSpPr>
+        <p:spPr>
+          <a:xfrm>
+            <a:off x="7595615" y="980732"/>
+            <a:ext cx="4261421" cy="5112094"/>
+          </a:xfrm>
+        </p:spPr>
+        <p:txBody>
+          <a:bodyPr/>
+          <a:lstStyle/>
+          <a:p>
+            <a:r>
+              <a:rPr lang="en-US" sz="1800" dirty="0"/>
+              <a:t>Execute</a:t>
+            </a:r>
+          </a:p>
+          <a:p>
+            <a:pPr lvl="1"/>
+            <a:r>
+              <a:rPr lang="en-US" sz="1600" dirty="0"/>
+              <a:t>Coordinates major operations</a:t>
+            </a:r>
+          </a:p>
+          <a:p>
+            <a:pPr lvl="1"/>
+            <a:r>
+              <a:rPr lang="en-US" sz="1600" dirty="0"/>
+              <a:t>Only class that interacts with GUI elements (through Interfaces)</a:t>
+            </a:r>
+          </a:p>
+          <a:p>
+            <a:r>
+              <a:rPr lang="en-US" sz="1800" dirty="0" err="1"/>
+              <a:t>ElementHelper</a:t>
+            </a:r>
+            <a:endParaRPr lang="en-US" sz="1800" dirty="0"/>
+          </a:p>
+          <a:p>
+            <a:pPr lvl="1"/>
+            <a:r>
+              <a:rPr lang="en-US" sz="1600" dirty="0"/>
+              <a:t>Contains relevant information for elements currently being modified</a:t>
+            </a:r>
+          </a:p>
+          <a:p>
+            <a:r>
+              <a:rPr lang="en-US" sz="1800" dirty="0" err="1"/>
+              <a:t>XMLHandler</a:t>
+            </a:r>
+            <a:endParaRPr lang="en-US" sz="1800" dirty="0"/>
+          </a:p>
+          <a:p>
+            <a:pPr lvl="1"/>
+            <a:r>
+              <a:rPr lang="en-US" sz="1600" dirty="0"/>
+              <a:t>Handles the reading and writing of </a:t>
+            </a:r>
+            <a:r>
+              <a:rPr lang="en-US" sz="1600"/>
+              <a:t>XML objects</a:t>
+            </a:r>
+            <a:endParaRPr lang="en-US" sz="1600" dirty="0"/>
+          </a:p>
+          <a:p>
+            <a:r>
+              <a:rPr lang="en-US" sz="1800" dirty="0" err="1"/>
+              <a:t>ValidationHandler</a:t>
+            </a:r>
+            <a:endParaRPr lang="en-US" sz="1800" dirty="0"/>
+          </a:p>
+          <a:p>
+            <a:pPr lvl="1"/>
+            <a:r>
+              <a:rPr lang="en-US" sz="1600" dirty="0"/>
+              <a:t>Handles reading of XSD file, passes information to </a:t>
+            </a:r>
+            <a:r>
+              <a:rPr lang="en-US" sz="1600" dirty="0" err="1"/>
+              <a:t>XMLHandler</a:t>
+            </a:r>
+            <a:endParaRPr lang="en-US" sz="1600" dirty="0"/>
+          </a:p>
+        </p:txBody>
+      </p:sp>
+      <p:sp>
+        <p:nvSpPr>
+          <p:cNvPr id="6" name="Footer Placeholder 5">
+            <a:extLst>
+              <a:ext uri="{FF2B5EF4-FFF2-40B4-BE49-F238E27FC236}">
+                <a16:creationId xmlns:a16="http://schemas.microsoft.com/office/drawing/2014/main" id="{6EACB492-E65F-C15E-A67C-498249C527CB}"/>
+              </a:ext>
+            </a:extLst>
+          </p:cNvPr>
+          <p:cNvSpPr>
+            <a:spLocks noGrp="1"/>
+          </p:cNvSpPr>
+          <p:nvPr>
+            <p:ph type="ftr" sz="quarter" idx="15"/>
+          </p:nvPr>
+        </p:nvSpPr>
+        <p:spPr>
+          <a:xfrm>
+            <a:off x="4086351" y="6469380"/>
+            <a:ext cx="1130300" cy="180000"/>
+          </a:xfrm>
+        </p:spPr>
+        <p:txBody>
+          <a:bodyPr wrap="none" anchor="ctr">
+            <a:normAutofit/>
+          </a:bodyPr>
+          <a:lstStyle/>
+          <a:p>
+            <a:pPr>
+              <a:lnSpc>
+                <a:spcPct val="90000"/>
+              </a:lnSpc>
+              <a:spcAft>
+                <a:spcPts val="600"/>
+              </a:spcAft>
+            </a:pPr>
+            <a:r>
+              <a:rPr lang="en-US"/>
+              <a:t>Corbin Ferguson</a:t>
+            </a:r>
+          </a:p>
+        </p:txBody>
+      </p:sp>
+      <p:sp>
+        <p:nvSpPr>
+          <p:cNvPr id="7" name="Slide Number Placeholder 6">
+            <a:extLst>
+              <a:ext uri="{FF2B5EF4-FFF2-40B4-BE49-F238E27FC236}">
+                <a16:creationId xmlns:a16="http://schemas.microsoft.com/office/drawing/2014/main" id="{6248CF65-0587-F225-E8E1-4881A1DE0251}"/>
+              </a:ext>
+            </a:extLst>
+          </p:cNvPr>
+          <p:cNvSpPr>
+            <a:spLocks noGrp="1"/>
+          </p:cNvSpPr>
+          <p:nvPr>
+            <p:ph type="sldNum" sz="quarter" idx="16"/>
+          </p:nvPr>
+        </p:nvSpPr>
+        <p:spPr>
+          <a:xfrm>
+            <a:off x="1633051" y="6469380"/>
+            <a:ext cx="571500" cy="180000"/>
+          </a:xfrm>
+        </p:spPr>
+        <p:txBody>
+          <a:bodyPr wrap="none" anchor="ctr">
+            <a:normAutofit/>
+          </a:bodyPr>
+          <a:lstStyle/>
+          <a:p>
+            <a:pPr>
+              <a:lnSpc>
+                <a:spcPct val="90000"/>
+              </a:lnSpc>
+              <a:spcAft>
+                <a:spcPts val="600"/>
+              </a:spcAft>
+            </a:pPr>
+            <a:r>
+              <a:rPr lang="en-US"/>
+              <a:t>Slide </a:t>
+            </a:r>
+            <a:fld id="{628FA54D-953C-47EB-A7E0-4AE7B797E29E}" type="slidenum">
+              <a:rPr lang="en-US" smtClean="0"/>
+              <a:pPr>
+                <a:lnSpc>
+                  <a:spcPct val="90000"/>
+                </a:lnSpc>
+                <a:spcAft>
+                  <a:spcPts val="600"/>
+                </a:spcAft>
+              </a:pPr>
+              <a:t>7</a:t>
+            </a:fld>
+            <a:endParaRPr lang="en-US"/>
+          </a:p>
+        </p:txBody>
+      </p:sp>
       <p:pic>
         <p:nvPicPr>
-          <p:cNvPr id="13" name="Picture 12">
-            <a:extLst>
-              <a:ext uri="{FF2B5EF4-FFF2-40B4-BE49-F238E27FC236}">
-                <a16:creationId xmlns:a16="http://schemas.microsoft.com/office/drawing/2014/main" id="{AFD30484-7327-2EF8-F791-E8AF4C39BD5C}"/>
+          <p:cNvPr id="17" name="Picture 16">
+            <a:extLst>
+              <a:ext uri="{FF2B5EF4-FFF2-40B4-BE49-F238E27FC236}">
+                <a16:creationId xmlns:a16="http://schemas.microsoft.com/office/drawing/2014/main" id="{07E999BB-F871-651D-2CBB-38D8B9FA34BA}"/>
               </a:ext>
             </a:extLst>
           </p:cNvPr>
@@ -24922,222 +25215,14 @@
         </p:blipFill>
         <p:spPr>
           <a:xfrm>
-            <a:off x="334963" y="1375131"/>
-            <a:ext cx="7112966" cy="4488253"/>
+            <a:off x="163512" y="1298404"/>
+            <a:ext cx="7267575" cy="4476750"/>
           </a:xfrm>
           <a:prstGeom prst="rect">
             <a:avLst/>
           </a:prstGeom>
-          <a:noFill/>
         </p:spPr>
       </p:pic>
-      <p:sp>
-        <p:nvSpPr>
-          <p:cNvPr id="26" name="Content Placeholder 4">
-            <a:extLst>
-              <a:ext uri="{FF2B5EF4-FFF2-40B4-BE49-F238E27FC236}">
-                <a16:creationId xmlns:a16="http://schemas.microsoft.com/office/drawing/2014/main" id="{ED360616-AB19-F180-EAE4-E484295C9E7C}"/>
-              </a:ext>
-            </a:extLst>
-          </p:cNvPr>
-          <p:cNvSpPr>
-            <a:spLocks noGrp="1"/>
-          </p:cNvSpPr>
-          <p:nvPr>
-            <p:ph sz="quarter" idx="14"/>
-          </p:nvPr>
-        </p:nvSpPr>
-        <p:spPr>
-          <a:xfrm>
-            <a:off x="7595615" y="980732"/>
-            <a:ext cx="4261421" cy="5112094"/>
-          </a:xfrm>
-        </p:spPr>
-        <p:txBody>
-          <a:bodyPr/>
-          <a:lstStyle/>
-          <a:p>
-            <a:r>
-              <a:rPr lang="en-US" sz="1800" dirty="0" err="1"/>
-              <a:t>ActionSelect</a:t>
-            </a:r>
-            <a:endParaRPr lang="en-US" sz="1800" dirty="0"/>
-          </a:p>
-          <a:p>
-            <a:pPr lvl="1"/>
-            <a:r>
-              <a:rPr lang="en-US" sz="1600" dirty="0"/>
-              <a:t>Main menu class, takes button input  events and calls functions in Execute class</a:t>
-            </a:r>
-          </a:p>
-          <a:p>
-            <a:r>
-              <a:rPr lang="en-US" sz="1800" dirty="0"/>
-              <a:t>Execute</a:t>
-            </a:r>
-          </a:p>
-          <a:p>
-            <a:pPr lvl="1"/>
-            <a:r>
-              <a:rPr lang="en-US" sz="1600" dirty="0"/>
-              <a:t>Coordinates major operations</a:t>
-            </a:r>
-          </a:p>
-          <a:p>
-            <a:pPr lvl="1"/>
-            <a:r>
-              <a:rPr lang="en-US" sz="1600" dirty="0"/>
-              <a:t>Only class that interacts with GUI elements (through Interfaces)</a:t>
-            </a:r>
-          </a:p>
-          <a:p>
-            <a:r>
-              <a:rPr lang="en-US" sz="1800" dirty="0" err="1"/>
-              <a:t>ElementHelper</a:t>
-            </a:r>
-            <a:endParaRPr lang="en-US" sz="1800" dirty="0"/>
-          </a:p>
-          <a:p>
-            <a:pPr lvl="1"/>
-            <a:r>
-              <a:rPr lang="en-US" sz="1600" dirty="0"/>
-              <a:t>Contains relevant information for elements currently being modified</a:t>
-            </a:r>
-          </a:p>
-          <a:p>
-            <a:r>
-              <a:rPr lang="en-US" sz="1800" dirty="0" err="1"/>
-              <a:t>XMLHandler</a:t>
-            </a:r>
-            <a:endParaRPr lang="en-US" sz="1800" dirty="0"/>
-          </a:p>
-          <a:p>
-            <a:pPr lvl="1"/>
-            <a:r>
-              <a:rPr lang="en-US" sz="1600" dirty="0"/>
-              <a:t>Handles the reading and writing of XML files</a:t>
-            </a:r>
-          </a:p>
-          <a:p>
-            <a:r>
-              <a:rPr lang="en-US" sz="1800" dirty="0" err="1"/>
-              <a:t>ValidationHandler</a:t>
-            </a:r>
-            <a:endParaRPr lang="en-US" sz="1800" dirty="0"/>
-          </a:p>
-          <a:p>
-            <a:pPr lvl="1"/>
-            <a:r>
-              <a:rPr lang="en-US" sz="1600" dirty="0"/>
-              <a:t>Handles reading of XSD file, passes information to </a:t>
-            </a:r>
-            <a:r>
-              <a:rPr lang="en-US" sz="1600" dirty="0" err="1"/>
-              <a:t>XMLHandler</a:t>
-            </a:r>
-            <a:endParaRPr lang="en-US" sz="1600" dirty="0"/>
-          </a:p>
-        </p:txBody>
-      </p:sp>
-      <p:sp>
-        <p:nvSpPr>
-          <p:cNvPr id="6" name="Footer Placeholder 5">
-            <a:extLst>
-              <a:ext uri="{FF2B5EF4-FFF2-40B4-BE49-F238E27FC236}">
-                <a16:creationId xmlns:a16="http://schemas.microsoft.com/office/drawing/2014/main" id="{6EACB492-E65F-C15E-A67C-498249C527CB}"/>
-              </a:ext>
-            </a:extLst>
-          </p:cNvPr>
-          <p:cNvSpPr>
-            <a:spLocks noGrp="1"/>
-          </p:cNvSpPr>
-          <p:nvPr>
-            <p:ph type="ftr" sz="quarter" idx="15"/>
-          </p:nvPr>
-        </p:nvSpPr>
-        <p:spPr>
-          <a:xfrm>
-            <a:off x="4086351" y="6469380"/>
-            <a:ext cx="1130300" cy="180000"/>
-          </a:xfrm>
-        </p:spPr>
-        <p:txBody>
-          <a:bodyPr wrap="none" anchor="ctr">
-            <a:normAutofit/>
-          </a:bodyPr>
-          <a:lstStyle/>
-          <a:p>
-            <a:pPr>
-              <a:lnSpc>
-                <a:spcPct val="90000"/>
-              </a:lnSpc>
-              <a:spcAft>
-                <a:spcPts val="600"/>
-              </a:spcAft>
-            </a:pPr>
-            <a:r>
-              <a:rPr lang="en-US"/>
-              <a:t>Corbin Ferguson</a:t>
-            </a:r>
-          </a:p>
-        </p:txBody>
-      </p:sp>
-      <p:sp>
-        <p:nvSpPr>
-          <p:cNvPr id="7" name="Slide Number Placeholder 6">
-            <a:extLst>
-              <a:ext uri="{FF2B5EF4-FFF2-40B4-BE49-F238E27FC236}">
-                <a16:creationId xmlns:a16="http://schemas.microsoft.com/office/drawing/2014/main" id="{6248CF65-0587-F225-E8E1-4881A1DE0251}"/>
-              </a:ext>
-            </a:extLst>
-          </p:cNvPr>
-          <p:cNvSpPr>
-            <a:spLocks noGrp="1"/>
-          </p:cNvSpPr>
-          <p:nvPr>
-            <p:ph type="sldNum" sz="quarter" idx="16"/>
-          </p:nvPr>
-        </p:nvSpPr>
-        <p:spPr>
-          <a:xfrm>
-            <a:off x="1633051" y="6469380"/>
-            <a:ext cx="571500" cy="180000"/>
-          </a:xfrm>
-        </p:spPr>
-        <p:txBody>
-          <a:bodyPr wrap="none" anchor="ctr">
-            <a:normAutofit/>
-          </a:bodyPr>
-          <a:lstStyle/>
-          <a:p>
-            <a:pPr>
-              <a:lnSpc>
-                <a:spcPct val="90000"/>
-              </a:lnSpc>
-              <a:spcAft>
-                <a:spcPts val="600"/>
-              </a:spcAft>
-            </a:pPr>
-            <a:r>
-              <a:rPr lang="en-US"/>
-              <a:t>Slide </a:t>
-            </a:r>
-            <a:fld id="{628FA54D-953C-47EB-A7E0-4AE7B797E29E}" type="slidenum">
-              <a:rPr lang="en-US" smtClean="0"/>
-              <a:pPr>
-                <a:lnSpc>
-                  <a:spcPct val="90000"/>
-                </a:lnSpc>
-                <a:spcAft>
-                  <a:spcPts val="600"/>
-                </a:spcAft>
-              </a:pPr>
-              <a:t>7</a:t>
-            </a:fld>
-            <a:endParaRPr lang="en-US"/>
-          </a:p>
-        </p:txBody>
-      </p:sp>
     </p:spTree>
     <p:extLst>
       <p:ext uri="{BB962C8B-B14F-4D97-AF65-F5344CB8AC3E}">
@@ -25256,10 +25341,10 @@
       </p:sp>
       <p:pic>
         <p:nvPicPr>
-          <p:cNvPr id="9" name="Picture 8">
-            <a:extLst>
-              <a:ext uri="{FF2B5EF4-FFF2-40B4-BE49-F238E27FC236}">
-                <a16:creationId xmlns:a16="http://schemas.microsoft.com/office/drawing/2014/main" id="{9E782A90-606C-B8FC-5DCD-B4609AECF711}"/>
+          <p:cNvPr id="11" name="Picture 10">
+            <a:extLst>
+              <a:ext uri="{FF2B5EF4-FFF2-40B4-BE49-F238E27FC236}">
+                <a16:creationId xmlns:a16="http://schemas.microsoft.com/office/drawing/2014/main" id="{B46A16E4-8866-CF99-290D-B3D2521747BE}"/>
               </a:ext>
             </a:extLst>
           </p:cNvPr>
@@ -25270,14 +25355,15 @@
         </p:nvPicPr>
         <p:blipFill>
           <a:blip r:embed="rId2"/>
+          <a:srcRect b="1398"/>
           <a:stretch>
             <a:fillRect/>
           </a:stretch>
         </p:blipFill>
         <p:spPr>
           <a:xfrm>
-            <a:off x="334963" y="1225812"/>
-            <a:ext cx="5616000" cy="4805675"/>
+            <a:off x="334963" y="1164474"/>
+            <a:ext cx="5616000" cy="4928351"/>
           </a:xfrm>
           <a:prstGeom prst="rect">
             <a:avLst/>
@@ -25308,76 +25394,140 @@
           </a:xfrm>
         </p:spPr>
         <p:txBody>
-          <a:bodyPr/>
-          <a:lstStyle/>
-          <a:p>
-            <a:r>
-              <a:rPr lang="en-US" dirty="0" err="1"/>
+          <a:bodyPr wrap="square" anchor="t">
+            <a:normAutofit/>
+          </a:bodyPr>
+          <a:lstStyle/>
+          <a:p>
+            <a:pPr>
+              <a:lnSpc>
+                <a:spcPct val="100000"/>
+              </a:lnSpc>
+            </a:pPr>
+            <a:r>
+              <a:rPr lang="en-US" sz="1900" err="1"/>
+              <a:t>ActionSelect</a:t>
+            </a:r>
+            <a:endParaRPr lang="en-US" sz="1900"/>
+          </a:p>
+          <a:p>
+            <a:pPr lvl="1">
+              <a:lnSpc>
+                <a:spcPct val="100000"/>
+              </a:lnSpc>
+            </a:pPr>
+            <a:r>
+              <a:rPr lang="en-US" sz="1900"/>
+              <a:t>Main menu class, takes button input  events and calls functions in Execute class</a:t>
+            </a:r>
+          </a:p>
+          <a:p>
+            <a:pPr>
+              <a:lnSpc>
+                <a:spcPct val="100000"/>
+              </a:lnSpc>
+            </a:pPr>
+            <a:r>
+              <a:rPr lang="en-US" sz="1900" err="1"/>
               <a:t>DropdownGui</a:t>
             </a:r>
-            <a:endParaRPr lang="en-US" dirty="0"/>
-          </a:p>
-          <a:p>
-            <a:pPr lvl="1"/>
-            <a:r>
-              <a:rPr lang="en-US" dirty="0"/>
+            <a:endParaRPr lang="en-US" sz="1900"/>
+          </a:p>
+          <a:p>
+            <a:pPr lvl="1">
+              <a:lnSpc>
+                <a:spcPct val="100000"/>
+              </a:lnSpc>
+            </a:pPr>
+            <a:r>
+              <a:rPr lang="en-US" sz="1900"/>
               <a:t>Single element selector via a dropdown</a:t>
             </a:r>
           </a:p>
           <a:p>
-            <a:pPr lvl="1"/>
-            <a:r>
-              <a:rPr lang="en-US" dirty="0"/>
+            <a:pPr lvl="1">
+              <a:lnSpc>
+                <a:spcPct val="100000"/>
+              </a:lnSpc>
+            </a:pPr>
+            <a:r>
+              <a:rPr lang="en-US" sz="1900"/>
               <a:t>Called when user must select between a defined list of options</a:t>
             </a:r>
           </a:p>
           <a:p>
-            <a:r>
-              <a:rPr lang="en-US" dirty="0" err="1"/>
+            <a:pPr>
+              <a:lnSpc>
+                <a:spcPct val="100000"/>
+              </a:lnSpc>
+            </a:pPr>
+            <a:r>
+              <a:rPr lang="en-US" sz="1900" err="1"/>
               <a:t>MultiSelectDropdown</a:t>
             </a:r>
-            <a:endParaRPr lang="en-US" dirty="0"/>
-          </a:p>
-          <a:p>
-            <a:pPr lvl="1"/>
-            <a:r>
-              <a:rPr lang="en-US" dirty="0"/>
+            <a:endParaRPr lang="en-US" sz="1900"/>
+          </a:p>
+          <a:p>
+            <a:pPr lvl="1">
+              <a:lnSpc>
+                <a:spcPct val="100000"/>
+              </a:lnSpc>
+            </a:pPr>
+            <a:r>
+              <a:rPr lang="en-US" sz="1900"/>
               <a:t>Multiple element selector via a dropdown</a:t>
             </a:r>
           </a:p>
           <a:p>
-            <a:pPr lvl="1"/>
-            <a:r>
-              <a:rPr lang="en-US" dirty="0"/>
+            <a:pPr lvl="1">
+              <a:lnSpc>
+                <a:spcPct val="100000"/>
+              </a:lnSpc>
+            </a:pPr>
+            <a:r>
+              <a:rPr lang="en-US" sz="1900"/>
               <a:t>Called when user must select between a defined list of options</a:t>
             </a:r>
           </a:p>
           <a:p>
-            <a:r>
-              <a:rPr lang="en-US" dirty="0" err="1"/>
+            <a:pPr>
+              <a:lnSpc>
+                <a:spcPct val="100000"/>
+              </a:lnSpc>
+            </a:pPr>
+            <a:r>
+              <a:rPr lang="en-US" sz="1900" err="1"/>
               <a:t>TextInput</a:t>
             </a:r>
-            <a:endParaRPr lang="en-US" dirty="0"/>
-          </a:p>
-          <a:p>
-            <a:pPr lvl="1"/>
-            <a:r>
-              <a:rPr lang="en-US" dirty="0"/>
+            <a:endParaRPr lang="en-US" sz="1900"/>
+          </a:p>
+          <a:p>
+            <a:pPr lvl="1">
+              <a:lnSpc>
+                <a:spcPct val="100000"/>
+              </a:lnSpc>
+            </a:pPr>
+            <a:r>
+              <a:rPr lang="en-US" sz="1900"/>
               <a:t>Text input field for user to type in text</a:t>
             </a:r>
           </a:p>
           <a:p>
-            <a:pPr lvl="1"/>
-            <a:r>
-              <a:rPr lang="en-US" dirty="0"/>
+            <a:pPr lvl="1">
+              <a:lnSpc>
+                <a:spcPct val="100000"/>
+              </a:lnSpc>
+            </a:pPr>
+            <a:r>
+              <a:rPr lang="en-US" sz="1900"/>
               <a:t>Can be </a:t>
             </a:r>
             <a:r>
-              <a:rPr lang="en-US" dirty="0" err="1"/>
+              <a:rPr lang="en-US" sz="1900" err="1"/>
               <a:t>regex’d</a:t>
             </a:r>
             <a:r>
-              <a:rPr lang="en-US" dirty="0"/>
+              <a:rPr lang="en-US" sz="1900"/>
               <a:t> to validate user input</a:t>
             </a:r>
           </a:p>

</xml_diff>

<commit_message>
It was not the last draft
</commit_message>
<xml_diff>
--- a/Thesis Writing Documents/Project Development.pptx
+++ b/Thesis Writing Documents/Project Development.pptx
@@ -218,7 +218,7 @@
 <file path=ppt/revisionInfo.xml><?xml version="1.0" encoding="utf-8"?>
 <p1510:revInfo xmlns:a="http://schemas.openxmlformats.org/drawingml/2006/main" xmlns:r="http://schemas.openxmlformats.org/officeDocument/2006/relationships" xmlns:p1510="http://schemas.microsoft.com/office/powerpoint/2015/10/main">
   <p1510:revLst>
-    <p1510:client id="{F0E03B4B-CC56-43F1-8F18-BCA697229170}" v="614" dt="2026-03-31T18:39:42.242"/>
+    <p1510:client id="{F0E03B4B-CC56-43F1-8F18-BCA697229170}" v="644" dt="2026-04-01T00:13:40.379"/>
   </p1510:revLst>
 </p1510:revInfo>
 </file>
@@ -228,7 +228,7 @@
   <pc:docChgLst>
     <pc:chgData name="Corbin Ferguson" userId="34a864e2-e65e-4cb2-823c-dc28f73f0e40" providerId="ADAL" clId="{8D2D96CF-1319-4CCC-9EA9-073445628049}"/>
     <pc:docChg chg="undo redo custSel addSld delSld modSld sldOrd modMainMaster">
-      <pc:chgData name="Corbin Ferguson" userId="34a864e2-e65e-4cb2-823c-dc28f73f0e40" providerId="ADAL" clId="{8D2D96CF-1319-4CCC-9EA9-073445628049}" dt="2026-03-31T20:35:44.222" v="10649" actId="20577"/>
+      <pc:chgData name="Corbin Ferguson" userId="34a864e2-e65e-4cb2-823c-dc28f73f0e40" providerId="ADAL" clId="{8D2D96CF-1319-4CCC-9EA9-073445628049}" dt="2026-04-01T00:13:56.004" v="10959" actId="14100"/>
       <pc:docMkLst>
         <pc:docMk/>
       </pc:docMkLst>
@@ -269,22 +269,6 @@
             <ac:spMk id="13" creationId="{50705606-BEFC-7BD3-6686-7F86A4FF0F2E}"/>
           </ac:spMkLst>
         </pc:spChg>
-        <pc:picChg chg="add del mod">
-          <ac:chgData name="Corbin Ferguson" userId="34a864e2-e65e-4cb2-823c-dc28f73f0e40" providerId="ADAL" clId="{8D2D96CF-1319-4CCC-9EA9-073445628049}" dt="2026-03-30T12:58:41.714" v="3679" actId="478"/>
-          <ac:picMkLst>
-            <pc:docMk/>
-            <pc:sldMk cId="463964235" sldId="257"/>
-            <ac:picMk id="1028" creationId="{6C86E4AC-1B5D-4CB7-A176-9C365C540E23}"/>
-          </ac:picMkLst>
-        </pc:picChg>
-        <pc:picChg chg="add del mod">
-          <ac:chgData name="Corbin Ferguson" userId="34a864e2-e65e-4cb2-823c-dc28f73f0e40" providerId="ADAL" clId="{8D2D96CF-1319-4CCC-9EA9-073445628049}" dt="2026-03-30T12:58:41.211" v="3678" actId="478"/>
-          <ac:picMkLst>
-            <pc:docMk/>
-            <pc:sldMk cId="463964235" sldId="257"/>
-            <ac:picMk id="1030" creationId="{84E072FF-ABEC-64D2-234E-9A5158069A12}"/>
-          </ac:picMkLst>
-        </pc:picChg>
       </pc:sldChg>
       <pc:sldChg chg="addSp delSp modSp mod modTransition modClrScheme chgLayout">
         <pc:chgData name="Corbin Ferguson" userId="34a864e2-e65e-4cb2-823c-dc28f73f0e40" providerId="ADAL" clId="{8D2D96CF-1319-4CCC-9EA9-073445628049}" dt="2026-03-31T19:08:48.793" v="10626" actId="14100"/>
@@ -324,14 +308,6 @@
             <ac:spMk id="7" creationId="{38D6E66F-E242-71AD-8EBC-F768E9376CE3}"/>
           </ac:spMkLst>
         </pc:spChg>
-        <pc:spChg chg="del">
-          <ac:chgData name="Corbin Ferguson" userId="34a864e2-e65e-4cb2-823c-dc28f73f0e40" providerId="ADAL" clId="{8D2D96CF-1319-4CCC-9EA9-073445628049}" dt="2026-03-30T12:19:03.827" v="2394" actId="478"/>
-          <ac:spMkLst>
-            <pc:docMk/>
-            <pc:sldMk cId="3766655233" sldId="2146848300"/>
-            <ac:spMk id="8" creationId="{A92DD050-2F4D-53AA-B5A1-03132F4C857B}"/>
-          </ac:spMkLst>
-        </pc:spChg>
         <pc:spChg chg="add del mod">
           <ac:chgData name="Corbin Ferguson" userId="34a864e2-e65e-4cb2-823c-dc28f73f0e40" providerId="ADAL" clId="{8D2D96CF-1319-4CCC-9EA9-073445628049}" dt="2026-03-31T19:08:19.591" v="10625" actId="20577"/>
           <ac:spMkLst>
@@ -340,46 +316,6 @@
             <ac:spMk id="16" creationId="{75043462-D499-CFD8-CA75-EACF7FECE616}"/>
           </ac:spMkLst>
         </pc:spChg>
-        <pc:graphicFrameChg chg="del">
-          <ac:chgData name="Corbin Ferguson" userId="34a864e2-e65e-4cb2-823c-dc28f73f0e40" providerId="ADAL" clId="{8D2D96CF-1319-4CCC-9EA9-073445628049}" dt="2026-03-30T12:18:54.973" v="2388" actId="478"/>
-          <ac:graphicFrameMkLst>
-            <pc:docMk/>
-            <pc:sldMk cId="3766655233" sldId="2146848300"/>
-            <ac:graphicFrameMk id="2" creationId="{00000000-0008-0000-0000-000002000000}"/>
-          </ac:graphicFrameMkLst>
-        </pc:graphicFrameChg>
-        <pc:graphicFrameChg chg="del">
-          <ac:chgData name="Corbin Ferguson" userId="34a864e2-e65e-4cb2-823c-dc28f73f0e40" providerId="ADAL" clId="{8D2D96CF-1319-4CCC-9EA9-073445628049}" dt="2026-03-30T12:18:56.361" v="2391" actId="478"/>
-          <ac:graphicFrameMkLst>
-            <pc:docMk/>
-            <pc:sldMk cId="3766655233" sldId="2146848300"/>
-            <ac:graphicFrameMk id="12" creationId="{00000000-0008-0000-0000-000003000000}"/>
-          </ac:graphicFrameMkLst>
-        </pc:graphicFrameChg>
-        <pc:graphicFrameChg chg="add del modGraphic">
-          <ac:chgData name="Corbin Ferguson" userId="34a864e2-e65e-4cb2-823c-dc28f73f0e40" providerId="ADAL" clId="{8D2D96CF-1319-4CCC-9EA9-073445628049}" dt="2026-03-30T12:20:41.105" v="2475" actId="1032"/>
-          <ac:graphicFrameMkLst>
-            <pc:docMk/>
-            <pc:sldMk cId="3766655233" sldId="2146848300"/>
-            <ac:graphicFrameMk id="13" creationId="{BED5C1C7-9FA3-06E9-39B9-D7350654734C}"/>
-          </ac:graphicFrameMkLst>
-        </pc:graphicFrameChg>
-        <pc:graphicFrameChg chg="del">
-          <ac:chgData name="Corbin Ferguson" userId="34a864e2-e65e-4cb2-823c-dc28f73f0e40" providerId="ADAL" clId="{8D2D96CF-1319-4CCC-9EA9-073445628049}" dt="2026-03-30T12:18:55.904" v="2390" actId="478"/>
-          <ac:graphicFrameMkLst>
-            <pc:docMk/>
-            <pc:sldMk cId="3766655233" sldId="2146848300"/>
-            <ac:graphicFrameMk id="14" creationId="{A2AF21A1-874A-01E1-B7E9-D274CA668642}"/>
-          </ac:graphicFrameMkLst>
-        </pc:graphicFrameChg>
-        <pc:graphicFrameChg chg="del">
-          <ac:chgData name="Corbin Ferguson" userId="34a864e2-e65e-4cb2-823c-dc28f73f0e40" providerId="ADAL" clId="{8D2D96CF-1319-4CCC-9EA9-073445628049}" dt="2026-03-30T12:18:55.510" v="2389" actId="478"/>
-          <ac:graphicFrameMkLst>
-            <pc:docMk/>
-            <pc:sldMk cId="3766655233" sldId="2146848300"/>
-            <ac:graphicFrameMk id="15" creationId="{33097FBC-2CBD-87D4-74AF-66102AD753AF}"/>
-          </ac:graphicFrameMkLst>
-        </pc:graphicFrameChg>
         <pc:picChg chg="add mod">
           <ac:chgData name="Corbin Ferguson" userId="34a864e2-e65e-4cb2-823c-dc28f73f0e40" providerId="ADAL" clId="{8D2D96CF-1319-4CCC-9EA9-073445628049}" dt="2026-03-30T12:20:42.313" v="2477" actId="26606"/>
           <ac:picMkLst>
@@ -410,30 +346,6 @@
           <pc:docMk/>
           <pc:sldMk cId="189939056" sldId="2146848304"/>
         </pc:sldMkLst>
-        <pc:spChg chg="add del mod">
-          <ac:chgData name="Corbin Ferguson" userId="34a864e2-e65e-4cb2-823c-dc28f73f0e40" providerId="ADAL" clId="{8D2D96CF-1319-4CCC-9EA9-073445628049}" dt="2026-03-30T13:50:46.665" v="4584" actId="478"/>
-          <ac:spMkLst>
-            <pc:docMk/>
-            <pc:sldMk cId="189939056" sldId="2146848304"/>
-            <ac:spMk id="9" creationId="{450D1C7F-8E37-F3F8-2112-AF2C44A0A141}"/>
-          </ac:spMkLst>
-        </pc:spChg>
-        <pc:spChg chg="del mod">
-          <ac:chgData name="Corbin Ferguson" userId="34a864e2-e65e-4cb2-823c-dc28f73f0e40" providerId="ADAL" clId="{8D2D96CF-1319-4CCC-9EA9-073445628049}" dt="2026-03-30T13:28:27.136" v="4576" actId="22"/>
-          <ac:spMkLst>
-            <pc:docMk/>
-            <pc:sldMk cId="189939056" sldId="2146848304"/>
-            <ac:spMk id="13" creationId="{4B3CDBD9-BD4E-E7E3-A1E9-2D692BAA1734}"/>
-          </ac:spMkLst>
-        </pc:spChg>
-        <pc:picChg chg="add del mod ord">
-          <ac:chgData name="Corbin Ferguson" userId="34a864e2-e65e-4cb2-823c-dc28f73f0e40" providerId="ADAL" clId="{8D2D96CF-1319-4CCC-9EA9-073445628049}" dt="2026-03-30T13:28:43.989" v="4579" actId="478"/>
-          <ac:picMkLst>
-            <pc:docMk/>
-            <pc:sldMk cId="189939056" sldId="2146848304"/>
-            <ac:picMk id="6" creationId="{93233039-22AC-BBA8-F2BF-D51DFD9769E2}"/>
-          </ac:picMkLst>
-        </pc:picChg>
         <pc:picChg chg="add mod">
           <ac:chgData name="Corbin Ferguson" userId="34a864e2-e65e-4cb2-823c-dc28f73f0e40" providerId="ADAL" clId="{8D2D96CF-1319-4CCC-9EA9-073445628049}" dt="2026-03-30T13:51:03.269" v="4586" actId="14100"/>
           <ac:picMkLst>
@@ -473,13 +385,6 @@
             <ac:spMk id="13" creationId="{929D0112-3559-BA85-36ED-E2064B91FC9A}"/>
           </ac:spMkLst>
         </pc:spChg>
-      </pc:sldChg>
-      <pc:sldChg chg="modSp del mod">
-        <pc:chgData name="Corbin Ferguson" userId="34a864e2-e65e-4cb2-823c-dc28f73f0e40" providerId="ADAL" clId="{8D2D96CF-1319-4CCC-9EA9-073445628049}" dt="2026-03-30T14:57:49.998" v="4888" actId="2696"/>
-        <pc:sldMkLst>
-          <pc:docMk/>
-          <pc:sldMk cId="364984994" sldId="2146848306"/>
-        </pc:sldMkLst>
       </pc:sldChg>
       <pc:sldChg chg="modSp mod ord modTransition modNotesTx">
         <pc:chgData name="Corbin Ferguson" userId="34a864e2-e65e-4cb2-823c-dc28f73f0e40" providerId="ADAL" clId="{8D2D96CF-1319-4CCC-9EA9-073445628049}" dt="2026-03-31T18:39:42.242" v="10560"/>
@@ -566,7 +471,7 @@
         </pc:sldMkLst>
       </pc:sldChg>
       <pc:sldChg chg="addSp modSp add mod modTransition">
-        <pc:chgData name="Corbin Ferguson" userId="34a864e2-e65e-4cb2-823c-dc28f73f0e40" providerId="ADAL" clId="{8D2D96CF-1319-4CCC-9EA9-073445628049}" dt="2026-03-30T15:50:23.046" v="7789"/>
+        <pc:chgData name="Corbin Ferguson" userId="34a864e2-e65e-4cb2-823c-dc28f73f0e40" providerId="ADAL" clId="{8D2D96CF-1319-4CCC-9EA9-073445628049}" dt="2026-04-01T00:03:48.423" v="10846" actId="20577"/>
         <pc:sldMkLst>
           <pc:docMk/>
           <pc:sldMk cId="1067535560" sldId="2146848314"/>
@@ -580,7 +485,7 @@
           </ac:spMkLst>
         </pc:spChg>
         <pc:spChg chg="mod">
-          <ac:chgData name="Corbin Ferguson" userId="34a864e2-e65e-4cb2-823c-dc28f73f0e40" providerId="ADAL" clId="{8D2D96CF-1319-4CCC-9EA9-073445628049}" dt="2026-03-16T15:12:46.375" v="1342" actId="20577"/>
+          <ac:chgData name="Corbin Ferguson" userId="34a864e2-e65e-4cb2-823c-dc28f73f0e40" providerId="ADAL" clId="{8D2D96CF-1319-4CCC-9EA9-073445628049}" dt="2026-04-01T00:03:48.423" v="10846" actId="20577"/>
           <ac:spMkLst>
             <pc:docMk/>
             <pc:sldMk cId="1067535560" sldId="2146848314"/>
@@ -639,14 +544,6 @@
             <pc:docMk/>
             <pc:sldMk cId="3831013115" sldId="2146848318"/>
             <ac:picMk id="6" creationId="{BF17B26E-CEBE-31E2-A928-A78B0BE175DA}"/>
-          </ac:picMkLst>
-        </pc:picChg>
-        <pc:picChg chg="add del mod ord modCrop">
-          <ac:chgData name="Corbin Ferguson" userId="34a864e2-e65e-4cb2-823c-dc28f73f0e40" providerId="ADAL" clId="{8D2D96CF-1319-4CCC-9EA9-073445628049}" dt="2026-03-30T15:42:30.036" v="7514" actId="21"/>
-          <ac:picMkLst>
-            <pc:docMk/>
-            <pc:sldMk cId="3831013115" sldId="2146848318"/>
-            <ac:picMk id="10" creationId="{36552AD4-E539-C4C4-F016-02E1B6D7EFCF}"/>
           </ac:picMkLst>
         </pc:picChg>
         <pc:picChg chg="mod ord modVis modCrop">
@@ -737,35 +634,19 @@
         </pc:picChg>
       </pc:sldChg>
       <pc:sldChg chg="addSp delSp modSp add mod ord modTransition delAnim modAnim modNotesTx">
-        <pc:chgData name="Corbin Ferguson" userId="34a864e2-e65e-4cb2-823c-dc28f73f0e40" providerId="ADAL" clId="{8D2D96CF-1319-4CCC-9EA9-073445628049}" dt="2026-03-31T14:29:52.063" v="10475"/>
+        <pc:chgData name="Corbin Ferguson" userId="34a864e2-e65e-4cb2-823c-dc28f73f0e40" providerId="ADAL" clId="{8D2D96CF-1319-4CCC-9EA9-073445628049}" dt="2026-04-01T00:10:33.119" v="10895" actId="14100"/>
         <pc:sldMkLst>
           <pc:docMk/>
           <pc:sldMk cId="1670292182" sldId="2146848323"/>
         </pc:sldMkLst>
         <pc:spChg chg="add mod">
-          <ac:chgData name="Corbin Ferguson" userId="34a864e2-e65e-4cb2-823c-dc28f73f0e40" providerId="ADAL" clId="{8D2D96CF-1319-4CCC-9EA9-073445628049}" dt="2026-03-16T20:44:01.003" v="1951" actId="207"/>
+          <ac:chgData name="Corbin Ferguson" userId="34a864e2-e65e-4cb2-823c-dc28f73f0e40" providerId="ADAL" clId="{8D2D96CF-1319-4CCC-9EA9-073445628049}" dt="2026-04-01T00:10:33.119" v="10895" actId="14100"/>
           <ac:spMkLst>
             <pc:docMk/>
             <pc:sldMk cId="1670292182" sldId="2146848323"/>
             <ac:spMk id="11" creationId="{BBDD576A-A414-9915-960B-C7192C1A13D8}"/>
           </ac:spMkLst>
         </pc:spChg>
-        <pc:picChg chg="del mod ord">
-          <ac:chgData name="Corbin Ferguson" userId="34a864e2-e65e-4cb2-823c-dc28f73f0e40" providerId="ADAL" clId="{8D2D96CF-1319-4CCC-9EA9-073445628049}" dt="2026-03-30T15:42:06.870" v="7509" actId="21"/>
-          <ac:picMkLst>
-            <pc:docMk/>
-            <pc:sldMk cId="1670292182" sldId="2146848323"/>
-            <ac:picMk id="6" creationId="{BF17B26E-CEBE-31E2-A928-A78B0BE175DA}"/>
-          </ac:picMkLst>
-        </pc:picChg>
-        <pc:picChg chg="add del mod ord">
-          <ac:chgData name="Corbin Ferguson" userId="34a864e2-e65e-4cb2-823c-dc28f73f0e40" providerId="ADAL" clId="{8D2D96CF-1319-4CCC-9EA9-073445628049}" dt="2026-03-30T15:43:16.250" v="7549" actId="21"/>
-          <ac:picMkLst>
-            <pc:docMk/>
-            <pc:sldMk cId="1670292182" sldId="2146848323"/>
-            <ac:picMk id="10" creationId="{36552AD4-E539-C4C4-F016-02E1B6D7EFCF}"/>
-          </ac:picMkLst>
-        </pc:picChg>
         <pc:picChg chg="add mod ord">
           <ac:chgData name="Corbin Ferguson" userId="34a864e2-e65e-4cb2-823c-dc28f73f0e40" providerId="ADAL" clId="{8D2D96CF-1319-4CCC-9EA9-073445628049}" dt="2026-03-30T15:43:47.495" v="7603" actId="14100"/>
           <ac:picMkLst>
@@ -774,8 +655,16 @@
             <ac:picMk id="15" creationId="{17752B2B-1B72-2430-A670-818B3CCFD41D}"/>
           </ac:picMkLst>
         </pc:picChg>
-        <pc:picChg chg="add mod modVis modCrop">
-          <ac:chgData name="Corbin Ferguson" userId="34a864e2-e65e-4cb2-823c-dc28f73f0e40" providerId="ADAL" clId="{8D2D96CF-1319-4CCC-9EA9-073445628049}" dt="2026-03-30T15:51:17.831" v="7798" actId="14429"/>
+        <pc:picChg chg="add mod ord">
+          <ac:chgData name="Corbin Ferguson" userId="34a864e2-e65e-4cb2-823c-dc28f73f0e40" providerId="ADAL" clId="{8D2D96CF-1319-4CCC-9EA9-073445628049}" dt="2026-04-01T00:10:10.563" v="10874" actId="962"/>
+          <ac:picMkLst>
+            <pc:docMk/>
+            <pc:sldMk cId="1670292182" sldId="2146848323"/>
+            <ac:picMk id="1026" creationId="{20890D35-21B5-65A3-4EB5-F39A5A0DCDD2}"/>
+          </ac:picMkLst>
+        </pc:picChg>
+        <pc:picChg chg="add del mod modVis modCrop">
+          <ac:chgData name="Corbin Ferguson" userId="34a864e2-e65e-4cb2-823c-dc28f73f0e40" providerId="ADAL" clId="{8D2D96CF-1319-4CCC-9EA9-073445628049}" dt="2026-04-01T00:09:14.387" v="10855" actId="478"/>
           <ac:picMkLst>
             <pc:docMk/>
             <pc:sldMk cId="1670292182" sldId="2146848323"/>
@@ -784,7 +673,7 @@
         </pc:picChg>
       </pc:sldChg>
       <pc:sldChg chg="addSp delSp modSp add mod modTransition delAnim modAnim modNotesTx">
-        <pc:chgData name="Corbin Ferguson" userId="34a864e2-e65e-4cb2-823c-dc28f73f0e40" providerId="ADAL" clId="{8D2D96CF-1319-4CCC-9EA9-073445628049}" dt="2026-03-31T14:29:55.376" v="10477"/>
+        <pc:chgData name="Corbin Ferguson" userId="34a864e2-e65e-4cb2-823c-dc28f73f0e40" providerId="ADAL" clId="{8D2D96CF-1319-4CCC-9EA9-073445628049}" dt="2026-04-01T00:13:14.955" v="10947" actId="14100"/>
         <pc:sldMkLst>
           <pc:docMk/>
           <pc:sldMk cId="2455060311" sldId="2146848324"/>
@@ -797,8 +686,8 @@
             <ac:spMk id="6" creationId="{A38A10BF-2126-40C7-FAE5-7BBF6C867EF1}"/>
           </ac:spMkLst>
         </pc:spChg>
-        <pc:picChg chg="add mod ord modVis modCrop">
-          <ac:chgData name="Corbin Ferguson" userId="34a864e2-e65e-4cb2-823c-dc28f73f0e40" providerId="ADAL" clId="{8D2D96CF-1319-4CCC-9EA9-073445628049}" dt="2026-03-30T15:47:45.781" v="7710" actId="14100"/>
+        <pc:picChg chg="add del mod ord modVis modCrop">
+          <ac:chgData name="Corbin Ferguson" userId="34a864e2-e65e-4cb2-823c-dc28f73f0e40" providerId="ADAL" clId="{8D2D96CF-1319-4CCC-9EA9-073445628049}" dt="2026-04-01T00:12:54.702" v="10939" actId="478"/>
           <ac:picMkLst>
             <pc:docMk/>
             <pc:sldMk cId="2455060311" sldId="2146848324"/>
@@ -806,50 +695,42 @@
           </ac:picMkLst>
         </pc:picChg>
         <pc:picChg chg="add mod modVis">
-          <ac:chgData name="Corbin Ferguson" userId="34a864e2-e65e-4cb2-823c-dc28f73f0e40" providerId="ADAL" clId="{8D2D96CF-1319-4CCC-9EA9-073445628049}" dt="2026-03-30T15:51:20.273" v="7799" actId="14429"/>
+          <ac:chgData name="Corbin Ferguson" userId="34a864e2-e65e-4cb2-823c-dc28f73f0e40" providerId="ADAL" clId="{8D2D96CF-1319-4CCC-9EA9-073445628049}" dt="2026-04-01T00:13:06.046" v="10943" actId="14429"/>
           <ac:picMkLst>
             <pc:docMk/>
             <pc:sldMk cId="2455060311" sldId="2146848324"/>
             <ac:picMk id="5" creationId="{BE5C2147-6B8C-1D93-D1D8-4113A963D2D0}"/>
           </ac:picMkLst>
         </pc:picChg>
-        <pc:picChg chg="add del mod ord">
-          <ac:chgData name="Corbin Ferguson" userId="34a864e2-e65e-4cb2-823c-dc28f73f0e40" providerId="ADAL" clId="{8D2D96CF-1319-4CCC-9EA9-073445628049}" dt="2026-03-30T15:46:55.485" v="7670" actId="478"/>
+        <pc:picChg chg="add mod ord">
+          <ac:chgData name="Corbin Ferguson" userId="34a864e2-e65e-4cb2-823c-dc28f73f0e40" providerId="ADAL" clId="{8D2D96CF-1319-4CCC-9EA9-073445628049}" dt="2026-04-01T00:13:14.955" v="10947" actId="14100"/>
           <ac:picMkLst>
             <pc:docMk/>
             <pc:sldMk cId="2455060311" sldId="2146848324"/>
-            <ac:picMk id="10" creationId="{36552AD4-E539-C4C4-F016-02E1B6D7EFCF}"/>
-          </ac:picMkLst>
-        </pc:picChg>
-        <pc:picChg chg="del mod">
-          <ac:chgData name="Corbin Ferguson" userId="34a864e2-e65e-4cb2-823c-dc28f73f0e40" providerId="ADAL" clId="{8D2D96CF-1319-4CCC-9EA9-073445628049}" dt="2026-03-30T15:43:35.840" v="7599" actId="21"/>
-          <ac:picMkLst>
-            <pc:docMk/>
-            <pc:sldMk cId="2455060311" sldId="2146848324"/>
-            <ac:picMk id="15" creationId="{17752B2B-1B72-2430-A670-818B3CCFD41D}"/>
+            <ac:picMk id="9" creationId="{8BFC2206-26A7-60F5-CBAC-314A71B8563A}"/>
           </ac:picMkLst>
         </pc:picChg>
       </pc:sldChg>
       <pc:sldChg chg="addSp delSp modSp add mod ord modTransition delAnim modAnim modNotesTx">
-        <pc:chgData name="Corbin Ferguson" userId="34a864e2-e65e-4cb2-823c-dc28f73f0e40" providerId="ADAL" clId="{8D2D96CF-1319-4CCC-9EA9-073445628049}" dt="2026-03-31T14:30:01.903" v="10481"/>
+        <pc:chgData name="Corbin Ferguson" userId="34a864e2-e65e-4cb2-823c-dc28f73f0e40" providerId="ADAL" clId="{8D2D96CF-1319-4CCC-9EA9-073445628049}" dt="2026-04-01T00:11:35.235" v="10933" actId="14429"/>
         <pc:sldMkLst>
           <pc:docMk/>
           <pc:sldMk cId="935187346" sldId="2146848325"/>
         </pc:sldMkLst>
-        <pc:spChg chg="mod">
-          <ac:chgData name="Corbin Ferguson" userId="34a864e2-e65e-4cb2-823c-dc28f73f0e40" providerId="ADAL" clId="{8D2D96CF-1319-4CCC-9EA9-073445628049}" dt="2026-03-30T15:37:53.843" v="7379" actId="1035"/>
+        <pc:spChg chg="mod modVis">
+          <ac:chgData name="Corbin Ferguson" userId="34a864e2-e65e-4cb2-823c-dc28f73f0e40" providerId="ADAL" clId="{8D2D96CF-1319-4CCC-9EA9-073445628049}" dt="2026-04-01T00:11:35.235" v="10933" actId="14429"/>
           <ac:spMkLst>
             <pc:docMk/>
             <pc:sldMk cId="935187346" sldId="2146848325"/>
             <ac:spMk id="11" creationId="{E527682E-55F4-1E8E-3D74-DD36AAF5EC17}"/>
           </ac:spMkLst>
         </pc:spChg>
-        <pc:picChg chg="add del mod ord">
-          <ac:chgData name="Corbin Ferguson" userId="34a864e2-e65e-4cb2-823c-dc28f73f0e40" providerId="ADAL" clId="{8D2D96CF-1319-4CCC-9EA9-073445628049}" dt="2026-03-30T15:48:48.749" v="7727" actId="478"/>
+        <pc:picChg chg="add mod ord">
+          <ac:chgData name="Corbin Ferguson" userId="34a864e2-e65e-4cb2-823c-dc28f73f0e40" providerId="ADAL" clId="{8D2D96CF-1319-4CCC-9EA9-073445628049}" dt="2026-04-01T00:10:46.878" v="10898" actId="13244"/>
           <ac:picMkLst>
             <pc:docMk/>
             <pc:sldMk cId="935187346" sldId="2146848325"/>
-            <ac:picMk id="3" creationId="{A34E6259-020A-CE8B-AC93-FDF3B8CB5BB9}"/>
+            <ac:picMk id="3" creationId="{35DB570D-C20F-4D18-AFA8-DB67D456C1A2}"/>
           </ac:picMkLst>
         </pc:picChg>
         <pc:picChg chg="add mod ord modVis">
@@ -860,56 +741,33 @@
             <ac:picMk id="5" creationId="{38941981-09C2-49EE-CBD3-2FA095358C90}"/>
           </ac:picMkLst>
         </pc:picChg>
-        <pc:picChg chg="add mod ord modCrop">
-          <ac:chgData name="Corbin Ferguson" userId="34a864e2-e65e-4cb2-823c-dc28f73f0e40" providerId="ADAL" clId="{8D2D96CF-1319-4CCC-9EA9-073445628049}" dt="2026-03-30T15:56:33.138" v="7942" actId="1037"/>
+        <pc:picChg chg="add del mod ord modCrop">
+          <ac:chgData name="Corbin Ferguson" userId="34a864e2-e65e-4cb2-823c-dc28f73f0e40" providerId="ADAL" clId="{8D2D96CF-1319-4CCC-9EA9-073445628049}" dt="2026-04-01T00:10:57.593" v="10899" actId="478"/>
           <ac:picMkLst>
             <pc:docMk/>
             <pc:sldMk cId="935187346" sldId="2146848325"/>
             <ac:picMk id="6" creationId="{8258F793-6C4B-B9D2-CC2E-6207D04A7C5C}"/>
           </ac:picMkLst>
         </pc:picChg>
-        <pc:picChg chg="add del mod">
-          <ac:chgData name="Corbin Ferguson" userId="34a864e2-e65e-4cb2-823c-dc28f73f0e40" providerId="ADAL" clId="{8D2D96CF-1319-4CCC-9EA9-073445628049}" dt="2026-03-30T15:35:03.940" v="7356" actId="478"/>
+        <pc:picChg chg="add mod ord modCrop">
+          <ac:chgData name="Corbin Ferguson" userId="34a864e2-e65e-4cb2-823c-dc28f73f0e40" providerId="ADAL" clId="{8D2D96CF-1319-4CCC-9EA9-073445628049}" dt="2026-04-01T00:11:32.939" v="10932" actId="13244"/>
           <ac:picMkLst>
             <pc:docMk/>
             <pc:sldMk cId="935187346" sldId="2146848325"/>
-            <ac:picMk id="4098" creationId="{8301C0C9-D4AA-0566-B820-5EAC6AD2ED11}"/>
+            <ac:picMk id="9" creationId="{0D495668-F0B2-4D67-2C55-18A3E3AB0F61}"/>
           </ac:picMkLst>
         </pc:picChg>
-        <pc:picChg chg="add mod ord modVis">
-          <ac:chgData name="Corbin Ferguson" userId="34a864e2-e65e-4cb2-823c-dc28f73f0e40" providerId="ADAL" clId="{8D2D96CF-1319-4CCC-9EA9-073445628049}" dt="2026-03-30T15:56:48.637" v="7943" actId="962"/>
+        <pc:picChg chg="add del mod ord modVis">
+          <ac:chgData name="Corbin Ferguson" userId="34a864e2-e65e-4cb2-823c-dc28f73f0e40" providerId="ADAL" clId="{8D2D96CF-1319-4CCC-9EA9-073445628049}" dt="2026-04-01T00:10:43.081" v="10896" actId="478"/>
           <ac:picMkLst>
             <pc:docMk/>
             <pc:sldMk cId="935187346" sldId="2146848325"/>
             <ac:picMk id="4100" creationId="{4C164929-3339-8372-C56E-6273FF8104E8}"/>
           </ac:picMkLst>
         </pc:picChg>
-        <pc:picChg chg="del mod modVis">
-          <ac:chgData name="Corbin Ferguson" userId="34a864e2-e65e-4cb2-823c-dc28f73f0e40" providerId="ADAL" clId="{8D2D96CF-1319-4CCC-9EA9-073445628049}" dt="2026-03-30T15:35:35.697" v="7360" actId="478"/>
-          <ac:picMkLst>
-            <pc:docMk/>
-            <pc:sldMk cId="935187346" sldId="2146848325"/>
-            <ac:picMk id="11268" creationId="{398BFDD6-EE1D-2233-1BC7-9B7205573827}"/>
-          </ac:picMkLst>
-        </pc:picChg>
-      </pc:sldChg>
-      <pc:sldChg chg="addSp delSp modSp new del mod ord">
-        <pc:chgData name="Corbin Ferguson" userId="34a864e2-e65e-4cb2-823c-dc28f73f0e40" providerId="ADAL" clId="{8D2D96CF-1319-4CCC-9EA9-073445628049}" dt="2026-03-30T14:41:28.637" v="4813" actId="2696"/>
-        <pc:sldMkLst>
-          <pc:docMk/>
-          <pc:sldMk cId="4147216281" sldId="2146848327"/>
-        </pc:sldMkLst>
-        <pc:spChg chg="mod">
-          <ac:chgData name="Corbin Ferguson" userId="34a864e2-e65e-4cb2-823c-dc28f73f0e40" providerId="ADAL" clId="{8D2D96CF-1319-4CCC-9EA9-073445628049}" dt="2026-03-30T14:19:20.036" v="4666" actId="20577"/>
-          <ac:spMkLst>
-            <pc:docMk/>
-            <pc:sldMk cId="4147216281" sldId="2146848327"/>
-            <ac:spMk id="2" creationId="{66F5F0CA-AE20-3F47-A2DA-544E05972351}"/>
-          </ac:spMkLst>
-        </pc:spChg>
       </pc:sldChg>
       <pc:sldChg chg="addSp delSp modSp new mod modTransition delAnim modAnim modNotesTx">
-        <pc:chgData name="Corbin Ferguson" userId="34a864e2-e65e-4cb2-823c-dc28f73f0e40" providerId="ADAL" clId="{8D2D96CF-1319-4CCC-9EA9-073445628049}" dt="2026-03-31T14:30:05.421" v="10483"/>
+        <pc:chgData name="Corbin Ferguson" userId="34a864e2-e65e-4cb2-823c-dc28f73f0e40" providerId="ADAL" clId="{8D2D96CF-1319-4CCC-9EA9-073445628049}" dt="2026-04-01T00:13:56.004" v="10959" actId="14100"/>
         <pc:sldMkLst>
           <pc:docMk/>
           <pc:sldMk cId="2633183682" sldId="2146848328"/>
@@ -922,22 +780,14 @@
             <ac:spMk id="2" creationId="{E3F023BE-C4A1-0C81-82B1-8BE303E6A0C4}"/>
           </ac:spMkLst>
         </pc:spChg>
-        <pc:spChg chg="del">
-          <ac:chgData name="Corbin Ferguson" userId="34a864e2-e65e-4cb2-823c-dc28f73f0e40" providerId="ADAL" clId="{8D2D96CF-1319-4CCC-9EA9-073445628049}" dt="2026-03-30T12:29:18.497" v="2513" actId="478"/>
-          <ac:spMkLst>
+        <pc:picChg chg="add mod ord modVis">
+          <ac:chgData name="Corbin Ferguson" userId="34a864e2-e65e-4cb2-823c-dc28f73f0e40" providerId="ADAL" clId="{8D2D96CF-1319-4CCC-9EA9-073445628049}" dt="2026-04-01T00:13:56.004" v="10959" actId="14100"/>
+          <ac:picMkLst>
             <pc:docMk/>
             <pc:sldMk cId="2633183682" sldId="2146848328"/>
-            <ac:spMk id="3" creationId="{C3E53D47-31DF-9BF6-2347-8A9B13DCC5CA}"/>
-          </ac:spMkLst>
-        </pc:spChg>
-        <pc:spChg chg="del">
-          <ac:chgData name="Corbin Ferguson" userId="34a864e2-e65e-4cb2-823c-dc28f73f0e40" providerId="ADAL" clId="{8D2D96CF-1319-4CCC-9EA9-073445628049}" dt="2026-03-30T12:29:17.305" v="2512" actId="478"/>
-          <ac:spMkLst>
-            <pc:docMk/>
-            <pc:sldMk cId="2633183682" sldId="2146848328"/>
-            <ac:spMk id="7" creationId="{8AC05C2F-2EF9-0069-B1C5-BAE17F07BBD5}"/>
-          </ac:spMkLst>
-        </pc:spChg>
+            <ac:picMk id="3" creationId="{06E6E34B-A3E4-5186-F073-42CEFA8945AB}"/>
+          </ac:picMkLst>
+        </pc:picChg>
         <pc:picChg chg="add mod modVis modCrop">
           <ac:chgData name="Corbin Ferguson" userId="34a864e2-e65e-4cb2-823c-dc28f73f0e40" providerId="ADAL" clId="{8D2D96CF-1319-4CCC-9EA9-073445628049}" dt="2026-03-30T18:33:13.337" v="7980" actId="14100"/>
           <ac:picMkLst>
@@ -946,16 +796,8 @@
             <ac:picMk id="9" creationId="{584FF30B-D15E-FA58-D2D2-6427F8479406}"/>
           </ac:picMkLst>
         </pc:picChg>
-        <pc:picChg chg="add del mod ord modCrop">
-          <ac:chgData name="Corbin Ferguson" userId="34a864e2-e65e-4cb2-823c-dc28f73f0e40" providerId="ADAL" clId="{8D2D96CF-1319-4CCC-9EA9-073445628049}" dt="2026-03-30T15:57:20.896" v="7944" actId="478"/>
-          <ac:picMkLst>
-            <pc:docMk/>
-            <pc:sldMk cId="2633183682" sldId="2146848328"/>
-            <ac:picMk id="10" creationId="{830F01A2-FC83-A9D1-7A0E-C2AB62460D0F}"/>
-          </ac:picMkLst>
-        </pc:picChg>
-        <pc:picChg chg="add mod ord">
-          <ac:chgData name="Corbin Ferguson" userId="34a864e2-e65e-4cb2-823c-dc28f73f0e40" providerId="ADAL" clId="{8D2D96CF-1319-4CCC-9EA9-073445628049}" dt="2026-03-30T15:57:51.920" v="7978" actId="1035"/>
+        <pc:picChg chg="add del mod ord">
+          <ac:chgData name="Corbin Ferguson" userId="34a864e2-e65e-4cb2-823c-dc28f73f0e40" providerId="ADAL" clId="{8D2D96CF-1319-4CCC-9EA9-073445628049}" dt="2026-04-01T00:13:50.116" v="10952" actId="478"/>
           <ac:picMkLst>
             <pc:docMk/>
             <pc:sldMk cId="2633183682" sldId="2146848328"/>
@@ -975,22 +817,6 @@
             <pc:docMk/>
             <pc:sldMk cId="3737639885" sldId="2146848329"/>
             <ac:spMk id="2" creationId="{739BBBBB-5627-C509-A3E9-051E4CBB9E93}"/>
-          </ac:spMkLst>
-        </pc:spChg>
-        <pc:spChg chg="del">
-          <ac:chgData name="Corbin Ferguson" userId="34a864e2-e65e-4cb2-823c-dc28f73f0e40" providerId="ADAL" clId="{8D2D96CF-1319-4CCC-9EA9-073445628049}" dt="2026-03-30T12:33:02.481" v="2571" actId="478"/>
-          <ac:spMkLst>
-            <pc:docMk/>
-            <pc:sldMk cId="3737639885" sldId="2146848329"/>
-            <ac:spMk id="3" creationId="{B2260CA0-C5E5-F52B-F364-ECF8CE007606}"/>
-          </ac:spMkLst>
-        </pc:spChg>
-        <pc:spChg chg="del">
-          <ac:chgData name="Corbin Ferguson" userId="34a864e2-e65e-4cb2-823c-dc28f73f0e40" providerId="ADAL" clId="{8D2D96CF-1319-4CCC-9EA9-073445628049}" dt="2026-03-30T12:33:01.640" v="2570" actId="478"/>
-          <ac:spMkLst>
-            <pc:docMk/>
-            <pc:sldMk cId="3737639885" sldId="2146848329"/>
-            <ac:spMk id="7" creationId="{5B72D51C-EDBC-2F65-F44F-A2103EB13E0A}"/>
           </ac:spMkLst>
         </pc:spChg>
         <pc:spChg chg="add mod">
@@ -1018,96 +844,12 @@
           </ac:picMkLst>
         </pc:picChg>
       </pc:sldChg>
-      <pc:sldChg chg="modSp add del mod ord">
-        <pc:chgData name="Corbin Ferguson" userId="34a864e2-e65e-4cb2-823c-dc28f73f0e40" providerId="ADAL" clId="{8D2D96CF-1319-4CCC-9EA9-073445628049}" dt="2026-03-30T12:34:20.254" v="2588" actId="2696"/>
-        <pc:sldMkLst>
-          <pc:docMk/>
-          <pc:sldMk cId="243149108" sldId="2146848330"/>
-        </pc:sldMkLst>
-        <pc:spChg chg="mod">
-          <ac:chgData name="Corbin Ferguson" userId="34a864e2-e65e-4cb2-823c-dc28f73f0e40" providerId="ADAL" clId="{8D2D96CF-1319-4CCC-9EA9-073445628049}" dt="2026-03-30T12:33:56.096" v="2585" actId="14100"/>
-          <ac:spMkLst>
-            <pc:docMk/>
-            <pc:sldMk cId="243149108" sldId="2146848330"/>
-            <ac:spMk id="11" creationId="{07991DD5-9A5C-E855-9D98-92A58A0146A6}"/>
-          </ac:spMkLst>
-        </pc:spChg>
-      </pc:sldChg>
-      <pc:sldChg chg="new del">
-        <pc:chgData name="Corbin Ferguson" userId="34a864e2-e65e-4cb2-823c-dc28f73f0e40" providerId="ADAL" clId="{8D2D96CF-1319-4CCC-9EA9-073445628049}" dt="2026-03-30T13:18:21.400" v="4574" actId="2696"/>
-        <pc:sldMkLst>
-          <pc:docMk/>
-          <pc:sldMk cId="1007462108" sldId="2146848330"/>
-        </pc:sldMkLst>
-      </pc:sldChg>
-      <pc:sldChg chg="addSp delSp modSp new del mod">
-        <pc:chgData name="Corbin Ferguson" userId="34a864e2-e65e-4cb2-823c-dc28f73f0e40" providerId="ADAL" clId="{8D2D96CF-1319-4CCC-9EA9-073445628049}" dt="2026-03-30T14:40:53.275" v="4788" actId="2696"/>
-        <pc:sldMkLst>
-          <pc:docMk/>
-          <pc:sldMk cId="4265443196" sldId="2146848331"/>
-        </pc:sldMkLst>
-        <pc:spChg chg="mod">
-          <ac:chgData name="Corbin Ferguson" userId="34a864e2-e65e-4cb2-823c-dc28f73f0e40" providerId="ADAL" clId="{8D2D96CF-1319-4CCC-9EA9-073445628049}" dt="2026-03-30T13:56:42.845" v="4650" actId="20577"/>
-          <ac:spMkLst>
-            <pc:docMk/>
-            <pc:sldMk cId="4265443196" sldId="2146848331"/>
-            <ac:spMk id="2" creationId="{78AF03D3-46E1-5CD8-2EF1-58210F086761}"/>
-          </ac:spMkLst>
-        </pc:spChg>
-        <pc:spChg chg="add del">
-          <ac:chgData name="Corbin Ferguson" userId="34a864e2-e65e-4cb2-823c-dc28f73f0e40" providerId="ADAL" clId="{8D2D96CF-1319-4CCC-9EA9-073445628049}" dt="2026-03-30T13:56:53.165" v="4652"/>
-          <ac:spMkLst>
-            <pc:docMk/>
-            <pc:sldMk cId="4265443196" sldId="2146848331"/>
-            <ac:spMk id="3" creationId="{55CB3071-6676-5655-7189-E9E7F7116C62}"/>
-          </ac:spMkLst>
-        </pc:spChg>
-        <pc:graphicFrameChg chg="add mod">
-          <ac:chgData name="Corbin Ferguson" userId="34a864e2-e65e-4cb2-823c-dc28f73f0e40" providerId="ADAL" clId="{8D2D96CF-1319-4CCC-9EA9-073445628049}" dt="2026-03-30T13:56:53.165" v="4652"/>
-          <ac:graphicFrameMkLst>
-            <pc:docMk/>
-            <pc:sldMk cId="4265443196" sldId="2146848331"/>
-            <ac:graphicFrameMk id="7" creationId="{E3D685B8-91B3-28F4-1DB3-9698C7C019E8}"/>
-          </ac:graphicFrameMkLst>
-        </pc:graphicFrameChg>
-      </pc:sldChg>
-      <pc:sldChg chg="modSp new del mod">
-        <pc:chgData name="Corbin Ferguson" userId="34a864e2-e65e-4cb2-823c-dc28f73f0e40" providerId="ADAL" clId="{8D2D96CF-1319-4CCC-9EA9-073445628049}" dt="2026-03-30T14:40:51.621" v="4787" actId="2696"/>
-        <pc:sldMkLst>
-          <pc:docMk/>
-          <pc:sldMk cId="4189671716" sldId="2146848332"/>
-        </pc:sldMkLst>
-        <pc:spChg chg="mod">
-          <ac:chgData name="Corbin Ferguson" userId="34a864e2-e65e-4cb2-823c-dc28f73f0e40" providerId="ADAL" clId="{8D2D96CF-1319-4CCC-9EA9-073445628049}" dt="2026-03-30T13:56:34.422" v="4627" actId="20577"/>
-          <ac:spMkLst>
-            <pc:docMk/>
-            <pc:sldMk cId="4189671716" sldId="2146848332"/>
-            <ac:spMk id="2" creationId="{F5C801AF-205E-CCC5-1469-42A47DA59246}"/>
-          </ac:spMkLst>
-        </pc:spChg>
-      </pc:sldChg>
       <pc:sldChg chg="addSp delSp modSp new mod modTransition modClrScheme chgLayout modNotesTx">
         <pc:chgData name="Corbin Ferguson" userId="34a864e2-e65e-4cb2-823c-dc28f73f0e40" providerId="ADAL" clId="{8D2D96CF-1319-4CCC-9EA9-073445628049}" dt="2026-03-31T19:17:40.468" v="10635" actId="20577"/>
         <pc:sldMkLst>
           <pc:docMk/>
           <pc:sldMk cId="3366771104" sldId="2146848333"/>
         </pc:sldMkLst>
-        <pc:spChg chg="del">
-          <ac:chgData name="Corbin Ferguson" userId="34a864e2-e65e-4cb2-823c-dc28f73f0e40" providerId="ADAL" clId="{8D2D96CF-1319-4CCC-9EA9-073445628049}" dt="2026-03-30T14:27:50.796" v="4668" actId="26606"/>
-          <ac:spMkLst>
-            <pc:docMk/>
-            <pc:sldMk cId="3366771104" sldId="2146848333"/>
-            <ac:spMk id="2" creationId="{B02CFBD2-353E-B389-D34D-FCF80EA69471}"/>
-          </ac:spMkLst>
-        </pc:spChg>
-        <pc:spChg chg="del">
-          <ac:chgData name="Corbin Ferguson" userId="34a864e2-e65e-4cb2-823c-dc28f73f0e40" providerId="ADAL" clId="{8D2D96CF-1319-4CCC-9EA9-073445628049}" dt="2026-03-30T14:27:50.796" v="4668" actId="26606"/>
-          <ac:spMkLst>
-            <pc:docMk/>
-            <pc:sldMk cId="3366771104" sldId="2146848333"/>
-            <ac:spMk id="3" creationId="{B069ABFB-1E08-3DD2-10E1-DFFA0076AEC1}"/>
-          </ac:spMkLst>
-        </pc:spChg>
         <pc:spChg chg="mod">
           <ac:chgData name="Corbin Ferguson" userId="34a864e2-e65e-4cb2-823c-dc28f73f0e40" providerId="ADAL" clId="{8D2D96CF-1319-4CCC-9EA9-073445628049}" dt="2026-03-30T14:27:50.796" v="4668" actId="26606"/>
           <ac:spMkLst>
@@ -1148,22 +890,6 @@
             <ac:spMk id="3081" creationId="{48E97AF7-5AD2-DC2E-0D5D-6756B90C946E}"/>
           </ac:spMkLst>
         </pc:spChg>
-        <pc:graphicFrameChg chg="add mod">
-          <ac:chgData name="Corbin Ferguson" userId="34a864e2-e65e-4cb2-823c-dc28f73f0e40" providerId="ADAL" clId="{8D2D96CF-1319-4CCC-9EA9-073445628049}" dt="2026-03-30T14:43:17.076" v="4853"/>
-          <ac:graphicFrameMkLst>
-            <pc:docMk/>
-            <pc:sldMk cId="3366771104" sldId="2146848333"/>
-            <ac:graphicFrameMk id="7" creationId="{BE047BC3-1128-EFE7-57C0-9E92F1E02BA4}"/>
-          </ac:graphicFrameMkLst>
-        </pc:graphicFrameChg>
-        <pc:graphicFrameChg chg="add mod">
-          <ac:chgData name="Corbin Ferguson" userId="34a864e2-e65e-4cb2-823c-dc28f73f0e40" providerId="ADAL" clId="{8D2D96CF-1319-4CCC-9EA9-073445628049}" dt="2026-03-30T14:43:19.705" v="4854"/>
-          <ac:graphicFrameMkLst>
-            <pc:docMk/>
-            <pc:sldMk cId="3366771104" sldId="2146848333"/>
-            <ac:graphicFrameMk id="8" creationId="{74D15E4F-78C3-5BD4-9D6A-FC3AC92DBCFF}"/>
-          </ac:graphicFrameMkLst>
-        </pc:graphicFrameChg>
         <pc:picChg chg="add mod ord">
           <ac:chgData name="Corbin Ferguson" userId="34a864e2-e65e-4cb2-823c-dc28f73f0e40" providerId="ADAL" clId="{8D2D96CF-1319-4CCC-9EA9-073445628049}" dt="2026-03-30T14:27:50.796" v="4668" actId="26606"/>
           <ac:picMkLst>
@@ -1174,7 +900,7 @@
         </pc:picChg>
       </pc:sldChg>
       <pc:sldChg chg="addSp delSp modSp new mod ord modTransition">
-        <pc:chgData name="Corbin Ferguson" userId="34a864e2-e65e-4cb2-823c-dc28f73f0e40" providerId="ADAL" clId="{8D2D96CF-1319-4CCC-9EA9-073445628049}" dt="2026-03-31T13:07:45.733" v="9084" actId="14100"/>
+        <pc:chgData name="Corbin Ferguson" userId="34a864e2-e65e-4cb2-823c-dc28f73f0e40" providerId="ADAL" clId="{8D2D96CF-1319-4CCC-9EA9-073445628049}" dt="2026-04-01T00:02:00.229" v="10668" actId="20577"/>
         <pc:sldMkLst>
           <pc:docMk/>
           <pc:sldMk cId="1111137208" sldId="2146848334"/>
@@ -1188,21 +914,13 @@
           </ac:spMkLst>
         </pc:spChg>
         <pc:spChg chg="mod">
-          <ac:chgData name="Corbin Ferguson" userId="34a864e2-e65e-4cb2-823c-dc28f73f0e40" providerId="ADAL" clId="{8D2D96CF-1319-4CCC-9EA9-073445628049}" dt="2026-03-31T13:07:45.733" v="9084" actId="14100"/>
+          <ac:chgData name="Corbin Ferguson" userId="34a864e2-e65e-4cb2-823c-dc28f73f0e40" providerId="ADAL" clId="{8D2D96CF-1319-4CCC-9EA9-073445628049}" dt="2026-04-01T00:02:00.229" v="10668" actId="20577"/>
           <ac:spMkLst>
             <pc:docMk/>
             <pc:sldMk cId="1111137208" sldId="2146848334"/>
             <ac:spMk id="3" creationId="{9B663C46-A793-3A1B-8101-817968A30164}"/>
           </ac:spMkLst>
         </pc:spChg>
-        <pc:picChg chg="add del">
-          <ac:chgData name="Corbin Ferguson" userId="34a864e2-e65e-4cb2-823c-dc28f73f0e40" providerId="ADAL" clId="{8D2D96CF-1319-4CCC-9EA9-073445628049}" dt="2026-03-30T13:11:30.020" v="3925" actId="478"/>
-          <ac:picMkLst>
-            <pc:docMk/>
-            <pc:sldMk cId="1111137208" sldId="2146848334"/>
-            <ac:picMk id="8" creationId="{122A7D7F-A135-94DF-62A6-8F9C5BC4365E}"/>
-          </ac:picMkLst>
-        </pc:picChg>
         <pc:picChg chg="add mod">
           <ac:chgData name="Corbin Ferguson" userId="34a864e2-e65e-4cb2-823c-dc28f73f0e40" providerId="ADAL" clId="{8D2D96CF-1319-4CCC-9EA9-073445628049}" dt="2026-03-30T13:16:50.251" v="4429" actId="1076"/>
           <ac:picMkLst>
@@ -1217,22 +935,6 @@
             <pc:docMk/>
             <pc:sldMk cId="1111137208" sldId="2146848334"/>
             <ac:picMk id="12" creationId="{E06BB708-2A6F-8850-88FE-C41AEC89FB75}"/>
-          </ac:picMkLst>
-        </pc:picChg>
-        <pc:picChg chg="add del mod">
-          <ac:chgData name="Corbin Ferguson" userId="34a864e2-e65e-4cb2-823c-dc28f73f0e40" providerId="ADAL" clId="{8D2D96CF-1319-4CCC-9EA9-073445628049}" dt="2026-03-30T13:13:33.676" v="4170" actId="478"/>
-          <ac:picMkLst>
-            <pc:docMk/>
-            <pc:sldMk cId="1111137208" sldId="2146848334"/>
-            <ac:picMk id="14" creationId="{06957091-5CD0-FF9F-41C8-E74BAFC760DD}"/>
-          </ac:picMkLst>
-        </pc:picChg>
-        <pc:picChg chg="add del">
-          <ac:chgData name="Corbin Ferguson" userId="34a864e2-e65e-4cb2-823c-dc28f73f0e40" providerId="ADAL" clId="{8D2D96CF-1319-4CCC-9EA9-073445628049}" dt="2026-03-30T13:13:32.666" v="4168" actId="478"/>
-          <ac:picMkLst>
-            <pc:docMk/>
-            <pc:sldMk cId="1111137208" sldId="2146848334"/>
-            <ac:picMk id="16" creationId="{99ABD223-57FD-53F5-F5A6-780849FE868A}"/>
           </ac:picMkLst>
         </pc:picChg>
         <pc:picChg chg="add mod">
@@ -1394,21 +1096,6 @@
             <ac:picMk id="17" creationId="{07E999BB-F871-651D-2CBB-38D8B9FA34BA}"/>
           </ac:picMkLst>
         </pc:picChg>
-      </pc:sldChg>
-      <pc:sldChg chg="modSp add del mod">
-        <pc:chgData name="Corbin Ferguson" userId="34a864e2-e65e-4cb2-823c-dc28f73f0e40" providerId="ADAL" clId="{8D2D96CF-1319-4CCC-9EA9-073445628049}" dt="2026-03-30T14:40:49.832" v="4786" actId="2696"/>
-        <pc:sldMkLst>
-          <pc:docMk/>
-          <pc:sldMk cId="2271584715" sldId="2146848335"/>
-        </pc:sldMkLst>
-        <pc:spChg chg="mod">
-          <ac:chgData name="Corbin Ferguson" userId="34a864e2-e65e-4cb2-823c-dc28f73f0e40" providerId="ADAL" clId="{8D2D96CF-1319-4CCC-9EA9-073445628049}" dt="2026-03-30T13:56:27.859" v="4607" actId="20577"/>
-          <ac:spMkLst>
-            <pc:docMk/>
-            <pc:sldMk cId="2271584715" sldId="2146848335"/>
-            <ac:spMk id="2" creationId="{52254D65-5761-ABD9-2C81-218FD1C54027}"/>
-          </ac:spMkLst>
-        </pc:spChg>
       </pc:sldChg>
       <pc:sldChg chg="addSp delSp modSp new mod modTransition">
         <pc:chgData name="Corbin Ferguson" userId="34a864e2-e65e-4cb2-823c-dc28f73f0e40" providerId="ADAL" clId="{8D2D96CF-1319-4CCC-9EA9-073445628049}" dt="2026-03-31T15:33:43.051" v="10516" actId="26606"/>
@@ -19098,13 +18785,13 @@
   <p:clrMapOvr>
     <a:masterClrMapping/>
   </p:clrMapOvr>
-  <mc:AlternateContent xmlns:mc="http://schemas.openxmlformats.org/markup-compatibility/2006">
-    <mc:Choice xmlns:p159="http://schemas.microsoft.com/office/powerpoint/2015/09/main" Requires="p159">
+  <mc:AlternateContent xmlns:mc="http://schemas.openxmlformats.org/markup-compatibility/2006" xmlns:p159="http://schemas.microsoft.com/office/powerpoint/2015/09/main">
+    <mc:Choice Requires="p159">
       <p:transition>
         <p159:morph option="byObject"/>
       </p:transition>
     </mc:Choice>
-    <mc:Fallback>
+    <mc:Fallback xmlns="">
       <p:transition>
         <p:fade/>
       </p:transition>
@@ -19533,13 +19220,13 @@
   <p:clrMapOvr>
     <a:masterClrMapping/>
   </p:clrMapOvr>
-  <mc:AlternateContent xmlns:mc="http://schemas.openxmlformats.org/markup-compatibility/2006">
-    <mc:Choice xmlns:p159="http://schemas.microsoft.com/office/powerpoint/2015/09/main" Requires="p159">
+  <mc:AlternateContent xmlns:mc="http://schemas.openxmlformats.org/markup-compatibility/2006" xmlns:p159="http://schemas.microsoft.com/office/powerpoint/2015/09/main">
+    <mc:Choice Requires="p159">
       <p:transition>
         <p159:morph option="byObject"/>
       </p:transition>
     </mc:Choice>
-    <mc:Fallback>
+    <mc:Fallback xmlns="">
       <p:transition>
         <p:fade/>
       </p:transition>
@@ -19853,10 +19540,10 @@
       </p:pic>
       <p:pic>
         <p:nvPicPr>
-          <p:cNvPr id="11268" name="NewFile">
-            <a:extLst>
-              <a:ext uri="{FF2B5EF4-FFF2-40B4-BE49-F238E27FC236}">
-                <a16:creationId xmlns:a16="http://schemas.microsoft.com/office/drawing/2014/main" id="{14AE5F5A-6C88-0F58-A592-0FB668BF99DA}"/>
+          <p:cNvPr id="1026" name="NewFile">
+            <a:extLst>
+              <a:ext uri="{FF2B5EF4-FFF2-40B4-BE49-F238E27FC236}">
+                <a16:creationId xmlns:a16="http://schemas.microsoft.com/office/drawing/2014/main" id="{20890D35-21B5-65A3-4EB5-F39A5A0DCDD2}"/>
               </a:ext>
             </a:extLst>
           </p:cNvPr>
@@ -19880,8 +19567,8 @@
         </p:blipFill>
         <p:spPr bwMode="auto">
           <a:xfrm>
-            <a:off x="365435" y="980731"/>
-            <a:ext cx="11428631" cy="4882654"/>
+            <a:off x="387104" y="905835"/>
+            <a:ext cx="11417792" cy="5068102"/>
           </a:xfrm>
           <a:prstGeom prst="rect">
             <a:avLst/>
@@ -19905,8 +19592,8 @@
         </p:nvSpPr>
         <p:spPr>
           <a:xfrm>
-            <a:off x="2514600" y="2705100"/>
-            <a:ext cx="8839200" cy="901700"/>
+            <a:off x="3483428" y="2498270"/>
+            <a:ext cx="7979229" cy="901700"/>
           </a:xfrm>
           <a:prstGeom prst="roundRect">
             <a:avLst/>
@@ -19970,13 +19657,13 @@
   <p:clrMapOvr>
     <a:masterClrMapping/>
   </p:clrMapOvr>
-  <mc:AlternateContent xmlns:mc="http://schemas.openxmlformats.org/markup-compatibility/2006">
-    <mc:Choice xmlns:p159="http://schemas.microsoft.com/office/powerpoint/2015/09/main" Requires="p159">
+  <mc:AlternateContent xmlns:mc="http://schemas.openxmlformats.org/markup-compatibility/2006" xmlns:p159="http://schemas.microsoft.com/office/powerpoint/2015/09/main">
+    <mc:Choice Requires="p159">
       <p:transition>
         <p159:morph option="byObject"/>
       </p:transition>
     </mc:Choice>
-    <mc:Fallback>
+    <mc:Fallback xmlns="">
       <p:transition>
         <p:fade/>
       </p:transition>
@@ -20259,10 +19946,10 @@
       </p:sp>
       <p:pic>
         <p:nvPicPr>
-          <p:cNvPr id="3" name="!NewFile">
-            <a:extLst>
-              <a:ext uri="{FF2B5EF4-FFF2-40B4-BE49-F238E27FC236}">
-                <a16:creationId xmlns:a16="http://schemas.microsoft.com/office/drawing/2014/main" id="{2C2C5AB6-0479-9BDD-DD83-40A7451A2B32}"/>
+          <p:cNvPr id="9" name="!NewFile">
+            <a:extLst>
+              <a:ext uri="{FF2B5EF4-FFF2-40B4-BE49-F238E27FC236}">
+                <a16:creationId xmlns:a16="http://schemas.microsoft.com/office/drawing/2014/main" id="{8BFC2206-26A7-60F5-CBAC-314A71B8563A}"/>
               </a:ext>
             </a:extLst>
           </p:cNvPr>
@@ -20279,15 +19966,15 @@
               </a:ext>
             </a:extLst>
           </a:blip>
-          <a:srcRect l="18830" t="34247" r="4223" b="46101"/>
+          <a:srcRect/>
           <a:stretch>
             <a:fillRect/>
           </a:stretch>
         </p:blipFill>
         <p:spPr bwMode="auto">
           <a:xfrm>
-            <a:off x="1433867" y="2599943"/>
-            <a:ext cx="9764534" cy="1065448"/>
+            <a:off x="2196748" y="1709095"/>
+            <a:ext cx="7798505" cy="3461582"/>
           </a:xfrm>
           <a:prstGeom prst="rect">
             <a:avLst/>
@@ -20406,13 +20093,13 @@
   <p:clrMapOvr>
     <a:masterClrMapping/>
   </p:clrMapOvr>
-  <mc:AlternateContent xmlns:mc="http://schemas.openxmlformats.org/markup-compatibility/2006">
-    <mc:Choice xmlns:p159="http://schemas.microsoft.com/office/powerpoint/2015/09/main" Requires="p159">
+  <mc:AlternateContent xmlns:mc="http://schemas.openxmlformats.org/markup-compatibility/2006" xmlns:p159="http://schemas.microsoft.com/office/powerpoint/2015/09/main">
+    <mc:Choice Requires="p159">
       <p:transition>
         <p159:morph option="byObject"/>
       </p:transition>
     </mc:Choice>
-    <mc:Fallback>
+    <mc:Fallback xmlns="">
       <p:transition>
         <p:fade/>
       </p:transition>
@@ -20479,42 +20166,6 @@
                             </p:childTnLst>
                           </p:cTn>
                         </p:par>
-                        <p:par>
-                          <p:cTn id="8" fill="hold">
-                            <p:stCondLst>
-                              <p:cond delay="600"/>
-                            </p:stCondLst>
-                            <p:childTnLst>
-                              <p:par>
-                                <p:cTn id="9" presetID="1" presetClass="exit" presetSubtype="0" fill="hold" nodeType="afterEffect">
-                                  <p:stCondLst>
-                                    <p:cond delay="0"/>
-                                  </p:stCondLst>
-                                  <p:childTnLst>
-                                    <p:set>
-                                      <p:cBhvr>
-                                        <p:cTn id="10" dur="1" fill="hold">
-                                          <p:stCondLst>
-                                            <p:cond delay="0"/>
-                                          </p:stCondLst>
-                                        </p:cTn>
-                                        <p:tgtEl>
-                                          <p:spTgt spid="3"/>
-                                        </p:tgtEl>
-                                        <p:attrNameLst>
-                                          <p:attrName>style.visibility</p:attrName>
-                                        </p:attrNameLst>
-                                      </p:cBhvr>
-                                      <p:to>
-                                        <p:strVal val="hidden"/>
-                                      </p:to>
-                                    </p:set>
-                                  </p:childTnLst>
-                                </p:cTn>
-                              </p:par>
-                            </p:childTnLst>
-                          </p:cTn>
-                        </p:par>
                       </p:childTnLst>
                     </p:cTn>
                   </p:par>
@@ -20832,13 +20483,13 @@
   <p:clrMapOvr>
     <a:masterClrMapping/>
   </p:clrMapOvr>
-  <mc:AlternateContent xmlns:mc="http://schemas.openxmlformats.org/markup-compatibility/2006">
-    <mc:Choice xmlns:p159="http://schemas.microsoft.com/office/powerpoint/2015/09/main" Requires="p159">
+  <mc:AlternateContent xmlns:mc="http://schemas.openxmlformats.org/markup-compatibility/2006" xmlns:p159="http://schemas.microsoft.com/office/powerpoint/2015/09/main">
+    <mc:Choice Requires="p159">
       <p:transition>
         <p159:morph option="byObject"/>
       </p:transition>
     </mc:Choice>
-    <mc:Fallback>
+    <mc:Fallback xmlns="">
       <p:transition>
         <p:fade/>
       </p:transition>
@@ -21161,10 +20812,10 @@
       </p:pic>
       <p:pic>
         <p:nvPicPr>
-          <p:cNvPr id="4100" name="NewFileFULL">
-            <a:extLst>
-              <a:ext uri="{FF2B5EF4-FFF2-40B4-BE49-F238E27FC236}">
-                <a16:creationId xmlns:a16="http://schemas.microsoft.com/office/drawing/2014/main" id="{4C164929-3339-8372-C56E-6273FF8104E8}"/>
+          <p:cNvPr id="3" name="NewFile">
+            <a:extLst>
+              <a:ext uri="{FF2B5EF4-FFF2-40B4-BE49-F238E27FC236}">
+                <a16:creationId xmlns:a16="http://schemas.microsoft.com/office/drawing/2014/main" id="{35DB570D-C20F-4D18-AFA8-DB67D456C1A2}"/>
               </a:ext>
             </a:extLst>
           </p:cNvPr>
@@ -21188,8 +20839,8 @@
         </p:blipFill>
         <p:spPr bwMode="auto">
           <a:xfrm>
-            <a:off x="199916" y="909969"/>
-            <a:ext cx="11480450" cy="4380698"/>
+            <a:off x="387104" y="905835"/>
+            <a:ext cx="11417792" cy="5068102"/>
           </a:xfrm>
           <a:prstGeom prst="rect">
             <a:avLst/>
@@ -21201,10 +20852,10 @@
       </p:pic>
       <p:pic>
         <p:nvPicPr>
-          <p:cNvPr id="6" name="NewFile">
-            <a:extLst>
-              <a:ext uri="{FF2B5EF4-FFF2-40B4-BE49-F238E27FC236}">
-                <a16:creationId xmlns:a16="http://schemas.microsoft.com/office/drawing/2014/main" id="{8258F793-6C4B-B9D2-CC2E-6207D04A7C5C}"/>
+          <p:cNvPr id="9" name="NewFile">
+            <a:extLst>
+              <a:ext uri="{FF2B5EF4-FFF2-40B4-BE49-F238E27FC236}">
+                <a16:creationId xmlns:a16="http://schemas.microsoft.com/office/drawing/2014/main" id="{0D495668-F0B2-4D67-2C55-18A3E3AB0F61}"/>
               </a:ext>
             </a:extLst>
           </p:cNvPr>
@@ -21221,15 +20872,15 @@
               </a:ext>
             </a:extLst>
           </a:blip>
-          <a:srcRect l="24267" t="50542" r="1330" b="6617"/>
+          <a:srcRect l="28358" t="48926"/>
           <a:stretch>
             <a:fillRect/>
           </a:stretch>
         </p:blipFill>
         <p:spPr bwMode="auto">
           <a:xfrm>
-            <a:off x="2985822" y="3104438"/>
-            <a:ext cx="8541879" cy="1876777"/>
+            <a:off x="3624942" y="3385455"/>
+            <a:ext cx="8179953" cy="2588481"/>
           </a:xfrm>
           <a:prstGeom prst="rect">
             <a:avLst/>
@@ -21253,8 +20904,8 @@
         </p:nvSpPr>
         <p:spPr>
           <a:xfrm>
-            <a:off x="2489200" y="3407832"/>
-            <a:ext cx="8839200" cy="1663700"/>
+            <a:off x="3494313" y="3429000"/>
+            <a:ext cx="8197429" cy="1663700"/>
           </a:xfrm>
           <a:prstGeom prst="roundRect">
             <a:avLst/>
@@ -21318,13 +20969,13 @@
   <p:clrMapOvr>
     <a:masterClrMapping/>
   </p:clrMapOvr>
-  <mc:AlternateContent xmlns:mc="http://schemas.openxmlformats.org/markup-compatibility/2006">
-    <mc:Choice xmlns:p159="http://schemas.microsoft.com/office/powerpoint/2015/09/main" Requires="p159">
+  <mc:AlternateContent xmlns:mc="http://schemas.openxmlformats.org/markup-compatibility/2006" xmlns:p159="http://schemas.microsoft.com/office/powerpoint/2015/09/main">
+    <mc:Choice Requires="p159">
       <p:transition>
         <p159:morph option="byObject"/>
       </p:transition>
     </mc:Choice>
-    <mc:Fallback>
+    <mc:Fallback xmlns="">
       <p:transition>
         <p:fade/>
       </p:transition>
@@ -21597,10 +21248,10 @@
       </p:sp>
       <p:pic>
         <p:nvPicPr>
-          <p:cNvPr id="11" name="!NewFile">
-            <a:extLst>
-              <a:ext uri="{FF2B5EF4-FFF2-40B4-BE49-F238E27FC236}">
-                <a16:creationId xmlns:a16="http://schemas.microsoft.com/office/drawing/2014/main" id="{52DEB6A1-15E1-625C-99FA-5170366012B3}"/>
+          <p:cNvPr id="3" name="NewFile">
+            <a:extLst>
+              <a:ext uri="{FF2B5EF4-FFF2-40B4-BE49-F238E27FC236}">
+                <a16:creationId xmlns:a16="http://schemas.microsoft.com/office/drawing/2014/main" id="{06E6E34B-A3E4-5186-F073-42CEFA8945AB}"/>
               </a:ext>
             </a:extLst>
           </p:cNvPr>
@@ -21617,15 +21268,15 @@
               </a:ext>
             </a:extLst>
           </a:blip>
-          <a:srcRect l="24267" t="50542" r="1330" b="6617"/>
+          <a:srcRect/>
           <a:stretch>
             <a:fillRect/>
           </a:stretch>
         </p:blipFill>
         <p:spPr bwMode="auto">
           <a:xfrm>
-            <a:off x="2637691" y="2539993"/>
-            <a:ext cx="7149776" cy="1570912"/>
+            <a:off x="2551225" y="1866440"/>
+            <a:ext cx="7089550" cy="3146893"/>
           </a:xfrm>
           <a:prstGeom prst="rect">
             <a:avLst/>
@@ -21676,13 +21327,13 @@
   <p:clrMapOvr>
     <a:masterClrMapping/>
   </p:clrMapOvr>
-  <mc:AlternateContent xmlns:mc="http://schemas.openxmlformats.org/markup-compatibility/2006">
-    <mc:Choice xmlns:p159="http://schemas.microsoft.com/office/powerpoint/2015/09/main" Requires="p159">
+  <mc:AlternateContent xmlns:mc="http://schemas.openxmlformats.org/markup-compatibility/2006" xmlns:p159="http://schemas.microsoft.com/office/powerpoint/2015/09/main">
+    <mc:Choice Requires="p159">
       <p:transition>
         <p159:morph option="byObject"/>
       </p:transition>
     </mc:Choice>
-    <mc:Fallback>
+    <mc:Fallback xmlns="">
       <p:transition>
         <p:fade/>
       </p:transition>
@@ -23048,7 +22699,37 @@
             </a:pPr>
             <a:r>
               <a:rPr lang="en-US" dirty="0"/>
-              <a:t>Application state OK but not shippable</a:t>
+              <a:t>Potential future additions:</a:t>
+            </a:r>
+          </a:p>
+          <a:p>
+            <a:pPr marL="703263" lvl="1" indent="-342900">
+              <a:buFont typeface="Arial" panose="020B0604020202020204" pitchFamily="34" charset="0"/>
+              <a:buChar char="•"/>
+            </a:pPr>
+            <a:r>
+              <a:rPr lang="en-US" dirty="0"/>
+              <a:t>Upgraded UI to more intuitive feel</a:t>
+            </a:r>
+          </a:p>
+          <a:p>
+            <a:pPr marL="703263" lvl="1" indent="-342900">
+              <a:buFont typeface="Arial" panose="020B0604020202020204" pitchFamily="34" charset="0"/>
+              <a:buChar char="•"/>
+            </a:pPr>
+            <a:r>
+              <a:rPr lang="en-US" dirty="0"/>
+              <a:t>Enhanced system validation</a:t>
+            </a:r>
+          </a:p>
+          <a:p>
+            <a:pPr marL="703263" lvl="1" indent="-342900">
+              <a:buFont typeface="Arial" panose="020B0604020202020204" pitchFamily="34" charset="0"/>
+              <a:buChar char="•"/>
+            </a:pPr>
+            <a:r>
+              <a:rPr lang="en-US" dirty="0"/>
+              <a:t>Opening file being actively modified</a:t>
             </a:r>
           </a:p>
           <a:p>
@@ -25233,11 +24914,11 @@
   <p:clrMapOvr>
     <a:masterClrMapping/>
   </p:clrMapOvr>
-  <mc:AlternateContent xmlns:mc="http://schemas.openxmlformats.org/markup-compatibility/2006">
-    <mc:Choice xmlns:p14="http://schemas.microsoft.com/office/powerpoint/2010/main" Requires="p14">
+  <mc:AlternateContent xmlns:mc="http://schemas.openxmlformats.org/markup-compatibility/2006" xmlns:p14="http://schemas.microsoft.com/office/powerpoint/2010/main">
+    <mc:Choice Requires="p14">
       <p:transition p14:dur="0"/>
     </mc:Choice>
-    <mc:Fallback>
+    <mc:Fallback xmlns="">
       <p:transition/>
     </mc:Fallback>
   </mc:AlternateContent>
@@ -25642,11 +25323,11 @@
   <p:clrMapOvr>
     <a:masterClrMapping/>
   </p:clrMapOvr>
-  <mc:AlternateContent xmlns:mc="http://schemas.openxmlformats.org/markup-compatibility/2006">
-    <mc:Choice xmlns:p14="http://schemas.microsoft.com/office/powerpoint/2010/main" Requires="p14">
+  <mc:AlternateContent xmlns:mc="http://schemas.openxmlformats.org/markup-compatibility/2006" xmlns:p14="http://schemas.microsoft.com/office/powerpoint/2010/main">
+    <mc:Choice Requires="p14">
       <p:transition p14:dur="0"/>
     </mc:Choice>
-    <mc:Fallback>
+    <mc:Fallback xmlns="">
       <p:transition/>
     </mc:Fallback>
   </mc:AlternateContent>
@@ -25788,6 +25469,14 @@
             <a:r>
               <a:rPr lang="en-US" dirty="0" err="1"/>
               <a:t>ImessageService</a:t>
+            </a:r>
+            <a:endParaRPr lang="en-US" dirty="0"/>
+          </a:p>
+          <a:p>
+            <a:pPr lvl="2"/>
+            <a:r>
+              <a:rPr lang="en-US" dirty="0" err="1"/>
+              <a:t>IUserPromptService</a:t>
             </a:r>
             <a:endParaRPr lang="en-US" dirty="0"/>
           </a:p>
@@ -27053,6 +26742,15 @@
 </file>
 
 <file path=customXml/item1.xml><?xml version="1.0" encoding="utf-8"?>
+<?mso-contentType ?>
+<FormTemplates xmlns="http://schemas.microsoft.com/sharepoint/v3/contenttype/forms">
+  <Display>DocumentLibraryForm</Display>
+  <Edit>DocumentLibraryForm</Edit>
+  <New>DocumentLibraryForm</New>
+</FormTemplates>
+</file>
+
+<file path=customXml/item2.xml><?xml version="1.0" encoding="utf-8"?>
 <p:properties xmlns:p="http://schemas.microsoft.com/office/2006/metadata/properties" xmlns:xsi="http://www.w3.org/2001/XMLSchema-instance" xmlns:pc="http://schemas.microsoft.com/office/infopath/2007/PartnerControls">
   <documentManagement>
     <_dlc_DocId xmlns="ff469461-7529-4054-b699-f189b0470135">JMTRRF7WE2PD-394290014-179107</_dlc_DocId>
@@ -27071,66 +26769,7 @@
 </p:properties>
 </file>
 
-<file path=customXml/item2.xml><?xml version="1.0" encoding="utf-8"?>
-<?mso-contentType ?>
-<FormTemplates xmlns="http://schemas.microsoft.com/sharepoint/v3/contenttype/forms">
-  <Display>DocumentLibraryForm</Display>
-  <Edit>DocumentLibraryForm</Edit>
-  <New>DocumentLibraryForm</New>
-</FormTemplates>
-</file>
-
 <file path=customXml/item3.xml><?xml version="1.0" encoding="utf-8"?>
-<?mso-contentType ?>
-<spe:Receivers xmlns:spe="http://schemas.microsoft.com/sharepoint/events">
-  <Receiver>
-    <Name>Document ID Generator</Name>
-    <Synchronization>Synchronous</Synchronization>
-    <Type>10001</Type>
-    <SequenceNumber>1000</SequenceNumber>
-    <Url/>
-    <Assembly>Microsoft.Office.DocumentManagement, Version=16.0.0.0, Culture=neutral, PublicKeyToken=71e9bce111e9429c</Assembly>
-    <Class>Microsoft.Office.DocumentManagement.Internal.DocIdHandler</Class>
-    <Data/>
-    <Filter/>
-  </Receiver>
-  <Receiver>
-    <Name>Document ID Generator</Name>
-    <Synchronization>Synchronous</Synchronization>
-    <Type>10002</Type>
-    <SequenceNumber>1001</SequenceNumber>
-    <Url/>
-    <Assembly>Microsoft.Office.DocumentManagement, Version=16.0.0.0, Culture=neutral, PublicKeyToken=71e9bce111e9429c</Assembly>
-    <Class>Microsoft.Office.DocumentManagement.Internal.DocIdHandler</Class>
-    <Data/>
-    <Filter/>
-  </Receiver>
-  <Receiver>
-    <Name>Document ID Generator</Name>
-    <Synchronization>Synchronous</Synchronization>
-    <Type>10004</Type>
-    <SequenceNumber>1002</SequenceNumber>
-    <Url/>
-    <Assembly>Microsoft.Office.DocumentManagement, Version=16.0.0.0, Culture=neutral, PublicKeyToken=71e9bce111e9429c</Assembly>
-    <Class>Microsoft.Office.DocumentManagement.Internal.DocIdHandler</Class>
-    <Data/>
-    <Filter/>
-  </Receiver>
-  <Receiver>
-    <Name>Document ID Generator</Name>
-    <Synchronization>Synchronous</Synchronization>
-    <Type>10006</Type>
-    <SequenceNumber>1003</SequenceNumber>
-    <Url/>
-    <Assembly>Microsoft.Office.DocumentManagement, Version=16.0.0.0, Culture=neutral, PublicKeyToken=71e9bce111e9429c</Assembly>
-    <Class>Microsoft.Office.DocumentManagement.Internal.DocIdHandler</Class>
-    <Data/>
-    <Filter/>
-  </Receiver>
-</spe:Receivers>
-</file>
-
-<file path=customXml/item4.xml><?xml version="1.0" encoding="utf-8"?>
 <ct:contentTypeSchema xmlns:ct="http://schemas.microsoft.com/office/2006/metadata/contentType" xmlns:ma="http://schemas.microsoft.com/office/2006/metadata/properties/metaAttributes" ct:_="" ma:_="" ma:contentTypeName="Document" ma:contentTypeID="0x0101006EDC6CC76FF9184F853A569783F97413" ma:contentTypeVersion="22" ma:contentTypeDescription="Create a new document." ma:contentTypeScope="" ma:versionID="fafba55adc5922abf3c9c892f4cb72c7">
   <xsd:schema xmlns:xsd="http://www.w3.org/2001/XMLSchema" xmlns:xs="http://www.w3.org/2001/XMLSchema" xmlns:p="http://schemas.microsoft.com/office/2006/metadata/properties" xmlns:ns2="ff469461-7529-4054-b699-f189b0470135" xmlns:ns3="fd34c5d5-5d34-46ed-9bd0-fe73508393dd" targetNamespace="http://schemas.microsoft.com/office/2006/metadata/properties" ma:root="true" ma:fieldsID="060795adfc307ec5b186d3bc1ba667bf" ns2:_="" ns3:_="">
     <xsd:import namespace="ff469461-7529-4054-b699-f189b0470135"/>
@@ -27412,18 +27051,57 @@
 </ct:contentTypeSchema>
 </file>
 
-<file path=customXml/itemProps1.xml><?xml version="1.0" encoding="utf-8"?>
-<ds:datastoreItem xmlns:ds="http://schemas.openxmlformats.org/officeDocument/2006/customXml" ds:itemID="{BDDCD54E-E6D4-44B7-9C63-36A87B0BC892}">
-  <ds:schemaRefs>
-    <ds:schemaRef ds:uri="http://schemas.microsoft.com/office/2006/metadata/properties"/>
-    <ds:schemaRef ds:uri="http://schemas.microsoft.com/office/infopath/2007/PartnerControls"/>
-    <ds:schemaRef ds:uri="ff469461-7529-4054-b699-f189b0470135"/>
-    <ds:schemaRef ds:uri="fd34c5d5-5d34-46ed-9bd0-fe73508393dd"/>
-  </ds:schemaRefs>
-</ds:datastoreItem>
+<file path=customXml/item4.xml><?xml version="1.0" encoding="utf-8"?>
+<?mso-contentType ?>
+<spe:Receivers xmlns:spe="http://schemas.microsoft.com/sharepoint/events">
+  <Receiver>
+    <Name>Document ID Generator</Name>
+    <Synchronization>Synchronous</Synchronization>
+    <Type>10001</Type>
+    <SequenceNumber>1000</SequenceNumber>
+    <Url/>
+    <Assembly>Microsoft.Office.DocumentManagement, Version=16.0.0.0, Culture=neutral, PublicKeyToken=71e9bce111e9429c</Assembly>
+    <Class>Microsoft.Office.DocumentManagement.Internal.DocIdHandler</Class>
+    <Data/>
+    <Filter/>
+  </Receiver>
+  <Receiver>
+    <Name>Document ID Generator</Name>
+    <Synchronization>Synchronous</Synchronization>
+    <Type>10002</Type>
+    <SequenceNumber>1001</SequenceNumber>
+    <Url/>
+    <Assembly>Microsoft.Office.DocumentManagement, Version=16.0.0.0, Culture=neutral, PublicKeyToken=71e9bce111e9429c</Assembly>
+    <Class>Microsoft.Office.DocumentManagement.Internal.DocIdHandler</Class>
+    <Data/>
+    <Filter/>
+  </Receiver>
+  <Receiver>
+    <Name>Document ID Generator</Name>
+    <Synchronization>Synchronous</Synchronization>
+    <Type>10004</Type>
+    <SequenceNumber>1002</SequenceNumber>
+    <Url/>
+    <Assembly>Microsoft.Office.DocumentManagement, Version=16.0.0.0, Culture=neutral, PublicKeyToken=71e9bce111e9429c</Assembly>
+    <Class>Microsoft.Office.DocumentManagement.Internal.DocIdHandler</Class>
+    <Data/>
+    <Filter/>
+  </Receiver>
+  <Receiver>
+    <Name>Document ID Generator</Name>
+    <Synchronization>Synchronous</Synchronization>
+    <Type>10006</Type>
+    <SequenceNumber>1003</SequenceNumber>
+    <Url/>
+    <Assembly>Microsoft.Office.DocumentManagement, Version=16.0.0.0, Culture=neutral, PublicKeyToken=71e9bce111e9429c</Assembly>
+    <Class>Microsoft.Office.DocumentManagement.Internal.DocIdHandler</Class>
+    <Data/>
+    <Filter/>
+  </Receiver>
+</spe:Receivers>
 </file>
 
-<file path=customXml/itemProps2.xml><?xml version="1.0" encoding="utf-8"?>
+<file path=customXml/itemProps1.xml><?xml version="1.0" encoding="utf-8"?>
 <ds:datastoreItem xmlns:ds="http://schemas.openxmlformats.org/officeDocument/2006/customXml" ds:itemID="{A6D3E88B-1A5A-4B73-80E5-69C18FD07D34}">
   <ds:schemaRefs>
     <ds:schemaRef ds:uri="http://schemas.microsoft.com/sharepoint/v3/contenttype/forms"/>
@@ -27431,15 +27109,24 @@
 </ds:datastoreItem>
 </file>
 
-<file path=customXml/itemProps3.xml><?xml version="1.0" encoding="utf-8"?>
-<ds:datastoreItem xmlns:ds="http://schemas.openxmlformats.org/officeDocument/2006/customXml" ds:itemID="{AE2F94C8-66CF-41ED-818B-048931D25A1F}">
+<file path=customXml/itemProps2.xml><?xml version="1.0" encoding="utf-8"?>
+<ds:datastoreItem xmlns:ds="http://schemas.openxmlformats.org/officeDocument/2006/customXml" ds:itemID="{BDDCD54E-E6D4-44B7-9C63-36A87B0BC892}">
   <ds:schemaRefs>
-    <ds:schemaRef ds:uri="http://schemas.microsoft.com/sharepoint/events"/>
+    <ds:schemaRef ds:uri="http://schemas.microsoft.com/office/2006/documentManagement/types"/>
+    <ds:schemaRef ds:uri="http://purl.org/dc/terms/"/>
+    <ds:schemaRef ds:uri="http://schemas.microsoft.com/office/2006/metadata/properties"/>
+    <ds:schemaRef ds:uri="http://purl.org/dc/elements/1.1/"/>
+    <ds:schemaRef ds:uri="http://schemas.openxmlformats.org/package/2006/metadata/core-properties"/>
+    <ds:schemaRef ds:uri="fd34c5d5-5d34-46ed-9bd0-fe73508393dd"/>
+    <ds:schemaRef ds:uri="http://purl.org/dc/dcmitype/"/>
+    <ds:schemaRef ds:uri="http://schemas.microsoft.com/office/infopath/2007/PartnerControls"/>
+    <ds:schemaRef ds:uri="ff469461-7529-4054-b699-f189b0470135"/>
+    <ds:schemaRef ds:uri="http://www.w3.org/XML/1998/namespace"/>
   </ds:schemaRefs>
 </ds:datastoreItem>
 </file>
 
-<file path=customXml/itemProps4.xml><?xml version="1.0" encoding="utf-8"?>
+<file path=customXml/itemProps3.xml><?xml version="1.0" encoding="utf-8"?>
 <ds:datastoreItem xmlns:ds="http://schemas.openxmlformats.org/officeDocument/2006/customXml" ds:itemID="{9DFD6D4B-0724-4B51-A318-8F6196A403FF}">
   <ds:schemaRefs>
     <ds:schemaRef ds:uri="http://schemas.microsoft.com/office/2006/metadata/contentType"/>
@@ -27458,6 +27145,14 @@
 </ds:datastoreItem>
 </file>
 
+<file path=customXml/itemProps4.xml><?xml version="1.0" encoding="utf-8"?>
+<ds:datastoreItem xmlns:ds="http://schemas.openxmlformats.org/officeDocument/2006/customXml" ds:itemID="{AE2F94C8-66CF-41ED-818B-048931D25A1F}">
+  <ds:schemaRefs>
+    <ds:schemaRef ds:uri="http://schemas.microsoft.com/sharepoint/events"/>
+  </ds:schemaRefs>
+</ds:datastoreItem>
+</file>
+
 <file path=docMetadata/LabelInfo.xml><?xml version="1.0" encoding="utf-8"?>
 <clbl:labelList xmlns:clbl="http://schemas.microsoft.com/office/2020/mipLabelMetadata">
   <clbl:label id="{2988f0a4-524a-45f2-829d-417725fa4957}" enabled="1" method="Standard" siteId="{52daf2a9-3b73-4da4-ac6a-3f81adc92b7e}" removed="0"/>

</xml_diff>